<commit_message>
Document deck collaboration baseline
</commit_message>
<xml_diff>
--- a/output/sections/01-个人介绍.pptx
+++ b/output/sections/01-个人介绍.pptx
@@ -2,15 +2,15 @@
 <file path=ppt/presentation.xml><?xml version="1.0" encoding="utf-8"?>
 <p:presentation xmlns:p="http://schemas.openxmlformats.org/presentationml/2006/main">
   <p:sldMasterIdLst>
-    <p:sldMasterId xmlns:r="http://schemas.openxmlformats.org/officeDocument/2006/relationships" id="2147483648" r:id="R097d40e6056244fa"/>
+    <p:sldMasterId xmlns:r="http://schemas.openxmlformats.org/officeDocument/2006/relationships" id="2147483648" r:id="Rac63a41583434f7f"/>
   </p:sldMasterIdLst>
   <p:notesMasterIdLst>
-    <p:notesMasterId xmlns:r="http://schemas.openxmlformats.org/officeDocument/2006/relationships" r:id="R036b7a8616a74666"/>
+    <p:notesMasterId xmlns:r="http://schemas.openxmlformats.org/officeDocument/2006/relationships" r:id="R6c27b066d24e493f"/>
   </p:notesMasterIdLst>
   <p:sldIdLst>
-    <p:sldId xmlns:r="http://schemas.openxmlformats.org/officeDocument/2006/relationships" id="256" r:id="R4930d2259f6746c9"/>
-    <p:sldId xmlns:r="http://schemas.openxmlformats.org/officeDocument/2006/relationships" id="257" r:id="R459285239e2446fb"/>
-    <p:sldId xmlns:r="http://schemas.openxmlformats.org/officeDocument/2006/relationships" id="258" r:id="R8bb3efe17afb4913"/>
+    <p:sldId xmlns:r="http://schemas.openxmlformats.org/officeDocument/2006/relationships" id="256" r:id="R5d7a27396eac4eb9"/>
+    <p:sldId xmlns:r="http://schemas.openxmlformats.org/officeDocument/2006/relationships" id="257" r:id="Ra16fdf63153c4462"/>
+    <p:sldId xmlns:r="http://schemas.openxmlformats.org/officeDocument/2006/relationships" id="258" r:id="R00ee5e4ca76f4c6c"/>
   </p:sldIdLst>
   <p:sldSz cx="12192000" cy="6858000"/>
   <p:notesSz cx="6858000" cy="9144000"/>
@@ -735,7 +735,7 @@
   </p:cSld>
   <p:clrMap bg1="lt1" tx1="dk1" bg2="lt2" tx2="dk2" accent1="accent1" accent2="accent2" accent3="accent3" accent4="accent4" accent5="accent5" accent6="accent6" hlink="hlink" folHlink="folHlink"/>
   <p:sldLayoutIdLst>
-    <p:sldLayoutId xmlns:r="http://schemas.openxmlformats.org/officeDocument/2006/relationships" id="2147483649" r:id="R413089f060c14911"/>
+    <p:sldLayoutId xmlns:r="http://schemas.openxmlformats.org/officeDocument/2006/relationships" id="2147483649" r:id="R8aa8567c5a334bc3"/>
   </p:sldLayoutIdLst>
   <p:txStyles>
     <p:titleStyle>
@@ -1383,7 +1383,7 @@
           <p:nvPr/>
         </p:nvPicPr>
         <p:blipFill>
-          <a:blip xmlns:r="http://schemas.openxmlformats.org/officeDocument/2006/relationships" xmlns:a="http://schemas.openxmlformats.org/drawingml/2006/main" r:embed="Rb255c127a9854a1a"/>
+          <a:blip xmlns:r="http://schemas.openxmlformats.org/officeDocument/2006/relationships" xmlns:a="http://schemas.openxmlformats.org/drawingml/2006/main" r:embed="R659efcf6b3d24f18"/>
           <a:stretch xmlns:a="http://schemas.openxmlformats.org/drawingml/2006/main"/>
         </p:blipFill>
         <p:spPr>
@@ -1864,7 +1864,7 @@
           <p:nvPr/>
         </p:nvPicPr>
         <p:blipFill>
-          <a:blip xmlns:r="http://schemas.openxmlformats.org/officeDocument/2006/relationships" xmlns:a="http://schemas.openxmlformats.org/drawingml/2006/main" r:embed="Rdbd4dfaf6d154f10"/>
+          <a:blip xmlns:r="http://schemas.openxmlformats.org/officeDocument/2006/relationships" xmlns:a="http://schemas.openxmlformats.org/drawingml/2006/main" r:embed="R071f08c7ea084036"/>
           <a:stretch xmlns:a="http://schemas.openxmlformats.org/drawingml/2006/main"/>
         </p:blipFill>
         <p:spPr>
@@ -3315,14 +3315,14 @@
       </p:grpSpPr>
       <p:pic>
         <p:nvPicPr>
-          <p:cNvPr id="41" name=""/>
+          <p:cNvPr id="56" name=""/>
           <p:cNvPicPr>
             <a:picLocks xmlns:a="http://schemas.openxmlformats.org/drawingml/2006/main" noChangeAspect="1"/>
           </p:cNvPicPr>
           <p:nvPr/>
         </p:nvPicPr>
         <p:blipFill>
-          <a:blip xmlns:r="http://schemas.openxmlformats.org/officeDocument/2006/relationships" xmlns:a="http://schemas.openxmlformats.org/drawingml/2006/main" r:embed="R781627a10b2749d1"/>
+          <a:blip xmlns:r="http://schemas.openxmlformats.org/officeDocument/2006/relationships" xmlns:a="http://schemas.openxmlformats.org/drawingml/2006/main" r:embed="R87d4b0008eaf4e60"/>
           <a:stretch xmlns:a="http://schemas.openxmlformats.org/drawingml/2006/main"/>
         </p:blipFill>
         <p:spPr>
@@ -3723,10 +3723,10 @@
       </p:sp>
       <p:sp>
         <p:nvSpPr>
-          <p:cNvPr id="10" name="">
-            <a:extLst xmlns:a="http://schemas.openxmlformats.org/drawingml/2006/main">
-              <a:ext uri="{FF2B5EF4-FFF2-40B4-BE49-F238E27FC236}">
-                <a16:creationId xmlns:a16="http://schemas.microsoft.com/office/drawing/2014/main" id="{64CCAF77-ABA7-483B-91A3-02AFC8EC7DB5}"/>
+          <p:cNvPr id="37" name="">
+            <a:extLst xmlns:a="http://schemas.openxmlformats.org/drawingml/2006/main">
+              <a:ext uri="{FF2B5EF4-FFF2-40B4-BE49-F238E27FC236}">
+                <a16:creationId xmlns:a16="http://schemas.microsoft.com/office/drawing/2014/main" id="{814C5BA9-84BE-486D-8C64-C5D97D7BEB2E}"/>
               </a:ext>
             </a:extLst>
           </p:cNvPr>
@@ -3738,7 +3738,7 @@
         <p:spPr>
           <a:xfrm xmlns:a="http://schemas.openxmlformats.org/drawingml/2006/main">
             <a:off x="838200" y="1447800"/>
-            <a:ext cx="3714750" cy="438150"/>
+            <a:ext cx="3714750" cy="514350"/>
           </a:xfrm>
           <a:prstGeom xmlns:a="http://schemas.openxmlformats.org/drawingml/2006/main" prst="rect">
             <a:avLst/>
@@ -3754,7 +3754,6 @@
           <a:lstStyle xmlns:a="http://schemas.openxmlformats.org/drawingml/2006/main"/>
           <a:p xmlns:a="http://schemas.openxmlformats.org/drawingml/2006/main">
             <a:pPr>
-              <a:buNone/>
               <a:defRPr sz="2700" b="1">
                 <a:solidFill>
                   <a:srgbClr val="635BFF"/>
@@ -3780,21 +3779,21 @@
       </p:sp>
       <p:sp>
         <p:nvSpPr>
-          <p:cNvPr id="11" name="">
-            <a:extLst xmlns:a="http://schemas.openxmlformats.org/drawingml/2006/main">
-              <a:ext uri="{FF2B5EF4-FFF2-40B4-BE49-F238E27FC236}">
-                <a16:creationId xmlns:a16="http://schemas.microsoft.com/office/drawing/2014/main" id="{C20F0A0D-AC30-49A4-9730-34E97C16B8EE}"/>
-              </a:ext>
-            </a:extLst>
-          </p:cNvPr>
-          <p:cNvSpPr>
-            <a:spLocks xmlns:a="http://schemas.openxmlformats.org/drawingml/2006/main" noGrp="1"/>
-          </p:cNvSpPr>
-          <p:nvPr/>
-        </p:nvSpPr>
-        <p:spPr>
-          <a:xfrm xmlns:a="http://schemas.openxmlformats.org/drawingml/2006/main">
-            <a:off x="876300" y="2057400"/>
+          <p:cNvPr id="38" name="">
+            <a:extLst xmlns:a="http://schemas.openxmlformats.org/drawingml/2006/main">
+              <a:ext uri="{FF2B5EF4-FFF2-40B4-BE49-F238E27FC236}">
+                <a16:creationId xmlns:a16="http://schemas.microsoft.com/office/drawing/2014/main" id="{84F40CC5-E753-481F-AC45-9EA405067F51}"/>
+              </a:ext>
+            </a:extLst>
+          </p:cNvPr>
+          <p:cNvSpPr>
+            <a:spLocks xmlns:a="http://schemas.openxmlformats.org/drawingml/2006/main" noGrp="1"/>
+          </p:cNvSpPr>
+          <p:nvPr/>
+        </p:nvSpPr>
+        <p:spPr>
+          <a:xfrm xmlns:a="http://schemas.openxmlformats.org/drawingml/2006/main">
+            <a:off x="876300" y="2095500"/>
             <a:ext cx="1428750" cy="38100"/>
           </a:xfrm>
           <a:prstGeom xmlns:a="http://schemas.openxmlformats.org/drawingml/2006/main" prst="rect">
@@ -3811,343 +3810,10 @@
       </p:sp>
       <p:sp>
         <p:nvSpPr>
-          <p:cNvPr id="12" name="">
-            <a:extLst xmlns:a="http://schemas.openxmlformats.org/drawingml/2006/main">
-              <a:ext uri="{FF2B5EF4-FFF2-40B4-BE49-F238E27FC236}">
-                <a16:creationId xmlns:a16="http://schemas.microsoft.com/office/drawing/2014/main" id="{F5729CF0-8B6E-4BFC-B2DE-7AFADCC865A2}"/>
-              </a:ext>
-            </a:extLst>
-          </p:cNvPr>
-          <p:cNvSpPr>
-            <a:spLocks xmlns:a="http://schemas.openxmlformats.org/drawingml/2006/main" noGrp="1"/>
-          </p:cNvSpPr>
-          <p:nvPr/>
-        </p:nvSpPr>
-        <p:spPr>
-          <a:xfrm xmlns:a="http://schemas.openxmlformats.org/drawingml/2006/main">
-            <a:off x="838200" y="2286000"/>
-            <a:ext cx="3429000" cy="228600"/>
-          </a:xfrm>
-          <a:prstGeom xmlns:a="http://schemas.openxmlformats.org/drawingml/2006/main" prst="rect">
-            <a:avLst/>
-          </a:prstGeom>
-          <a:noFill xmlns:a="http://schemas.openxmlformats.org/drawingml/2006/main"/>
-          <a:ln xmlns:a="http://schemas.openxmlformats.org/drawingml/2006/main" w="0">
-            <a:noFill/>
-            <a:prstDash val="solid"/>
-          </a:ln>
-        </p:spPr>
-        <p:txBody>
-          <a:bodyPr xmlns:a="http://schemas.openxmlformats.org/drawingml/2006/main" wrap="square" lIns="0" tIns="0" rIns="0" bIns="0"/>
-          <a:lstStyle xmlns:a="http://schemas.openxmlformats.org/drawingml/2006/main"/>
-          <a:p xmlns:a="http://schemas.openxmlformats.org/drawingml/2006/main">
-            <a:pPr>
-              <a:buNone/>
-              <a:defRPr sz="1275" b="1">
-                <a:solidFill>
-                  <a:srgbClr val="14113D"/>
-                </a:solidFill>
-                <a:latin typeface="PingFang SC"/>
-                <a:ea typeface="PingFang SC"/>
-                <a:cs typeface="PingFang SC"/>
-              </a:defRPr>
-            </a:pPr>
-            <a:r>
-              <a:rPr sz="1275" b="1">
-                <a:solidFill>
-                  <a:srgbClr val="14113D"/>
-                </a:solidFill>
-                <a:latin typeface="PingFang SC"/>
-                <a:ea typeface="PingFang SC"/>
-                <a:cs typeface="PingFang SC"/>
-              </a:rPr>
-              <a:t>统计建模 · 推荐广告链路 · 生成式推荐探索</a:t>
-            </a:r>
-          </a:p>
-        </p:txBody>
-      </p:sp>
-      <p:sp>
-        <p:nvSpPr>
-          <p:cNvPr id="13" name="">
-            <a:extLst xmlns:a="http://schemas.openxmlformats.org/drawingml/2006/main">
-              <a:ext uri="{FF2B5EF4-FFF2-40B4-BE49-F238E27FC236}">
-                <a16:creationId xmlns:a16="http://schemas.microsoft.com/office/drawing/2014/main" id="{A7C66EDA-9585-4CB6-953F-543DEF34B9BB}"/>
-              </a:ext>
-            </a:extLst>
-          </p:cNvPr>
-          <p:cNvSpPr>
-            <a:spLocks xmlns:a="http://schemas.openxmlformats.org/drawingml/2006/main" noGrp="1"/>
-          </p:cNvSpPr>
-          <p:nvPr/>
-        </p:nvSpPr>
-        <p:spPr>
-          <a:xfrm xmlns:a="http://schemas.openxmlformats.org/drawingml/2006/main">
-            <a:off x="838200" y="2800350"/>
-            <a:ext cx="914400" cy="304800"/>
-          </a:xfrm>
-          <a:prstGeom xmlns:a="http://schemas.openxmlformats.org/drawingml/2006/main" prst="roundRect">
-            <a:avLst>
-              <a:gd name="adj" fmla="val 18750"/>
-            </a:avLst>
-          </a:prstGeom>
-          <a:solidFill xmlns:a="http://schemas.openxmlformats.org/drawingml/2006/main">
-            <a:srgbClr val="F8FBFF"/>
-          </a:solidFill>
-          <a:ln xmlns:a="http://schemas.openxmlformats.org/drawingml/2006/main" w="9525">
-            <a:solidFill>
-              <a:srgbClr val="C7E7FF"/>
-            </a:solidFill>
-            <a:prstDash val="solid"/>
-          </a:ln>
-        </p:spPr>
-      </p:sp>
-      <p:sp>
-        <p:nvSpPr>
-          <p:cNvPr id="14" name="">
-            <a:extLst xmlns:a="http://schemas.openxmlformats.org/drawingml/2006/main">
-              <a:ext uri="{FF2B5EF4-FFF2-40B4-BE49-F238E27FC236}">
-                <a16:creationId xmlns:a16="http://schemas.microsoft.com/office/drawing/2014/main" id="{74DD4342-D485-403A-A235-A3EB70769B72}"/>
-              </a:ext>
-            </a:extLst>
-          </p:cNvPr>
-          <p:cNvSpPr>
-            <a:spLocks xmlns:a="http://schemas.openxmlformats.org/drawingml/2006/main" noGrp="1"/>
-          </p:cNvSpPr>
-          <p:nvPr/>
-        </p:nvSpPr>
-        <p:spPr>
-          <a:xfrm xmlns:a="http://schemas.openxmlformats.org/drawingml/2006/main">
-            <a:off x="838200" y="2876550"/>
-            <a:ext cx="914400" cy="152400"/>
-          </a:xfrm>
-          <a:prstGeom xmlns:a="http://schemas.openxmlformats.org/drawingml/2006/main" prst="rect">
-            <a:avLst/>
-          </a:prstGeom>
-          <a:noFill xmlns:a="http://schemas.openxmlformats.org/drawingml/2006/main"/>
-          <a:ln xmlns:a="http://schemas.openxmlformats.org/drawingml/2006/main" w="0">
-            <a:noFill/>
-            <a:prstDash val="solid"/>
-          </a:ln>
-        </p:spPr>
-        <p:txBody>
-          <a:bodyPr xmlns:a="http://schemas.openxmlformats.org/drawingml/2006/main" wrap="square" lIns="0" tIns="0" rIns="0" bIns="0"/>
-          <a:lstStyle xmlns:a="http://schemas.openxmlformats.org/drawingml/2006/main"/>
-          <a:p xmlns:a="http://schemas.openxmlformats.org/drawingml/2006/main">
-            <a:pPr algn="ctr">
-              <a:buNone/>
-              <a:defRPr sz="900" b="1">
-                <a:solidFill>
-                  <a:srgbClr val="344054"/>
-                </a:solidFill>
-                <a:latin typeface="PingFang SC"/>
-                <a:ea typeface="PingFang SC"/>
-                <a:cs typeface="PingFang SC"/>
-              </a:defRPr>
-            </a:pPr>
-            <a:r>
-              <a:rPr sz="900" b="1">
-                <a:solidFill>
-                  <a:srgbClr val="344054"/>
-                </a:solidFill>
-                <a:latin typeface="PingFang SC"/>
-                <a:ea typeface="PingFang SC"/>
-                <a:cs typeface="PingFang SC"/>
-              </a:rPr>
-              <a:t>统计背景</a:t>
-            </a:r>
-          </a:p>
-        </p:txBody>
-      </p:sp>
-      <p:sp>
-        <p:nvSpPr>
-          <p:cNvPr id="15" name="">
-            <a:extLst xmlns:a="http://schemas.openxmlformats.org/drawingml/2006/main">
-              <a:ext uri="{FF2B5EF4-FFF2-40B4-BE49-F238E27FC236}">
-                <a16:creationId xmlns:a16="http://schemas.microsoft.com/office/drawing/2014/main" id="{DB69D1FE-E048-4330-AAED-432E5DBEE01E}"/>
-              </a:ext>
-            </a:extLst>
-          </p:cNvPr>
-          <p:cNvSpPr>
-            <a:spLocks xmlns:a="http://schemas.openxmlformats.org/drawingml/2006/main" noGrp="1"/>
-          </p:cNvSpPr>
-          <p:nvPr/>
-        </p:nvSpPr>
-        <p:spPr>
-          <a:xfrm xmlns:a="http://schemas.openxmlformats.org/drawingml/2006/main">
-            <a:off x="1943100" y="2800350"/>
-            <a:ext cx="914400" cy="304800"/>
-          </a:xfrm>
-          <a:prstGeom xmlns:a="http://schemas.openxmlformats.org/drawingml/2006/main" prst="roundRect">
-            <a:avLst>
-              <a:gd name="adj" fmla="val 18750"/>
-            </a:avLst>
-          </a:prstGeom>
-          <a:solidFill xmlns:a="http://schemas.openxmlformats.org/drawingml/2006/main">
-            <a:srgbClr val="F8FBFF"/>
-          </a:solidFill>
-          <a:ln xmlns:a="http://schemas.openxmlformats.org/drawingml/2006/main" w="9525">
-            <a:solidFill>
-              <a:srgbClr val="C7E7FF"/>
-            </a:solidFill>
-            <a:prstDash val="solid"/>
-          </a:ln>
-        </p:spPr>
-      </p:sp>
-      <p:sp>
-        <p:nvSpPr>
-          <p:cNvPr id="16" name="">
-            <a:extLst xmlns:a="http://schemas.openxmlformats.org/drawingml/2006/main">
-              <a:ext uri="{FF2B5EF4-FFF2-40B4-BE49-F238E27FC236}">
-                <a16:creationId xmlns:a16="http://schemas.microsoft.com/office/drawing/2014/main" id="{2E3DF612-6A35-44E6-81DD-A1E8AD02B133}"/>
-              </a:ext>
-            </a:extLst>
-          </p:cNvPr>
-          <p:cNvSpPr>
-            <a:spLocks xmlns:a="http://schemas.openxmlformats.org/drawingml/2006/main" noGrp="1"/>
-          </p:cNvSpPr>
-          <p:nvPr/>
-        </p:nvSpPr>
-        <p:spPr>
-          <a:xfrm xmlns:a="http://schemas.openxmlformats.org/drawingml/2006/main">
-            <a:off x="1943100" y="2876550"/>
-            <a:ext cx="914400" cy="152400"/>
-          </a:xfrm>
-          <a:prstGeom xmlns:a="http://schemas.openxmlformats.org/drawingml/2006/main" prst="rect">
-            <a:avLst/>
-          </a:prstGeom>
-          <a:noFill xmlns:a="http://schemas.openxmlformats.org/drawingml/2006/main"/>
-          <a:ln xmlns:a="http://schemas.openxmlformats.org/drawingml/2006/main" w="0">
-            <a:noFill/>
-            <a:prstDash val="solid"/>
-          </a:ln>
-        </p:spPr>
-        <p:txBody>
-          <a:bodyPr xmlns:a="http://schemas.openxmlformats.org/drawingml/2006/main" wrap="square" lIns="0" tIns="0" rIns="0" bIns="0"/>
-          <a:lstStyle xmlns:a="http://schemas.openxmlformats.org/drawingml/2006/main"/>
-          <a:p xmlns:a="http://schemas.openxmlformats.org/drawingml/2006/main">
-            <a:pPr algn="ctr">
-              <a:buNone/>
-              <a:defRPr sz="900" b="1">
-                <a:solidFill>
-                  <a:srgbClr val="344054"/>
-                </a:solidFill>
-                <a:latin typeface="PingFang SC"/>
-                <a:ea typeface="PingFang SC"/>
-                <a:cs typeface="PingFang SC"/>
-              </a:defRPr>
-            </a:pPr>
-            <a:r>
-              <a:rPr sz="900" b="1">
-                <a:solidFill>
-                  <a:srgbClr val="344054"/>
-                </a:solidFill>
-                <a:latin typeface="PingFang SC"/>
-                <a:ea typeface="PingFang SC"/>
-                <a:cs typeface="PingFang SC"/>
-              </a:rPr>
-              <a:t>广告推荐</a:t>
-            </a:r>
-          </a:p>
-        </p:txBody>
-      </p:sp>
-      <p:sp>
-        <p:nvSpPr>
-          <p:cNvPr id="17" name="">
-            <a:extLst xmlns:a="http://schemas.openxmlformats.org/drawingml/2006/main">
-              <a:ext uri="{FF2B5EF4-FFF2-40B4-BE49-F238E27FC236}">
-                <a16:creationId xmlns:a16="http://schemas.microsoft.com/office/drawing/2014/main" id="{C74138EC-7F40-40BE-9B28-7C90DC52CEB8}"/>
-              </a:ext>
-            </a:extLst>
-          </p:cNvPr>
-          <p:cNvSpPr>
-            <a:spLocks xmlns:a="http://schemas.openxmlformats.org/drawingml/2006/main" noGrp="1"/>
-          </p:cNvSpPr>
-          <p:nvPr/>
-        </p:nvSpPr>
-        <p:spPr>
-          <a:xfrm xmlns:a="http://schemas.openxmlformats.org/drawingml/2006/main">
-            <a:off x="3048000" y="2800350"/>
-            <a:ext cx="914400" cy="304800"/>
-          </a:xfrm>
-          <a:prstGeom xmlns:a="http://schemas.openxmlformats.org/drawingml/2006/main" prst="roundRect">
-            <a:avLst>
-              <a:gd name="adj" fmla="val 18750"/>
-            </a:avLst>
-          </a:prstGeom>
-          <a:solidFill xmlns:a="http://schemas.openxmlformats.org/drawingml/2006/main">
-            <a:srgbClr val="F4F1FF"/>
-          </a:solidFill>
-          <a:ln xmlns:a="http://schemas.openxmlformats.org/drawingml/2006/main" w="9525">
-            <a:solidFill>
-              <a:srgbClr val="C7E7FF"/>
-            </a:solidFill>
-            <a:prstDash val="solid"/>
-          </a:ln>
-        </p:spPr>
-      </p:sp>
-      <p:sp>
-        <p:nvSpPr>
-          <p:cNvPr id="18" name="">
-            <a:extLst xmlns:a="http://schemas.openxmlformats.org/drawingml/2006/main">
-              <a:ext uri="{FF2B5EF4-FFF2-40B4-BE49-F238E27FC236}">
-                <a16:creationId xmlns:a16="http://schemas.microsoft.com/office/drawing/2014/main" id="{A7492B6F-8160-4D03-8350-99B544D26787}"/>
-              </a:ext>
-            </a:extLst>
-          </p:cNvPr>
-          <p:cNvSpPr>
-            <a:spLocks xmlns:a="http://schemas.openxmlformats.org/drawingml/2006/main" noGrp="1"/>
-          </p:cNvSpPr>
-          <p:nvPr/>
-        </p:nvSpPr>
-        <p:spPr>
-          <a:xfrm xmlns:a="http://schemas.openxmlformats.org/drawingml/2006/main">
-            <a:off x="3048000" y="2876550"/>
-            <a:ext cx="914400" cy="152400"/>
-          </a:xfrm>
-          <a:prstGeom xmlns:a="http://schemas.openxmlformats.org/drawingml/2006/main" prst="rect">
-            <a:avLst/>
-          </a:prstGeom>
-          <a:noFill xmlns:a="http://schemas.openxmlformats.org/drawingml/2006/main"/>
-          <a:ln xmlns:a="http://schemas.openxmlformats.org/drawingml/2006/main" w="0">
-            <a:noFill/>
-            <a:prstDash val="solid"/>
-          </a:ln>
-        </p:spPr>
-        <p:txBody>
-          <a:bodyPr xmlns:a="http://schemas.openxmlformats.org/drawingml/2006/main" wrap="square" lIns="0" tIns="0" rIns="0" bIns="0"/>
-          <a:lstStyle xmlns:a="http://schemas.openxmlformats.org/drawingml/2006/main"/>
-          <a:p xmlns:a="http://schemas.openxmlformats.org/drawingml/2006/main">
-            <a:pPr algn="ctr">
-              <a:buNone/>
-              <a:defRPr sz="900" b="1">
-                <a:solidFill>
-                  <a:srgbClr val="635BFF"/>
-                </a:solidFill>
-                <a:latin typeface="PingFang SC"/>
-                <a:ea typeface="PingFang SC"/>
-                <a:cs typeface="PingFang SC"/>
-              </a:defRPr>
-            </a:pPr>
-            <a:r>
-              <a:rPr sz="900" b="1">
-                <a:solidFill>
-                  <a:srgbClr val="635BFF"/>
-                </a:solidFill>
-                <a:latin typeface="PingFang SC"/>
-                <a:ea typeface="PingFang SC"/>
-                <a:cs typeface="PingFang SC"/>
-              </a:rPr>
-              <a:t>OneRec</a:t>
-            </a:r>
-          </a:p>
-        </p:txBody>
-      </p:sp>
-      <p:sp>
-        <p:nvSpPr>
-          <p:cNvPr id="19" name="">
-            <a:extLst xmlns:a="http://schemas.openxmlformats.org/drawingml/2006/main">
-              <a:ext uri="{FF2B5EF4-FFF2-40B4-BE49-F238E27FC236}">
-                <a16:creationId xmlns:a16="http://schemas.microsoft.com/office/drawing/2014/main" id="{A14933AE-B094-4B53-96CC-7F3F8653F7B4}"/>
+          <p:cNvPr id="39" name="">
+            <a:extLst xmlns:a="http://schemas.openxmlformats.org/drawingml/2006/main">
+              <a:ext uri="{FF2B5EF4-FFF2-40B4-BE49-F238E27FC236}">
+                <a16:creationId xmlns:a16="http://schemas.microsoft.com/office/drawing/2014/main" id="{BC6A3154-5B20-498E-9752-810F71A1CEB5}"/>
               </a:ext>
             </a:extLst>
           </p:cNvPr>
@@ -4173,34 +3839,12 @@
           </a:ln>
         </p:spPr>
       </p:sp>
-      <p:pic>
-        <p:nvPicPr>
-          <p:cNvPr id="60" name=""/>
-          <p:cNvPicPr>
-            <a:picLocks xmlns:a="http://schemas.openxmlformats.org/drawingml/2006/main" noChangeAspect="1"/>
-          </p:cNvPicPr>
-          <p:nvPr/>
-        </p:nvPicPr>
-        <p:blipFill>
-          <a:blip xmlns:r="http://schemas.openxmlformats.org/officeDocument/2006/relationships" xmlns:a="http://schemas.openxmlformats.org/drawingml/2006/main" r:embed="R307f7f1c984d4d37"/>
-          <a:stretch xmlns:a="http://schemas.openxmlformats.org/drawingml/2006/main"/>
-        </p:blipFill>
-        <p:spPr>
-          <a:xfrm xmlns:a="http://schemas.openxmlformats.org/drawingml/2006/main">
-            <a:off x="4305300" y="1495425"/>
-            <a:ext cx="476250" cy="476250"/>
-          </a:xfrm>
-          <a:prstGeom xmlns:a="http://schemas.openxmlformats.org/drawingml/2006/main" prst="rect">
-            <a:avLst/>
-          </a:prstGeom>
-        </p:spPr>
-      </p:pic>
-      <p:sp>
-        <p:nvSpPr>
-          <p:cNvPr id="21" name="">
-            <a:extLst xmlns:a="http://schemas.openxmlformats.org/drawingml/2006/main">
-              <a:ext uri="{FF2B5EF4-FFF2-40B4-BE49-F238E27FC236}">
-                <a16:creationId xmlns:a16="http://schemas.microsoft.com/office/drawing/2014/main" id="{AC31BFF0-4B26-4D2F-A9E2-3C2BA1FF5B42}"/>
+      <p:sp>
+        <p:nvSpPr>
+          <p:cNvPr id="40" name="">
+            <a:extLst xmlns:a="http://schemas.openxmlformats.org/drawingml/2006/main">
+              <a:ext uri="{FF2B5EF4-FFF2-40B4-BE49-F238E27FC236}">
+                <a16:creationId xmlns:a16="http://schemas.microsoft.com/office/drawing/2014/main" id="{89DF0C6B-6F78-420E-98A7-D87821A6A26F}"/>
               </a:ext>
             </a:extLst>
           </p:cNvPr>
@@ -4230,10 +3874,10 @@
       </p:sp>
       <p:sp>
         <p:nvSpPr>
-          <p:cNvPr id="22" name="">
-            <a:extLst xmlns:a="http://schemas.openxmlformats.org/drawingml/2006/main">
-              <a:ext uri="{FF2B5EF4-FFF2-40B4-BE49-F238E27FC236}">
-                <a16:creationId xmlns:a16="http://schemas.microsoft.com/office/drawing/2014/main" id="{5F447B83-FCE9-4773-9FA4-1770E66EABE6}"/>
+          <p:cNvPr id="41" name="">
+            <a:extLst xmlns:a="http://schemas.openxmlformats.org/drawingml/2006/main">
+              <a:ext uri="{FF2B5EF4-FFF2-40B4-BE49-F238E27FC236}">
+                <a16:creationId xmlns:a16="http://schemas.microsoft.com/office/drawing/2014/main" id="{CDB9A9F9-1499-4DD7-8F83-4AB60E3E2585}"/>
               </a:ext>
             </a:extLst>
           </p:cNvPr>
@@ -4261,7 +3905,6 @@
           <a:lstStyle xmlns:a="http://schemas.openxmlformats.org/drawingml/2006/main"/>
           <a:p xmlns:a="http://schemas.openxmlformats.org/drawingml/2006/main">
             <a:pPr>
-              <a:buNone/>
               <a:defRPr sz="1650" b="1">
                 <a:solidFill>
                   <a:srgbClr val="111827"/>
@@ -4287,10 +3930,10 @@
       </p:sp>
       <p:sp>
         <p:nvSpPr>
-          <p:cNvPr id="23" name="">
-            <a:extLst xmlns:a="http://schemas.openxmlformats.org/drawingml/2006/main">
-              <a:ext uri="{FF2B5EF4-FFF2-40B4-BE49-F238E27FC236}">
-                <a16:creationId xmlns:a16="http://schemas.microsoft.com/office/drawing/2014/main" id="{E0B35967-4BFB-4AAE-9F27-CA9B407C68E8}"/>
+          <p:cNvPr id="42" name="">
+            <a:extLst xmlns:a="http://schemas.openxmlformats.org/drawingml/2006/main">
+              <a:ext uri="{FF2B5EF4-FFF2-40B4-BE49-F238E27FC236}">
+                <a16:creationId xmlns:a16="http://schemas.microsoft.com/office/drawing/2014/main" id="{42EA3C47-2DCF-41A5-89DF-A678910B274A}"/>
               </a:ext>
             </a:extLst>
           </p:cNvPr>
@@ -4318,7 +3961,6 @@
           <a:lstStyle xmlns:a="http://schemas.openxmlformats.org/drawingml/2006/main"/>
           <a:p xmlns:a="http://schemas.openxmlformats.org/drawingml/2006/main">
             <a:pPr>
-              <a:buNone/>
               <a:defRPr sz="1350" b="0">
                 <a:solidFill>
                   <a:srgbClr val="344054"/>
@@ -4342,34 +3984,12 @@
           </a:p>
         </p:txBody>
       </p:sp>
-      <p:pic>
-        <p:nvPicPr>
-          <p:cNvPr id="64" name=""/>
-          <p:cNvPicPr>
-            <a:picLocks xmlns:a="http://schemas.openxmlformats.org/drawingml/2006/main" noChangeAspect="1"/>
-          </p:cNvPicPr>
-          <p:nvPr/>
-        </p:nvPicPr>
-        <p:blipFill>
-          <a:blip xmlns:r="http://schemas.openxmlformats.org/officeDocument/2006/relationships" xmlns:a="http://schemas.openxmlformats.org/drawingml/2006/main" r:embed="R669bc22a35d3492b"/>
-          <a:stretch xmlns:a="http://schemas.openxmlformats.org/drawingml/2006/main"/>
-        </p:blipFill>
-        <p:spPr>
-          <a:xfrm xmlns:a="http://schemas.openxmlformats.org/drawingml/2006/main">
-            <a:off x="4038600" y="2576647"/>
-            <a:ext cx="1104900" cy="199756"/>
-          </a:xfrm>
-          <a:prstGeom xmlns:a="http://schemas.openxmlformats.org/drawingml/2006/main" prst="rect">
-            <a:avLst/>
-          </a:prstGeom>
-        </p:spPr>
-      </p:pic>
-      <p:sp>
-        <p:nvSpPr>
-          <p:cNvPr id="25" name="">
-            <a:extLst xmlns:a="http://schemas.openxmlformats.org/drawingml/2006/main">
-              <a:ext uri="{FF2B5EF4-FFF2-40B4-BE49-F238E27FC236}">
-                <a16:creationId xmlns:a16="http://schemas.microsoft.com/office/drawing/2014/main" id="{A2C5794D-F342-4F7E-8B91-BC5B6FF301E8}"/>
+      <p:sp>
+        <p:nvSpPr>
+          <p:cNvPr id="43" name="">
+            <a:extLst xmlns:a="http://schemas.openxmlformats.org/drawingml/2006/main">
+              <a:ext uri="{FF2B5EF4-FFF2-40B4-BE49-F238E27FC236}">
+                <a16:creationId xmlns:a16="http://schemas.microsoft.com/office/drawing/2014/main" id="{84ACDABF-C135-48A1-AB58-B81E9F0712FB}"/>
               </a:ext>
             </a:extLst>
           </p:cNvPr>
@@ -4399,10 +4019,10 @@
       </p:sp>
       <p:sp>
         <p:nvSpPr>
-          <p:cNvPr id="26" name="">
-            <a:extLst xmlns:a="http://schemas.openxmlformats.org/drawingml/2006/main">
-              <a:ext uri="{FF2B5EF4-FFF2-40B4-BE49-F238E27FC236}">
-                <a16:creationId xmlns:a16="http://schemas.microsoft.com/office/drawing/2014/main" id="{959F2582-AB3A-4117-B316-0447C4372D73}"/>
+          <p:cNvPr id="44" name="">
+            <a:extLst xmlns:a="http://schemas.openxmlformats.org/drawingml/2006/main">
+              <a:ext uri="{FF2B5EF4-FFF2-40B4-BE49-F238E27FC236}">
+                <a16:creationId xmlns:a16="http://schemas.microsoft.com/office/drawing/2014/main" id="{6824CDFF-7345-4A5C-B589-0C0A33875A7B}"/>
               </a:ext>
             </a:extLst>
           </p:cNvPr>
@@ -4430,7 +4050,6 @@
           <a:lstStyle xmlns:a="http://schemas.openxmlformats.org/drawingml/2006/main"/>
           <a:p xmlns:a="http://schemas.openxmlformats.org/drawingml/2006/main">
             <a:pPr>
-              <a:buNone/>
               <a:defRPr sz="1650" b="1">
                 <a:solidFill>
                   <a:srgbClr val="111827"/>
@@ -4456,10 +4075,10 @@
       </p:sp>
       <p:sp>
         <p:nvSpPr>
-          <p:cNvPr id="27" name="">
-            <a:extLst xmlns:a="http://schemas.openxmlformats.org/drawingml/2006/main">
-              <a:ext uri="{FF2B5EF4-FFF2-40B4-BE49-F238E27FC236}">
-                <a16:creationId xmlns:a16="http://schemas.microsoft.com/office/drawing/2014/main" id="{0CE60C49-B5DA-45CA-A0B6-B7A8BA3E9973}"/>
+          <p:cNvPr id="45" name="">
+            <a:extLst xmlns:a="http://schemas.openxmlformats.org/drawingml/2006/main">
+              <a:ext uri="{FF2B5EF4-FFF2-40B4-BE49-F238E27FC236}">
+                <a16:creationId xmlns:a16="http://schemas.microsoft.com/office/drawing/2014/main" id="{7073DB66-A41A-48DF-BF97-CB4F9A30A461}"/>
               </a:ext>
             </a:extLst>
           </p:cNvPr>
@@ -4487,7 +4106,6 @@
           <a:lstStyle xmlns:a="http://schemas.openxmlformats.org/drawingml/2006/main"/>
           <a:p xmlns:a="http://schemas.openxmlformats.org/drawingml/2006/main">
             <a:pPr>
-              <a:buNone/>
               <a:defRPr sz="1350" b="0">
                 <a:solidFill>
                   <a:srgbClr val="344054"/>
@@ -4511,7 +4129,6 @@
           </a:p>
           <a:p xmlns:a="http://schemas.openxmlformats.org/drawingml/2006/main">
             <a:pPr>
-              <a:buNone/>
               <a:defRPr sz="1350" b="0">
                 <a:solidFill>
                   <a:srgbClr val="344054"/>
@@ -4535,34 +4152,12 @@
           </a:p>
         </p:txBody>
       </p:sp>
-      <p:pic>
-        <p:nvPicPr>
-          <p:cNvPr id="68" name=""/>
-          <p:cNvPicPr>
-            <a:picLocks xmlns:a="http://schemas.openxmlformats.org/drawingml/2006/main" noChangeAspect="1"/>
-          </p:cNvPicPr>
-          <p:nvPr/>
-        </p:nvPicPr>
-        <p:blipFill>
-          <a:blip xmlns:r="http://schemas.openxmlformats.org/officeDocument/2006/relationships" xmlns:a="http://schemas.openxmlformats.org/drawingml/2006/main" r:embed="R9afe944ce769473f"/>
-          <a:stretch xmlns:a="http://schemas.openxmlformats.org/drawingml/2006/main"/>
-        </p:blipFill>
-        <p:spPr>
-          <a:xfrm xmlns:a="http://schemas.openxmlformats.org/drawingml/2006/main">
-            <a:off x="4038600" y="3548197"/>
-            <a:ext cx="1104900" cy="199756"/>
-          </a:xfrm>
-          <a:prstGeom xmlns:a="http://schemas.openxmlformats.org/drawingml/2006/main" prst="rect">
-            <a:avLst/>
-          </a:prstGeom>
-        </p:spPr>
-      </p:pic>
-      <p:sp>
-        <p:nvSpPr>
-          <p:cNvPr id="29" name="">
-            <a:extLst xmlns:a="http://schemas.openxmlformats.org/drawingml/2006/main">
-              <a:ext uri="{FF2B5EF4-FFF2-40B4-BE49-F238E27FC236}">
-                <a16:creationId xmlns:a16="http://schemas.microsoft.com/office/drawing/2014/main" id="{554E2E42-59F8-40DE-BBA3-DB5399CDC336}"/>
+      <p:sp>
+        <p:nvSpPr>
+          <p:cNvPr id="46" name="">
+            <a:extLst xmlns:a="http://schemas.openxmlformats.org/drawingml/2006/main">
+              <a:ext uri="{FF2B5EF4-FFF2-40B4-BE49-F238E27FC236}">
+                <a16:creationId xmlns:a16="http://schemas.microsoft.com/office/drawing/2014/main" id="{917490B6-F907-46C0-BC0B-673757CB742E}"/>
               </a:ext>
             </a:extLst>
           </p:cNvPr>
@@ -4592,10 +4187,10 @@
       </p:sp>
       <p:sp>
         <p:nvSpPr>
-          <p:cNvPr id="30" name="">
-            <a:extLst xmlns:a="http://schemas.openxmlformats.org/drawingml/2006/main">
-              <a:ext uri="{FF2B5EF4-FFF2-40B4-BE49-F238E27FC236}">
-                <a16:creationId xmlns:a16="http://schemas.microsoft.com/office/drawing/2014/main" id="{69254EB7-E332-4619-BEB4-0E927703E3D3}"/>
+          <p:cNvPr id="47" name="">
+            <a:extLst xmlns:a="http://schemas.openxmlformats.org/drawingml/2006/main">
+              <a:ext uri="{FF2B5EF4-FFF2-40B4-BE49-F238E27FC236}">
+                <a16:creationId xmlns:a16="http://schemas.microsoft.com/office/drawing/2014/main" id="{2B712186-BBB3-4C9B-88CC-888979026DCE}"/>
               </a:ext>
             </a:extLst>
           </p:cNvPr>
@@ -4623,7 +4218,6 @@
           <a:lstStyle xmlns:a="http://schemas.openxmlformats.org/drawingml/2006/main"/>
           <a:p xmlns:a="http://schemas.openxmlformats.org/drawingml/2006/main">
             <a:pPr>
-              <a:buNone/>
               <a:defRPr sz="1650" b="1">
                 <a:solidFill>
                   <a:srgbClr val="111827"/>
@@ -4649,10 +4243,10 @@
       </p:sp>
       <p:sp>
         <p:nvSpPr>
-          <p:cNvPr id="31" name="">
-            <a:extLst xmlns:a="http://schemas.openxmlformats.org/drawingml/2006/main">
-              <a:ext uri="{FF2B5EF4-FFF2-40B4-BE49-F238E27FC236}">
-                <a16:creationId xmlns:a16="http://schemas.microsoft.com/office/drawing/2014/main" id="{7EBB3281-A29F-4F7D-B84F-90F66223C743}"/>
+          <p:cNvPr id="48" name="">
+            <a:extLst xmlns:a="http://schemas.openxmlformats.org/drawingml/2006/main">
+              <a:ext uri="{FF2B5EF4-FFF2-40B4-BE49-F238E27FC236}">
+                <a16:creationId xmlns:a16="http://schemas.microsoft.com/office/drawing/2014/main" id="{FA79A19D-E9E0-4A00-B79D-99C5D3905B65}"/>
               </a:ext>
             </a:extLst>
           </p:cNvPr>
@@ -4680,7 +4274,6 @@
           <a:lstStyle xmlns:a="http://schemas.openxmlformats.org/drawingml/2006/main"/>
           <a:p xmlns:a="http://schemas.openxmlformats.org/drawingml/2006/main">
             <a:pPr>
-              <a:buNone/>
               <a:defRPr sz="1350" b="0">
                 <a:solidFill>
                   <a:srgbClr val="344054"/>
@@ -4704,7 +4297,6 @@
           </a:p>
           <a:p xmlns:a="http://schemas.openxmlformats.org/drawingml/2006/main">
             <a:pPr>
-              <a:buNone/>
               <a:defRPr sz="1350" b="0">
                 <a:solidFill>
                   <a:srgbClr val="344054"/>
@@ -4728,34 +4320,12 @@
           </a:p>
         </p:txBody>
       </p:sp>
-      <p:pic>
-        <p:nvPicPr>
-          <p:cNvPr id="72" name=""/>
-          <p:cNvPicPr>
-            <a:picLocks xmlns:a="http://schemas.openxmlformats.org/drawingml/2006/main" noChangeAspect="1"/>
-          </p:cNvPicPr>
-          <p:nvPr/>
-        </p:nvPicPr>
-        <p:blipFill>
-          <a:blip xmlns:r="http://schemas.openxmlformats.org/officeDocument/2006/relationships" xmlns:a="http://schemas.openxmlformats.org/drawingml/2006/main" r:embed="Rd476eb6739064867"/>
-          <a:stretch xmlns:a="http://schemas.openxmlformats.org/drawingml/2006/main"/>
-        </p:blipFill>
-        <p:spPr>
-          <a:xfrm xmlns:a="http://schemas.openxmlformats.org/drawingml/2006/main">
-            <a:off x="4095750" y="4468762"/>
-            <a:ext cx="323850" cy="320777"/>
-          </a:xfrm>
-          <a:prstGeom xmlns:a="http://schemas.openxmlformats.org/drawingml/2006/main" prst="rect">
-            <a:avLst/>
-          </a:prstGeom>
-        </p:spPr>
-      </p:pic>
-      <p:sp>
-        <p:nvSpPr>
-          <p:cNvPr id="33" name="">
-            <a:extLst xmlns:a="http://schemas.openxmlformats.org/drawingml/2006/main">
-              <a:ext uri="{FF2B5EF4-FFF2-40B4-BE49-F238E27FC236}">
-                <a16:creationId xmlns:a16="http://schemas.microsoft.com/office/drawing/2014/main" id="{52F0255B-B129-44FD-A4B5-29CC0AF34FB3}"/>
+      <p:sp>
+        <p:nvSpPr>
+          <p:cNvPr id="49" name="">
+            <a:extLst xmlns:a="http://schemas.openxmlformats.org/drawingml/2006/main">
+              <a:ext uri="{FF2B5EF4-FFF2-40B4-BE49-F238E27FC236}">
+                <a16:creationId xmlns:a16="http://schemas.microsoft.com/office/drawing/2014/main" id="{CF320538-8E66-4F8E-99D1-0055A8C481F9}"/>
               </a:ext>
             </a:extLst>
           </p:cNvPr>
@@ -4785,10 +4355,10 @@
       </p:sp>
       <p:sp>
         <p:nvSpPr>
-          <p:cNvPr id="34" name="">
-            <a:extLst xmlns:a="http://schemas.openxmlformats.org/drawingml/2006/main">
-              <a:ext uri="{FF2B5EF4-FFF2-40B4-BE49-F238E27FC236}">
-                <a16:creationId xmlns:a16="http://schemas.microsoft.com/office/drawing/2014/main" id="{E49E91A2-AC64-48D8-8647-133F919898E5}"/>
+          <p:cNvPr id="50" name="">
+            <a:extLst xmlns:a="http://schemas.openxmlformats.org/drawingml/2006/main">
+              <a:ext uri="{FF2B5EF4-FFF2-40B4-BE49-F238E27FC236}">
+                <a16:creationId xmlns:a16="http://schemas.microsoft.com/office/drawing/2014/main" id="{B5E11D51-C814-4388-8AE9-48DE3265B94D}"/>
               </a:ext>
             </a:extLst>
           </p:cNvPr>
@@ -4816,7 +4386,6 @@
           <a:lstStyle xmlns:a="http://schemas.openxmlformats.org/drawingml/2006/main"/>
           <a:p xmlns:a="http://schemas.openxmlformats.org/drawingml/2006/main">
             <a:pPr>
-              <a:buNone/>
               <a:defRPr sz="1650" b="1">
                 <a:solidFill>
                   <a:srgbClr val="111827"/>
@@ -4842,10 +4411,10 @@
       </p:sp>
       <p:sp>
         <p:nvSpPr>
-          <p:cNvPr id="35" name="">
-            <a:extLst xmlns:a="http://schemas.openxmlformats.org/drawingml/2006/main">
-              <a:ext uri="{FF2B5EF4-FFF2-40B4-BE49-F238E27FC236}">
-                <a16:creationId xmlns:a16="http://schemas.microsoft.com/office/drawing/2014/main" id="{7AB60FF9-91AE-485C-BED8-F13D79FC29E9}"/>
+          <p:cNvPr id="51" name="">
+            <a:extLst xmlns:a="http://schemas.openxmlformats.org/drawingml/2006/main">
+              <a:ext uri="{FF2B5EF4-FFF2-40B4-BE49-F238E27FC236}">
+                <a16:creationId xmlns:a16="http://schemas.microsoft.com/office/drawing/2014/main" id="{378C9982-41BF-42BA-8901-8DD0D7AA15AF}"/>
               </a:ext>
             </a:extLst>
           </p:cNvPr>
@@ -4873,7 +4442,6 @@
           <a:lstStyle xmlns:a="http://schemas.openxmlformats.org/drawingml/2006/main"/>
           <a:p xmlns:a="http://schemas.openxmlformats.org/drawingml/2006/main">
             <a:pPr>
-              <a:buNone/>
               <a:defRPr sz="1350" b="0">
                 <a:solidFill>
                   <a:srgbClr val="344054"/>
@@ -4897,7 +4465,6 @@
           </a:p>
           <a:p xmlns:a="http://schemas.openxmlformats.org/drawingml/2006/main">
             <a:pPr>
-              <a:buNone/>
               <a:defRPr sz="1350" b="0">
                 <a:solidFill>
                   <a:srgbClr val="344054"/>
@@ -4921,6 +4488,94 @@
           </a:p>
         </p:txBody>
       </p:sp>
+      <p:pic>
+        <p:nvPicPr>
+          <p:cNvPr id="80" name=""/>
+          <p:cNvPicPr>
+            <a:picLocks xmlns:a="http://schemas.openxmlformats.org/drawingml/2006/main" noChangeAspect="1"/>
+          </p:cNvPicPr>
+          <p:nvPr/>
+        </p:nvPicPr>
+        <p:blipFill>
+          <a:blip xmlns:r="http://schemas.openxmlformats.org/officeDocument/2006/relationships" xmlns:a="http://schemas.openxmlformats.org/drawingml/2006/main" r:embed="R301d1e64a9fb410b"/>
+          <a:stretch xmlns:a="http://schemas.openxmlformats.org/drawingml/2006/main"/>
+        </p:blipFill>
+        <p:spPr>
+          <a:xfrm xmlns:a="http://schemas.openxmlformats.org/drawingml/2006/main">
+            <a:off x="4305300" y="1495425"/>
+            <a:ext cx="476250" cy="476250"/>
+          </a:xfrm>
+          <a:prstGeom xmlns:a="http://schemas.openxmlformats.org/drawingml/2006/main" prst="rect">
+            <a:avLst/>
+          </a:prstGeom>
+        </p:spPr>
+      </p:pic>
+      <p:pic>
+        <p:nvPicPr>
+          <p:cNvPr id="81" name=""/>
+          <p:cNvPicPr>
+            <a:picLocks xmlns:a="http://schemas.openxmlformats.org/drawingml/2006/main" noChangeAspect="1"/>
+          </p:cNvPicPr>
+          <p:nvPr/>
+        </p:nvPicPr>
+        <p:blipFill>
+          <a:blip xmlns:r="http://schemas.openxmlformats.org/officeDocument/2006/relationships" xmlns:a="http://schemas.openxmlformats.org/drawingml/2006/main" r:embed="R83eed30112ce4ca3"/>
+          <a:stretch xmlns:a="http://schemas.openxmlformats.org/drawingml/2006/main"/>
+        </p:blipFill>
+        <p:spPr>
+          <a:xfrm xmlns:a="http://schemas.openxmlformats.org/drawingml/2006/main">
+            <a:off x="4038600" y="2576647"/>
+            <a:ext cx="1104900" cy="199756"/>
+          </a:xfrm>
+          <a:prstGeom xmlns:a="http://schemas.openxmlformats.org/drawingml/2006/main" prst="rect">
+            <a:avLst/>
+          </a:prstGeom>
+        </p:spPr>
+      </p:pic>
+      <p:pic>
+        <p:nvPicPr>
+          <p:cNvPr id="82" name=""/>
+          <p:cNvPicPr>
+            <a:picLocks xmlns:a="http://schemas.openxmlformats.org/drawingml/2006/main" noChangeAspect="1"/>
+          </p:cNvPicPr>
+          <p:nvPr/>
+        </p:nvPicPr>
+        <p:blipFill>
+          <a:blip xmlns:r="http://schemas.openxmlformats.org/officeDocument/2006/relationships" xmlns:a="http://schemas.openxmlformats.org/drawingml/2006/main" r:embed="Reed608e3120e4a62"/>
+          <a:stretch xmlns:a="http://schemas.openxmlformats.org/drawingml/2006/main"/>
+        </p:blipFill>
+        <p:spPr>
+          <a:xfrm xmlns:a="http://schemas.openxmlformats.org/drawingml/2006/main">
+            <a:off x="4038600" y="3548197"/>
+            <a:ext cx="1104900" cy="199756"/>
+          </a:xfrm>
+          <a:prstGeom xmlns:a="http://schemas.openxmlformats.org/drawingml/2006/main" prst="rect">
+            <a:avLst/>
+          </a:prstGeom>
+        </p:spPr>
+      </p:pic>
+      <p:pic>
+        <p:nvPicPr>
+          <p:cNvPr id="83" name=""/>
+          <p:cNvPicPr>
+            <a:picLocks xmlns:a="http://schemas.openxmlformats.org/drawingml/2006/main" noChangeAspect="1"/>
+          </p:cNvPicPr>
+          <p:nvPr/>
+        </p:nvPicPr>
+        <p:blipFill>
+          <a:blip xmlns:r="http://schemas.openxmlformats.org/officeDocument/2006/relationships" xmlns:a="http://schemas.openxmlformats.org/drawingml/2006/main" r:embed="Rd80ee0fd27e54093"/>
+          <a:stretch xmlns:a="http://schemas.openxmlformats.org/drawingml/2006/main"/>
+        </p:blipFill>
+        <p:spPr>
+          <a:xfrm xmlns:a="http://schemas.openxmlformats.org/drawingml/2006/main">
+            <a:off x="4095750" y="4468762"/>
+            <a:ext cx="323850" cy="320777"/>
+          </a:xfrm>
+          <a:prstGeom xmlns:a="http://schemas.openxmlformats.org/drawingml/2006/main" prst="rect">
+            <a:avLst/>
+          </a:prstGeom>
+        </p:spPr>
+      </p:pic>
     </p:spTree>
     <p:extLst>
       <p:ext uri="{BB962C8B-B14F-4D97-AF65-F5344CB8AC3E}">

</xml_diff>

<commit_message>
Merge optimized Qwen deck sections
</commit_message>
<xml_diff>
--- a/output/sections/01-个人介绍.pptx
+++ b/output/sections/01-个人介绍.pptx
@@ -2,15 +2,15 @@
 <file path=ppt/presentation.xml><?xml version="1.0" encoding="utf-8"?>
 <p:presentation xmlns:p="http://schemas.openxmlformats.org/presentationml/2006/main">
   <p:sldMasterIdLst>
-    <p:sldMasterId xmlns:r="http://schemas.openxmlformats.org/officeDocument/2006/relationships" id="2147483648" r:id="Rac63a41583434f7f"/>
+    <p:sldMasterId xmlns:r="http://schemas.openxmlformats.org/officeDocument/2006/relationships" id="2147483648" r:id="Rdd20926b4aa9484f"/>
   </p:sldMasterIdLst>
   <p:notesMasterIdLst>
-    <p:notesMasterId xmlns:r="http://schemas.openxmlformats.org/officeDocument/2006/relationships" r:id="R6c27b066d24e493f"/>
+    <p:notesMasterId xmlns:r="http://schemas.openxmlformats.org/officeDocument/2006/relationships" r:id="R1596497c5b324018"/>
   </p:notesMasterIdLst>
   <p:sldIdLst>
-    <p:sldId xmlns:r="http://schemas.openxmlformats.org/officeDocument/2006/relationships" id="256" r:id="R5d7a27396eac4eb9"/>
-    <p:sldId xmlns:r="http://schemas.openxmlformats.org/officeDocument/2006/relationships" id="257" r:id="Ra16fdf63153c4462"/>
-    <p:sldId xmlns:r="http://schemas.openxmlformats.org/officeDocument/2006/relationships" id="258" r:id="R00ee5e4ca76f4c6c"/>
+    <p:sldId xmlns:r="http://schemas.openxmlformats.org/officeDocument/2006/relationships" id="256" r:id="Rd2158651175f4b52"/>
+    <p:sldId xmlns:r="http://schemas.openxmlformats.org/officeDocument/2006/relationships" id="257" r:id="Rea2cd94c2f224b12"/>
+    <p:sldId xmlns:r="http://schemas.openxmlformats.org/officeDocument/2006/relationships" id="258" r:id="R63f08a565b364f0e"/>
   </p:sldIdLst>
   <p:sldSz cx="12192000" cy="6858000"/>
   <p:notesSz cx="6858000" cy="9144000"/>
@@ -735,7 +735,7 @@
   </p:cSld>
   <p:clrMap bg1="lt1" tx1="dk1" bg2="lt2" tx2="dk2" accent1="accent1" accent2="accent2" accent3="accent3" accent4="accent4" accent5="accent5" accent6="accent6" hlink="hlink" folHlink="folHlink"/>
   <p:sldLayoutIdLst>
-    <p:sldLayoutId xmlns:r="http://schemas.openxmlformats.org/officeDocument/2006/relationships" id="2147483649" r:id="R8aa8567c5a334bc3"/>
+    <p:sldLayoutId xmlns:r="http://schemas.openxmlformats.org/officeDocument/2006/relationships" id="2147483649" r:id="Ra74e77b5766b4738"/>
   </p:sldLayoutIdLst>
   <p:txStyles>
     <p:titleStyle>
@@ -1383,7 +1383,7 @@
           <p:nvPr/>
         </p:nvPicPr>
         <p:blipFill>
-          <a:blip xmlns:r="http://schemas.openxmlformats.org/officeDocument/2006/relationships" xmlns:a="http://schemas.openxmlformats.org/drawingml/2006/main" r:embed="R659efcf6b3d24f18"/>
+          <a:blip xmlns:r="http://schemas.openxmlformats.org/officeDocument/2006/relationships" xmlns:a="http://schemas.openxmlformats.org/drawingml/2006/main" r:embed="R19f24c5f3df84908"/>
           <a:stretch xmlns:a="http://schemas.openxmlformats.org/drawingml/2006/main"/>
         </p:blipFill>
         <p:spPr>
@@ -1857,14 +1857,14 @@
       </p:grpSpPr>
       <p:pic>
         <p:nvPicPr>
-          <p:cNvPr id="32" name=""/>
+          <p:cNvPr id="52" name=""/>
           <p:cNvPicPr>
             <a:picLocks xmlns:a="http://schemas.openxmlformats.org/drawingml/2006/main" noChangeAspect="1"/>
           </p:cNvPicPr>
           <p:nvPr/>
         </p:nvPicPr>
         <p:blipFill>
-          <a:blip xmlns:r="http://schemas.openxmlformats.org/officeDocument/2006/relationships" xmlns:a="http://schemas.openxmlformats.org/drawingml/2006/main" r:embed="R071f08c7ea084036"/>
+          <a:blip xmlns:r="http://schemas.openxmlformats.org/officeDocument/2006/relationships" xmlns:a="http://schemas.openxmlformats.org/drawingml/2006/main" r:embed="Re69a02ad35a14b8e"/>
           <a:stretch xmlns:a="http://schemas.openxmlformats.org/drawingml/2006/main"/>
         </p:blipFill>
         <p:spPr>
@@ -2081,22 +2081,22 @@
       </p:sp>
       <p:sp>
         <p:nvSpPr>
-          <p:cNvPr id="6" name="">
-            <a:extLst xmlns:a="http://schemas.openxmlformats.org/drawingml/2006/main">
-              <a:ext uri="{FF2B5EF4-FFF2-40B4-BE49-F238E27FC236}">
-                <a16:creationId xmlns:a16="http://schemas.microsoft.com/office/drawing/2014/main" id="{E03B9B6F-569E-41AC-AD98-D5B5F34960FF}"/>
-              </a:ext>
-            </a:extLst>
-          </p:cNvPr>
-          <p:cNvSpPr>
-            <a:spLocks xmlns:a="http://schemas.openxmlformats.org/drawingml/2006/main" noGrp="1"/>
-          </p:cNvSpPr>
-          <p:nvPr/>
-        </p:nvSpPr>
-        <p:spPr>
-          <a:xfrm xmlns:a="http://schemas.openxmlformats.org/drawingml/2006/main">
-            <a:off x="3676650" y="1609725"/>
-            <a:ext cx="5219700" cy="476250"/>
+          <p:cNvPr id="32" name="">
+            <a:extLst xmlns:a="http://schemas.openxmlformats.org/drawingml/2006/main">
+              <a:ext uri="{FF2B5EF4-FFF2-40B4-BE49-F238E27FC236}">
+                <a16:creationId xmlns:a16="http://schemas.microsoft.com/office/drawing/2014/main" id="{4BA3AF9A-1137-40C6-A371-240FAEF70D91}"/>
+              </a:ext>
+            </a:extLst>
+          </p:cNvPr>
+          <p:cNvSpPr>
+            <a:spLocks xmlns:a="http://schemas.openxmlformats.org/drawingml/2006/main" noGrp="1"/>
+          </p:cNvSpPr>
+          <p:nvPr/>
+        </p:nvSpPr>
+        <p:spPr>
+          <a:xfrm xmlns:a="http://schemas.openxmlformats.org/drawingml/2006/main">
+            <a:off x="3629025" y="1609725"/>
+            <a:ext cx="5581650" cy="476250"/>
           </a:xfrm>
           <a:prstGeom xmlns:a="http://schemas.openxmlformats.org/drawingml/2006/main" prst="rect">
             <a:avLst/>
@@ -2112,21 +2112,21 @@
       </p:sp>
       <p:sp>
         <p:nvSpPr>
-          <p:cNvPr id="7" name="">
-            <a:extLst xmlns:a="http://schemas.openxmlformats.org/drawingml/2006/main">
-              <a:ext uri="{FF2B5EF4-FFF2-40B4-BE49-F238E27FC236}">
-                <a16:creationId xmlns:a16="http://schemas.microsoft.com/office/drawing/2014/main" id="{6F4BC510-4065-46A4-ADEE-784951B52242}"/>
-              </a:ext>
-            </a:extLst>
-          </p:cNvPr>
-          <p:cNvSpPr>
-            <a:spLocks xmlns:a="http://schemas.openxmlformats.org/drawingml/2006/main" noGrp="1"/>
-          </p:cNvSpPr>
-          <p:nvPr/>
-        </p:nvSpPr>
-        <p:spPr>
-          <a:xfrm xmlns:a="http://schemas.openxmlformats.org/drawingml/2006/main">
-            <a:off x="3333750" y="1524000"/>
+          <p:cNvPr id="33" name="">
+            <a:extLst xmlns:a="http://schemas.openxmlformats.org/drawingml/2006/main">
+              <a:ext uri="{FF2B5EF4-FFF2-40B4-BE49-F238E27FC236}">
+                <a16:creationId xmlns:a16="http://schemas.microsoft.com/office/drawing/2014/main" id="{4E287C9C-DF45-4534-9220-75113A82B5E0}"/>
+              </a:ext>
+            </a:extLst>
+          </p:cNvPr>
+          <p:cNvSpPr>
+            <a:spLocks xmlns:a="http://schemas.openxmlformats.org/drawingml/2006/main" noGrp="1"/>
+          </p:cNvSpPr>
+          <p:nvPr/>
+        </p:nvSpPr>
+        <p:spPr>
+          <a:xfrm xmlns:a="http://schemas.openxmlformats.org/drawingml/2006/main">
+            <a:off x="2981325" y="1524000"/>
             <a:ext cx="647700" cy="647700"/>
           </a:xfrm>
           <a:prstGeom xmlns:a="http://schemas.openxmlformats.org/drawingml/2006/main" prst="ellipse">
@@ -2142,30 +2142,24 @@
             <a:prstDash val="solid"/>
           </a:ln>
         </p:spPr>
-        <p:style>
-          <a:lnRef xmlns:a="http://schemas.openxmlformats.org/drawingml/2006/main" idx="0"/>
-          <a:fillRef xmlns:a="http://schemas.openxmlformats.org/drawingml/2006/main" idx="0"/>
-          <a:effectRef xmlns:a="http://schemas.openxmlformats.org/drawingml/2006/main" idx="4"/>
-          <a:fontRef xmlns:a="http://schemas.openxmlformats.org/drawingml/2006/main" idx="major"/>
-        </p:style>
-      </p:sp>
-      <p:sp>
-        <p:nvSpPr>
-          <p:cNvPr id="8" name="">
-            <a:extLst xmlns:a="http://schemas.openxmlformats.org/drawingml/2006/main">
-              <a:ext uri="{FF2B5EF4-FFF2-40B4-BE49-F238E27FC236}">
-                <a16:creationId xmlns:a16="http://schemas.microsoft.com/office/drawing/2014/main" id="{A0EA7D1B-0BE4-425A-AA74-51892841F736}"/>
-              </a:ext>
-            </a:extLst>
-          </p:cNvPr>
-          <p:cNvSpPr>
-            <a:spLocks xmlns:a="http://schemas.openxmlformats.org/drawingml/2006/main" noGrp="1"/>
-          </p:cNvSpPr>
-          <p:nvPr/>
-        </p:nvSpPr>
-        <p:spPr>
-          <a:xfrm xmlns:a="http://schemas.openxmlformats.org/drawingml/2006/main">
-            <a:off x="3333750" y="1647825"/>
+      </p:sp>
+      <p:sp>
+        <p:nvSpPr>
+          <p:cNvPr id="34" name="">
+            <a:extLst xmlns:a="http://schemas.openxmlformats.org/drawingml/2006/main">
+              <a:ext uri="{FF2B5EF4-FFF2-40B4-BE49-F238E27FC236}">
+                <a16:creationId xmlns:a16="http://schemas.microsoft.com/office/drawing/2014/main" id="{6BE88EFF-7A66-4924-A406-FA7CCCE097B4}"/>
+              </a:ext>
+            </a:extLst>
+          </p:cNvPr>
+          <p:cNvSpPr>
+            <a:spLocks xmlns:a="http://schemas.openxmlformats.org/drawingml/2006/main" noGrp="1"/>
+          </p:cNvSpPr>
+          <p:nvPr/>
+        </p:nvSpPr>
+        <p:spPr>
+          <a:xfrm xmlns:a="http://schemas.openxmlformats.org/drawingml/2006/main">
+            <a:off x="2981325" y="1647825"/>
             <a:ext cx="647700" cy="342900"/>
           </a:xfrm>
           <a:prstGeom xmlns:a="http://schemas.openxmlformats.org/drawingml/2006/main" prst="rect">
@@ -2182,8 +2176,7 @@
           <a:lstStyle xmlns:a="http://schemas.openxmlformats.org/drawingml/2006/main"/>
           <a:p xmlns:a="http://schemas.openxmlformats.org/drawingml/2006/main">
             <a:pPr algn="ctr">
-              <a:buNone/>
-              <a:defRPr sz="2325" b="1">
+              <a:defRPr sz="2250" b="1">
                 <a:solidFill>
                   <a:srgbClr val="635BFF"/>
                 </a:solidFill>
@@ -2193,7 +2186,7 @@
               </a:defRPr>
             </a:pPr>
             <a:r>
-              <a:rPr sz="2325" b="1">
+              <a:rPr sz="2250" b="1">
                 <a:solidFill>
                   <a:srgbClr val="635BFF"/>
                 </a:solidFill>
@@ -2208,22 +2201,22 @@
       </p:sp>
       <p:sp>
         <p:nvSpPr>
-          <p:cNvPr id="9" name="">
-            <a:extLst xmlns:a="http://schemas.openxmlformats.org/drawingml/2006/main">
-              <a:ext uri="{FF2B5EF4-FFF2-40B4-BE49-F238E27FC236}">
-                <a16:creationId xmlns:a16="http://schemas.microsoft.com/office/drawing/2014/main" id="{4940B41A-270E-4C24-90B6-1D3F4CB55BBB}"/>
-              </a:ext>
-            </a:extLst>
-          </p:cNvPr>
-          <p:cNvSpPr>
-            <a:spLocks xmlns:a="http://schemas.openxmlformats.org/drawingml/2006/main" noGrp="1"/>
-          </p:cNvSpPr>
-          <p:nvPr/>
-        </p:nvSpPr>
-        <p:spPr>
-          <a:xfrm xmlns:a="http://schemas.openxmlformats.org/drawingml/2006/main">
-            <a:off x="4133850" y="1724025"/>
-            <a:ext cx="4286250" cy="228600"/>
+          <p:cNvPr id="35" name="">
+            <a:extLst xmlns:a="http://schemas.openxmlformats.org/drawingml/2006/main">
+              <a:ext uri="{FF2B5EF4-FFF2-40B4-BE49-F238E27FC236}">
+                <a16:creationId xmlns:a16="http://schemas.microsoft.com/office/drawing/2014/main" id="{B40601E8-0C4D-4ACA-A449-565DD2C8BACB}"/>
+              </a:ext>
+            </a:extLst>
+          </p:cNvPr>
+          <p:cNvSpPr>
+            <a:spLocks xmlns:a="http://schemas.openxmlformats.org/drawingml/2006/main" noGrp="1"/>
+          </p:cNvSpPr>
+          <p:nvPr/>
+        </p:nvSpPr>
+        <p:spPr>
+          <a:xfrm xmlns:a="http://schemas.openxmlformats.org/drawingml/2006/main">
+            <a:off x="3629025" y="1714500"/>
+            <a:ext cx="5581650" cy="266700"/>
           </a:xfrm>
           <a:prstGeom xmlns:a="http://schemas.openxmlformats.org/drawingml/2006/main" prst="rect">
             <a:avLst/>
@@ -2239,8 +2232,7 @@
           <a:lstStyle xmlns:a="http://schemas.openxmlformats.org/drawingml/2006/main"/>
           <a:p xmlns:a="http://schemas.openxmlformats.org/drawingml/2006/main">
             <a:pPr algn="ctr">
-              <a:buNone/>
-              <a:defRPr sz="1725" b="1">
+              <a:defRPr sz="1950" b="1">
                 <a:solidFill>
                   <a:srgbClr val="FFFFFF"/>
                 </a:solidFill>
@@ -2250,7 +2242,7 @@
               </a:defRPr>
             </a:pPr>
             <a:r>
-              <a:rPr sz="1725" b="1">
+              <a:rPr sz="1950" b="1">
                 <a:solidFill>
                   <a:srgbClr val="FFFFFF"/>
                 </a:solidFill>
@@ -2265,79 +2257,22 @@
       </p:sp>
       <p:sp>
         <p:nvSpPr>
-          <p:cNvPr id="10" name="">
-            <a:extLst xmlns:a="http://schemas.openxmlformats.org/drawingml/2006/main">
-              <a:ext uri="{FF2B5EF4-FFF2-40B4-BE49-F238E27FC236}">
-                <a16:creationId xmlns:a16="http://schemas.microsoft.com/office/drawing/2014/main" id="{ED43C268-A0C4-4F7E-969C-F1DC9C0FF6ED}"/>
-              </a:ext>
-            </a:extLst>
-          </p:cNvPr>
-          <p:cNvSpPr>
-            <a:spLocks xmlns:a="http://schemas.openxmlformats.org/drawingml/2006/main" noGrp="1"/>
-          </p:cNvSpPr>
-          <p:nvPr/>
-        </p:nvSpPr>
-        <p:spPr>
-          <a:xfrm xmlns:a="http://schemas.openxmlformats.org/drawingml/2006/main">
-            <a:off x="9086850" y="1743075"/>
-            <a:ext cx="2381250" cy="190500"/>
-          </a:xfrm>
-          <a:prstGeom xmlns:a="http://schemas.openxmlformats.org/drawingml/2006/main" prst="rect">
-            <a:avLst/>
-          </a:prstGeom>
-          <a:noFill xmlns:a="http://schemas.openxmlformats.org/drawingml/2006/main"/>
-          <a:ln xmlns:a="http://schemas.openxmlformats.org/drawingml/2006/main" w="0">
-            <a:noFill/>
-            <a:prstDash val="solid"/>
-          </a:ln>
-        </p:spPr>
-        <p:txBody>
-          <a:bodyPr xmlns:a="http://schemas.openxmlformats.org/drawingml/2006/main" wrap="square" lIns="0" tIns="0" rIns="0" bIns="0"/>
-          <a:lstStyle xmlns:a="http://schemas.openxmlformats.org/drawingml/2006/main"/>
-          <a:p xmlns:a="http://schemas.openxmlformats.org/drawingml/2006/main">
-            <a:pPr>
-              <a:buNone/>
-              <a:defRPr sz="900" b="0">
-                <a:solidFill>
-                  <a:srgbClr val="667085"/>
-                </a:solidFill>
-                <a:latin typeface="PingFang SC"/>
-                <a:ea typeface="PingFang SC"/>
-                <a:cs typeface="PingFang SC"/>
-              </a:defRPr>
-            </a:pPr>
-            <a:r>
-              <a:rPr sz="900" b="0">
-                <a:solidFill>
-                  <a:srgbClr val="667085"/>
-                </a:solidFill>
-                <a:latin typeface="PingFang SC"/>
-                <a:ea typeface="PingFang SC"/>
-                <a:cs typeface="PingFang SC"/>
-              </a:rPr>
-              <a:t>试用期主线与能力背景</a:t>
-            </a:r>
-          </a:p>
-        </p:txBody>
-      </p:sp>
-      <p:sp>
-        <p:nvSpPr>
-          <p:cNvPr id="11" name="">
-            <a:extLst xmlns:a="http://schemas.openxmlformats.org/drawingml/2006/main">
-              <a:ext uri="{FF2B5EF4-FFF2-40B4-BE49-F238E27FC236}">
-                <a16:creationId xmlns:a16="http://schemas.microsoft.com/office/drawing/2014/main" id="{C8CC3882-708F-4FB1-89E4-378C3B327ABA}"/>
-              </a:ext>
-            </a:extLst>
-          </p:cNvPr>
-          <p:cNvSpPr>
-            <a:spLocks xmlns:a="http://schemas.openxmlformats.org/drawingml/2006/main" noGrp="1"/>
-          </p:cNvSpPr>
-          <p:nvPr/>
-        </p:nvSpPr>
-        <p:spPr>
-          <a:xfrm xmlns:a="http://schemas.openxmlformats.org/drawingml/2006/main">
-            <a:off x="3676650" y="2447925"/>
-            <a:ext cx="5219700" cy="476250"/>
+          <p:cNvPr id="36" name="">
+            <a:extLst xmlns:a="http://schemas.openxmlformats.org/drawingml/2006/main">
+              <a:ext uri="{FF2B5EF4-FFF2-40B4-BE49-F238E27FC236}">
+                <a16:creationId xmlns:a16="http://schemas.microsoft.com/office/drawing/2014/main" id="{F6B30F4E-4437-4EB1-800E-EB4A94399E30}"/>
+              </a:ext>
+            </a:extLst>
+          </p:cNvPr>
+          <p:cNvSpPr>
+            <a:spLocks xmlns:a="http://schemas.openxmlformats.org/drawingml/2006/main" noGrp="1"/>
+          </p:cNvSpPr>
+          <p:nvPr/>
+        </p:nvSpPr>
+        <p:spPr>
+          <a:xfrm xmlns:a="http://schemas.openxmlformats.org/drawingml/2006/main">
+            <a:off x="3629025" y="2447925"/>
+            <a:ext cx="5581650" cy="476250"/>
           </a:xfrm>
           <a:prstGeom xmlns:a="http://schemas.openxmlformats.org/drawingml/2006/main" prst="rect">
             <a:avLst/>
@@ -2353,21 +2288,21 @@
       </p:sp>
       <p:sp>
         <p:nvSpPr>
-          <p:cNvPr id="12" name="">
-            <a:extLst xmlns:a="http://schemas.openxmlformats.org/drawingml/2006/main">
-              <a:ext uri="{FF2B5EF4-FFF2-40B4-BE49-F238E27FC236}">
-                <a16:creationId xmlns:a16="http://schemas.microsoft.com/office/drawing/2014/main" id="{684C4509-F68B-4E35-9158-D483EBA31FE4}"/>
-              </a:ext>
-            </a:extLst>
-          </p:cNvPr>
-          <p:cNvSpPr>
-            <a:spLocks xmlns:a="http://schemas.openxmlformats.org/drawingml/2006/main" noGrp="1"/>
-          </p:cNvSpPr>
-          <p:nvPr/>
-        </p:nvSpPr>
-        <p:spPr>
-          <a:xfrm xmlns:a="http://schemas.openxmlformats.org/drawingml/2006/main">
-            <a:off x="3333750" y="2362200"/>
+          <p:cNvPr id="37" name="">
+            <a:extLst xmlns:a="http://schemas.openxmlformats.org/drawingml/2006/main">
+              <a:ext uri="{FF2B5EF4-FFF2-40B4-BE49-F238E27FC236}">
+                <a16:creationId xmlns:a16="http://schemas.microsoft.com/office/drawing/2014/main" id="{494AC598-E2F8-4953-AFA1-F4C5E31B8087}"/>
+              </a:ext>
+            </a:extLst>
+          </p:cNvPr>
+          <p:cNvSpPr>
+            <a:spLocks xmlns:a="http://schemas.openxmlformats.org/drawingml/2006/main" noGrp="1"/>
+          </p:cNvSpPr>
+          <p:nvPr/>
+        </p:nvSpPr>
+        <p:spPr>
+          <a:xfrm xmlns:a="http://schemas.openxmlformats.org/drawingml/2006/main">
+            <a:off x="2981325" y="2362200"/>
             <a:ext cx="647700" cy="647700"/>
           </a:xfrm>
           <a:prstGeom xmlns:a="http://schemas.openxmlformats.org/drawingml/2006/main" prst="ellipse">
@@ -2383,30 +2318,24 @@
             <a:prstDash val="solid"/>
           </a:ln>
         </p:spPr>
-        <p:style>
-          <a:lnRef xmlns:a="http://schemas.openxmlformats.org/drawingml/2006/main" idx="0"/>
-          <a:fillRef xmlns:a="http://schemas.openxmlformats.org/drawingml/2006/main" idx="0"/>
-          <a:effectRef xmlns:a="http://schemas.openxmlformats.org/drawingml/2006/main" idx="4"/>
-          <a:fontRef xmlns:a="http://schemas.openxmlformats.org/drawingml/2006/main" idx="major"/>
-        </p:style>
-      </p:sp>
-      <p:sp>
-        <p:nvSpPr>
-          <p:cNvPr id="13" name="">
-            <a:extLst xmlns:a="http://schemas.openxmlformats.org/drawingml/2006/main">
-              <a:ext uri="{FF2B5EF4-FFF2-40B4-BE49-F238E27FC236}">
-                <a16:creationId xmlns:a16="http://schemas.microsoft.com/office/drawing/2014/main" id="{8D08B177-FB1E-42CC-A5D5-C7078376019E}"/>
-              </a:ext>
-            </a:extLst>
-          </p:cNvPr>
-          <p:cNvSpPr>
-            <a:spLocks xmlns:a="http://schemas.openxmlformats.org/drawingml/2006/main" noGrp="1"/>
-          </p:cNvSpPr>
-          <p:nvPr/>
-        </p:nvSpPr>
-        <p:spPr>
-          <a:xfrm xmlns:a="http://schemas.openxmlformats.org/drawingml/2006/main">
-            <a:off x="3333750" y="2486025"/>
+      </p:sp>
+      <p:sp>
+        <p:nvSpPr>
+          <p:cNvPr id="38" name="">
+            <a:extLst xmlns:a="http://schemas.openxmlformats.org/drawingml/2006/main">
+              <a:ext uri="{FF2B5EF4-FFF2-40B4-BE49-F238E27FC236}">
+                <a16:creationId xmlns:a16="http://schemas.microsoft.com/office/drawing/2014/main" id="{52D9C66D-559A-4730-8C32-7E6E6FF807A9}"/>
+              </a:ext>
+            </a:extLst>
+          </p:cNvPr>
+          <p:cNvSpPr>
+            <a:spLocks xmlns:a="http://schemas.openxmlformats.org/drawingml/2006/main" noGrp="1"/>
+          </p:cNvSpPr>
+          <p:nvPr/>
+        </p:nvSpPr>
+        <p:spPr>
+          <a:xfrm xmlns:a="http://schemas.openxmlformats.org/drawingml/2006/main">
+            <a:off x="2981325" y="2486025"/>
             <a:ext cx="647700" cy="342900"/>
           </a:xfrm>
           <a:prstGeom xmlns:a="http://schemas.openxmlformats.org/drawingml/2006/main" prst="rect">
@@ -2423,8 +2352,7 @@
           <a:lstStyle xmlns:a="http://schemas.openxmlformats.org/drawingml/2006/main"/>
           <a:p xmlns:a="http://schemas.openxmlformats.org/drawingml/2006/main">
             <a:pPr algn="ctr">
-              <a:buNone/>
-              <a:defRPr sz="2325" b="1">
+              <a:defRPr sz="2250" b="1">
                 <a:solidFill>
                   <a:srgbClr val="635BFF"/>
                 </a:solidFill>
@@ -2434,7 +2362,7 @@
               </a:defRPr>
             </a:pPr>
             <a:r>
-              <a:rPr sz="2325" b="1">
+              <a:rPr sz="2250" b="1">
                 <a:solidFill>
                   <a:srgbClr val="635BFF"/>
                 </a:solidFill>
@@ -2449,22 +2377,22 @@
       </p:sp>
       <p:sp>
         <p:nvSpPr>
-          <p:cNvPr id="14" name="">
-            <a:extLst xmlns:a="http://schemas.openxmlformats.org/drawingml/2006/main">
-              <a:ext uri="{FF2B5EF4-FFF2-40B4-BE49-F238E27FC236}">
-                <a16:creationId xmlns:a16="http://schemas.microsoft.com/office/drawing/2014/main" id="{13E173BE-8492-4E9A-8192-860354A8D8CA}"/>
-              </a:ext>
-            </a:extLst>
-          </p:cNvPr>
-          <p:cNvSpPr>
-            <a:spLocks xmlns:a="http://schemas.openxmlformats.org/drawingml/2006/main" noGrp="1"/>
-          </p:cNvSpPr>
-          <p:nvPr/>
-        </p:nvSpPr>
-        <p:spPr>
-          <a:xfrm xmlns:a="http://schemas.openxmlformats.org/drawingml/2006/main">
-            <a:off x="4133850" y="2562225"/>
-            <a:ext cx="4286250" cy="228600"/>
+          <p:cNvPr id="39" name="">
+            <a:extLst xmlns:a="http://schemas.openxmlformats.org/drawingml/2006/main">
+              <a:ext uri="{FF2B5EF4-FFF2-40B4-BE49-F238E27FC236}">
+                <a16:creationId xmlns:a16="http://schemas.microsoft.com/office/drawing/2014/main" id="{4AE3B666-C87E-45F8-995B-519D983B55D1}"/>
+              </a:ext>
+            </a:extLst>
+          </p:cNvPr>
+          <p:cNvSpPr>
+            <a:spLocks xmlns:a="http://schemas.openxmlformats.org/drawingml/2006/main" noGrp="1"/>
+          </p:cNvSpPr>
+          <p:nvPr/>
+        </p:nvSpPr>
+        <p:spPr>
+          <a:xfrm xmlns:a="http://schemas.openxmlformats.org/drawingml/2006/main">
+            <a:off x="3629025" y="2552700"/>
+            <a:ext cx="5581650" cy="266700"/>
           </a:xfrm>
           <a:prstGeom xmlns:a="http://schemas.openxmlformats.org/drawingml/2006/main" prst="rect">
             <a:avLst/>
@@ -2480,8 +2408,7 @@
           <a:lstStyle xmlns:a="http://schemas.openxmlformats.org/drawingml/2006/main"/>
           <a:p xmlns:a="http://schemas.openxmlformats.org/drawingml/2006/main">
             <a:pPr algn="ctr">
-              <a:buNone/>
-              <a:defRPr sz="1725" b="1">
+              <a:defRPr sz="1950" b="1">
                 <a:solidFill>
                   <a:srgbClr val="FFFFFF"/>
                 </a:solidFill>
@@ -2491,7 +2418,7 @@
               </a:defRPr>
             </a:pPr>
             <a:r>
-              <a:rPr sz="1725" b="1">
+              <a:rPr sz="1950" b="1">
                 <a:solidFill>
                   <a:srgbClr val="FFFFFF"/>
                 </a:solidFill>
@@ -2506,79 +2433,22 @@
       </p:sp>
       <p:sp>
         <p:nvSpPr>
-          <p:cNvPr id="15" name="">
-            <a:extLst xmlns:a="http://schemas.openxmlformats.org/drawingml/2006/main">
-              <a:ext uri="{FF2B5EF4-FFF2-40B4-BE49-F238E27FC236}">
-                <a16:creationId xmlns:a16="http://schemas.microsoft.com/office/drawing/2014/main" id="{CA3D3FCA-9FD2-4468-ADBB-78B27F19FE71}"/>
-              </a:ext>
-            </a:extLst>
-          </p:cNvPr>
-          <p:cNvSpPr>
-            <a:spLocks xmlns:a="http://schemas.openxmlformats.org/drawingml/2006/main" noGrp="1"/>
-          </p:cNvSpPr>
-          <p:nvPr/>
-        </p:nvSpPr>
-        <p:spPr>
-          <a:xfrm xmlns:a="http://schemas.openxmlformats.org/drawingml/2006/main">
-            <a:off x="9086850" y="2581275"/>
-            <a:ext cx="2381250" cy="190500"/>
-          </a:xfrm>
-          <a:prstGeom xmlns:a="http://schemas.openxmlformats.org/drawingml/2006/main" prst="rect">
-            <a:avLst/>
-          </a:prstGeom>
-          <a:noFill xmlns:a="http://schemas.openxmlformats.org/drawingml/2006/main"/>
-          <a:ln xmlns:a="http://schemas.openxmlformats.org/drawingml/2006/main" w="0">
-            <a:noFill/>
-            <a:prstDash val="solid"/>
-          </a:ln>
-        </p:spPr>
-        <p:txBody>
-          <a:bodyPr xmlns:a="http://schemas.openxmlformats.org/drawingml/2006/main" wrap="square" lIns="0" tIns="0" rIns="0" bIns="0"/>
-          <a:lstStyle xmlns:a="http://schemas.openxmlformats.org/drawingml/2006/main"/>
-          <a:p xmlns:a="http://schemas.openxmlformats.org/drawingml/2006/main">
-            <a:pPr>
-              <a:buNone/>
-              <a:defRPr sz="900" b="0">
-                <a:solidFill>
-                  <a:srgbClr val="667085"/>
-                </a:solidFill>
-                <a:latin typeface="PingFang SC"/>
-                <a:ea typeface="PingFang SC"/>
-                <a:cs typeface="PingFang SC"/>
-              </a:defRPr>
-            </a:pPr>
-            <a:r>
-              <a:rPr sz="900" b="0">
-                <a:solidFill>
-                  <a:srgbClr val="667085"/>
-                </a:solidFill>
-                <a:latin typeface="PingFang SC"/>
-                <a:ea typeface="PingFang SC"/>
-                <a:cs typeface="PingFang SC"/>
-              </a:rPr>
-              <a:t>教育推荐为什么需要 OneRec</a:t>
-            </a:r>
-          </a:p>
-        </p:txBody>
-      </p:sp>
-      <p:sp>
-        <p:nvSpPr>
-          <p:cNvPr id="16" name="">
-            <a:extLst xmlns:a="http://schemas.openxmlformats.org/drawingml/2006/main">
-              <a:ext uri="{FF2B5EF4-FFF2-40B4-BE49-F238E27FC236}">
-                <a16:creationId xmlns:a16="http://schemas.microsoft.com/office/drawing/2014/main" id="{4ECC0ADE-0D1A-40C1-9748-38DA3881C1E6}"/>
-              </a:ext>
-            </a:extLst>
-          </p:cNvPr>
-          <p:cNvSpPr>
-            <a:spLocks xmlns:a="http://schemas.openxmlformats.org/drawingml/2006/main" noGrp="1"/>
-          </p:cNvSpPr>
-          <p:nvPr/>
-        </p:nvSpPr>
-        <p:spPr>
-          <a:xfrm xmlns:a="http://schemas.openxmlformats.org/drawingml/2006/main">
-            <a:off x="3676650" y="3286125"/>
-            <a:ext cx="5219700" cy="476250"/>
+          <p:cNvPr id="40" name="">
+            <a:extLst xmlns:a="http://schemas.openxmlformats.org/drawingml/2006/main">
+              <a:ext uri="{FF2B5EF4-FFF2-40B4-BE49-F238E27FC236}">
+                <a16:creationId xmlns:a16="http://schemas.microsoft.com/office/drawing/2014/main" id="{8302A81F-B53C-4CEC-8A88-419956A11F9B}"/>
+              </a:ext>
+            </a:extLst>
+          </p:cNvPr>
+          <p:cNvSpPr>
+            <a:spLocks xmlns:a="http://schemas.openxmlformats.org/drawingml/2006/main" noGrp="1"/>
+          </p:cNvSpPr>
+          <p:nvPr/>
+        </p:nvSpPr>
+        <p:spPr>
+          <a:xfrm xmlns:a="http://schemas.openxmlformats.org/drawingml/2006/main">
+            <a:off x="3629025" y="3286125"/>
+            <a:ext cx="5581650" cy="476250"/>
           </a:xfrm>
           <a:prstGeom xmlns:a="http://schemas.openxmlformats.org/drawingml/2006/main" prst="rect">
             <a:avLst/>
@@ -2594,21 +2464,21 @@
       </p:sp>
       <p:sp>
         <p:nvSpPr>
-          <p:cNvPr id="17" name="">
-            <a:extLst xmlns:a="http://schemas.openxmlformats.org/drawingml/2006/main">
-              <a:ext uri="{FF2B5EF4-FFF2-40B4-BE49-F238E27FC236}">
-                <a16:creationId xmlns:a16="http://schemas.microsoft.com/office/drawing/2014/main" id="{3156F6DA-F453-49EF-BA45-2C6AEFA35C00}"/>
-              </a:ext>
-            </a:extLst>
-          </p:cNvPr>
-          <p:cNvSpPr>
-            <a:spLocks xmlns:a="http://schemas.openxmlformats.org/drawingml/2006/main" noGrp="1"/>
-          </p:cNvSpPr>
-          <p:nvPr/>
-        </p:nvSpPr>
-        <p:spPr>
-          <a:xfrm xmlns:a="http://schemas.openxmlformats.org/drawingml/2006/main">
-            <a:off x="3333750" y="3200400"/>
+          <p:cNvPr id="41" name="">
+            <a:extLst xmlns:a="http://schemas.openxmlformats.org/drawingml/2006/main">
+              <a:ext uri="{FF2B5EF4-FFF2-40B4-BE49-F238E27FC236}">
+                <a16:creationId xmlns:a16="http://schemas.microsoft.com/office/drawing/2014/main" id="{90C91A4B-75FA-4AA2-B0D4-51FC0269F0AB}"/>
+              </a:ext>
+            </a:extLst>
+          </p:cNvPr>
+          <p:cNvSpPr>
+            <a:spLocks xmlns:a="http://schemas.openxmlformats.org/drawingml/2006/main" noGrp="1"/>
+          </p:cNvSpPr>
+          <p:nvPr/>
+        </p:nvSpPr>
+        <p:spPr>
+          <a:xfrm xmlns:a="http://schemas.openxmlformats.org/drawingml/2006/main">
+            <a:off x="2981325" y="3200400"/>
             <a:ext cx="647700" cy="647700"/>
           </a:xfrm>
           <a:prstGeom xmlns:a="http://schemas.openxmlformats.org/drawingml/2006/main" prst="ellipse">
@@ -2624,30 +2494,24 @@
             <a:prstDash val="solid"/>
           </a:ln>
         </p:spPr>
-        <p:style>
-          <a:lnRef xmlns:a="http://schemas.openxmlformats.org/drawingml/2006/main" idx="0"/>
-          <a:fillRef xmlns:a="http://schemas.openxmlformats.org/drawingml/2006/main" idx="0"/>
-          <a:effectRef xmlns:a="http://schemas.openxmlformats.org/drawingml/2006/main" idx="4"/>
-          <a:fontRef xmlns:a="http://schemas.openxmlformats.org/drawingml/2006/main" idx="major"/>
-        </p:style>
-      </p:sp>
-      <p:sp>
-        <p:nvSpPr>
-          <p:cNvPr id="18" name="">
-            <a:extLst xmlns:a="http://schemas.openxmlformats.org/drawingml/2006/main">
-              <a:ext uri="{FF2B5EF4-FFF2-40B4-BE49-F238E27FC236}">
-                <a16:creationId xmlns:a16="http://schemas.microsoft.com/office/drawing/2014/main" id="{FFDC9AB4-73A8-4E81-A297-6B74B231124E}"/>
-              </a:ext>
-            </a:extLst>
-          </p:cNvPr>
-          <p:cNvSpPr>
-            <a:spLocks xmlns:a="http://schemas.openxmlformats.org/drawingml/2006/main" noGrp="1"/>
-          </p:cNvSpPr>
-          <p:nvPr/>
-        </p:nvSpPr>
-        <p:spPr>
-          <a:xfrm xmlns:a="http://schemas.openxmlformats.org/drawingml/2006/main">
-            <a:off x="3333750" y="3324225"/>
+      </p:sp>
+      <p:sp>
+        <p:nvSpPr>
+          <p:cNvPr id="42" name="">
+            <a:extLst xmlns:a="http://schemas.openxmlformats.org/drawingml/2006/main">
+              <a:ext uri="{FF2B5EF4-FFF2-40B4-BE49-F238E27FC236}">
+                <a16:creationId xmlns:a16="http://schemas.microsoft.com/office/drawing/2014/main" id="{9B40ECC8-C7E7-4621-8BD7-F0B97DDBFAFB}"/>
+              </a:ext>
+            </a:extLst>
+          </p:cNvPr>
+          <p:cNvSpPr>
+            <a:spLocks xmlns:a="http://schemas.openxmlformats.org/drawingml/2006/main" noGrp="1"/>
+          </p:cNvSpPr>
+          <p:nvPr/>
+        </p:nvSpPr>
+        <p:spPr>
+          <a:xfrm xmlns:a="http://schemas.openxmlformats.org/drawingml/2006/main">
+            <a:off x="2981325" y="3324225"/>
             <a:ext cx="647700" cy="342900"/>
           </a:xfrm>
           <a:prstGeom xmlns:a="http://schemas.openxmlformats.org/drawingml/2006/main" prst="rect">
@@ -2664,8 +2528,7 @@
           <a:lstStyle xmlns:a="http://schemas.openxmlformats.org/drawingml/2006/main"/>
           <a:p xmlns:a="http://schemas.openxmlformats.org/drawingml/2006/main">
             <a:pPr algn="ctr">
-              <a:buNone/>
-              <a:defRPr sz="2325" b="1">
+              <a:defRPr sz="2250" b="1">
                 <a:solidFill>
                   <a:srgbClr val="635BFF"/>
                 </a:solidFill>
@@ -2675,7 +2538,7 @@
               </a:defRPr>
             </a:pPr>
             <a:r>
-              <a:rPr sz="2325" b="1">
+              <a:rPr sz="2250" b="1">
                 <a:solidFill>
                   <a:srgbClr val="635BFF"/>
                 </a:solidFill>
@@ -2690,22 +2553,22 @@
       </p:sp>
       <p:sp>
         <p:nvSpPr>
-          <p:cNvPr id="19" name="">
-            <a:extLst xmlns:a="http://schemas.openxmlformats.org/drawingml/2006/main">
-              <a:ext uri="{FF2B5EF4-FFF2-40B4-BE49-F238E27FC236}">
-                <a16:creationId xmlns:a16="http://schemas.microsoft.com/office/drawing/2014/main" id="{645DF0AC-5092-45F5-B688-F53C644C4623}"/>
-              </a:ext>
-            </a:extLst>
-          </p:cNvPr>
-          <p:cNvSpPr>
-            <a:spLocks xmlns:a="http://schemas.openxmlformats.org/drawingml/2006/main" noGrp="1"/>
-          </p:cNvSpPr>
-          <p:nvPr/>
-        </p:nvSpPr>
-        <p:spPr>
-          <a:xfrm xmlns:a="http://schemas.openxmlformats.org/drawingml/2006/main">
-            <a:off x="4133850" y="3400425"/>
-            <a:ext cx="4286250" cy="228600"/>
+          <p:cNvPr id="43" name="">
+            <a:extLst xmlns:a="http://schemas.openxmlformats.org/drawingml/2006/main">
+              <a:ext uri="{FF2B5EF4-FFF2-40B4-BE49-F238E27FC236}">
+                <a16:creationId xmlns:a16="http://schemas.microsoft.com/office/drawing/2014/main" id="{835BCFC6-2638-43CA-87D8-51D82F8F4FED}"/>
+              </a:ext>
+            </a:extLst>
+          </p:cNvPr>
+          <p:cNvSpPr>
+            <a:spLocks xmlns:a="http://schemas.openxmlformats.org/drawingml/2006/main" noGrp="1"/>
+          </p:cNvSpPr>
+          <p:nvPr/>
+        </p:nvSpPr>
+        <p:spPr>
+          <a:xfrm xmlns:a="http://schemas.openxmlformats.org/drawingml/2006/main">
+            <a:off x="3629025" y="3390900"/>
+            <a:ext cx="5581650" cy="266700"/>
           </a:xfrm>
           <a:prstGeom xmlns:a="http://schemas.openxmlformats.org/drawingml/2006/main" prst="rect">
             <a:avLst/>
@@ -2721,8 +2584,7 @@
           <a:lstStyle xmlns:a="http://schemas.openxmlformats.org/drawingml/2006/main"/>
           <a:p xmlns:a="http://schemas.openxmlformats.org/drawingml/2006/main">
             <a:pPr algn="ctr">
-              <a:buNone/>
-              <a:defRPr sz="1725" b="1">
+              <a:defRPr sz="1950" b="1">
                 <a:solidFill>
                   <a:srgbClr val="FFFFFF"/>
                 </a:solidFill>
@@ -2732,7 +2594,7 @@
               </a:defRPr>
             </a:pPr>
             <a:r>
-              <a:rPr sz="1725" b="1">
+              <a:rPr sz="1950" b="1">
                 <a:solidFill>
                   <a:srgbClr val="FFFFFF"/>
                 </a:solidFill>
@@ -2747,79 +2609,22 @@
       </p:sp>
       <p:sp>
         <p:nvSpPr>
-          <p:cNvPr id="20" name="">
-            <a:extLst xmlns:a="http://schemas.openxmlformats.org/drawingml/2006/main">
-              <a:ext uri="{FF2B5EF4-FFF2-40B4-BE49-F238E27FC236}">
-                <a16:creationId xmlns:a16="http://schemas.microsoft.com/office/drawing/2014/main" id="{69EF3B81-3801-48DC-970F-CBD30DAB5328}"/>
-              </a:ext>
-            </a:extLst>
-          </p:cNvPr>
-          <p:cNvSpPr>
-            <a:spLocks xmlns:a="http://schemas.openxmlformats.org/drawingml/2006/main" noGrp="1"/>
-          </p:cNvSpPr>
-          <p:nvPr/>
-        </p:nvSpPr>
-        <p:spPr>
-          <a:xfrm xmlns:a="http://schemas.openxmlformats.org/drawingml/2006/main">
-            <a:off x="9086850" y="3419475"/>
-            <a:ext cx="2381250" cy="190500"/>
-          </a:xfrm>
-          <a:prstGeom xmlns:a="http://schemas.openxmlformats.org/drawingml/2006/main" prst="rect">
-            <a:avLst/>
-          </a:prstGeom>
-          <a:noFill xmlns:a="http://schemas.openxmlformats.org/drawingml/2006/main"/>
-          <a:ln xmlns:a="http://schemas.openxmlformats.org/drawingml/2006/main" w="0">
-            <a:noFill/>
-            <a:prstDash val="solid"/>
-          </a:ln>
-        </p:spPr>
-        <p:txBody>
-          <a:bodyPr xmlns:a="http://schemas.openxmlformats.org/drawingml/2006/main" wrap="square" lIns="0" tIns="0" rIns="0" bIns="0"/>
-          <a:lstStyle xmlns:a="http://schemas.openxmlformats.org/drawingml/2006/main"/>
-          <a:p xmlns:a="http://schemas.openxmlformats.org/drawingml/2006/main">
-            <a:pPr>
-              <a:buNone/>
-              <a:defRPr sz="900" b="0">
-                <a:solidFill>
-                  <a:srgbClr val="667085"/>
-                </a:solidFill>
-                <a:latin typeface="PingFang SC"/>
-                <a:ea typeface="PingFang SC"/>
-                <a:cs typeface="PingFang SC"/>
-              </a:defRPr>
-            </a:pPr>
-            <a:r>
-              <a:rPr sz="900" b="0">
-                <a:solidFill>
-                  <a:srgbClr val="667085"/>
-                </a:solidFill>
-                <a:latin typeface="PingFang SC"/>
-                <a:ea typeface="PingFang SC"/>
-                <a:cs typeface="PingFang SC"/>
-              </a:rPr>
-              <a:t>五个差异点 + 六个 demo case</a:t>
-            </a:r>
-          </a:p>
-        </p:txBody>
-      </p:sp>
-      <p:sp>
-        <p:nvSpPr>
-          <p:cNvPr id="21" name="">
-            <a:extLst xmlns:a="http://schemas.openxmlformats.org/drawingml/2006/main">
-              <a:ext uri="{FF2B5EF4-FFF2-40B4-BE49-F238E27FC236}">
-                <a16:creationId xmlns:a16="http://schemas.microsoft.com/office/drawing/2014/main" id="{8C29EF32-5879-4601-B36B-30DD1121A8B4}"/>
-              </a:ext>
-            </a:extLst>
-          </p:cNvPr>
-          <p:cNvSpPr>
-            <a:spLocks xmlns:a="http://schemas.openxmlformats.org/drawingml/2006/main" noGrp="1"/>
-          </p:cNvSpPr>
-          <p:nvPr/>
-        </p:nvSpPr>
-        <p:spPr>
-          <a:xfrm xmlns:a="http://schemas.openxmlformats.org/drawingml/2006/main">
-            <a:off x="3676650" y="4124325"/>
-            <a:ext cx="5219700" cy="476250"/>
+          <p:cNvPr id="44" name="">
+            <a:extLst xmlns:a="http://schemas.openxmlformats.org/drawingml/2006/main">
+              <a:ext uri="{FF2B5EF4-FFF2-40B4-BE49-F238E27FC236}">
+                <a16:creationId xmlns:a16="http://schemas.microsoft.com/office/drawing/2014/main" id="{63EF2F44-D7FE-4137-8BEB-56D87ED769B3}"/>
+              </a:ext>
+            </a:extLst>
+          </p:cNvPr>
+          <p:cNvSpPr>
+            <a:spLocks xmlns:a="http://schemas.openxmlformats.org/drawingml/2006/main" noGrp="1"/>
+          </p:cNvSpPr>
+          <p:nvPr/>
+        </p:nvSpPr>
+        <p:spPr>
+          <a:xfrm xmlns:a="http://schemas.openxmlformats.org/drawingml/2006/main">
+            <a:off x="3629025" y="4124325"/>
+            <a:ext cx="5581650" cy="476250"/>
           </a:xfrm>
           <a:prstGeom xmlns:a="http://schemas.openxmlformats.org/drawingml/2006/main" prst="rect">
             <a:avLst/>
@@ -2835,21 +2640,21 @@
       </p:sp>
       <p:sp>
         <p:nvSpPr>
-          <p:cNvPr id="22" name="">
-            <a:extLst xmlns:a="http://schemas.openxmlformats.org/drawingml/2006/main">
-              <a:ext uri="{FF2B5EF4-FFF2-40B4-BE49-F238E27FC236}">
-                <a16:creationId xmlns:a16="http://schemas.microsoft.com/office/drawing/2014/main" id="{2C07DBEB-685E-4024-B22F-32DE195097A0}"/>
-              </a:ext>
-            </a:extLst>
-          </p:cNvPr>
-          <p:cNvSpPr>
-            <a:spLocks xmlns:a="http://schemas.openxmlformats.org/drawingml/2006/main" noGrp="1"/>
-          </p:cNvSpPr>
-          <p:nvPr/>
-        </p:nvSpPr>
-        <p:spPr>
-          <a:xfrm xmlns:a="http://schemas.openxmlformats.org/drawingml/2006/main">
-            <a:off x="3333750" y="4038600"/>
+          <p:cNvPr id="45" name="">
+            <a:extLst xmlns:a="http://schemas.openxmlformats.org/drawingml/2006/main">
+              <a:ext uri="{FF2B5EF4-FFF2-40B4-BE49-F238E27FC236}">
+                <a16:creationId xmlns:a16="http://schemas.microsoft.com/office/drawing/2014/main" id="{CF934246-085C-43AA-A267-8335535D09C3}"/>
+              </a:ext>
+            </a:extLst>
+          </p:cNvPr>
+          <p:cNvSpPr>
+            <a:spLocks xmlns:a="http://schemas.openxmlformats.org/drawingml/2006/main" noGrp="1"/>
+          </p:cNvSpPr>
+          <p:nvPr/>
+        </p:nvSpPr>
+        <p:spPr>
+          <a:xfrm xmlns:a="http://schemas.openxmlformats.org/drawingml/2006/main">
+            <a:off x="2981325" y="4038600"/>
             <a:ext cx="647700" cy="647700"/>
           </a:xfrm>
           <a:prstGeom xmlns:a="http://schemas.openxmlformats.org/drawingml/2006/main" prst="ellipse">
@@ -2865,30 +2670,24 @@
             <a:prstDash val="solid"/>
           </a:ln>
         </p:spPr>
-        <p:style>
-          <a:lnRef xmlns:a="http://schemas.openxmlformats.org/drawingml/2006/main" idx="0"/>
-          <a:fillRef xmlns:a="http://schemas.openxmlformats.org/drawingml/2006/main" idx="0"/>
-          <a:effectRef xmlns:a="http://schemas.openxmlformats.org/drawingml/2006/main" idx="4"/>
-          <a:fontRef xmlns:a="http://schemas.openxmlformats.org/drawingml/2006/main" idx="major"/>
-        </p:style>
-      </p:sp>
-      <p:sp>
-        <p:nvSpPr>
-          <p:cNvPr id="23" name="">
-            <a:extLst xmlns:a="http://schemas.openxmlformats.org/drawingml/2006/main">
-              <a:ext uri="{FF2B5EF4-FFF2-40B4-BE49-F238E27FC236}">
-                <a16:creationId xmlns:a16="http://schemas.microsoft.com/office/drawing/2014/main" id="{D180194C-1F23-4498-AB29-4461153A4763}"/>
-              </a:ext>
-            </a:extLst>
-          </p:cNvPr>
-          <p:cNvSpPr>
-            <a:spLocks xmlns:a="http://schemas.openxmlformats.org/drawingml/2006/main" noGrp="1"/>
-          </p:cNvSpPr>
-          <p:nvPr/>
-        </p:nvSpPr>
-        <p:spPr>
-          <a:xfrm xmlns:a="http://schemas.openxmlformats.org/drawingml/2006/main">
-            <a:off x="3333750" y="4162425"/>
+      </p:sp>
+      <p:sp>
+        <p:nvSpPr>
+          <p:cNvPr id="46" name="">
+            <a:extLst xmlns:a="http://schemas.openxmlformats.org/drawingml/2006/main">
+              <a:ext uri="{FF2B5EF4-FFF2-40B4-BE49-F238E27FC236}">
+                <a16:creationId xmlns:a16="http://schemas.microsoft.com/office/drawing/2014/main" id="{125847D5-6676-449E-ADC8-A605F9050E43}"/>
+              </a:ext>
+            </a:extLst>
+          </p:cNvPr>
+          <p:cNvSpPr>
+            <a:spLocks xmlns:a="http://schemas.openxmlformats.org/drawingml/2006/main" noGrp="1"/>
+          </p:cNvSpPr>
+          <p:nvPr/>
+        </p:nvSpPr>
+        <p:spPr>
+          <a:xfrm xmlns:a="http://schemas.openxmlformats.org/drawingml/2006/main">
+            <a:off x="2981325" y="4162425"/>
             <a:ext cx="647700" cy="342900"/>
           </a:xfrm>
           <a:prstGeom xmlns:a="http://schemas.openxmlformats.org/drawingml/2006/main" prst="rect">
@@ -2905,8 +2704,7 @@
           <a:lstStyle xmlns:a="http://schemas.openxmlformats.org/drawingml/2006/main"/>
           <a:p xmlns:a="http://schemas.openxmlformats.org/drawingml/2006/main">
             <a:pPr algn="ctr">
-              <a:buNone/>
-              <a:defRPr sz="2325" b="1">
+              <a:defRPr sz="2250" b="1">
                 <a:solidFill>
                   <a:srgbClr val="635BFF"/>
                 </a:solidFill>
@@ -2916,7 +2714,7 @@
               </a:defRPr>
             </a:pPr>
             <a:r>
-              <a:rPr sz="2325" b="1">
+              <a:rPr sz="2250" b="1">
                 <a:solidFill>
                   <a:srgbClr val="635BFF"/>
                 </a:solidFill>
@@ -2931,22 +2729,22 @@
       </p:sp>
       <p:sp>
         <p:nvSpPr>
-          <p:cNvPr id="24" name="">
-            <a:extLst xmlns:a="http://schemas.openxmlformats.org/drawingml/2006/main">
-              <a:ext uri="{FF2B5EF4-FFF2-40B4-BE49-F238E27FC236}">
-                <a16:creationId xmlns:a16="http://schemas.microsoft.com/office/drawing/2014/main" id="{2C422139-1C99-467A-948A-10C60A863D69}"/>
-              </a:ext>
-            </a:extLst>
-          </p:cNvPr>
-          <p:cNvSpPr>
-            <a:spLocks xmlns:a="http://schemas.openxmlformats.org/drawingml/2006/main" noGrp="1"/>
-          </p:cNvSpPr>
-          <p:nvPr/>
-        </p:nvSpPr>
-        <p:spPr>
-          <a:xfrm xmlns:a="http://schemas.openxmlformats.org/drawingml/2006/main">
-            <a:off x="4133850" y="4238625"/>
-            <a:ext cx="4286250" cy="228600"/>
+          <p:cNvPr id="47" name="">
+            <a:extLst xmlns:a="http://schemas.openxmlformats.org/drawingml/2006/main">
+              <a:ext uri="{FF2B5EF4-FFF2-40B4-BE49-F238E27FC236}">
+                <a16:creationId xmlns:a16="http://schemas.microsoft.com/office/drawing/2014/main" id="{5DFFE1E1-B139-41E8-9183-93AA1C9718E2}"/>
+              </a:ext>
+            </a:extLst>
+          </p:cNvPr>
+          <p:cNvSpPr>
+            <a:spLocks xmlns:a="http://schemas.openxmlformats.org/drawingml/2006/main" noGrp="1"/>
+          </p:cNvSpPr>
+          <p:nvPr/>
+        </p:nvSpPr>
+        <p:spPr>
+          <a:xfrm xmlns:a="http://schemas.openxmlformats.org/drawingml/2006/main">
+            <a:off x="3629025" y="4229100"/>
+            <a:ext cx="5581650" cy="266700"/>
           </a:xfrm>
           <a:prstGeom xmlns:a="http://schemas.openxmlformats.org/drawingml/2006/main" prst="rect">
             <a:avLst/>
@@ -2962,8 +2760,7 @@
           <a:lstStyle xmlns:a="http://schemas.openxmlformats.org/drawingml/2006/main"/>
           <a:p xmlns:a="http://schemas.openxmlformats.org/drawingml/2006/main">
             <a:pPr algn="ctr">
-              <a:buNone/>
-              <a:defRPr sz="1725" b="1">
+              <a:defRPr sz="1950" b="1">
                 <a:solidFill>
                   <a:srgbClr val="FFFFFF"/>
                 </a:solidFill>
@@ -2973,7 +2770,7 @@
               </a:defRPr>
             </a:pPr>
             <a:r>
-              <a:rPr sz="1725" b="1">
+              <a:rPr sz="1950" b="1">
                 <a:solidFill>
                   <a:srgbClr val="FFFFFF"/>
                 </a:solidFill>
@@ -2988,79 +2785,22 @@
       </p:sp>
       <p:sp>
         <p:nvSpPr>
-          <p:cNvPr id="25" name="">
-            <a:extLst xmlns:a="http://schemas.openxmlformats.org/drawingml/2006/main">
-              <a:ext uri="{FF2B5EF4-FFF2-40B4-BE49-F238E27FC236}">
-                <a16:creationId xmlns:a16="http://schemas.microsoft.com/office/drawing/2014/main" id="{67B44DAA-C335-4725-8B98-14DAE4DE992F}"/>
-              </a:ext>
-            </a:extLst>
-          </p:cNvPr>
-          <p:cNvSpPr>
-            <a:spLocks xmlns:a="http://schemas.openxmlformats.org/drawingml/2006/main" noGrp="1"/>
-          </p:cNvSpPr>
-          <p:nvPr/>
-        </p:nvSpPr>
-        <p:spPr>
-          <a:xfrm xmlns:a="http://schemas.openxmlformats.org/drawingml/2006/main">
-            <a:off x="9086850" y="4257675"/>
-            <a:ext cx="2381250" cy="190500"/>
-          </a:xfrm>
-          <a:prstGeom xmlns:a="http://schemas.openxmlformats.org/drawingml/2006/main" prst="rect">
-            <a:avLst/>
-          </a:prstGeom>
-          <a:noFill xmlns:a="http://schemas.openxmlformats.org/drawingml/2006/main"/>
-          <a:ln xmlns:a="http://schemas.openxmlformats.org/drawingml/2006/main" w="0">
-            <a:noFill/>
-            <a:prstDash val="solid"/>
-          </a:ln>
-        </p:spPr>
-        <p:txBody>
-          <a:bodyPr xmlns:a="http://schemas.openxmlformats.org/drawingml/2006/main" wrap="square" lIns="0" tIns="0" rIns="0" bIns="0"/>
-          <a:lstStyle xmlns:a="http://schemas.openxmlformats.org/drawingml/2006/main"/>
-          <a:p xmlns:a="http://schemas.openxmlformats.org/drawingml/2006/main">
-            <a:pPr>
-              <a:buNone/>
-              <a:defRPr sz="900" b="0">
-                <a:solidFill>
-                  <a:srgbClr val="667085"/>
-                </a:solidFill>
-                <a:latin typeface="PingFang SC"/>
-                <a:ea typeface="PingFang SC"/>
-                <a:cs typeface="PingFang SC"/>
-              </a:defRPr>
-            </a:pPr>
-            <a:r>
-              <a:rPr sz="900" b="0">
-                <a:solidFill>
-                  <a:srgbClr val="667085"/>
-                </a:solidFill>
-                <a:latin typeface="PingFang SC"/>
-                <a:ea typeface="PingFang SC"/>
-                <a:cs typeface="PingFang SC"/>
-              </a:rPr>
-              <a:t>Tokenizer、训练、下游任务、限制性解码</a:t>
-            </a:r>
-          </a:p>
-        </p:txBody>
-      </p:sp>
-      <p:sp>
-        <p:nvSpPr>
-          <p:cNvPr id="26" name="">
-            <a:extLst xmlns:a="http://schemas.openxmlformats.org/drawingml/2006/main">
-              <a:ext uri="{FF2B5EF4-FFF2-40B4-BE49-F238E27FC236}">
-                <a16:creationId xmlns:a16="http://schemas.microsoft.com/office/drawing/2014/main" id="{DDEC20B4-339A-4818-8B52-01CD9424825D}"/>
-              </a:ext>
-            </a:extLst>
-          </p:cNvPr>
-          <p:cNvSpPr>
-            <a:spLocks xmlns:a="http://schemas.openxmlformats.org/drawingml/2006/main" noGrp="1"/>
-          </p:cNvSpPr>
-          <p:nvPr/>
-        </p:nvSpPr>
-        <p:spPr>
-          <a:xfrm xmlns:a="http://schemas.openxmlformats.org/drawingml/2006/main">
-            <a:off x="3676650" y="4962525"/>
-            <a:ext cx="5219700" cy="476250"/>
+          <p:cNvPr id="48" name="">
+            <a:extLst xmlns:a="http://schemas.openxmlformats.org/drawingml/2006/main">
+              <a:ext uri="{FF2B5EF4-FFF2-40B4-BE49-F238E27FC236}">
+                <a16:creationId xmlns:a16="http://schemas.microsoft.com/office/drawing/2014/main" id="{83ECC91A-07D6-415A-BBA1-45DD061B3D44}"/>
+              </a:ext>
+            </a:extLst>
+          </p:cNvPr>
+          <p:cNvSpPr>
+            <a:spLocks xmlns:a="http://schemas.openxmlformats.org/drawingml/2006/main" noGrp="1"/>
+          </p:cNvSpPr>
+          <p:nvPr/>
+        </p:nvSpPr>
+        <p:spPr>
+          <a:xfrm xmlns:a="http://schemas.openxmlformats.org/drawingml/2006/main">
+            <a:off x="3629025" y="4962525"/>
+            <a:ext cx="5581650" cy="476250"/>
           </a:xfrm>
           <a:prstGeom xmlns:a="http://schemas.openxmlformats.org/drawingml/2006/main" prst="rect">
             <a:avLst/>
@@ -3076,21 +2816,21 @@
       </p:sp>
       <p:sp>
         <p:nvSpPr>
-          <p:cNvPr id="27" name="">
-            <a:extLst xmlns:a="http://schemas.openxmlformats.org/drawingml/2006/main">
-              <a:ext uri="{FF2B5EF4-FFF2-40B4-BE49-F238E27FC236}">
-                <a16:creationId xmlns:a16="http://schemas.microsoft.com/office/drawing/2014/main" id="{0D0AD58D-FF0D-4438-974C-6EB701B26BEF}"/>
-              </a:ext>
-            </a:extLst>
-          </p:cNvPr>
-          <p:cNvSpPr>
-            <a:spLocks xmlns:a="http://schemas.openxmlformats.org/drawingml/2006/main" noGrp="1"/>
-          </p:cNvSpPr>
-          <p:nvPr/>
-        </p:nvSpPr>
-        <p:spPr>
-          <a:xfrm xmlns:a="http://schemas.openxmlformats.org/drawingml/2006/main">
-            <a:off x="3333750" y="4876800"/>
+          <p:cNvPr id="49" name="">
+            <a:extLst xmlns:a="http://schemas.openxmlformats.org/drawingml/2006/main">
+              <a:ext uri="{FF2B5EF4-FFF2-40B4-BE49-F238E27FC236}">
+                <a16:creationId xmlns:a16="http://schemas.microsoft.com/office/drawing/2014/main" id="{4B6DC8FD-E1EF-4379-8634-C0A1D7ED41A0}"/>
+              </a:ext>
+            </a:extLst>
+          </p:cNvPr>
+          <p:cNvSpPr>
+            <a:spLocks xmlns:a="http://schemas.openxmlformats.org/drawingml/2006/main" noGrp="1"/>
+          </p:cNvSpPr>
+          <p:nvPr/>
+        </p:nvSpPr>
+        <p:spPr>
+          <a:xfrm xmlns:a="http://schemas.openxmlformats.org/drawingml/2006/main">
+            <a:off x="2981325" y="4876800"/>
             <a:ext cx="647700" cy="647700"/>
           </a:xfrm>
           <a:prstGeom xmlns:a="http://schemas.openxmlformats.org/drawingml/2006/main" prst="ellipse">
@@ -3106,30 +2846,24 @@
             <a:prstDash val="solid"/>
           </a:ln>
         </p:spPr>
-        <p:style>
-          <a:lnRef xmlns:a="http://schemas.openxmlformats.org/drawingml/2006/main" idx="0"/>
-          <a:fillRef xmlns:a="http://schemas.openxmlformats.org/drawingml/2006/main" idx="0"/>
-          <a:effectRef xmlns:a="http://schemas.openxmlformats.org/drawingml/2006/main" idx="4"/>
-          <a:fontRef xmlns:a="http://schemas.openxmlformats.org/drawingml/2006/main" idx="major"/>
-        </p:style>
-      </p:sp>
-      <p:sp>
-        <p:nvSpPr>
-          <p:cNvPr id="28" name="">
-            <a:extLst xmlns:a="http://schemas.openxmlformats.org/drawingml/2006/main">
-              <a:ext uri="{FF2B5EF4-FFF2-40B4-BE49-F238E27FC236}">
-                <a16:creationId xmlns:a16="http://schemas.microsoft.com/office/drawing/2014/main" id="{CB2E6ABD-7841-44E4-816E-F40A4825B410}"/>
-              </a:ext>
-            </a:extLst>
-          </p:cNvPr>
-          <p:cNvSpPr>
-            <a:spLocks xmlns:a="http://schemas.openxmlformats.org/drawingml/2006/main" noGrp="1"/>
-          </p:cNvSpPr>
-          <p:nvPr/>
-        </p:nvSpPr>
-        <p:spPr>
-          <a:xfrm xmlns:a="http://schemas.openxmlformats.org/drawingml/2006/main">
-            <a:off x="3333750" y="5000625"/>
+      </p:sp>
+      <p:sp>
+        <p:nvSpPr>
+          <p:cNvPr id="50" name="">
+            <a:extLst xmlns:a="http://schemas.openxmlformats.org/drawingml/2006/main">
+              <a:ext uri="{FF2B5EF4-FFF2-40B4-BE49-F238E27FC236}">
+                <a16:creationId xmlns:a16="http://schemas.microsoft.com/office/drawing/2014/main" id="{16E5B032-1998-4460-A452-1C45A1036825}"/>
+              </a:ext>
+            </a:extLst>
+          </p:cNvPr>
+          <p:cNvSpPr>
+            <a:spLocks xmlns:a="http://schemas.openxmlformats.org/drawingml/2006/main" noGrp="1"/>
+          </p:cNvSpPr>
+          <p:nvPr/>
+        </p:nvSpPr>
+        <p:spPr>
+          <a:xfrm xmlns:a="http://schemas.openxmlformats.org/drawingml/2006/main">
+            <a:off x="2981325" y="5000625"/>
             <a:ext cx="647700" cy="342900"/>
           </a:xfrm>
           <a:prstGeom xmlns:a="http://schemas.openxmlformats.org/drawingml/2006/main" prst="rect">
@@ -3146,8 +2880,7 @@
           <a:lstStyle xmlns:a="http://schemas.openxmlformats.org/drawingml/2006/main"/>
           <a:p xmlns:a="http://schemas.openxmlformats.org/drawingml/2006/main">
             <a:pPr algn="ctr">
-              <a:buNone/>
-              <a:defRPr sz="2325" b="1">
+              <a:defRPr sz="2250" b="1">
                 <a:solidFill>
                   <a:srgbClr val="635BFF"/>
                 </a:solidFill>
@@ -3157,7 +2890,7 @@
               </a:defRPr>
             </a:pPr>
             <a:r>
-              <a:rPr sz="2325" b="1">
+              <a:rPr sz="2250" b="1">
                 <a:solidFill>
                   <a:srgbClr val="635BFF"/>
                 </a:solidFill>
@@ -3172,22 +2905,22 @@
       </p:sp>
       <p:sp>
         <p:nvSpPr>
-          <p:cNvPr id="29" name="">
-            <a:extLst xmlns:a="http://schemas.openxmlformats.org/drawingml/2006/main">
-              <a:ext uri="{FF2B5EF4-FFF2-40B4-BE49-F238E27FC236}">
-                <a16:creationId xmlns:a16="http://schemas.microsoft.com/office/drawing/2014/main" id="{56722C08-A4F5-4BA8-B715-B86926E2A2B4}"/>
-              </a:ext>
-            </a:extLst>
-          </p:cNvPr>
-          <p:cNvSpPr>
-            <a:spLocks xmlns:a="http://schemas.openxmlformats.org/drawingml/2006/main" noGrp="1"/>
-          </p:cNvSpPr>
-          <p:nvPr/>
-        </p:nvSpPr>
-        <p:spPr>
-          <a:xfrm xmlns:a="http://schemas.openxmlformats.org/drawingml/2006/main">
-            <a:off x="4133850" y="5076825"/>
-            <a:ext cx="4286250" cy="228600"/>
+          <p:cNvPr id="51" name="">
+            <a:extLst xmlns:a="http://schemas.openxmlformats.org/drawingml/2006/main">
+              <a:ext uri="{FF2B5EF4-FFF2-40B4-BE49-F238E27FC236}">
+                <a16:creationId xmlns:a16="http://schemas.microsoft.com/office/drawing/2014/main" id="{A39560BA-3976-4975-AF8C-8835FBBF9127}"/>
+              </a:ext>
+            </a:extLst>
+          </p:cNvPr>
+          <p:cNvSpPr>
+            <a:spLocks xmlns:a="http://schemas.openxmlformats.org/drawingml/2006/main" noGrp="1"/>
+          </p:cNvSpPr>
+          <p:nvPr/>
+        </p:nvSpPr>
+        <p:spPr>
+          <a:xfrm xmlns:a="http://schemas.openxmlformats.org/drawingml/2006/main">
+            <a:off x="3629025" y="5067300"/>
+            <a:ext cx="5581650" cy="266700"/>
           </a:xfrm>
           <a:prstGeom xmlns:a="http://schemas.openxmlformats.org/drawingml/2006/main" prst="rect">
             <a:avLst/>
@@ -3203,8 +2936,7 @@
           <a:lstStyle xmlns:a="http://schemas.openxmlformats.org/drawingml/2006/main"/>
           <a:p xmlns:a="http://schemas.openxmlformats.org/drawingml/2006/main">
             <a:pPr algn="ctr">
-              <a:buNone/>
-              <a:defRPr sz="1725" b="1">
+              <a:defRPr sz="1950" b="1">
                 <a:solidFill>
                   <a:srgbClr val="FFFFFF"/>
                 </a:solidFill>
@@ -3214,7 +2946,7 @@
               </a:defRPr>
             </a:pPr>
             <a:r>
-              <a:rPr sz="1725" b="1">
+              <a:rPr sz="1950" b="1">
                 <a:solidFill>
                   <a:srgbClr val="FFFFFF"/>
                 </a:solidFill>
@@ -3222,64 +2954,7 @@
                 <a:ea typeface="PingFang SC"/>
                 <a:cs typeface="PingFang SC"/>
               </a:rPr>
-              <a:t>效果与复盘</a:t>
-            </a:r>
-          </a:p>
-        </p:txBody>
-      </p:sp>
-      <p:sp>
-        <p:nvSpPr>
-          <p:cNvPr id="30" name="">
-            <a:extLst xmlns:a="http://schemas.openxmlformats.org/drawingml/2006/main">
-              <a:ext uri="{FF2B5EF4-FFF2-40B4-BE49-F238E27FC236}">
-                <a16:creationId xmlns:a16="http://schemas.microsoft.com/office/drawing/2014/main" id="{BEF403D7-38EC-473A-9B96-14D281A35916}"/>
-              </a:ext>
-            </a:extLst>
-          </p:cNvPr>
-          <p:cNvSpPr>
-            <a:spLocks xmlns:a="http://schemas.openxmlformats.org/drawingml/2006/main" noGrp="1"/>
-          </p:cNvSpPr>
-          <p:nvPr/>
-        </p:nvSpPr>
-        <p:spPr>
-          <a:xfrm xmlns:a="http://schemas.openxmlformats.org/drawingml/2006/main">
-            <a:off x="9086850" y="5095875"/>
-            <a:ext cx="2381250" cy="190500"/>
-          </a:xfrm>
-          <a:prstGeom xmlns:a="http://schemas.openxmlformats.org/drawingml/2006/main" prst="rect">
-            <a:avLst/>
-          </a:prstGeom>
-          <a:noFill xmlns:a="http://schemas.openxmlformats.org/drawingml/2006/main"/>
-          <a:ln xmlns:a="http://schemas.openxmlformats.org/drawingml/2006/main" w="0">
-            <a:noFill/>
-            <a:prstDash val="solid"/>
-          </a:ln>
-        </p:spPr>
-        <p:txBody>
-          <a:bodyPr xmlns:a="http://schemas.openxmlformats.org/drawingml/2006/main" wrap="square" lIns="0" tIns="0" rIns="0" bIns="0"/>
-          <a:lstStyle xmlns:a="http://schemas.openxmlformats.org/drawingml/2006/main"/>
-          <a:p xmlns:a="http://schemas.openxmlformats.org/drawingml/2006/main">
-            <a:pPr>
-              <a:buNone/>
-              <a:defRPr sz="900" b="0">
-                <a:solidFill>
-                  <a:srgbClr val="667085"/>
-                </a:solidFill>
-                <a:latin typeface="PingFang SC"/>
-                <a:ea typeface="PingFang SC"/>
-                <a:cs typeface="PingFang SC"/>
-              </a:defRPr>
-            </a:pPr>
-            <a:r>
-              <a:rPr sz="900" b="0">
-                <a:solidFill>
-                  <a:srgbClr val="667085"/>
-                </a:solidFill>
-                <a:latin typeface="PingFang SC"/>
-                <a:ea typeface="PingFang SC"/>
-                <a:cs typeface="PingFang SC"/>
-              </a:rPr>
-              <a:t>指标收益、坑点和后续方向</a:t>
+              <a:t>思考与总结</a:t>
             </a:r>
           </a:p>
         </p:txBody>
@@ -3315,14 +2990,14 @@
       </p:grpSpPr>
       <p:pic>
         <p:nvPicPr>
-          <p:cNvPr id="56" name=""/>
+          <p:cNvPr id="65" name=""/>
           <p:cNvPicPr>
             <a:picLocks xmlns:a="http://schemas.openxmlformats.org/drawingml/2006/main" noChangeAspect="1"/>
           </p:cNvPicPr>
           <p:nvPr/>
         </p:nvPicPr>
         <p:blipFill>
-          <a:blip xmlns:r="http://schemas.openxmlformats.org/officeDocument/2006/relationships" xmlns:a="http://schemas.openxmlformats.org/drawingml/2006/main" r:embed="R87d4b0008eaf4e60"/>
+          <a:blip xmlns:r="http://schemas.openxmlformats.org/officeDocument/2006/relationships" xmlns:a="http://schemas.openxmlformats.org/drawingml/2006/main" r:embed="R396051f722e34e8f"/>
           <a:stretch xmlns:a="http://schemas.openxmlformats.org/drawingml/2006/main"/>
         </p:blipFill>
         <p:spPr>
@@ -3578,10 +3253,98 @@
       </p:sp>
       <p:sp>
         <p:nvSpPr>
-          <p:cNvPr id="7" name="">
-            <a:extLst xmlns:a="http://schemas.openxmlformats.org/drawingml/2006/main">
-              <a:ext uri="{FF2B5EF4-FFF2-40B4-BE49-F238E27FC236}">
-                <a16:creationId xmlns:a16="http://schemas.microsoft.com/office/drawing/2014/main" id="{6BF9C2E4-B50C-4DC9-A875-53B8173EB114}"/>
+          <p:cNvPr id="8" name="">
+            <a:extLst xmlns:a="http://schemas.openxmlformats.org/drawingml/2006/main">
+              <a:ext uri="{FF2B5EF4-FFF2-40B4-BE49-F238E27FC236}">
+                <a16:creationId xmlns:a16="http://schemas.microsoft.com/office/drawing/2014/main" id="{DB07FD50-B3A6-4640-9CBD-29891EC658F1}"/>
+              </a:ext>
+            </a:extLst>
+          </p:cNvPr>
+          <p:cNvSpPr>
+            <a:spLocks xmlns:a="http://schemas.openxmlformats.org/drawingml/2006/main" noGrp="1"/>
+          </p:cNvSpPr>
+          <p:nvPr/>
+        </p:nvSpPr>
+        <p:spPr>
+          <a:xfrm xmlns:a="http://schemas.openxmlformats.org/drawingml/2006/main">
+            <a:off x="495300" y="1066800"/>
+            <a:ext cx="11049000" cy="28575"/>
+          </a:xfrm>
+          <a:prstGeom xmlns:a="http://schemas.openxmlformats.org/drawingml/2006/main" prst="rect">
+            <a:avLst/>
+          </a:prstGeom>
+          <a:solidFill xmlns:a="http://schemas.openxmlformats.org/drawingml/2006/main">
+            <a:srgbClr val="635BFF"/>
+          </a:solidFill>
+          <a:ln xmlns:a="http://schemas.openxmlformats.org/drawingml/2006/main" w="0">
+            <a:noFill/>
+            <a:prstDash val="solid"/>
+          </a:ln>
+        </p:spPr>
+      </p:sp>
+      <p:sp>
+        <p:nvSpPr>
+          <p:cNvPr id="9" name="">
+            <a:extLst xmlns:a="http://schemas.openxmlformats.org/drawingml/2006/main">
+              <a:ext uri="{FF2B5EF4-FFF2-40B4-BE49-F238E27FC236}">
+                <a16:creationId xmlns:a16="http://schemas.microsoft.com/office/drawing/2014/main" id="{A389899D-CAE4-41B5-90FE-6FA173A33AF3}"/>
+              </a:ext>
+            </a:extLst>
+          </p:cNvPr>
+          <p:cNvSpPr>
+            <a:spLocks xmlns:a="http://schemas.openxmlformats.org/drawingml/2006/main" noGrp="1"/>
+          </p:cNvSpPr>
+          <p:nvPr/>
+        </p:nvSpPr>
+        <p:spPr>
+          <a:xfrm xmlns:a="http://schemas.openxmlformats.org/drawingml/2006/main">
+            <a:off x="11125200" y="6515100"/>
+            <a:ext cx="400050" cy="152400"/>
+          </a:xfrm>
+          <a:prstGeom xmlns:a="http://schemas.openxmlformats.org/drawingml/2006/main" prst="rect">
+            <a:avLst/>
+          </a:prstGeom>
+          <a:noFill xmlns:a="http://schemas.openxmlformats.org/drawingml/2006/main"/>
+          <a:ln xmlns:a="http://schemas.openxmlformats.org/drawingml/2006/main" w="0">
+            <a:noFill/>
+            <a:prstDash val="solid"/>
+          </a:ln>
+        </p:spPr>
+        <p:txBody>
+          <a:bodyPr xmlns:a="http://schemas.openxmlformats.org/drawingml/2006/main" wrap="square" lIns="0" tIns="0" rIns="0" bIns="0"/>
+          <a:lstStyle xmlns:a="http://schemas.openxmlformats.org/drawingml/2006/main"/>
+          <a:p xmlns:a="http://schemas.openxmlformats.org/drawingml/2006/main">
+            <a:pPr algn="r">
+              <a:buNone/>
+              <a:defRPr sz="825" b="0">
+                <a:solidFill>
+                  <a:srgbClr val="98A2B3"/>
+                </a:solidFill>
+                <a:latin typeface="PingFang SC"/>
+                <a:ea typeface="PingFang SC"/>
+                <a:cs typeface="PingFang SC"/>
+              </a:defRPr>
+            </a:pPr>
+            <a:r>
+              <a:rPr sz="825" b="0">
+                <a:solidFill>
+                  <a:srgbClr val="98A2B3"/>
+                </a:solidFill>
+                <a:latin typeface="PingFang SC"/>
+                <a:ea typeface="PingFang SC"/>
+                <a:cs typeface="PingFang SC"/>
+              </a:rPr>
+              <a:t>03</a:t>
+            </a:r>
+          </a:p>
+        </p:txBody>
+      </p:sp>
+      <p:sp>
+        <p:nvSpPr>
+          <p:cNvPr id="41" name="">
+            <a:extLst xmlns:a="http://schemas.openxmlformats.org/drawingml/2006/main">
+              <a:ext uri="{FF2B5EF4-FFF2-40B4-BE49-F238E27FC236}">
+                <a16:creationId xmlns:a16="http://schemas.microsoft.com/office/drawing/2014/main" id="{A1023466-698E-4D8E-B480-0BE4966D42C1}"/>
               </a:ext>
             </a:extLst>
           </p:cNvPr>
@@ -3609,7 +3372,6 @@
           <a:lstStyle xmlns:a="http://schemas.openxmlformats.org/drawingml/2006/main"/>
           <a:p xmlns:a="http://schemas.openxmlformats.org/drawingml/2006/main">
             <a:pPr algn="ctr">
-              <a:buNone/>
               <a:defRPr sz="1800" b="1">
                 <a:solidFill>
                   <a:srgbClr val="FFFFFF"/>
@@ -3628,60 +3390,29 @@
                 <a:ea typeface="PingFang SC"/>
                 <a:cs typeface="PingFang SC"/>
               </a:rPr>
-              <a:t>个人介绍 | 试用期主线</a:t>
+              <a:t>个人介绍</a:t>
             </a:r>
           </a:p>
         </p:txBody>
       </p:sp>
       <p:sp>
         <p:nvSpPr>
-          <p:cNvPr id="8" name="">
-            <a:extLst xmlns:a="http://schemas.openxmlformats.org/drawingml/2006/main">
-              <a:ext uri="{FF2B5EF4-FFF2-40B4-BE49-F238E27FC236}">
-                <a16:creationId xmlns:a16="http://schemas.microsoft.com/office/drawing/2014/main" id="{DB07FD50-B3A6-4640-9CBD-29891EC658F1}"/>
-              </a:ext>
-            </a:extLst>
-          </p:cNvPr>
-          <p:cNvSpPr>
-            <a:spLocks xmlns:a="http://schemas.openxmlformats.org/drawingml/2006/main" noGrp="1"/>
-          </p:cNvSpPr>
-          <p:nvPr/>
-        </p:nvSpPr>
-        <p:spPr>
-          <a:xfrm xmlns:a="http://schemas.openxmlformats.org/drawingml/2006/main">
-            <a:off x="495300" y="1066800"/>
-            <a:ext cx="11049000" cy="28575"/>
-          </a:xfrm>
-          <a:prstGeom xmlns:a="http://schemas.openxmlformats.org/drawingml/2006/main" prst="rect">
-            <a:avLst/>
-          </a:prstGeom>
-          <a:solidFill xmlns:a="http://schemas.openxmlformats.org/drawingml/2006/main">
-            <a:srgbClr val="635BFF"/>
-          </a:solidFill>
-          <a:ln xmlns:a="http://schemas.openxmlformats.org/drawingml/2006/main" w="0">
-            <a:noFill/>
-            <a:prstDash val="solid"/>
-          </a:ln>
-        </p:spPr>
-      </p:sp>
-      <p:sp>
-        <p:nvSpPr>
-          <p:cNvPr id="9" name="">
-            <a:extLst xmlns:a="http://schemas.openxmlformats.org/drawingml/2006/main">
-              <a:ext uri="{FF2B5EF4-FFF2-40B4-BE49-F238E27FC236}">
-                <a16:creationId xmlns:a16="http://schemas.microsoft.com/office/drawing/2014/main" id="{A389899D-CAE4-41B5-90FE-6FA173A33AF3}"/>
-              </a:ext>
-            </a:extLst>
-          </p:cNvPr>
-          <p:cNvSpPr>
-            <a:spLocks xmlns:a="http://schemas.openxmlformats.org/drawingml/2006/main" noGrp="1"/>
-          </p:cNvSpPr>
-          <p:nvPr/>
-        </p:nvSpPr>
-        <p:spPr>
-          <a:xfrm xmlns:a="http://schemas.openxmlformats.org/drawingml/2006/main">
-            <a:off x="11125200" y="6515100"/>
-            <a:ext cx="400050" cy="152400"/>
+          <p:cNvPr id="42" name="">
+            <a:extLst xmlns:a="http://schemas.openxmlformats.org/drawingml/2006/main">
+              <a:ext uri="{FF2B5EF4-FFF2-40B4-BE49-F238E27FC236}">
+                <a16:creationId xmlns:a16="http://schemas.microsoft.com/office/drawing/2014/main" id="{A0351797-41D0-4822-B260-EDC3D693B7A7}"/>
+              </a:ext>
+            </a:extLst>
+          </p:cNvPr>
+          <p:cNvSpPr>
+            <a:spLocks xmlns:a="http://schemas.openxmlformats.org/drawingml/2006/main" noGrp="1"/>
+          </p:cNvSpPr>
+          <p:nvPr/>
+        </p:nvSpPr>
+        <p:spPr>
+          <a:xfrm xmlns:a="http://schemas.openxmlformats.org/drawingml/2006/main">
+            <a:off x="762000" y="1409700"/>
+            <a:ext cx="10668000" cy="457200"/>
           </a:xfrm>
           <a:prstGeom xmlns:a="http://schemas.openxmlformats.org/drawingml/2006/main" prst="rect">
             <a:avLst/>
@@ -3696,64 +3427,7 @@
           <a:bodyPr xmlns:a="http://schemas.openxmlformats.org/drawingml/2006/main" wrap="square" lIns="0" tIns="0" rIns="0" bIns="0"/>
           <a:lstStyle xmlns:a="http://schemas.openxmlformats.org/drawingml/2006/main"/>
           <a:p xmlns:a="http://schemas.openxmlformats.org/drawingml/2006/main">
-            <a:pPr algn="r">
-              <a:buNone/>
-              <a:defRPr sz="825" b="0">
-                <a:solidFill>
-                  <a:srgbClr val="98A2B3"/>
-                </a:solidFill>
-                <a:latin typeface="PingFang SC"/>
-                <a:ea typeface="PingFang SC"/>
-                <a:cs typeface="PingFang SC"/>
-              </a:defRPr>
-            </a:pPr>
-            <a:r>
-              <a:rPr sz="825" b="0">
-                <a:solidFill>
-                  <a:srgbClr val="98A2B3"/>
-                </a:solidFill>
-                <a:latin typeface="PingFang SC"/>
-                <a:ea typeface="PingFang SC"/>
-                <a:cs typeface="PingFang SC"/>
-              </a:rPr>
-              <a:t>03</a:t>
-            </a:r>
-          </a:p>
-        </p:txBody>
-      </p:sp>
-      <p:sp>
-        <p:nvSpPr>
-          <p:cNvPr id="37" name="">
-            <a:extLst xmlns:a="http://schemas.openxmlformats.org/drawingml/2006/main">
-              <a:ext uri="{FF2B5EF4-FFF2-40B4-BE49-F238E27FC236}">
-                <a16:creationId xmlns:a16="http://schemas.microsoft.com/office/drawing/2014/main" id="{814C5BA9-84BE-486D-8C64-C5D97D7BEB2E}"/>
-              </a:ext>
-            </a:extLst>
-          </p:cNvPr>
-          <p:cNvSpPr>
-            <a:spLocks xmlns:a="http://schemas.openxmlformats.org/drawingml/2006/main" noGrp="1"/>
-          </p:cNvSpPr>
-          <p:nvPr/>
-        </p:nvSpPr>
-        <p:spPr>
-          <a:xfrm xmlns:a="http://schemas.openxmlformats.org/drawingml/2006/main">
-            <a:off x="838200" y="1447800"/>
-            <a:ext cx="3714750" cy="514350"/>
-          </a:xfrm>
-          <a:prstGeom xmlns:a="http://schemas.openxmlformats.org/drawingml/2006/main" prst="rect">
-            <a:avLst/>
-          </a:prstGeom>
-          <a:noFill xmlns:a="http://schemas.openxmlformats.org/drawingml/2006/main"/>
-          <a:ln xmlns:a="http://schemas.openxmlformats.org/drawingml/2006/main" w="0">
-            <a:noFill/>
-            <a:prstDash val="solid"/>
-          </a:ln>
-        </p:spPr>
-        <p:txBody>
-          <a:bodyPr xmlns:a="http://schemas.openxmlformats.org/drawingml/2006/main" wrap="square" lIns="0" tIns="0" rIns="0" bIns="0"/>
-          <a:lstStyle xmlns:a="http://schemas.openxmlformats.org/drawingml/2006/main"/>
-          <a:p xmlns:a="http://schemas.openxmlformats.org/drawingml/2006/main">
-            <a:pPr>
+            <a:pPr algn="ctr">
               <a:defRPr sz="2700" b="1">
                 <a:solidFill>
                   <a:srgbClr val="635BFF"/>
@@ -3779,21 +3453,21 @@
       </p:sp>
       <p:sp>
         <p:nvSpPr>
-          <p:cNvPr id="38" name="">
-            <a:extLst xmlns:a="http://schemas.openxmlformats.org/drawingml/2006/main">
-              <a:ext uri="{FF2B5EF4-FFF2-40B4-BE49-F238E27FC236}">
-                <a16:creationId xmlns:a16="http://schemas.microsoft.com/office/drawing/2014/main" id="{84F40CC5-E753-481F-AC45-9EA405067F51}"/>
-              </a:ext>
-            </a:extLst>
-          </p:cNvPr>
-          <p:cNvSpPr>
-            <a:spLocks xmlns:a="http://schemas.openxmlformats.org/drawingml/2006/main" noGrp="1"/>
-          </p:cNvSpPr>
-          <p:nvPr/>
-        </p:nvSpPr>
-        <p:spPr>
-          <a:xfrm xmlns:a="http://schemas.openxmlformats.org/drawingml/2006/main">
-            <a:off x="876300" y="2095500"/>
+          <p:cNvPr id="43" name="">
+            <a:extLst xmlns:a="http://schemas.openxmlformats.org/drawingml/2006/main">
+              <a:ext uri="{FF2B5EF4-FFF2-40B4-BE49-F238E27FC236}">
+                <a16:creationId xmlns:a16="http://schemas.microsoft.com/office/drawing/2014/main" id="{C3CBE01C-4959-4D93-BB84-DE66C122E7C9}"/>
+              </a:ext>
+            </a:extLst>
+          </p:cNvPr>
+          <p:cNvSpPr>
+            <a:spLocks xmlns:a="http://schemas.openxmlformats.org/drawingml/2006/main" noGrp="1"/>
+          </p:cNvSpPr>
+          <p:nvPr/>
+        </p:nvSpPr>
+        <p:spPr>
+          <a:xfrm xmlns:a="http://schemas.openxmlformats.org/drawingml/2006/main">
+            <a:off x="5381625" y="1971675"/>
             <a:ext cx="1428750" cy="38100"/>
           </a:xfrm>
           <a:prstGeom xmlns:a="http://schemas.openxmlformats.org/drawingml/2006/main" prst="rect">
@@ -3810,22 +3484,22 @@
       </p:sp>
       <p:sp>
         <p:nvSpPr>
-          <p:cNvPr id="39" name="">
-            <a:extLst xmlns:a="http://schemas.openxmlformats.org/drawingml/2006/main">
-              <a:ext uri="{FF2B5EF4-FFF2-40B4-BE49-F238E27FC236}">
-                <a16:creationId xmlns:a16="http://schemas.microsoft.com/office/drawing/2014/main" id="{BC6A3154-5B20-498E-9752-810F71A1CEB5}"/>
-              </a:ext>
-            </a:extLst>
-          </p:cNvPr>
-          <p:cNvSpPr>
-            <a:spLocks xmlns:a="http://schemas.openxmlformats.org/drawingml/2006/main" noGrp="1"/>
-          </p:cNvSpPr>
-          <p:nvPr/>
-        </p:nvSpPr>
-        <p:spPr>
-          <a:xfrm xmlns:a="http://schemas.openxmlformats.org/drawingml/2006/main">
-            <a:off x="5314950" y="1428750"/>
-            <a:ext cx="19050" cy="4095750"/>
+          <p:cNvPr id="44" name="">
+            <a:extLst xmlns:a="http://schemas.openxmlformats.org/drawingml/2006/main">
+              <a:ext uri="{FF2B5EF4-FFF2-40B4-BE49-F238E27FC236}">
+                <a16:creationId xmlns:a16="http://schemas.microsoft.com/office/drawing/2014/main" id="{16FCDF10-27E2-4FE3-98FE-AA8E4C8C119C}"/>
+              </a:ext>
+            </a:extLst>
+          </p:cNvPr>
+          <p:cNvSpPr>
+            <a:spLocks xmlns:a="http://schemas.openxmlformats.org/drawingml/2006/main" noGrp="1"/>
+          </p:cNvSpPr>
+          <p:nvPr/>
+        </p:nvSpPr>
+        <p:spPr>
+          <a:xfrm xmlns:a="http://schemas.openxmlformats.org/drawingml/2006/main">
+            <a:off x="3714750" y="2266950"/>
+            <a:ext cx="19050" cy="3124200"/>
           </a:xfrm>
           <a:prstGeom xmlns:a="http://schemas.openxmlformats.org/drawingml/2006/main" prst="rect">
             <a:avLst/>
@@ -3841,22 +3515,22 @@
       </p:sp>
       <p:sp>
         <p:nvSpPr>
-          <p:cNvPr id="40" name="">
-            <a:extLst xmlns:a="http://schemas.openxmlformats.org/drawingml/2006/main">
-              <a:ext uri="{FF2B5EF4-FFF2-40B4-BE49-F238E27FC236}">
-                <a16:creationId xmlns:a16="http://schemas.microsoft.com/office/drawing/2014/main" id="{89DF0C6B-6F78-420E-98A7-D87821A6A26F}"/>
-              </a:ext>
-            </a:extLst>
-          </p:cNvPr>
-          <p:cNvSpPr>
-            <a:spLocks xmlns:a="http://schemas.openxmlformats.org/drawingml/2006/main" noGrp="1"/>
-          </p:cNvSpPr>
-          <p:nvPr/>
-        </p:nvSpPr>
-        <p:spPr>
-          <a:xfrm xmlns:a="http://schemas.openxmlformats.org/drawingml/2006/main">
-            <a:off x="5200650" y="1609725"/>
-            <a:ext cx="266700" cy="266700"/>
+          <p:cNvPr id="45" name="">
+            <a:extLst xmlns:a="http://schemas.openxmlformats.org/drawingml/2006/main">
+              <a:ext uri="{FF2B5EF4-FFF2-40B4-BE49-F238E27FC236}">
+                <a16:creationId xmlns:a16="http://schemas.microsoft.com/office/drawing/2014/main" id="{67C1DED1-DA9E-439E-A380-140290D7DE8D}"/>
+              </a:ext>
+            </a:extLst>
+          </p:cNvPr>
+          <p:cNvSpPr>
+            <a:spLocks xmlns:a="http://schemas.openxmlformats.org/drawingml/2006/main" noGrp="1"/>
+          </p:cNvSpPr>
+          <p:nvPr/>
+        </p:nvSpPr>
+        <p:spPr>
+          <a:xfrm xmlns:a="http://schemas.openxmlformats.org/drawingml/2006/main">
+            <a:off x="3581400" y="2409825"/>
+            <a:ext cx="285750" cy="285750"/>
           </a:xfrm>
           <a:prstGeom xmlns:a="http://schemas.openxmlformats.org/drawingml/2006/main" prst="ellipse">
             <a:avLst/>
@@ -3874,22 +3548,22 @@
       </p:sp>
       <p:sp>
         <p:nvSpPr>
-          <p:cNvPr id="41" name="">
-            <a:extLst xmlns:a="http://schemas.openxmlformats.org/drawingml/2006/main">
-              <a:ext uri="{FF2B5EF4-FFF2-40B4-BE49-F238E27FC236}">
-                <a16:creationId xmlns:a16="http://schemas.microsoft.com/office/drawing/2014/main" id="{CDB9A9F9-1499-4DD7-8F83-4AB60E3E2585}"/>
-              </a:ext>
-            </a:extLst>
-          </p:cNvPr>
-          <p:cNvSpPr>
-            <a:spLocks xmlns:a="http://schemas.openxmlformats.org/drawingml/2006/main" noGrp="1"/>
-          </p:cNvSpPr>
-          <p:nvPr/>
-        </p:nvSpPr>
-        <p:spPr>
-          <a:xfrm xmlns:a="http://schemas.openxmlformats.org/drawingml/2006/main">
-            <a:off x="5924550" y="1543050"/>
-            <a:ext cx="2190750" cy="285750"/>
+          <p:cNvPr id="46" name="">
+            <a:extLst xmlns:a="http://schemas.openxmlformats.org/drawingml/2006/main">
+              <a:ext uri="{FF2B5EF4-FFF2-40B4-BE49-F238E27FC236}">
+                <a16:creationId xmlns:a16="http://schemas.microsoft.com/office/drawing/2014/main" id="{1657BEFA-D647-48D3-8FC7-FADF8619087E}"/>
+              </a:ext>
+            </a:extLst>
+          </p:cNvPr>
+          <p:cNvSpPr>
+            <a:spLocks xmlns:a="http://schemas.openxmlformats.org/drawingml/2006/main" noGrp="1"/>
+          </p:cNvSpPr>
+          <p:nvPr/>
+        </p:nvSpPr>
+        <p:spPr>
+          <a:xfrm xmlns:a="http://schemas.openxmlformats.org/drawingml/2006/main">
+            <a:off x="4381500" y="2352675"/>
+            <a:ext cx="1952625" cy="323850"/>
           </a:xfrm>
           <a:prstGeom xmlns:a="http://schemas.openxmlformats.org/drawingml/2006/main" prst="rect">
             <a:avLst/>
@@ -3905,7 +3579,7 @@
           <a:lstStyle xmlns:a="http://schemas.openxmlformats.org/drawingml/2006/main"/>
           <a:p xmlns:a="http://schemas.openxmlformats.org/drawingml/2006/main">
             <a:pPr>
-              <a:defRPr sz="1650" b="1">
+              <a:defRPr sz="1500" b="0">
                 <a:solidFill>
                   <a:srgbClr val="111827"/>
                 </a:solidFill>
@@ -3915,7 +3589,7 @@
               </a:defRPr>
             </a:pPr>
             <a:r>
-              <a:rPr sz="1650" b="1">
+              <a:rPr sz="1500" b="0">
                 <a:solidFill>
                   <a:srgbClr val="111827"/>
                 </a:solidFill>
@@ -3923,29 +3597,29 @@
                 <a:ea typeface="PingFang SC"/>
                 <a:cs typeface="PingFang SC"/>
               </a:rPr>
-              <a:t>2018.09 - 2024.06</a:t>
+              <a:t>2018.09–2024.06</a:t>
             </a:r>
           </a:p>
         </p:txBody>
       </p:sp>
       <p:sp>
         <p:nvSpPr>
-          <p:cNvPr id="42" name="">
-            <a:extLst xmlns:a="http://schemas.openxmlformats.org/drawingml/2006/main">
-              <a:ext uri="{FF2B5EF4-FFF2-40B4-BE49-F238E27FC236}">
-                <a16:creationId xmlns:a16="http://schemas.microsoft.com/office/drawing/2014/main" id="{42EA3C47-2DCF-41A5-89DF-A678910B274A}"/>
-              </a:ext>
-            </a:extLst>
-          </p:cNvPr>
-          <p:cNvSpPr>
-            <a:spLocks xmlns:a="http://schemas.openxmlformats.org/drawingml/2006/main" noGrp="1"/>
-          </p:cNvSpPr>
-          <p:nvPr/>
-        </p:nvSpPr>
-        <p:spPr>
-          <a:xfrm xmlns:a="http://schemas.openxmlformats.org/drawingml/2006/main">
-            <a:off x="8305800" y="1562100"/>
-            <a:ext cx="3105150" cy="514350"/>
+          <p:cNvPr id="47" name="">
+            <a:extLst xmlns:a="http://schemas.openxmlformats.org/drawingml/2006/main">
+              <a:ext uri="{FF2B5EF4-FFF2-40B4-BE49-F238E27FC236}">
+                <a16:creationId xmlns:a16="http://schemas.microsoft.com/office/drawing/2014/main" id="{0E1753D8-0EB7-4156-B4E4-74B0A3C9970C}"/>
+              </a:ext>
+            </a:extLst>
+          </p:cNvPr>
+          <p:cNvSpPr>
+            <a:spLocks xmlns:a="http://schemas.openxmlformats.org/drawingml/2006/main" noGrp="1"/>
+          </p:cNvSpPr>
+          <p:nvPr/>
+        </p:nvSpPr>
+        <p:spPr>
+          <a:xfrm xmlns:a="http://schemas.openxmlformats.org/drawingml/2006/main">
+            <a:off x="6572250" y="2295525"/>
+            <a:ext cx="5143500" cy="228600"/>
           </a:xfrm>
           <a:prstGeom xmlns:a="http://schemas.openxmlformats.org/drawingml/2006/main" prst="rect">
             <a:avLst/>
@@ -3963,7 +3637,7 @@
             <a:pPr>
               <a:defRPr sz="1350" b="0">
                 <a:solidFill>
-                  <a:srgbClr val="344054"/>
+                  <a:srgbClr val="111827"/>
                 </a:solidFill>
                 <a:latin typeface="PingFang SC"/>
                 <a:ea typeface="PingFang SC"/>
@@ -3973,35 +3647,91 @@
             <a:r>
               <a:rPr sz="1350" b="0">
                 <a:solidFill>
-                  <a:srgbClr val="344054"/>
+                  <a:srgbClr val="111827"/>
                 </a:solidFill>
                 <a:latin typeface="PingFang SC"/>
                 <a:ea typeface="PingFang SC"/>
                 <a:cs typeface="PingFang SC"/>
               </a:rPr>
-              <a:t>中国人民大学统计学院（本硕）</a:t>
+              <a:t>中国人民大学统计学院</a:t>
             </a:r>
           </a:p>
         </p:txBody>
       </p:sp>
       <p:sp>
         <p:nvSpPr>
-          <p:cNvPr id="43" name="">
-            <a:extLst xmlns:a="http://schemas.openxmlformats.org/drawingml/2006/main">
-              <a:ext uri="{FF2B5EF4-FFF2-40B4-BE49-F238E27FC236}">
-                <a16:creationId xmlns:a16="http://schemas.microsoft.com/office/drawing/2014/main" id="{84ACDABF-C135-48A1-AB58-B81E9F0712FB}"/>
-              </a:ext>
-            </a:extLst>
-          </p:cNvPr>
-          <p:cNvSpPr>
-            <a:spLocks xmlns:a="http://schemas.openxmlformats.org/drawingml/2006/main" noGrp="1"/>
-          </p:cNvSpPr>
-          <p:nvPr/>
-        </p:nvSpPr>
-        <p:spPr>
-          <a:xfrm xmlns:a="http://schemas.openxmlformats.org/drawingml/2006/main">
-            <a:off x="5200650" y="2581275"/>
-            <a:ext cx="266700" cy="266700"/>
+          <p:cNvPr id="48" name="">
+            <a:extLst xmlns:a="http://schemas.openxmlformats.org/drawingml/2006/main">
+              <a:ext uri="{FF2B5EF4-FFF2-40B4-BE49-F238E27FC236}">
+                <a16:creationId xmlns:a16="http://schemas.microsoft.com/office/drawing/2014/main" id="{1502C1CC-CC54-4D6B-82CF-323C524CFAE4}"/>
+              </a:ext>
+            </a:extLst>
+          </p:cNvPr>
+          <p:cNvSpPr>
+            <a:spLocks xmlns:a="http://schemas.openxmlformats.org/drawingml/2006/main" noGrp="1"/>
+          </p:cNvSpPr>
+          <p:nvPr/>
+        </p:nvSpPr>
+        <p:spPr>
+          <a:xfrm xmlns:a="http://schemas.openxmlformats.org/drawingml/2006/main">
+            <a:off x="6572250" y="2543175"/>
+            <a:ext cx="5143500" cy="228600"/>
+          </a:xfrm>
+          <a:prstGeom xmlns:a="http://schemas.openxmlformats.org/drawingml/2006/main" prst="rect">
+            <a:avLst/>
+          </a:prstGeom>
+          <a:noFill xmlns:a="http://schemas.openxmlformats.org/drawingml/2006/main"/>
+          <a:ln xmlns:a="http://schemas.openxmlformats.org/drawingml/2006/main" w="0">
+            <a:noFill/>
+            <a:prstDash val="solid"/>
+          </a:ln>
+        </p:spPr>
+        <p:txBody>
+          <a:bodyPr xmlns:a="http://schemas.openxmlformats.org/drawingml/2006/main" wrap="square" lIns="0" tIns="0" rIns="0" bIns="0"/>
+          <a:lstStyle xmlns:a="http://schemas.openxmlformats.org/drawingml/2006/main"/>
+          <a:p xmlns:a="http://schemas.openxmlformats.org/drawingml/2006/main">
+            <a:pPr>
+              <a:defRPr sz="1200" b="0">
+                <a:solidFill>
+                  <a:srgbClr val="111827"/>
+                </a:solidFill>
+                <a:latin typeface="PingFang SC"/>
+                <a:ea typeface="PingFang SC"/>
+                <a:cs typeface="PingFang SC"/>
+              </a:defRPr>
+            </a:pPr>
+            <a:r>
+              <a:rPr sz="1200" b="0">
+                <a:solidFill>
+                  <a:srgbClr val="111827"/>
+                </a:solidFill>
+                <a:latin typeface="PingFang SC"/>
+                <a:ea typeface="PingFang SC"/>
+                <a:cs typeface="PingFang SC"/>
+              </a:rPr>
+              <a:t>本硕</a:t>
+            </a:r>
+          </a:p>
+        </p:txBody>
+      </p:sp>
+      <p:sp>
+        <p:nvSpPr>
+          <p:cNvPr id="49" name="">
+            <a:extLst xmlns:a="http://schemas.openxmlformats.org/drawingml/2006/main">
+              <a:ext uri="{FF2B5EF4-FFF2-40B4-BE49-F238E27FC236}">
+                <a16:creationId xmlns:a16="http://schemas.microsoft.com/office/drawing/2014/main" id="{9F2112FD-4523-496B-9F30-8415E67266B9}"/>
+              </a:ext>
+            </a:extLst>
+          </p:cNvPr>
+          <p:cNvSpPr>
+            <a:spLocks xmlns:a="http://schemas.openxmlformats.org/drawingml/2006/main" noGrp="1"/>
+          </p:cNvSpPr>
+          <p:nvPr/>
+        </p:nvSpPr>
+        <p:spPr>
+          <a:xfrm xmlns:a="http://schemas.openxmlformats.org/drawingml/2006/main">
+            <a:off x="3581400" y="3286125"/>
+            <a:ext cx="285750" cy="285750"/>
           </a:xfrm>
           <a:prstGeom xmlns:a="http://schemas.openxmlformats.org/drawingml/2006/main" prst="ellipse">
             <a:avLst/>
@@ -4019,22 +3749,22 @@
       </p:sp>
       <p:sp>
         <p:nvSpPr>
-          <p:cNvPr id="44" name="">
-            <a:extLst xmlns:a="http://schemas.openxmlformats.org/drawingml/2006/main">
-              <a:ext uri="{FF2B5EF4-FFF2-40B4-BE49-F238E27FC236}">
-                <a16:creationId xmlns:a16="http://schemas.microsoft.com/office/drawing/2014/main" id="{6824CDFF-7345-4A5C-B589-0C0A33875A7B}"/>
-              </a:ext>
-            </a:extLst>
-          </p:cNvPr>
-          <p:cNvSpPr>
-            <a:spLocks xmlns:a="http://schemas.openxmlformats.org/drawingml/2006/main" noGrp="1"/>
-          </p:cNvSpPr>
-          <p:nvPr/>
-        </p:nvSpPr>
-        <p:spPr>
-          <a:xfrm xmlns:a="http://schemas.openxmlformats.org/drawingml/2006/main">
-            <a:off x="5924550" y="2514600"/>
-            <a:ext cx="2190750" cy="285750"/>
+          <p:cNvPr id="50" name="">
+            <a:extLst xmlns:a="http://schemas.openxmlformats.org/drawingml/2006/main">
+              <a:ext uri="{FF2B5EF4-FFF2-40B4-BE49-F238E27FC236}">
+                <a16:creationId xmlns:a16="http://schemas.microsoft.com/office/drawing/2014/main" id="{BFE2EA26-404E-4A6A-8AF3-5CF14C22E1F7}"/>
+              </a:ext>
+            </a:extLst>
+          </p:cNvPr>
+          <p:cNvSpPr>
+            <a:spLocks xmlns:a="http://schemas.openxmlformats.org/drawingml/2006/main" noGrp="1"/>
+          </p:cNvSpPr>
+          <p:nvPr/>
+        </p:nvSpPr>
+        <p:spPr>
+          <a:xfrm xmlns:a="http://schemas.openxmlformats.org/drawingml/2006/main">
+            <a:off x="4381500" y="3228975"/>
+            <a:ext cx="1952625" cy="323850"/>
           </a:xfrm>
           <a:prstGeom xmlns:a="http://schemas.openxmlformats.org/drawingml/2006/main" prst="rect">
             <a:avLst/>
@@ -4050,7 +3780,7 @@
           <a:lstStyle xmlns:a="http://schemas.openxmlformats.org/drawingml/2006/main"/>
           <a:p xmlns:a="http://schemas.openxmlformats.org/drawingml/2006/main">
             <a:pPr>
-              <a:defRPr sz="1650" b="1">
+              <a:defRPr sz="1500" b="0">
                 <a:solidFill>
                   <a:srgbClr val="111827"/>
                 </a:solidFill>
@@ -4060,7 +3790,7 @@
               </a:defRPr>
             </a:pPr>
             <a:r>
-              <a:rPr sz="1650" b="1">
+              <a:rPr sz="1500" b="0">
                 <a:solidFill>
                   <a:srgbClr val="111827"/>
                 </a:solidFill>
@@ -4068,29 +3798,29 @@
                 <a:ea typeface="PingFang SC"/>
                 <a:cs typeface="PingFang SC"/>
               </a:rPr>
-              <a:t>2024.07 - 2025.03</a:t>
+              <a:t>2024.07–2025.03</a:t>
             </a:r>
           </a:p>
         </p:txBody>
       </p:sp>
       <p:sp>
         <p:nvSpPr>
-          <p:cNvPr id="45" name="">
-            <a:extLst xmlns:a="http://schemas.openxmlformats.org/drawingml/2006/main">
-              <a:ext uri="{FF2B5EF4-FFF2-40B4-BE49-F238E27FC236}">
-                <a16:creationId xmlns:a16="http://schemas.microsoft.com/office/drawing/2014/main" id="{7073DB66-A41A-48DF-BF97-CB4F9A30A461}"/>
-              </a:ext>
-            </a:extLst>
-          </p:cNvPr>
-          <p:cNvSpPr>
-            <a:spLocks xmlns:a="http://schemas.openxmlformats.org/drawingml/2006/main" noGrp="1"/>
-          </p:cNvSpPr>
-          <p:nvPr/>
-        </p:nvSpPr>
-        <p:spPr>
-          <a:xfrm xmlns:a="http://schemas.openxmlformats.org/drawingml/2006/main">
-            <a:off x="8305800" y="2533650"/>
-            <a:ext cx="3105150" cy="514350"/>
+          <p:cNvPr id="51" name="">
+            <a:extLst xmlns:a="http://schemas.openxmlformats.org/drawingml/2006/main">
+              <a:ext uri="{FF2B5EF4-FFF2-40B4-BE49-F238E27FC236}">
+                <a16:creationId xmlns:a16="http://schemas.microsoft.com/office/drawing/2014/main" id="{0044D3FE-2565-4731-8467-A85C6F2F3BC8}"/>
+              </a:ext>
+            </a:extLst>
+          </p:cNvPr>
+          <p:cNvSpPr>
+            <a:spLocks xmlns:a="http://schemas.openxmlformats.org/drawingml/2006/main" noGrp="1"/>
+          </p:cNvSpPr>
+          <p:nvPr/>
+        </p:nvSpPr>
+        <p:spPr>
+          <a:xfrm xmlns:a="http://schemas.openxmlformats.org/drawingml/2006/main">
+            <a:off x="6572250" y="3171825"/>
+            <a:ext cx="5143500" cy="228600"/>
           </a:xfrm>
           <a:prstGeom xmlns:a="http://schemas.openxmlformats.org/drawingml/2006/main" prst="rect">
             <a:avLst/>
@@ -4108,7 +3838,7 @@
             <a:pPr>
               <a:defRPr sz="1350" b="0">
                 <a:solidFill>
-                  <a:srgbClr val="344054"/>
+                  <a:srgbClr val="111827"/>
                 </a:solidFill>
                 <a:latin typeface="PingFang SC"/>
                 <a:ea typeface="PingFang SC"/>
@@ -4118,20 +3848,198 @@
             <a:r>
               <a:rPr sz="1350" b="0">
                 <a:solidFill>
-                  <a:srgbClr val="344054"/>
+                  <a:srgbClr val="111827"/>
                 </a:solidFill>
                 <a:latin typeface="PingFang SC"/>
                 <a:ea typeface="PingFang SC"/>
                 <a:cs typeface="PingFang SC"/>
               </a:rPr>
-              <a:t>流量支持中心</a:t>
+              <a:t>腾讯广告 —— 流量支持中心</a:t>
             </a:r>
           </a:p>
+        </p:txBody>
+      </p:sp>
+      <p:sp>
+        <p:nvSpPr>
+          <p:cNvPr id="52" name="">
+            <a:extLst xmlns:a="http://schemas.openxmlformats.org/drawingml/2006/main">
+              <a:ext uri="{FF2B5EF4-FFF2-40B4-BE49-F238E27FC236}">
+                <a16:creationId xmlns:a16="http://schemas.microsoft.com/office/drawing/2014/main" id="{A763EF96-49FE-447F-B392-08B1F9CAC01A}"/>
+              </a:ext>
+            </a:extLst>
+          </p:cNvPr>
+          <p:cNvSpPr>
+            <a:spLocks xmlns:a="http://schemas.openxmlformats.org/drawingml/2006/main" noGrp="1"/>
+          </p:cNvSpPr>
+          <p:nvPr/>
+        </p:nvSpPr>
+        <p:spPr>
+          <a:xfrm xmlns:a="http://schemas.openxmlformats.org/drawingml/2006/main">
+            <a:off x="6572250" y="3419475"/>
+            <a:ext cx="5143500" cy="228600"/>
+          </a:xfrm>
+          <a:prstGeom xmlns:a="http://schemas.openxmlformats.org/drawingml/2006/main" prst="rect">
+            <a:avLst/>
+          </a:prstGeom>
+          <a:noFill xmlns:a="http://schemas.openxmlformats.org/drawingml/2006/main"/>
+          <a:ln xmlns:a="http://schemas.openxmlformats.org/drawingml/2006/main" w="0">
+            <a:noFill/>
+            <a:prstDash val="solid"/>
+          </a:ln>
+        </p:spPr>
+        <p:txBody>
+          <a:bodyPr xmlns:a="http://schemas.openxmlformats.org/drawingml/2006/main" wrap="square" lIns="0" tIns="0" rIns="0" bIns="0"/>
+          <a:lstStyle xmlns:a="http://schemas.openxmlformats.org/drawingml/2006/main"/>
+          <a:p xmlns:a="http://schemas.openxmlformats.org/drawingml/2006/main">
+            <a:pPr>
+              <a:defRPr sz="1200" b="0">
+                <a:solidFill>
+                  <a:srgbClr val="111827"/>
+                </a:solidFill>
+                <a:latin typeface="PingFang SC"/>
+                <a:ea typeface="PingFang SC"/>
+                <a:cs typeface="PingFang SC"/>
+              </a:defRPr>
+            </a:pPr>
+            <a:r>
+              <a:rPr sz="1200" b="0">
+                <a:solidFill>
+                  <a:srgbClr val="111827"/>
+                </a:solidFill>
+                <a:latin typeface="PingFang SC"/>
+                <a:ea typeface="PingFang SC"/>
+                <a:cs typeface="PingFang SC"/>
+              </a:rPr>
+              <a:t>广告业务问题全链路策略优化</a:t>
+            </a:r>
+          </a:p>
+        </p:txBody>
+      </p:sp>
+      <p:sp>
+        <p:nvSpPr>
+          <p:cNvPr id="53" name="">
+            <a:extLst xmlns:a="http://schemas.openxmlformats.org/drawingml/2006/main">
+              <a:ext uri="{FF2B5EF4-FFF2-40B4-BE49-F238E27FC236}">
+                <a16:creationId xmlns:a16="http://schemas.microsoft.com/office/drawing/2014/main" id="{55E838C8-D98F-4A71-AA16-A9AE8487B1FB}"/>
+              </a:ext>
+            </a:extLst>
+          </p:cNvPr>
+          <p:cNvSpPr>
+            <a:spLocks xmlns:a="http://schemas.openxmlformats.org/drawingml/2006/main" noGrp="1"/>
+          </p:cNvSpPr>
+          <p:nvPr/>
+        </p:nvSpPr>
+        <p:spPr>
+          <a:xfrm xmlns:a="http://schemas.openxmlformats.org/drawingml/2006/main">
+            <a:off x="3581400" y="4162425"/>
+            <a:ext cx="285750" cy="285750"/>
+          </a:xfrm>
+          <a:prstGeom xmlns:a="http://schemas.openxmlformats.org/drawingml/2006/main" prst="ellipse">
+            <a:avLst/>
+          </a:prstGeom>
+          <a:solidFill xmlns:a="http://schemas.openxmlformats.org/drawingml/2006/main">
+            <a:srgbClr val="FFFFFF"/>
+          </a:solidFill>
+          <a:ln xmlns:a="http://schemas.openxmlformats.org/drawingml/2006/main" w="28575">
+            <a:solidFill>
+              <a:srgbClr val="00A8FF"/>
+            </a:solidFill>
+            <a:prstDash val="solid"/>
+          </a:ln>
+        </p:spPr>
+      </p:sp>
+      <p:sp>
+        <p:nvSpPr>
+          <p:cNvPr id="54" name="">
+            <a:extLst xmlns:a="http://schemas.openxmlformats.org/drawingml/2006/main">
+              <a:ext uri="{FF2B5EF4-FFF2-40B4-BE49-F238E27FC236}">
+                <a16:creationId xmlns:a16="http://schemas.microsoft.com/office/drawing/2014/main" id="{2E29A591-7341-4027-93BA-89B5B2D262C5}"/>
+              </a:ext>
+            </a:extLst>
+          </p:cNvPr>
+          <p:cNvSpPr>
+            <a:spLocks xmlns:a="http://schemas.openxmlformats.org/drawingml/2006/main" noGrp="1"/>
+          </p:cNvSpPr>
+          <p:nvPr/>
+        </p:nvSpPr>
+        <p:spPr>
+          <a:xfrm xmlns:a="http://schemas.openxmlformats.org/drawingml/2006/main">
+            <a:off x="4381500" y="4105275"/>
+            <a:ext cx="1952625" cy="323850"/>
+          </a:xfrm>
+          <a:prstGeom xmlns:a="http://schemas.openxmlformats.org/drawingml/2006/main" prst="rect">
+            <a:avLst/>
+          </a:prstGeom>
+          <a:noFill xmlns:a="http://schemas.openxmlformats.org/drawingml/2006/main"/>
+          <a:ln xmlns:a="http://schemas.openxmlformats.org/drawingml/2006/main" w="0">
+            <a:noFill/>
+            <a:prstDash val="solid"/>
+          </a:ln>
+        </p:spPr>
+        <p:txBody>
+          <a:bodyPr xmlns:a="http://schemas.openxmlformats.org/drawingml/2006/main" wrap="square" lIns="0" tIns="0" rIns="0" bIns="0"/>
+          <a:lstStyle xmlns:a="http://schemas.openxmlformats.org/drawingml/2006/main"/>
+          <a:p xmlns:a="http://schemas.openxmlformats.org/drawingml/2006/main">
+            <a:pPr>
+              <a:defRPr sz="1500" b="0">
+                <a:solidFill>
+                  <a:srgbClr val="111827"/>
+                </a:solidFill>
+                <a:latin typeface="PingFang SC"/>
+                <a:ea typeface="PingFang SC"/>
+                <a:cs typeface="PingFang SC"/>
+              </a:defRPr>
+            </a:pPr>
+            <a:r>
+              <a:rPr sz="1500" b="0">
+                <a:solidFill>
+                  <a:srgbClr val="111827"/>
+                </a:solidFill>
+                <a:latin typeface="PingFang SC"/>
+                <a:ea typeface="PingFang SC"/>
+                <a:cs typeface="PingFang SC"/>
+              </a:rPr>
+              <a:t>2025.04–2026.03</a:t>
+            </a:r>
+          </a:p>
+        </p:txBody>
+      </p:sp>
+      <p:sp>
+        <p:nvSpPr>
+          <p:cNvPr id="55" name="">
+            <a:extLst xmlns:a="http://schemas.openxmlformats.org/drawingml/2006/main">
+              <a:ext uri="{FF2B5EF4-FFF2-40B4-BE49-F238E27FC236}">
+                <a16:creationId xmlns:a16="http://schemas.microsoft.com/office/drawing/2014/main" id="{51CFC09D-15BE-405D-88BE-D6E1EB9A6473}"/>
+              </a:ext>
+            </a:extLst>
+          </p:cNvPr>
+          <p:cNvSpPr>
+            <a:spLocks xmlns:a="http://schemas.openxmlformats.org/drawingml/2006/main" noGrp="1"/>
+          </p:cNvSpPr>
+          <p:nvPr/>
+        </p:nvSpPr>
+        <p:spPr>
+          <a:xfrm xmlns:a="http://schemas.openxmlformats.org/drawingml/2006/main">
+            <a:off x="6572250" y="4048125"/>
+            <a:ext cx="5143500" cy="228600"/>
+          </a:xfrm>
+          <a:prstGeom xmlns:a="http://schemas.openxmlformats.org/drawingml/2006/main" prst="rect">
+            <a:avLst/>
+          </a:prstGeom>
+          <a:noFill xmlns:a="http://schemas.openxmlformats.org/drawingml/2006/main"/>
+          <a:ln xmlns:a="http://schemas.openxmlformats.org/drawingml/2006/main" w="0">
+            <a:noFill/>
+            <a:prstDash val="solid"/>
+          </a:ln>
+        </p:spPr>
+        <p:txBody>
+          <a:bodyPr xmlns:a="http://schemas.openxmlformats.org/drawingml/2006/main" wrap="square" lIns="0" tIns="0" rIns="0" bIns="0"/>
+          <a:lstStyle xmlns:a="http://schemas.openxmlformats.org/drawingml/2006/main"/>
           <a:p xmlns:a="http://schemas.openxmlformats.org/drawingml/2006/main">
             <a:pPr>
               <a:defRPr sz="1350" b="0">
                 <a:solidFill>
-                  <a:srgbClr val="344054"/>
+                  <a:srgbClr val="111827"/>
                 </a:solidFill>
                 <a:latin typeface="PingFang SC"/>
                 <a:ea typeface="PingFang SC"/>
@@ -4141,68 +4049,35 @@
             <a:r>
               <a:rPr sz="1350" b="0">
                 <a:solidFill>
-                  <a:srgbClr val="344054"/>
+                  <a:srgbClr val="111827"/>
                 </a:solidFill>
                 <a:latin typeface="PingFang SC"/>
                 <a:ea typeface="PingFang SC"/>
                 <a:cs typeface="PingFang SC"/>
               </a:rPr>
-              <a:t>广告业务问题全链路策略优化</a:t>
+              <a:t>腾讯广告 —— AI 推荐中心</a:t>
             </a:r>
           </a:p>
         </p:txBody>
       </p:sp>
       <p:sp>
         <p:nvSpPr>
-          <p:cNvPr id="46" name="">
-            <a:extLst xmlns:a="http://schemas.openxmlformats.org/drawingml/2006/main">
-              <a:ext uri="{FF2B5EF4-FFF2-40B4-BE49-F238E27FC236}">
-                <a16:creationId xmlns:a16="http://schemas.microsoft.com/office/drawing/2014/main" id="{917490B6-F907-46C0-BC0B-673757CB742E}"/>
-              </a:ext>
-            </a:extLst>
-          </p:cNvPr>
-          <p:cNvSpPr>
-            <a:spLocks xmlns:a="http://schemas.openxmlformats.org/drawingml/2006/main" noGrp="1"/>
-          </p:cNvSpPr>
-          <p:nvPr/>
-        </p:nvSpPr>
-        <p:spPr>
-          <a:xfrm xmlns:a="http://schemas.openxmlformats.org/drawingml/2006/main">
-            <a:off x="5200650" y="3552825"/>
-            <a:ext cx="266700" cy="266700"/>
-          </a:xfrm>
-          <a:prstGeom xmlns:a="http://schemas.openxmlformats.org/drawingml/2006/main" prst="ellipse">
-            <a:avLst/>
-          </a:prstGeom>
-          <a:solidFill xmlns:a="http://schemas.openxmlformats.org/drawingml/2006/main">
-            <a:srgbClr val="FFFFFF"/>
-          </a:solidFill>
-          <a:ln xmlns:a="http://schemas.openxmlformats.org/drawingml/2006/main" w="28575">
-            <a:solidFill>
-              <a:srgbClr val="00A8FF"/>
-            </a:solidFill>
-            <a:prstDash val="solid"/>
-          </a:ln>
-        </p:spPr>
-      </p:sp>
-      <p:sp>
-        <p:nvSpPr>
-          <p:cNvPr id="47" name="">
-            <a:extLst xmlns:a="http://schemas.openxmlformats.org/drawingml/2006/main">
-              <a:ext uri="{FF2B5EF4-FFF2-40B4-BE49-F238E27FC236}">
-                <a16:creationId xmlns:a16="http://schemas.microsoft.com/office/drawing/2014/main" id="{2B712186-BBB3-4C9B-88CC-888979026DCE}"/>
-              </a:ext>
-            </a:extLst>
-          </p:cNvPr>
-          <p:cNvSpPr>
-            <a:spLocks xmlns:a="http://schemas.openxmlformats.org/drawingml/2006/main" noGrp="1"/>
-          </p:cNvSpPr>
-          <p:nvPr/>
-        </p:nvSpPr>
-        <p:spPr>
-          <a:xfrm xmlns:a="http://schemas.openxmlformats.org/drawingml/2006/main">
-            <a:off x="5924550" y="3486150"/>
-            <a:ext cx="2190750" cy="285750"/>
+          <p:cNvPr id="56" name="">
+            <a:extLst xmlns:a="http://schemas.openxmlformats.org/drawingml/2006/main">
+              <a:ext uri="{FF2B5EF4-FFF2-40B4-BE49-F238E27FC236}">
+                <a16:creationId xmlns:a16="http://schemas.microsoft.com/office/drawing/2014/main" id="{07CFF037-300E-4D43-84BD-757894EC01EA}"/>
+              </a:ext>
+            </a:extLst>
+          </p:cNvPr>
+          <p:cNvSpPr>
+            <a:spLocks xmlns:a="http://schemas.openxmlformats.org/drawingml/2006/main" noGrp="1"/>
+          </p:cNvSpPr>
+          <p:nvPr/>
+        </p:nvSpPr>
+        <p:spPr>
+          <a:xfrm xmlns:a="http://schemas.openxmlformats.org/drawingml/2006/main">
+            <a:off x="6572250" y="4295775"/>
+            <a:ext cx="5143500" cy="228600"/>
           </a:xfrm>
           <a:prstGeom xmlns:a="http://schemas.openxmlformats.org/drawingml/2006/main" prst="rect">
             <a:avLst/>
@@ -4218,7 +4093,7 @@
           <a:lstStyle xmlns:a="http://schemas.openxmlformats.org/drawingml/2006/main"/>
           <a:p xmlns:a="http://schemas.openxmlformats.org/drawingml/2006/main">
             <a:pPr>
-              <a:defRPr sz="1650" b="1">
+              <a:defRPr sz="1200" b="0">
                 <a:solidFill>
                   <a:srgbClr val="111827"/>
                 </a:solidFill>
@@ -4228,7 +4103,7 @@
               </a:defRPr>
             </a:pPr>
             <a:r>
-              <a:rPr sz="1650" b="1">
+              <a:rPr sz="1200" b="0">
                 <a:solidFill>
                   <a:srgbClr val="111827"/>
                 </a:solidFill>
@@ -4236,29 +4111,118 @@
                 <a:ea typeface="PingFang SC"/>
                 <a:cs typeface="PingFang SC"/>
               </a:rPr>
-              <a:t>2025.04 - 2026.03</a:t>
+              <a:t>生成式推荐与大模型广告落地</a:t>
             </a:r>
           </a:p>
         </p:txBody>
       </p:sp>
       <p:sp>
         <p:nvSpPr>
-          <p:cNvPr id="48" name="">
-            <a:extLst xmlns:a="http://schemas.openxmlformats.org/drawingml/2006/main">
-              <a:ext uri="{FF2B5EF4-FFF2-40B4-BE49-F238E27FC236}">
-                <a16:creationId xmlns:a16="http://schemas.microsoft.com/office/drawing/2014/main" id="{FA79A19D-E9E0-4A00-B79D-99C5D3905B65}"/>
-              </a:ext>
-            </a:extLst>
-          </p:cNvPr>
-          <p:cNvSpPr>
-            <a:spLocks xmlns:a="http://schemas.openxmlformats.org/drawingml/2006/main" noGrp="1"/>
-          </p:cNvSpPr>
-          <p:nvPr/>
-        </p:nvSpPr>
-        <p:spPr>
-          <a:xfrm xmlns:a="http://schemas.openxmlformats.org/drawingml/2006/main">
-            <a:off x="8305800" y="3505200"/>
-            <a:ext cx="3105150" cy="514350"/>
+          <p:cNvPr id="57" name="">
+            <a:extLst xmlns:a="http://schemas.openxmlformats.org/drawingml/2006/main">
+              <a:ext uri="{FF2B5EF4-FFF2-40B4-BE49-F238E27FC236}">
+                <a16:creationId xmlns:a16="http://schemas.microsoft.com/office/drawing/2014/main" id="{7D33130E-7117-483C-B5E4-AF1BE2E7B001}"/>
+              </a:ext>
+            </a:extLst>
+          </p:cNvPr>
+          <p:cNvSpPr>
+            <a:spLocks xmlns:a="http://schemas.openxmlformats.org/drawingml/2006/main" noGrp="1"/>
+          </p:cNvSpPr>
+          <p:nvPr/>
+        </p:nvSpPr>
+        <p:spPr>
+          <a:xfrm xmlns:a="http://schemas.openxmlformats.org/drawingml/2006/main">
+            <a:off x="3581400" y="5038725"/>
+            <a:ext cx="285750" cy="285750"/>
+          </a:xfrm>
+          <a:prstGeom xmlns:a="http://schemas.openxmlformats.org/drawingml/2006/main" prst="ellipse">
+            <a:avLst/>
+          </a:prstGeom>
+          <a:solidFill xmlns:a="http://schemas.openxmlformats.org/drawingml/2006/main">
+            <a:srgbClr val="635BFF"/>
+          </a:solidFill>
+          <a:ln xmlns:a="http://schemas.openxmlformats.org/drawingml/2006/main" w="28575">
+            <a:solidFill>
+              <a:srgbClr val="635BFF"/>
+            </a:solidFill>
+            <a:prstDash val="solid"/>
+          </a:ln>
+        </p:spPr>
+      </p:sp>
+      <p:sp>
+        <p:nvSpPr>
+          <p:cNvPr id="58" name="">
+            <a:extLst xmlns:a="http://schemas.openxmlformats.org/drawingml/2006/main">
+              <a:ext uri="{FF2B5EF4-FFF2-40B4-BE49-F238E27FC236}">
+                <a16:creationId xmlns:a16="http://schemas.microsoft.com/office/drawing/2014/main" id="{1CB8619E-77D9-4252-9ED8-F0738F1C50E8}"/>
+              </a:ext>
+            </a:extLst>
+          </p:cNvPr>
+          <p:cNvSpPr>
+            <a:spLocks xmlns:a="http://schemas.openxmlformats.org/drawingml/2006/main" noGrp="1"/>
+          </p:cNvSpPr>
+          <p:nvPr/>
+        </p:nvSpPr>
+        <p:spPr>
+          <a:xfrm xmlns:a="http://schemas.openxmlformats.org/drawingml/2006/main">
+            <a:off x="4381500" y="4981575"/>
+            <a:ext cx="1952625" cy="323850"/>
+          </a:xfrm>
+          <a:prstGeom xmlns:a="http://schemas.openxmlformats.org/drawingml/2006/main" prst="rect">
+            <a:avLst/>
+          </a:prstGeom>
+          <a:noFill xmlns:a="http://schemas.openxmlformats.org/drawingml/2006/main"/>
+          <a:ln xmlns:a="http://schemas.openxmlformats.org/drawingml/2006/main" w="0">
+            <a:noFill/>
+            <a:prstDash val="solid"/>
+          </a:ln>
+        </p:spPr>
+        <p:txBody>
+          <a:bodyPr xmlns:a="http://schemas.openxmlformats.org/drawingml/2006/main" wrap="square" lIns="0" tIns="0" rIns="0" bIns="0"/>
+          <a:lstStyle xmlns:a="http://schemas.openxmlformats.org/drawingml/2006/main"/>
+          <a:p xmlns:a="http://schemas.openxmlformats.org/drawingml/2006/main">
+            <a:pPr>
+              <a:defRPr sz="1500" b="0">
+                <a:solidFill>
+                  <a:srgbClr val="111827"/>
+                </a:solidFill>
+                <a:latin typeface="PingFang SC"/>
+                <a:ea typeface="PingFang SC"/>
+                <a:cs typeface="PingFang SC"/>
+              </a:defRPr>
+            </a:pPr>
+            <a:r>
+              <a:rPr sz="1500" b="0">
+                <a:solidFill>
+                  <a:srgbClr val="111827"/>
+                </a:solidFill>
+                <a:latin typeface="PingFang SC"/>
+                <a:ea typeface="PingFang SC"/>
+                <a:cs typeface="PingFang SC"/>
+              </a:rPr>
+              <a:t>2026.04–至今</a:t>
+            </a:r>
+          </a:p>
+        </p:txBody>
+      </p:sp>
+      <p:sp>
+        <p:nvSpPr>
+          <p:cNvPr id="59" name="">
+            <a:extLst xmlns:a="http://schemas.openxmlformats.org/drawingml/2006/main">
+              <a:ext uri="{FF2B5EF4-FFF2-40B4-BE49-F238E27FC236}">
+                <a16:creationId xmlns:a16="http://schemas.microsoft.com/office/drawing/2014/main" id="{4B2F3051-464A-41BC-BA21-36043F48FD72}"/>
+              </a:ext>
+            </a:extLst>
+          </p:cNvPr>
+          <p:cNvSpPr>
+            <a:spLocks xmlns:a="http://schemas.openxmlformats.org/drawingml/2006/main" noGrp="1"/>
+          </p:cNvSpPr>
+          <p:nvPr/>
+        </p:nvSpPr>
+        <p:spPr>
+          <a:xfrm xmlns:a="http://schemas.openxmlformats.org/drawingml/2006/main">
+            <a:off x="6572250" y="4924425"/>
+            <a:ext cx="5143500" cy="228600"/>
           </a:xfrm>
           <a:prstGeom xmlns:a="http://schemas.openxmlformats.org/drawingml/2006/main" prst="rect">
             <a:avLst/>
@@ -4276,7 +4240,7 @@
             <a:pPr>
               <a:defRPr sz="1350" b="0">
                 <a:solidFill>
-                  <a:srgbClr val="344054"/>
+                  <a:srgbClr val="111827"/>
                 </a:solidFill>
                 <a:latin typeface="PingFang SC"/>
                 <a:ea typeface="PingFang SC"/>
@@ -4286,20 +4250,53 @@
             <a:r>
               <a:rPr sz="1350" b="0">
                 <a:solidFill>
-                  <a:srgbClr val="344054"/>
+                  <a:srgbClr val="111827"/>
                 </a:solidFill>
                 <a:latin typeface="PingFang SC"/>
                 <a:ea typeface="PingFang SC"/>
                 <a:cs typeface="PingFang SC"/>
               </a:rPr>
-              <a:t>AI 推荐中心</a:t>
+              <a:t>阿里千问 —— 学习创新</a:t>
             </a:r>
           </a:p>
+        </p:txBody>
+      </p:sp>
+      <p:sp>
+        <p:nvSpPr>
+          <p:cNvPr id="60" name="">
+            <a:extLst xmlns:a="http://schemas.openxmlformats.org/drawingml/2006/main">
+              <a:ext uri="{FF2B5EF4-FFF2-40B4-BE49-F238E27FC236}">
+                <a16:creationId xmlns:a16="http://schemas.microsoft.com/office/drawing/2014/main" id="{CE56EBE5-2B70-44F3-9025-2EE638DB0A1D}"/>
+              </a:ext>
+            </a:extLst>
+          </p:cNvPr>
+          <p:cNvSpPr>
+            <a:spLocks xmlns:a="http://schemas.openxmlformats.org/drawingml/2006/main" noGrp="1"/>
+          </p:cNvSpPr>
+          <p:nvPr/>
+        </p:nvSpPr>
+        <p:spPr>
+          <a:xfrm xmlns:a="http://schemas.openxmlformats.org/drawingml/2006/main">
+            <a:off x="6572250" y="5172075"/>
+            <a:ext cx="5143500" cy="228600"/>
+          </a:xfrm>
+          <a:prstGeom xmlns:a="http://schemas.openxmlformats.org/drawingml/2006/main" prst="rect">
+            <a:avLst/>
+          </a:prstGeom>
+          <a:noFill xmlns:a="http://schemas.openxmlformats.org/drawingml/2006/main"/>
+          <a:ln xmlns:a="http://schemas.openxmlformats.org/drawingml/2006/main" w="0">
+            <a:noFill/>
+            <a:prstDash val="solid"/>
+          </a:ln>
+        </p:spPr>
+        <p:txBody>
+          <a:bodyPr xmlns:a="http://schemas.openxmlformats.org/drawingml/2006/main" wrap="square" lIns="0" tIns="0" rIns="0" bIns="0"/>
+          <a:lstStyle xmlns:a="http://schemas.openxmlformats.org/drawingml/2006/main"/>
           <a:p xmlns:a="http://schemas.openxmlformats.org/drawingml/2006/main">
             <a:pPr>
-              <a:defRPr sz="1350" b="0">
-                <a:solidFill>
-                  <a:srgbClr val="344054"/>
+              <a:defRPr sz="1200" b="0">
+                <a:solidFill>
+                  <a:srgbClr val="111827"/>
                 </a:solidFill>
                 <a:latin typeface="PingFang SC"/>
                 <a:ea typeface="PingFang SC"/>
@@ -4307,177 +4304,9 @@
               </a:defRPr>
             </a:pPr>
             <a:r>
-              <a:rPr sz="1350" b="0">
-                <a:solidFill>
-                  <a:srgbClr val="344054"/>
-                </a:solidFill>
-                <a:latin typeface="PingFang SC"/>
-                <a:ea typeface="PingFang SC"/>
-                <a:cs typeface="PingFang SC"/>
-              </a:rPr>
-              <a:t>生成式推荐与大模型广告落地</a:t>
-            </a:r>
-          </a:p>
-        </p:txBody>
-      </p:sp>
-      <p:sp>
-        <p:nvSpPr>
-          <p:cNvPr id="49" name="">
-            <a:extLst xmlns:a="http://schemas.openxmlformats.org/drawingml/2006/main">
-              <a:ext uri="{FF2B5EF4-FFF2-40B4-BE49-F238E27FC236}">
-                <a16:creationId xmlns:a16="http://schemas.microsoft.com/office/drawing/2014/main" id="{CF320538-8E66-4F8E-99D1-0055A8C481F9}"/>
-              </a:ext>
-            </a:extLst>
-          </p:cNvPr>
-          <p:cNvSpPr>
-            <a:spLocks xmlns:a="http://schemas.openxmlformats.org/drawingml/2006/main" noGrp="1"/>
-          </p:cNvSpPr>
-          <p:nvPr/>
-        </p:nvSpPr>
-        <p:spPr>
-          <a:xfrm xmlns:a="http://schemas.openxmlformats.org/drawingml/2006/main">
-            <a:off x="5200650" y="4524375"/>
-            <a:ext cx="266700" cy="266700"/>
-          </a:xfrm>
-          <a:prstGeom xmlns:a="http://schemas.openxmlformats.org/drawingml/2006/main" prst="ellipse">
-            <a:avLst/>
-          </a:prstGeom>
-          <a:solidFill xmlns:a="http://schemas.openxmlformats.org/drawingml/2006/main">
-            <a:srgbClr val="635BFF"/>
-          </a:solidFill>
-          <a:ln xmlns:a="http://schemas.openxmlformats.org/drawingml/2006/main" w="28575">
-            <a:solidFill>
-              <a:srgbClr val="635BFF"/>
-            </a:solidFill>
-            <a:prstDash val="solid"/>
-          </a:ln>
-        </p:spPr>
-      </p:sp>
-      <p:sp>
-        <p:nvSpPr>
-          <p:cNvPr id="50" name="">
-            <a:extLst xmlns:a="http://schemas.openxmlformats.org/drawingml/2006/main">
-              <a:ext uri="{FF2B5EF4-FFF2-40B4-BE49-F238E27FC236}">
-                <a16:creationId xmlns:a16="http://schemas.microsoft.com/office/drawing/2014/main" id="{B5E11D51-C814-4388-8AE9-48DE3265B94D}"/>
-              </a:ext>
-            </a:extLst>
-          </p:cNvPr>
-          <p:cNvSpPr>
-            <a:spLocks xmlns:a="http://schemas.openxmlformats.org/drawingml/2006/main" noGrp="1"/>
-          </p:cNvSpPr>
-          <p:nvPr/>
-        </p:nvSpPr>
-        <p:spPr>
-          <a:xfrm xmlns:a="http://schemas.openxmlformats.org/drawingml/2006/main">
-            <a:off x="5924550" y="4457700"/>
-            <a:ext cx="2190750" cy="285750"/>
-          </a:xfrm>
-          <a:prstGeom xmlns:a="http://schemas.openxmlformats.org/drawingml/2006/main" prst="rect">
-            <a:avLst/>
-          </a:prstGeom>
-          <a:noFill xmlns:a="http://schemas.openxmlformats.org/drawingml/2006/main"/>
-          <a:ln xmlns:a="http://schemas.openxmlformats.org/drawingml/2006/main" w="0">
-            <a:noFill/>
-            <a:prstDash val="solid"/>
-          </a:ln>
-        </p:spPr>
-        <p:txBody>
-          <a:bodyPr xmlns:a="http://schemas.openxmlformats.org/drawingml/2006/main" wrap="square" lIns="0" tIns="0" rIns="0" bIns="0"/>
-          <a:lstStyle xmlns:a="http://schemas.openxmlformats.org/drawingml/2006/main"/>
-          <a:p xmlns:a="http://schemas.openxmlformats.org/drawingml/2006/main">
-            <a:pPr>
-              <a:defRPr sz="1650" b="1">
+              <a:rPr sz="1200" b="0">
                 <a:solidFill>
                   <a:srgbClr val="111827"/>
-                </a:solidFill>
-                <a:latin typeface="PingFang SC"/>
-                <a:ea typeface="PingFang SC"/>
-                <a:cs typeface="PingFang SC"/>
-              </a:defRPr>
-            </a:pPr>
-            <a:r>
-              <a:rPr sz="1650" b="1">
-                <a:solidFill>
-                  <a:srgbClr val="111827"/>
-                </a:solidFill>
-                <a:latin typeface="PingFang SC"/>
-                <a:ea typeface="PingFang SC"/>
-                <a:cs typeface="PingFang SC"/>
-              </a:rPr>
-              <a:t>2026.04 - 至今</a:t>
-            </a:r>
-          </a:p>
-        </p:txBody>
-      </p:sp>
-      <p:sp>
-        <p:nvSpPr>
-          <p:cNvPr id="51" name="">
-            <a:extLst xmlns:a="http://schemas.openxmlformats.org/drawingml/2006/main">
-              <a:ext uri="{FF2B5EF4-FFF2-40B4-BE49-F238E27FC236}">
-                <a16:creationId xmlns:a16="http://schemas.microsoft.com/office/drawing/2014/main" id="{378C9982-41BF-42BA-8901-8DD0D7AA15AF}"/>
-              </a:ext>
-            </a:extLst>
-          </p:cNvPr>
-          <p:cNvSpPr>
-            <a:spLocks xmlns:a="http://schemas.openxmlformats.org/drawingml/2006/main" noGrp="1"/>
-          </p:cNvSpPr>
-          <p:nvPr/>
-        </p:nvSpPr>
-        <p:spPr>
-          <a:xfrm xmlns:a="http://schemas.openxmlformats.org/drawingml/2006/main">
-            <a:off x="8305800" y="4476750"/>
-            <a:ext cx="3105150" cy="514350"/>
-          </a:xfrm>
-          <a:prstGeom xmlns:a="http://schemas.openxmlformats.org/drawingml/2006/main" prst="rect">
-            <a:avLst/>
-          </a:prstGeom>
-          <a:noFill xmlns:a="http://schemas.openxmlformats.org/drawingml/2006/main"/>
-          <a:ln xmlns:a="http://schemas.openxmlformats.org/drawingml/2006/main" w="0">
-            <a:noFill/>
-            <a:prstDash val="solid"/>
-          </a:ln>
-        </p:spPr>
-        <p:txBody>
-          <a:bodyPr xmlns:a="http://schemas.openxmlformats.org/drawingml/2006/main" wrap="square" lIns="0" tIns="0" rIns="0" bIns="0"/>
-          <a:lstStyle xmlns:a="http://schemas.openxmlformats.org/drawingml/2006/main"/>
-          <a:p xmlns:a="http://schemas.openxmlformats.org/drawingml/2006/main">
-            <a:pPr>
-              <a:defRPr sz="1350" b="0">
-                <a:solidFill>
-                  <a:srgbClr val="344054"/>
-                </a:solidFill>
-                <a:latin typeface="PingFang SC"/>
-                <a:ea typeface="PingFang SC"/>
-                <a:cs typeface="PingFang SC"/>
-              </a:defRPr>
-            </a:pPr>
-            <a:r>
-              <a:rPr sz="1350" b="0">
-                <a:solidFill>
-                  <a:srgbClr val="344054"/>
-                </a:solidFill>
-                <a:latin typeface="PingFang SC"/>
-                <a:ea typeface="PingFang SC"/>
-                <a:cs typeface="PingFang SC"/>
-              </a:rPr>
-              <a:t>学习创新</a:t>
-            </a:r>
-          </a:p>
-          <a:p xmlns:a="http://schemas.openxmlformats.org/drawingml/2006/main">
-            <a:pPr>
-              <a:defRPr sz="1350" b="0">
-                <a:solidFill>
-                  <a:srgbClr val="344054"/>
-                </a:solidFill>
-                <a:latin typeface="PingFang SC"/>
-                <a:ea typeface="PingFang SC"/>
-                <a:cs typeface="PingFang SC"/>
-              </a:defRPr>
-            </a:pPr>
-            <a:r>
-              <a:rPr sz="1350" b="0">
-                <a:solidFill>
-                  <a:srgbClr val="344054"/>
                 </a:solidFill>
                 <a:latin typeface="PingFang SC"/>
                 <a:ea typeface="PingFang SC"/>
@@ -4490,20 +4319,20 @@
       </p:sp>
       <p:pic>
         <p:nvPicPr>
-          <p:cNvPr id="80" name=""/>
+          <p:cNvPr id="93" name=""/>
           <p:cNvPicPr>
             <a:picLocks xmlns:a="http://schemas.openxmlformats.org/drawingml/2006/main" noChangeAspect="1"/>
           </p:cNvPicPr>
           <p:nvPr/>
         </p:nvPicPr>
         <p:blipFill>
-          <a:blip xmlns:r="http://schemas.openxmlformats.org/officeDocument/2006/relationships" xmlns:a="http://schemas.openxmlformats.org/drawingml/2006/main" r:embed="R301d1e64a9fb410b"/>
+          <a:blip xmlns:r="http://schemas.openxmlformats.org/officeDocument/2006/relationships" xmlns:a="http://schemas.openxmlformats.org/drawingml/2006/main" r:embed="R93d951d38f8a4da8"/>
           <a:stretch xmlns:a="http://schemas.openxmlformats.org/drawingml/2006/main"/>
         </p:blipFill>
         <p:spPr>
           <a:xfrm xmlns:a="http://schemas.openxmlformats.org/drawingml/2006/main">
-            <a:off x="4305300" y="1495425"/>
-            <a:ext cx="476250" cy="476250"/>
+            <a:off x="1962150" y="2257425"/>
+            <a:ext cx="590550" cy="590550"/>
           </a:xfrm>
           <a:prstGeom xmlns:a="http://schemas.openxmlformats.org/drawingml/2006/main" prst="rect">
             <a:avLst/>
@@ -4512,20 +4341,20 @@
       </p:pic>
       <p:pic>
         <p:nvPicPr>
-          <p:cNvPr id="81" name=""/>
+          <p:cNvPr id="94" name=""/>
           <p:cNvPicPr>
             <a:picLocks xmlns:a="http://schemas.openxmlformats.org/drawingml/2006/main" noChangeAspect="1"/>
           </p:cNvPicPr>
           <p:nvPr/>
         </p:nvPicPr>
         <p:blipFill>
-          <a:blip xmlns:r="http://schemas.openxmlformats.org/officeDocument/2006/relationships" xmlns:a="http://schemas.openxmlformats.org/drawingml/2006/main" r:embed="R83eed30112ce4ca3"/>
+          <a:blip xmlns:r="http://schemas.openxmlformats.org/officeDocument/2006/relationships" xmlns:a="http://schemas.openxmlformats.org/drawingml/2006/main" r:embed="R346c5210f21c4048"/>
           <a:stretch xmlns:a="http://schemas.openxmlformats.org/drawingml/2006/main"/>
         </p:blipFill>
         <p:spPr>
           <a:xfrm xmlns:a="http://schemas.openxmlformats.org/drawingml/2006/main">
-            <a:off x="4038600" y="2576647"/>
-            <a:ext cx="1104900" cy="199756"/>
+            <a:off x="1524000" y="3298125"/>
+            <a:ext cx="1447800" cy="261749"/>
           </a:xfrm>
           <a:prstGeom xmlns:a="http://schemas.openxmlformats.org/drawingml/2006/main" prst="rect">
             <a:avLst/>
@@ -4534,20 +4363,20 @@
       </p:pic>
       <p:pic>
         <p:nvPicPr>
-          <p:cNvPr id="82" name=""/>
+          <p:cNvPr id="95" name=""/>
           <p:cNvPicPr>
             <a:picLocks xmlns:a="http://schemas.openxmlformats.org/drawingml/2006/main" noChangeAspect="1"/>
           </p:cNvPicPr>
           <p:nvPr/>
         </p:nvPicPr>
         <p:blipFill>
-          <a:blip xmlns:r="http://schemas.openxmlformats.org/officeDocument/2006/relationships" xmlns:a="http://schemas.openxmlformats.org/drawingml/2006/main" r:embed="Reed608e3120e4a62"/>
+          <a:blip xmlns:r="http://schemas.openxmlformats.org/officeDocument/2006/relationships" xmlns:a="http://schemas.openxmlformats.org/drawingml/2006/main" r:embed="R273df0f17df14780"/>
           <a:stretch xmlns:a="http://schemas.openxmlformats.org/drawingml/2006/main"/>
         </p:blipFill>
         <p:spPr>
           <a:xfrm xmlns:a="http://schemas.openxmlformats.org/drawingml/2006/main">
-            <a:off x="4038600" y="3548197"/>
-            <a:ext cx="1104900" cy="199756"/>
+            <a:off x="1524000" y="4174425"/>
+            <a:ext cx="1447800" cy="261749"/>
           </a:xfrm>
           <a:prstGeom xmlns:a="http://schemas.openxmlformats.org/drawingml/2006/main" prst="rect">
             <a:avLst/>
@@ -4556,20 +4385,20 @@
       </p:pic>
       <p:pic>
         <p:nvPicPr>
-          <p:cNvPr id="83" name=""/>
+          <p:cNvPr id="96" name=""/>
           <p:cNvPicPr>
             <a:picLocks xmlns:a="http://schemas.openxmlformats.org/drawingml/2006/main" noChangeAspect="1"/>
           </p:cNvPicPr>
           <p:nvPr/>
         </p:nvPicPr>
         <p:blipFill>
-          <a:blip xmlns:r="http://schemas.openxmlformats.org/officeDocument/2006/relationships" xmlns:a="http://schemas.openxmlformats.org/drawingml/2006/main" r:embed="Rd80ee0fd27e54093"/>
+          <a:blip xmlns:r="http://schemas.openxmlformats.org/officeDocument/2006/relationships" xmlns:a="http://schemas.openxmlformats.org/drawingml/2006/main" r:embed="R9ec1dd687956481f"/>
           <a:stretch xmlns:a="http://schemas.openxmlformats.org/drawingml/2006/main"/>
         </p:blipFill>
         <p:spPr>
           <a:xfrm xmlns:a="http://schemas.openxmlformats.org/drawingml/2006/main">
-            <a:off x="4095750" y="4468762"/>
-            <a:ext cx="323850" cy="320777"/>
+            <a:off x="2000250" y="4917431"/>
+            <a:ext cx="533400" cy="528338"/>
           </a:xfrm>
           <a:prstGeom xmlns:a="http://schemas.openxmlformats.org/drawingml/2006/main" prst="rect">
             <a:avLst/>

</xml_diff>

<commit_message>
Merge second-round Qwen deck refinements
</commit_message>
<xml_diff>
--- a/output/sections/01-个人介绍.pptx
+++ b/output/sections/01-个人介绍.pptx
@@ -2,15 +2,15 @@
 <file path=ppt/presentation.xml><?xml version="1.0" encoding="utf-8"?>
 <p:presentation xmlns:p="http://schemas.openxmlformats.org/presentationml/2006/main">
   <p:sldMasterIdLst>
-    <p:sldMasterId xmlns:r="http://schemas.openxmlformats.org/officeDocument/2006/relationships" id="2147483648" r:id="Rdd20926b4aa9484f"/>
+    <p:sldMasterId xmlns:r="http://schemas.openxmlformats.org/officeDocument/2006/relationships" id="2147483648" r:id="Rcc2a564f8b3f4014"/>
   </p:sldMasterIdLst>
   <p:notesMasterIdLst>
-    <p:notesMasterId xmlns:r="http://schemas.openxmlformats.org/officeDocument/2006/relationships" r:id="R1596497c5b324018"/>
+    <p:notesMasterId xmlns:r="http://schemas.openxmlformats.org/officeDocument/2006/relationships" r:id="R07266e1986ad4af7"/>
   </p:notesMasterIdLst>
   <p:sldIdLst>
-    <p:sldId xmlns:r="http://schemas.openxmlformats.org/officeDocument/2006/relationships" id="256" r:id="Rd2158651175f4b52"/>
-    <p:sldId xmlns:r="http://schemas.openxmlformats.org/officeDocument/2006/relationships" id="257" r:id="Rea2cd94c2f224b12"/>
-    <p:sldId xmlns:r="http://schemas.openxmlformats.org/officeDocument/2006/relationships" id="258" r:id="R63f08a565b364f0e"/>
+    <p:sldId xmlns:r="http://schemas.openxmlformats.org/officeDocument/2006/relationships" id="256" r:id="Re0d4dded7c1d4175"/>
+    <p:sldId xmlns:r="http://schemas.openxmlformats.org/officeDocument/2006/relationships" id="257" r:id="Rf8ca3fdca0724f41"/>
+    <p:sldId xmlns:r="http://schemas.openxmlformats.org/officeDocument/2006/relationships" id="258" r:id="Rcf665e7e23d946a9"/>
   </p:sldIdLst>
   <p:sldSz cx="12192000" cy="6858000"/>
   <p:notesSz cx="6858000" cy="9144000"/>
@@ -735,7 +735,7 @@
   </p:cSld>
   <p:clrMap bg1="lt1" tx1="dk1" bg2="lt2" tx2="dk2" accent1="accent1" accent2="accent2" accent3="accent3" accent4="accent4" accent5="accent5" accent6="accent6" hlink="hlink" folHlink="folHlink"/>
   <p:sldLayoutIdLst>
-    <p:sldLayoutId xmlns:r="http://schemas.openxmlformats.org/officeDocument/2006/relationships" id="2147483649" r:id="Ra74e77b5766b4738"/>
+    <p:sldLayoutId xmlns:r="http://schemas.openxmlformats.org/officeDocument/2006/relationships" id="2147483649" r:id="R715c7748bb04481d"/>
   </p:sldLayoutIdLst>
   <p:txStyles>
     <p:titleStyle>
@@ -1383,7 +1383,7 @@
           <p:nvPr/>
         </p:nvPicPr>
         <p:blipFill>
-          <a:blip xmlns:r="http://schemas.openxmlformats.org/officeDocument/2006/relationships" xmlns:a="http://schemas.openxmlformats.org/drawingml/2006/main" r:embed="R19f24c5f3df84908"/>
+          <a:blip xmlns:r="http://schemas.openxmlformats.org/officeDocument/2006/relationships" xmlns:a="http://schemas.openxmlformats.org/drawingml/2006/main" r:embed="R812b0349ee8e4ef4"/>
           <a:stretch xmlns:a="http://schemas.openxmlformats.org/drawingml/2006/main"/>
         </p:blipFill>
         <p:spPr>
@@ -1864,7 +1864,7 @@
           <p:nvPr/>
         </p:nvPicPr>
         <p:blipFill>
-          <a:blip xmlns:r="http://schemas.openxmlformats.org/officeDocument/2006/relationships" xmlns:a="http://schemas.openxmlformats.org/drawingml/2006/main" r:embed="Re69a02ad35a14b8e"/>
+          <a:blip xmlns:r="http://schemas.openxmlformats.org/officeDocument/2006/relationships" xmlns:a="http://schemas.openxmlformats.org/drawingml/2006/main" r:embed="Re2f9f196c9924ecc"/>
           <a:stretch xmlns:a="http://schemas.openxmlformats.org/drawingml/2006/main"/>
         </p:blipFill>
         <p:spPr>
@@ -2084,18 +2084,18 @@
           <p:cNvPr id="32" name="">
             <a:extLst xmlns:a="http://schemas.openxmlformats.org/drawingml/2006/main">
               <a:ext uri="{FF2B5EF4-FFF2-40B4-BE49-F238E27FC236}">
-                <a16:creationId xmlns:a16="http://schemas.microsoft.com/office/drawing/2014/main" id="{4BA3AF9A-1137-40C6-A371-240FAEF70D91}"/>
-              </a:ext>
-            </a:extLst>
-          </p:cNvPr>
-          <p:cNvSpPr>
-            <a:spLocks xmlns:a="http://schemas.openxmlformats.org/drawingml/2006/main" noGrp="1"/>
-          </p:cNvSpPr>
-          <p:nvPr/>
-        </p:nvSpPr>
-        <p:spPr>
-          <a:xfrm xmlns:a="http://schemas.openxmlformats.org/drawingml/2006/main">
-            <a:off x="3629025" y="1609725"/>
+                <a16:creationId xmlns:a16="http://schemas.microsoft.com/office/drawing/2014/main" id="{ACE72426-046F-442F-8552-524ECBF9BD9F}"/>
+              </a:ext>
+            </a:extLst>
+          </p:cNvPr>
+          <p:cNvSpPr>
+            <a:spLocks xmlns:a="http://schemas.openxmlformats.org/drawingml/2006/main" noGrp="1"/>
+          </p:cNvSpPr>
+          <p:nvPr/>
+        </p:nvSpPr>
+        <p:spPr>
+          <a:xfrm xmlns:a="http://schemas.openxmlformats.org/drawingml/2006/main">
+            <a:off x="3629025" y="1762125"/>
             <a:ext cx="5581650" cy="476250"/>
           </a:xfrm>
           <a:prstGeom xmlns:a="http://schemas.openxmlformats.org/drawingml/2006/main" prst="rect">
@@ -2115,18 +2115,18 @@
           <p:cNvPr id="33" name="">
             <a:extLst xmlns:a="http://schemas.openxmlformats.org/drawingml/2006/main">
               <a:ext uri="{FF2B5EF4-FFF2-40B4-BE49-F238E27FC236}">
-                <a16:creationId xmlns:a16="http://schemas.microsoft.com/office/drawing/2014/main" id="{4E287C9C-DF45-4534-9220-75113A82B5E0}"/>
-              </a:ext>
-            </a:extLst>
-          </p:cNvPr>
-          <p:cNvSpPr>
-            <a:spLocks xmlns:a="http://schemas.openxmlformats.org/drawingml/2006/main" noGrp="1"/>
-          </p:cNvSpPr>
-          <p:nvPr/>
-        </p:nvSpPr>
-        <p:spPr>
-          <a:xfrm xmlns:a="http://schemas.openxmlformats.org/drawingml/2006/main">
-            <a:off x="2981325" y="1524000"/>
+                <a16:creationId xmlns:a16="http://schemas.microsoft.com/office/drawing/2014/main" id="{79273447-BE47-4805-BB99-FA3AD7FEC9C8}"/>
+              </a:ext>
+            </a:extLst>
+          </p:cNvPr>
+          <p:cNvSpPr>
+            <a:spLocks xmlns:a="http://schemas.openxmlformats.org/drawingml/2006/main" noGrp="1"/>
+          </p:cNvSpPr>
+          <p:nvPr/>
+        </p:nvSpPr>
+        <p:spPr>
+          <a:xfrm xmlns:a="http://schemas.openxmlformats.org/drawingml/2006/main">
+            <a:off x="2981325" y="1676400"/>
             <a:ext cx="647700" cy="647700"/>
           </a:xfrm>
           <a:prstGeom xmlns:a="http://schemas.openxmlformats.org/drawingml/2006/main" prst="ellipse">
@@ -2148,18 +2148,18 @@
           <p:cNvPr id="34" name="">
             <a:extLst xmlns:a="http://schemas.openxmlformats.org/drawingml/2006/main">
               <a:ext uri="{FF2B5EF4-FFF2-40B4-BE49-F238E27FC236}">
-                <a16:creationId xmlns:a16="http://schemas.microsoft.com/office/drawing/2014/main" id="{6BE88EFF-7A66-4924-A406-FA7CCCE097B4}"/>
-              </a:ext>
-            </a:extLst>
-          </p:cNvPr>
-          <p:cNvSpPr>
-            <a:spLocks xmlns:a="http://schemas.openxmlformats.org/drawingml/2006/main" noGrp="1"/>
-          </p:cNvSpPr>
-          <p:nvPr/>
-        </p:nvSpPr>
-        <p:spPr>
-          <a:xfrm xmlns:a="http://schemas.openxmlformats.org/drawingml/2006/main">
-            <a:off x="2981325" y="1647825"/>
+                <a16:creationId xmlns:a16="http://schemas.microsoft.com/office/drawing/2014/main" id="{9B75B555-7AF3-44FA-A108-E2657A2B8689}"/>
+              </a:ext>
+            </a:extLst>
+          </p:cNvPr>
+          <p:cNvSpPr>
+            <a:spLocks xmlns:a="http://schemas.openxmlformats.org/drawingml/2006/main" noGrp="1"/>
+          </p:cNvSpPr>
+          <p:nvPr/>
+        </p:nvSpPr>
+        <p:spPr>
+          <a:xfrm xmlns:a="http://schemas.openxmlformats.org/drawingml/2006/main">
+            <a:off x="2981325" y="1800225"/>
             <a:ext cx="647700" cy="342900"/>
           </a:xfrm>
           <a:prstGeom xmlns:a="http://schemas.openxmlformats.org/drawingml/2006/main" prst="rect">
@@ -2204,18 +2204,18 @@
           <p:cNvPr id="35" name="">
             <a:extLst xmlns:a="http://schemas.openxmlformats.org/drawingml/2006/main">
               <a:ext uri="{FF2B5EF4-FFF2-40B4-BE49-F238E27FC236}">
-                <a16:creationId xmlns:a16="http://schemas.microsoft.com/office/drawing/2014/main" id="{B40601E8-0C4D-4ACA-A449-565DD2C8BACB}"/>
-              </a:ext>
-            </a:extLst>
-          </p:cNvPr>
-          <p:cNvSpPr>
-            <a:spLocks xmlns:a="http://schemas.openxmlformats.org/drawingml/2006/main" noGrp="1"/>
-          </p:cNvSpPr>
-          <p:nvPr/>
-        </p:nvSpPr>
-        <p:spPr>
-          <a:xfrm xmlns:a="http://schemas.openxmlformats.org/drawingml/2006/main">
-            <a:off x="3629025" y="1714500"/>
+                <a16:creationId xmlns:a16="http://schemas.microsoft.com/office/drawing/2014/main" id="{1918D7CE-D888-4DD4-A5E8-CE3EF4098FCC}"/>
+              </a:ext>
+            </a:extLst>
+          </p:cNvPr>
+          <p:cNvSpPr>
+            <a:spLocks xmlns:a="http://schemas.openxmlformats.org/drawingml/2006/main" noGrp="1"/>
+          </p:cNvSpPr>
+          <p:nvPr/>
+        </p:nvSpPr>
+        <p:spPr>
+          <a:xfrm xmlns:a="http://schemas.openxmlformats.org/drawingml/2006/main">
+            <a:off x="3629025" y="1866900"/>
             <a:ext cx="5581650" cy="266700"/>
           </a:xfrm>
           <a:prstGeom xmlns:a="http://schemas.openxmlformats.org/drawingml/2006/main" prst="rect">
@@ -2260,18 +2260,18 @@
           <p:cNvPr id="36" name="">
             <a:extLst xmlns:a="http://schemas.openxmlformats.org/drawingml/2006/main">
               <a:ext uri="{FF2B5EF4-FFF2-40B4-BE49-F238E27FC236}">
-                <a16:creationId xmlns:a16="http://schemas.microsoft.com/office/drawing/2014/main" id="{F6B30F4E-4437-4EB1-800E-EB4A94399E30}"/>
-              </a:ext>
-            </a:extLst>
-          </p:cNvPr>
-          <p:cNvSpPr>
-            <a:spLocks xmlns:a="http://schemas.openxmlformats.org/drawingml/2006/main" noGrp="1"/>
-          </p:cNvSpPr>
-          <p:nvPr/>
-        </p:nvSpPr>
-        <p:spPr>
-          <a:xfrm xmlns:a="http://schemas.openxmlformats.org/drawingml/2006/main">
-            <a:off x="3629025" y="2447925"/>
+                <a16:creationId xmlns:a16="http://schemas.microsoft.com/office/drawing/2014/main" id="{57067804-6BDF-44AA-BD81-AE7E14973EE2}"/>
+              </a:ext>
+            </a:extLst>
+          </p:cNvPr>
+          <p:cNvSpPr>
+            <a:spLocks xmlns:a="http://schemas.openxmlformats.org/drawingml/2006/main" noGrp="1"/>
+          </p:cNvSpPr>
+          <p:nvPr/>
+        </p:nvSpPr>
+        <p:spPr>
+          <a:xfrm xmlns:a="http://schemas.openxmlformats.org/drawingml/2006/main">
+            <a:off x="3629025" y="2600325"/>
             <a:ext cx="5581650" cy="476250"/>
           </a:xfrm>
           <a:prstGeom xmlns:a="http://schemas.openxmlformats.org/drawingml/2006/main" prst="rect">
@@ -2291,18 +2291,18 @@
           <p:cNvPr id="37" name="">
             <a:extLst xmlns:a="http://schemas.openxmlformats.org/drawingml/2006/main">
               <a:ext uri="{FF2B5EF4-FFF2-40B4-BE49-F238E27FC236}">
-                <a16:creationId xmlns:a16="http://schemas.microsoft.com/office/drawing/2014/main" id="{494AC598-E2F8-4953-AFA1-F4C5E31B8087}"/>
-              </a:ext>
-            </a:extLst>
-          </p:cNvPr>
-          <p:cNvSpPr>
-            <a:spLocks xmlns:a="http://schemas.openxmlformats.org/drawingml/2006/main" noGrp="1"/>
-          </p:cNvSpPr>
-          <p:nvPr/>
-        </p:nvSpPr>
-        <p:spPr>
-          <a:xfrm xmlns:a="http://schemas.openxmlformats.org/drawingml/2006/main">
-            <a:off x="2981325" y="2362200"/>
+                <a16:creationId xmlns:a16="http://schemas.microsoft.com/office/drawing/2014/main" id="{1F06FEFA-7EA5-4C3A-B6D9-939DD2B18E77}"/>
+              </a:ext>
+            </a:extLst>
+          </p:cNvPr>
+          <p:cNvSpPr>
+            <a:spLocks xmlns:a="http://schemas.openxmlformats.org/drawingml/2006/main" noGrp="1"/>
+          </p:cNvSpPr>
+          <p:nvPr/>
+        </p:nvSpPr>
+        <p:spPr>
+          <a:xfrm xmlns:a="http://schemas.openxmlformats.org/drawingml/2006/main">
+            <a:off x="2981325" y="2514600"/>
             <a:ext cx="647700" cy="647700"/>
           </a:xfrm>
           <a:prstGeom xmlns:a="http://schemas.openxmlformats.org/drawingml/2006/main" prst="ellipse">
@@ -2324,18 +2324,18 @@
           <p:cNvPr id="38" name="">
             <a:extLst xmlns:a="http://schemas.openxmlformats.org/drawingml/2006/main">
               <a:ext uri="{FF2B5EF4-FFF2-40B4-BE49-F238E27FC236}">
-                <a16:creationId xmlns:a16="http://schemas.microsoft.com/office/drawing/2014/main" id="{52D9C66D-559A-4730-8C32-7E6E6FF807A9}"/>
-              </a:ext>
-            </a:extLst>
-          </p:cNvPr>
-          <p:cNvSpPr>
-            <a:spLocks xmlns:a="http://schemas.openxmlformats.org/drawingml/2006/main" noGrp="1"/>
-          </p:cNvSpPr>
-          <p:nvPr/>
-        </p:nvSpPr>
-        <p:spPr>
-          <a:xfrm xmlns:a="http://schemas.openxmlformats.org/drawingml/2006/main">
-            <a:off x="2981325" y="2486025"/>
+                <a16:creationId xmlns:a16="http://schemas.microsoft.com/office/drawing/2014/main" id="{DA7FB69E-CD70-420D-9169-9E867C51DF5D}"/>
+              </a:ext>
+            </a:extLst>
+          </p:cNvPr>
+          <p:cNvSpPr>
+            <a:spLocks xmlns:a="http://schemas.openxmlformats.org/drawingml/2006/main" noGrp="1"/>
+          </p:cNvSpPr>
+          <p:nvPr/>
+        </p:nvSpPr>
+        <p:spPr>
+          <a:xfrm xmlns:a="http://schemas.openxmlformats.org/drawingml/2006/main">
+            <a:off x="2981325" y="2638425"/>
             <a:ext cx="647700" cy="342900"/>
           </a:xfrm>
           <a:prstGeom xmlns:a="http://schemas.openxmlformats.org/drawingml/2006/main" prst="rect">
@@ -2380,18 +2380,18 @@
           <p:cNvPr id="39" name="">
             <a:extLst xmlns:a="http://schemas.openxmlformats.org/drawingml/2006/main">
               <a:ext uri="{FF2B5EF4-FFF2-40B4-BE49-F238E27FC236}">
-                <a16:creationId xmlns:a16="http://schemas.microsoft.com/office/drawing/2014/main" id="{4AE3B666-C87E-45F8-995B-519D983B55D1}"/>
-              </a:ext>
-            </a:extLst>
-          </p:cNvPr>
-          <p:cNvSpPr>
-            <a:spLocks xmlns:a="http://schemas.openxmlformats.org/drawingml/2006/main" noGrp="1"/>
-          </p:cNvSpPr>
-          <p:nvPr/>
-        </p:nvSpPr>
-        <p:spPr>
-          <a:xfrm xmlns:a="http://schemas.openxmlformats.org/drawingml/2006/main">
-            <a:off x="3629025" y="2552700"/>
+                <a16:creationId xmlns:a16="http://schemas.microsoft.com/office/drawing/2014/main" id="{6F50B901-4D6E-4419-B6C3-5200CEDA13FD}"/>
+              </a:ext>
+            </a:extLst>
+          </p:cNvPr>
+          <p:cNvSpPr>
+            <a:spLocks xmlns:a="http://schemas.openxmlformats.org/drawingml/2006/main" noGrp="1"/>
+          </p:cNvSpPr>
+          <p:nvPr/>
+        </p:nvSpPr>
+        <p:spPr>
+          <a:xfrm xmlns:a="http://schemas.openxmlformats.org/drawingml/2006/main">
+            <a:off x="3629025" y="2705100"/>
             <a:ext cx="5581650" cy="266700"/>
           </a:xfrm>
           <a:prstGeom xmlns:a="http://schemas.openxmlformats.org/drawingml/2006/main" prst="rect">
@@ -2436,18 +2436,18 @@
           <p:cNvPr id="40" name="">
             <a:extLst xmlns:a="http://schemas.openxmlformats.org/drawingml/2006/main">
               <a:ext uri="{FF2B5EF4-FFF2-40B4-BE49-F238E27FC236}">
-                <a16:creationId xmlns:a16="http://schemas.microsoft.com/office/drawing/2014/main" id="{8302A81F-B53C-4CEC-8A88-419956A11F9B}"/>
-              </a:ext>
-            </a:extLst>
-          </p:cNvPr>
-          <p:cNvSpPr>
-            <a:spLocks xmlns:a="http://schemas.openxmlformats.org/drawingml/2006/main" noGrp="1"/>
-          </p:cNvSpPr>
-          <p:nvPr/>
-        </p:nvSpPr>
-        <p:spPr>
-          <a:xfrm xmlns:a="http://schemas.openxmlformats.org/drawingml/2006/main">
-            <a:off x="3629025" y="3286125"/>
+                <a16:creationId xmlns:a16="http://schemas.microsoft.com/office/drawing/2014/main" id="{391B4C53-08C9-462F-A272-C30E586D8B66}"/>
+              </a:ext>
+            </a:extLst>
+          </p:cNvPr>
+          <p:cNvSpPr>
+            <a:spLocks xmlns:a="http://schemas.openxmlformats.org/drawingml/2006/main" noGrp="1"/>
+          </p:cNvSpPr>
+          <p:nvPr/>
+        </p:nvSpPr>
+        <p:spPr>
+          <a:xfrm xmlns:a="http://schemas.openxmlformats.org/drawingml/2006/main">
+            <a:off x="3629025" y="3438525"/>
             <a:ext cx="5581650" cy="476250"/>
           </a:xfrm>
           <a:prstGeom xmlns:a="http://schemas.openxmlformats.org/drawingml/2006/main" prst="rect">
@@ -2467,18 +2467,18 @@
           <p:cNvPr id="41" name="">
             <a:extLst xmlns:a="http://schemas.openxmlformats.org/drawingml/2006/main">
               <a:ext uri="{FF2B5EF4-FFF2-40B4-BE49-F238E27FC236}">
-                <a16:creationId xmlns:a16="http://schemas.microsoft.com/office/drawing/2014/main" id="{90C91A4B-75FA-4AA2-B0D4-51FC0269F0AB}"/>
-              </a:ext>
-            </a:extLst>
-          </p:cNvPr>
-          <p:cNvSpPr>
-            <a:spLocks xmlns:a="http://schemas.openxmlformats.org/drawingml/2006/main" noGrp="1"/>
-          </p:cNvSpPr>
-          <p:nvPr/>
-        </p:nvSpPr>
-        <p:spPr>
-          <a:xfrm xmlns:a="http://schemas.openxmlformats.org/drawingml/2006/main">
-            <a:off x="2981325" y="3200400"/>
+                <a16:creationId xmlns:a16="http://schemas.microsoft.com/office/drawing/2014/main" id="{2BC0C2B5-257E-43D2-9D42-8C46BE862D02}"/>
+              </a:ext>
+            </a:extLst>
+          </p:cNvPr>
+          <p:cNvSpPr>
+            <a:spLocks xmlns:a="http://schemas.openxmlformats.org/drawingml/2006/main" noGrp="1"/>
+          </p:cNvSpPr>
+          <p:nvPr/>
+        </p:nvSpPr>
+        <p:spPr>
+          <a:xfrm xmlns:a="http://schemas.openxmlformats.org/drawingml/2006/main">
+            <a:off x="2981325" y="3352800"/>
             <a:ext cx="647700" cy="647700"/>
           </a:xfrm>
           <a:prstGeom xmlns:a="http://schemas.openxmlformats.org/drawingml/2006/main" prst="ellipse">
@@ -2500,18 +2500,18 @@
           <p:cNvPr id="42" name="">
             <a:extLst xmlns:a="http://schemas.openxmlformats.org/drawingml/2006/main">
               <a:ext uri="{FF2B5EF4-FFF2-40B4-BE49-F238E27FC236}">
-                <a16:creationId xmlns:a16="http://schemas.microsoft.com/office/drawing/2014/main" id="{9B40ECC8-C7E7-4621-8BD7-F0B97DDBFAFB}"/>
-              </a:ext>
-            </a:extLst>
-          </p:cNvPr>
-          <p:cNvSpPr>
-            <a:spLocks xmlns:a="http://schemas.openxmlformats.org/drawingml/2006/main" noGrp="1"/>
-          </p:cNvSpPr>
-          <p:nvPr/>
-        </p:nvSpPr>
-        <p:spPr>
-          <a:xfrm xmlns:a="http://schemas.openxmlformats.org/drawingml/2006/main">
-            <a:off x="2981325" y="3324225"/>
+                <a16:creationId xmlns:a16="http://schemas.microsoft.com/office/drawing/2014/main" id="{87640CED-184A-4A08-9F55-5FC03A2D649C}"/>
+              </a:ext>
+            </a:extLst>
+          </p:cNvPr>
+          <p:cNvSpPr>
+            <a:spLocks xmlns:a="http://schemas.openxmlformats.org/drawingml/2006/main" noGrp="1"/>
+          </p:cNvSpPr>
+          <p:nvPr/>
+        </p:nvSpPr>
+        <p:spPr>
+          <a:xfrm xmlns:a="http://schemas.openxmlformats.org/drawingml/2006/main">
+            <a:off x="2981325" y="3476625"/>
             <a:ext cx="647700" cy="342900"/>
           </a:xfrm>
           <a:prstGeom xmlns:a="http://schemas.openxmlformats.org/drawingml/2006/main" prst="rect">
@@ -2556,18 +2556,18 @@
           <p:cNvPr id="43" name="">
             <a:extLst xmlns:a="http://schemas.openxmlformats.org/drawingml/2006/main">
               <a:ext uri="{FF2B5EF4-FFF2-40B4-BE49-F238E27FC236}">
-                <a16:creationId xmlns:a16="http://schemas.microsoft.com/office/drawing/2014/main" id="{835BCFC6-2638-43CA-87D8-51D82F8F4FED}"/>
-              </a:ext>
-            </a:extLst>
-          </p:cNvPr>
-          <p:cNvSpPr>
-            <a:spLocks xmlns:a="http://schemas.openxmlformats.org/drawingml/2006/main" noGrp="1"/>
-          </p:cNvSpPr>
-          <p:nvPr/>
-        </p:nvSpPr>
-        <p:spPr>
-          <a:xfrm xmlns:a="http://schemas.openxmlformats.org/drawingml/2006/main">
-            <a:off x="3629025" y="3390900"/>
+                <a16:creationId xmlns:a16="http://schemas.microsoft.com/office/drawing/2014/main" id="{69CD02B5-7CE3-461E-A62F-A5999EF7DF51}"/>
+              </a:ext>
+            </a:extLst>
+          </p:cNvPr>
+          <p:cNvSpPr>
+            <a:spLocks xmlns:a="http://schemas.openxmlformats.org/drawingml/2006/main" noGrp="1"/>
+          </p:cNvSpPr>
+          <p:nvPr/>
+        </p:nvSpPr>
+        <p:spPr>
+          <a:xfrm xmlns:a="http://schemas.openxmlformats.org/drawingml/2006/main">
+            <a:off x="3629025" y="3543300"/>
             <a:ext cx="5581650" cy="266700"/>
           </a:xfrm>
           <a:prstGeom xmlns:a="http://schemas.openxmlformats.org/drawingml/2006/main" prst="rect">
@@ -2612,18 +2612,18 @@
           <p:cNvPr id="44" name="">
             <a:extLst xmlns:a="http://schemas.openxmlformats.org/drawingml/2006/main">
               <a:ext uri="{FF2B5EF4-FFF2-40B4-BE49-F238E27FC236}">
-                <a16:creationId xmlns:a16="http://schemas.microsoft.com/office/drawing/2014/main" id="{63EF2F44-D7FE-4137-8BEB-56D87ED769B3}"/>
-              </a:ext>
-            </a:extLst>
-          </p:cNvPr>
-          <p:cNvSpPr>
-            <a:spLocks xmlns:a="http://schemas.openxmlformats.org/drawingml/2006/main" noGrp="1"/>
-          </p:cNvSpPr>
-          <p:nvPr/>
-        </p:nvSpPr>
-        <p:spPr>
-          <a:xfrm xmlns:a="http://schemas.openxmlformats.org/drawingml/2006/main">
-            <a:off x="3629025" y="4124325"/>
+                <a16:creationId xmlns:a16="http://schemas.microsoft.com/office/drawing/2014/main" id="{A00C9144-8100-476C-B228-4BF8102426EA}"/>
+              </a:ext>
+            </a:extLst>
+          </p:cNvPr>
+          <p:cNvSpPr>
+            <a:spLocks xmlns:a="http://schemas.openxmlformats.org/drawingml/2006/main" noGrp="1"/>
+          </p:cNvSpPr>
+          <p:nvPr/>
+        </p:nvSpPr>
+        <p:spPr>
+          <a:xfrm xmlns:a="http://schemas.openxmlformats.org/drawingml/2006/main">
+            <a:off x="3629025" y="4276725"/>
             <a:ext cx="5581650" cy="476250"/>
           </a:xfrm>
           <a:prstGeom xmlns:a="http://schemas.openxmlformats.org/drawingml/2006/main" prst="rect">
@@ -2643,18 +2643,18 @@
           <p:cNvPr id="45" name="">
             <a:extLst xmlns:a="http://schemas.openxmlformats.org/drawingml/2006/main">
               <a:ext uri="{FF2B5EF4-FFF2-40B4-BE49-F238E27FC236}">
-                <a16:creationId xmlns:a16="http://schemas.microsoft.com/office/drawing/2014/main" id="{CF934246-085C-43AA-A267-8335535D09C3}"/>
-              </a:ext>
-            </a:extLst>
-          </p:cNvPr>
-          <p:cNvSpPr>
-            <a:spLocks xmlns:a="http://schemas.openxmlformats.org/drawingml/2006/main" noGrp="1"/>
-          </p:cNvSpPr>
-          <p:nvPr/>
-        </p:nvSpPr>
-        <p:spPr>
-          <a:xfrm xmlns:a="http://schemas.openxmlformats.org/drawingml/2006/main">
-            <a:off x="2981325" y="4038600"/>
+                <a16:creationId xmlns:a16="http://schemas.microsoft.com/office/drawing/2014/main" id="{17A0B47C-1B73-4B07-AE3A-B55FE17FA33D}"/>
+              </a:ext>
+            </a:extLst>
+          </p:cNvPr>
+          <p:cNvSpPr>
+            <a:spLocks xmlns:a="http://schemas.openxmlformats.org/drawingml/2006/main" noGrp="1"/>
+          </p:cNvSpPr>
+          <p:nvPr/>
+        </p:nvSpPr>
+        <p:spPr>
+          <a:xfrm xmlns:a="http://schemas.openxmlformats.org/drawingml/2006/main">
+            <a:off x="2981325" y="4191000"/>
             <a:ext cx="647700" cy="647700"/>
           </a:xfrm>
           <a:prstGeom xmlns:a="http://schemas.openxmlformats.org/drawingml/2006/main" prst="ellipse">
@@ -2676,18 +2676,18 @@
           <p:cNvPr id="46" name="">
             <a:extLst xmlns:a="http://schemas.openxmlformats.org/drawingml/2006/main">
               <a:ext uri="{FF2B5EF4-FFF2-40B4-BE49-F238E27FC236}">
-                <a16:creationId xmlns:a16="http://schemas.microsoft.com/office/drawing/2014/main" id="{125847D5-6676-449E-ADC8-A605F9050E43}"/>
-              </a:ext>
-            </a:extLst>
-          </p:cNvPr>
-          <p:cNvSpPr>
-            <a:spLocks xmlns:a="http://schemas.openxmlformats.org/drawingml/2006/main" noGrp="1"/>
-          </p:cNvSpPr>
-          <p:nvPr/>
-        </p:nvSpPr>
-        <p:spPr>
-          <a:xfrm xmlns:a="http://schemas.openxmlformats.org/drawingml/2006/main">
-            <a:off x="2981325" y="4162425"/>
+                <a16:creationId xmlns:a16="http://schemas.microsoft.com/office/drawing/2014/main" id="{10AE5274-547C-4B25-B4C0-FEB5E6FAA1C2}"/>
+              </a:ext>
+            </a:extLst>
+          </p:cNvPr>
+          <p:cNvSpPr>
+            <a:spLocks xmlns:a="http://schemas.openxmlformats.org/drawingml/2006/main" noGrp="1"/>
+          </p:cNvSpPr>
+          <p:nvPr/>
+        </p:nvSpPr>
+        <p:spPr>
+          <a:xfrm xmlns:a="http://schemas.openxmlformats.org/drawingml/2006/main">
+            <a:off x="2981325" y="4314825"/>
             <a:ext cx="647700" cy="342900"/>
           </a:xfrm>
           <a:prstGeom xmlns:a="http://schemas.openxmlformats.org/drawingml/2006/main" prst="rect">
@@ -2732,18 +2732,18 @@
           <p:cNvPr id="47" name="">
             <a:extLst xmlns:a="http://schemas.openxmlformats.org/drawingml/2006/main">
               <a:ext uri="{FF2B5EF4-FFF2-40B4-BE49-F238E27FC236}">
-                <a16:creationId xmlns:a16="http://schemas.microsoft.com/office/drawing/2014/main" id="{5DFFE1E1-B139-41E8-9183-93AA1C9718E2}"/>
-              </a:ext>
-            </a:extLst>
-          </p:cNvPr>
-          <p:cNvSpPr>
-            <a:spLocks xmlns:a="http://schemas.openxmlformats.org/drawingml/2006/main" noGrp="1"/>
-          </p:cNvSpPr>
-          <p:nvPr/>
-        </p:nvSpPr>
-        <p:spPr>
-          <a:xfrm xmlns:a="http://schemas.openxmlformats.org/drawingml/2006/main">
-            <a:off x="3629025" y="4229100"/>
+                <a16:creationId xmlns:a16="http://schemas.microsoft.com/office/drawing/2014/main" id="{A7C375FA-2E10-4FE1-AD0A-F7B6934AA33A}"/>
+              </a:ext>
+            </a:extLst>
+          </p:cNvPr>
+          <p:cNvSpPr>
+            <a:spLocks xmlns:a="http://schemas.openxmlformats.org/drawingml/2006/main" noGrp="1"/>
+          </p:cNvSpPr>
+          <p:nvPr/>
+        </p:nvSpPr>
+        <p:spPr>
+          <a:xfrm xmlns:a="http://schemas.openxmlformats.org/drawingml/2006/main">
+            <a:off x="3629025" y="4381500"/>
             <a:ext cx="5581650" cy="266700"/>
           </a:xfrm>
           <a:prstGeom xmlns:a="http://schemas.openxmlformats.org/drawingml/2006/main" prst="rect">
@@ -2788,18 +2788,18 @@
           <p:cNvPr id="48" name="">
             <a:extLst xmlns:a="http://schemas.openxmlformats.org/drawingml/2006/main">
               <a:ext uri="{FF2B5EF4-FFF2-40B4-BE49-F238E27FC236}">
-                <a16:creationId xmlns:a16="http://schemas.microsoft.com/office/drawing/2014/main" id="{83ECC91A-07D6-415A-BBA1-45DD061B3D44}"/>
-              </a:ext>
-            </a:extLst>
-          </p:cNvPr>
-          <p:cNvSpPr>
-            <a:spLocks xmlns:a="http://schemas.openxmlformats.org/drawingml/2006/main" noGrp="1"/>
-          </p:cNvSpPr>
-          <p:nvPr/>
-        </p:nvSpPr>
-        <p:spPr>
-          <a:xfrm xmlns:a="http://schemas.openxmlformats.org/drawingml/2006/main">
-            <a:off x="3629025" y="4962525"/>
+                <a16:creationId xmlns:a16="http://schemas.microsoft.com/office/drawing/2014/main" id="{B24CA0CF-84EF-4B40-87ED-45B326F4ACD8}"/>
+              </a:ext>
+            </a:extLst>
+          </p:cNvPr>
+          <p:cNvSpPr>
+            <a:spLocks xmlns:a="http://schemas.openxmlformats.org/drawingml/2006/main" noGrp="1"/>
+          </p:cNvSpPr>
+          <p:nvPr/>
+        </p:nvSpPr>
+        <p:spPr>
+          <a:xfrm xmlns:a="http://schemas.openxmlformats.org/drawingml/2006/main">
+            <a:off x="3629025" y="5114925"/>
             <a:ext cx="5581650" cy="476250"/>
           </a:xfrm>
           <a:prstGeom xmlns:a="http://schemas.openxmlformats.org/drawingml/2006/main" prst="rect">
@@ -2819,18 +2819,18 @@
           <p:cNvPr id="49" name="">
             <a:extLst xmlns:a="http://schemas.openxmlformats.org/drawingml/2006/main">
               <a:ext uri="{FF2B5EF4-FFF2-40B4-BE49-F238E27FC236}">
-                <a16:creationId xmlns:a16="http://schemas.microsoft.com/office/drawing/2014/main" id="{4B6DC8FD-E1EF-4379-8634-C0A1D7ED41A0}"/>
-              </a:ext>
-            </a:extLst>
-          </p:cNvPr>
-          <p:cNvSpPr>
-            <a:spLocks xmlns:a="http://schemas.openxmlformats.org/drawingml/2006/main" noGrp="1"/>
-          </p:cNvSpPr>
-          <p:nvPr/>
-        </p:nvSpPr>
-        <p:spPr>
-          <a:xfrm xmlns:a="http://schemas.openxmlformats.org/drawingml/2006/main">
-            <a:off x="2981325" y="4876800"/>
+                <a16:creationId xmlns:a16="http://schemas.microsoft.com/office/drawing/2014/main" id="{9084BE54-AE7C-47D6-B349-BB5C057B6119}"/>
+              </a:ext>
+            </a:extLst>
+          </p:cNvPr>
+          <p:cNvSpPr>
+            <a:spLocks xmlns:a="http://schemas.openxmlformats.org/drawingml/2006/main" noGrp="1"/>
+          </p:cNvSpPr>
+          <p:nvPr/>
+        </p:nvSpPr>
+        <p:spPr>
+          <a:xfrm xmlns:a="http://schemas.openxmlformats.org/drawingml/2006/main">
+            <a:off x="2981325" y="5029200"/>
             <a:ext cx="647700" cy="647700"/>
           </a:xfrm>
           <a:prstGeom xmlns:a="http://schemas.openxmlformats.org/drawingml/2006/main" prst="ellipse">
@@ -2852,18 +2852,18 @@
           <p:cNvPr id="50" name="">
             <a:extLst xmlns:a="http://schemas.openxmlformats.org/drawingml/2006/main">
               <a:ext uri="{FF2B5EF4-FFF2-40B4-BE49-F238E27FC236}">
-                <a16:creationId xmlns:a16="http://schemas.microsoft.com/office/drawing/2014/main" id="{16E5B032-1998-4460-A452-1C45A1036825}"/>
-              </a:ext>
-            </a:extLst>
-          </p:cNvPr>
-          <p:cNvSpPr>
-            <a:spLocks xmlns:a="http://schemas.openxmlformats.org/drawingml/2006/main" noGrp="1"/>
-          </p:cNvSpPr>
-          <p:nvPr/>
-        </p:nvSpPr>
-        <p:spPr>
-          <a:xfrm xmlns:a="http://schemas.openxmlformats.org/drawingml/2006/main">
-            <a:off x="2981325" y="5000625"/>
+                <a16:creationId xmlns:a16="http://schemas.microsoft.com/office/drawing/2014/main" id="{B041F87B-5964-460B-AA7A-B58D50A471E2}"/>
+              </a:ext>
+            </a:extLst>
+          </p:cNvPr>
+          <p:cNvSpPr>
+            <a:spLocks xmlns:a="http://schemas.openxmlformats.org/drawingml/2006/main" noGrp="1"/>
+          </p:cNvSpPr>
+          <p:nvPr/>
+        </p:nvSpPr>
+        <p:spPr>
+          <a:xfrm xmlns:a="http://schemas.openxmlformats.org/drawingml/2006/main">
+            <a:off x="2981325" y="5153025"/>
             <a:ext cx="647700" cy="342900"/>
           </a:xfrm>
           <a:prstGeom xmlns:a="http://schemas.openxmlformats.org/drawingml/2006/main" prst="rect">
@@ -2908,18 +2908,18 @@
           <p:cNvPr id="51" name="">
             <a:extLst xmlns:a="http://schemas.openxmlformats.org/drawingml/2006/main">
               <a:ext uri="{FF2B5EF4-FFF2-40B4-BE49-F238E27FC236}">
-                <a16:creationId xmlns:a16="http://schemas.microsoft.com/office/drawing/2014/main" id="{A39560BA-3976-4975-AF8C-8835FBBF9127}"/>
-              </a:ext>
-            </a:extLst>
-          </p:cNvPr>
-          <p:cNvSpPr>
-            <a:spLocks xmlns:a="http://schemas.openxmlformats.org/drawingml/2006/main" noGrp="1"/>
-          </p:cNvSpPr>
-          <p:nvPr/>
-        </p:nvSpPr>
-        <p:spPr>
-          <a:xfrm xmlns:a="http://schemas.openxmlformats.org/drawingml/2006/main">
-            <a:off x="3629025" y="5067300"/>
+                <a16:creationId xmlns:a16="http://schemas.microsoft.com/office/drawing/2014/main" id="{E19C118F-5963-4A88-BB09-34940CF80F1E}"/>
+              </a:ext>
+            </a:extLst>
+          </p:cNvPr>
+          <p:cNvSpPr>
+            <a:spLocks xmlns:a="http://schemas.openxmlformats.org/drawingml/2006/main" noGrp="1"/>
+          </p:cNvSpPr>
+          <p:nvPr/>
+        </p:nvSpPr>
+        <p:spPr>
+          <a:xfrm xmlns:a="http://schemas.openxmlformats.org/drawingml/2006/main">
+            <a:off x="3629025" y="5219700"/>
             <a:ext cx="5581650" cy="266700"/>
           </a:xfrm>
           <a:prstGeom xmlns:a="http://schemas.openxmlformats.org/drawingml/2006/main" prst="rect">
@@ -2990,14 +2990,14 @@
       </p:grpSpPr>
       <p:pic>
         <p:nvPicPr>
-          <p:cNvPr id="65" name=""/>
+          <p:cNvPr id="64" name=""/>
           <p:cNvPicPr>
             <a:picLocks xmlns:a="http://schemas.openxmlformats.org/drawingml/2006/main" noChangeAspect="1"/>
           </p:cNvPicPr>
           <p:nvPr/>
         </p:nvPicPr>
         <p:blipFill>
-          <a:blip xmlns:r="http://schemas.openxmlformats.org/officeDocument/2006/relationships" xmlns:a="http://schemas.openxmlformats.org/drawingml/2006/main" r:embed="R396051f722e34e8f"/>
+          <a:blip xmlns:r="http://schemas.openxmlformats.org/officeDocument/2006/relationships" xmlns:a="http://schemas.openxmlformats.org/drawingml/2006/main" r:embed="Rd03b4ea4fbd246e5"/>
           <a:stretch xmlns:a="http://schemas.openxmlformats.org/drawingml/2006/main"/>
         </p:blipFill>
         <p:spPr>
@@ -3344,7 +3344,7 @@
           <p:cNvPr id="41" name="">
             <a:extLst xmlns:a="http://schemas.openxmlformats.org/drawingml/2006/main">
               <a:ext uri="{FF2B5EF4-FFF2-40B4-BE49-F238E27FC236}">
-                <a16:creationId xmlns:a16="http://schemas.microsoft.com/office/drawing/2014/main" id="{A1023466-698E-4D8E-B480-0BE4966D42C1}"/>
+                <a16:creationId xmlns:a16="http://schemas.microsoft.com/office/drawing/2014/main" id="{BEAA1B6E-38B7-484A-A135-C56B87A890D9}"/>
               </a:ext>
             </a:extLst>
           </p:cNvPr>
@@ -3400,7 +3400,7 @@
           <p:cNvPr id="42" name="">
             <a:extLst xmlns:a="http://schemas.openxmlformats.org/drawingml/2006/main">
               <a:ext uri="{FF2B5EF4-FFF2-40B4-BE49-F238E27FC236}">
-                <a16:creationId xmlns:a16="http://schemas.microsoft.com/office/drawing/2014/main" id="{A0351797-41D0-4822-B260-EDC3D693B7A7}"/>
+                <a16:creationId xmlns:a16="http://schemas.microsoft.com/office/drawing/2014/main" id="{2CAC5EE5-4384-4980-B8EB-9CE72D7A7A51}"/>
               </a:ext>
             </a:extLst>
           </p:cNvPr>
@@ -3456,7 +3456,7 @@
           <p:cNvPr id="43" name="">
             <a:extLst xmlns:a="http://schemas.openxmlformats.org/drawingml/2006/main">
               <a:ext uri="{FF2B5EF4-FFF2-40B4-BE49-F238E27FC236}">
-                <a16:creationId xmlns:a16="http://schemas.microsoft.com/office/drawing/2014/main" id="{C3CBE01C-4959-4D93-BB84-DE66C122E7C9}"/>
+                <a16:creationId xmlns:a16="http://schemas.microsoft.com/office/drawing/2014/main" id="{7C33DCEB-328F-422A-BACD-1CF12DF3C860}"/>
               </a:ext>
             </a:extLst>
           </p:cNvPr>
@@ -3487,19 +3487,19 @@
           <p:cNvPr id="44" name="">
             <a:extLst xmlns:a="http://schemas.openxmlformats.org/drawingml/2006/main">
               <a:ext uri="{FF2B5EF4-FFF2-40B4-BE49-F238E27FC236}">
-                <a16:creationId xmlns:a16="http://schemas.microsoft.com/office/drawing/2014/main" id="{16FCDF10-27E2-4FE3-98FE-AA8E4C8C119C}"/>
-              </a:ext>
-            </a:extLst>
-          </p:cNvPr>
-          <p:cNvSpPr>
-            <a:spLocks xmlns:a="http://schemas.openxmlformats.org/drawingml/2006/main" noGrp="1"/>
-          </p:cNvSpPr>
-          <p:nvPr/>
-        </p:nvSpPr>
-        <p:spPr>
-          <a:xfrm xmlns:a="http://schemas.openxmlformats.org/drawingml/2006/main">
-            <a:off x="3714750" y="2266950"/>
-            <a:ext cx="19050" cy="3124200"/>
+                <a16:creationId xmlns:a16="http://schemas.microsoft.com/office/drawing/2014/main" id="{CF52CB3F-51E1-4876-A434-00003EA51482}"/>
+              </a:ext>
+            </a:extLst>
+          </p:cNvPr>
+          <p:cNvSpPr>
+            <a:spLocks xmlns:a="http://schemas.openxmlformats.org/drawingml/2006/main" noGrp="1"/>
+          </p:cNvSpPr>
+          <p:nvPr/>
+        </p:nvSpPr>
+        <p:spPr>
+          <a:xfrm xmlns:a="http://schemas.openxmlformats.org/drawingml/2006/main">
+            <a:off x="3714750" y="2095500"/>
+            <a:ext cx="19050" cy="3524250"/>
           </a:xfrm>
           <a:prstGeom xmlns:a="http://schemas.openxmlformats.org/drawingml/2006/main" prst="rect">
             <a:avLst/>
@@ -3518,7 +3518,7 @@
           <p:cNvPr id="45" name="">
             <a:extLst xmlns:a="http://schemas.openxmlformats.org/drawingml/2006/main">
               <a:ext uri="{FF2B5EF4-FFF2-40B4-BE49-F238E27FC236}">
-                <a16:creationId xmlns:a16="http://schemas.microsoft.com/office/drawing/2014/main" id="{67C1DED1-DA9E-439E-A380-140290D7DE8D}"/>
+                <a16:creationId xmlns:a16="http://schemas.microsoft.com/office/drawing/2014/main" id="{D04C12BA-29BA-4EBD-8518-9045DFC07CC9}"/>
               </a:ext>
             </a:extLst>
           </p:cNvPr>
@@ -3551,7 +3551,7 @@
           <p:cNvPr id="46" name="">
             <a:extLst xmlns:a="http://schemas.openxmlformats.org/drawingml/2006/main">
               <a:ext uri="{FF2B5EF4-FFF2-40B4-BE49-F238E27FC236}">
-                <a16:creationId xmlns:a16="http://schemas.microsoft.com/office/drawing/2014/main" id="{1657BEFA-D647-48D3-8FC7-FADF8619087E}"/>
+                <a16:creationId xmlns:a16="http://schemas.microsoft.com/office/drawing/2014/main" id="{FFCCE9F0-2FFB-4D6C-A08A-03C6F02EB9EF}"/>
               </a:ext>
             </a:extLst>
           </p:cNvPr>
@@ -3564,6 +3564,62 @@
           <a:xfrm xmlns:a="http://schemas.openxmlformats.org/drawingml/2006/main">
             <a:off x="4381500" y="2352675"/>
             <a:ext cx="1952625" cy="323850"/>
+          </a:xfrm>
+          <a:prstGeom xmlns:a="http://schemas.openxmlformats.org/drawingml/2006/main" prst="rect">
+            <a:avLst/>
+          </a:prstGeom>
+          <a:noFill xmlns:a="http://schemas.openxmlformats.org/drawingml/2006/main"/>
+          <a:ln xmlns:a="http://schemas.openxmlformats.org/drawingml/2006/main" w="0">
+            <a:noFill/>
+            <a:prstDash val="solid"/>
+          </a:ln>
+        </p:spPr>
+        <p:txBody>
+          <a:bodyPr xmlns:a="http://schemas.openxmlformats.org/drawingml/2006/main" wrap="square" lIns="0" tIns="0" rIns="0" bIns="0"/>
+          <a:lstStyle xmlns:a="http://schemas.openxmlformats.org/drawingml/2006/main"/>
+          <a:p xmlns:a="http://schemas.openxmlformats.org/drawingml/2006/main">
+            <a:pPr>
+              <a:defRPr sz="1650" b="0">
+                <a:solidFill>
+                  <a:srgbClr val="111827"/>
+                </a:solidFill>
+                <a:latin typeface="PingFang SC"/>
+                <a:ea typeface="PingFang SC"/>
+                <a:cs typeface="PingFang SC"/>
+              </a:defRPr>
+            </a:pPr>
+            <a:r>
+              <a:rPr sz="1650" b="0">
+                <a:solidFill>
+                  <a:srgbClr val="111827"/>
+                </a:solidFill>
+                <a:latin typeface="PingFang SC"/>
+                <a:ea typeface="PingFang SC"/>
+                <a:cs typeface="PingFang SC"/>
+              </a:rPr>
+              <a:t>2018.09–2024.06</a:t>
+            </a:r>
+          </a:p>
+        </p:txBody>
+      </p:sp>
+      <p:sp>
+        <p:nvSpPr>
+          <p:cNvPr id="47" name="">
+            <a:extLst xmlns:a="http://schemas.openxmlformats.org/drawingml/2006/main">
+              <a:ext uri="{FF2B5EF4-FFF2-40B4-BE49-F238E27FC236}">
+                <a16:creationId xmlns:a16="http://schemas.microsoft.com/office/drawing/2014/main" id="{0BAD07E4-E211-46E6-844E-4FAD798F0B03}"/>
+              </a:ext>
+            </a:extLst>
+          </p:cNvPr>
+          <p:cNvSpPr>
+            <a:spLocks xmlns:a="http://schemas.openxmlformats.org/drawingml/2006/main" noGrp="1"/>
+          </p:cNvSpPr>
+          <p:nvPr/>
+        </p:nvSpPr>
+        <p:spPr>
+          <a:xfrm xmlns:a="http://schemas.openxmlformats.org/drawingml/2006/main">
+            <a:off x="6572250" y="2276475"/>
+            <a:ext cx="5143500" cy="247650"/>
           </a:xfrm>
           <a:prstGeom xmlns:a="http://schemas.openxmlformats.org/drawingml/2006/main" prst="rect">
             <a:avLst/>
@@ -3597,29 +3653,29 @@
                 <a:ea typeface="PingFang SC"/>
                 <a:cs typeface="PingFang SC"/>
               </a:rPr>
-              <a:t>2018.09–2024.06</a:t>
+              <a:t>中国人民大学统计学院</a:t>
             </a:r>
           </a:p>
         </p:txBody>
       </p:sp>
       <p:sp>
         <p:nvSpPr>
-          <p:cNvPr id="47" name="">
-            <a:extLst xmlns:a="http://schemas.openxmlformats.org/drawingml/2006/main">
-              <a:ext uri="{FF2B5EF4-FFF2-40B4-BE49-F238E27FC236}">
-                <a16:creationId xmlns:a16="http://schemas.microsoft.com/office/drawing/2014/main" id="{0E1753D8-0EB7-4156-B4E4-74B0A3C9970C}"/>
-              </a:ext>
-            </a:extLst>
-          </p:cNvPr>
-          <p:cNvSpPr>
-            <a:spLocks xmlns:a="http://schemas.openxmlformats.org/drawingml/2006/main" noGrp="1"/>
-          </p:cNvSpPr>
-          <p:nvPr/>
-        </p:nvSpPr>
-        <p:spPr>
-          <a:xfrm xmlns:a="http://schemas.openxmlformats.org/drawingml/2006/main">
-            <a:off x="6572250" y="2295525"/>
-            <a:ext cx="5143500" cy="228600"/>
+          <p:cNvPr id="48" name="">
+            <a:extLst xmlns:a="http://schemas.openxmlformats.org/drawingml/2006/main">
+              <a:ext uri="{FF2B5EF4-FFF2-40B4-BE49-F238E27FC236}">
+                <a16:creationId xmlns:a16="http://schemas.microsoft.com/office/drawing/2014/main" id="{C18A1017-E364-4F2B-A98E-ABB4AE618291}"/>
+              </a:ext>
+            </a:extLst>
+          </p:cNvPr>
+          <p:cNvSpPr>
+            <a:spLocks xmlns:a="http://schemas.openxmlformats.org/drawingml/2006/main" noGrp="1"/>
+          </p:cNvSpPr>
+          <p:nvPr/>
+        </p:nvSpPr>
+        <p:spPr>
+          <a:xfrm xmlns:a="http://schemas.openxmlformats.org/drawingml/2006/main">
+            <a:off x="6572250" y="2552700"/>
+            <a:ext cx="5143500" cy="238125"/>
           </a:xfrm>
           <a:prstGeom xmlns:a="http://schemas.openxmlformats.org/drawingml/2006/main" prst="rect">
             <a:avLst/>
@@ -3635,7 +3691,7 @@
           <a:lstStyle xmlns:a="http://schemas.openxmlformats.org/drawingml/2006/main"/>
           <a:p xmlns:a="http://schemas.openxmlformats.org/drawingml/2006/main">
             <a:pPr>
-              <a:defRPr sz="1350" b="0">
+              <a:defRPr sz="1275" b="0">
                 <a:solidFill>
                   <a:srgbClr val="111827"/>
                 </a:solidFill>
@@ -3645,63 +3701,7 @@
               </a:defRPr>
             </a:pPr>
             <a:r>
-              <a:rPr sz="1350" b="0">
-                <a:solidFill>
-                  <a:srgbClr val="111827"/>
-                </a:solidFill>
-                <a:latin typeface="PingFang SC"/>
-                <a:ea typeface="PingFang SC"/>
-                <a:cs typeface="PingFang SC"/>
-              </a:rPr>
-              <a:t>中国人民大学统计学院</a:t>
-            </a:r>
-          </a:p>
-        </p:txBody>
-      </p:sp>
-      <p:sp>
-        <p:nvSpPr>
-          <p:cNvPr id="48" name="">
-            <a:extLst xmlns:a="http://schemas.openxmlformats.org/drawingml/2006/main">
-              <a:ext uri="{FF2B5EF4-FFF2-40B4-BE49-F238E27FC236}">
-                <a16:creationId xmlns:a16="http://schemas.microsoft.com/office/drawing/2014/main" id="{1502C1CC-CC54-4D6B-82CF-323C524CFAE4}"/>
-              </a:ext>
-            </a:extLst>
-          </p:cNvPr>
-          <p:cNvSpPr>
-            <a:spLocks xmlns:a="http://schemas.openxmlformats.org/drawingml/2006/main" noGrp="1"/>
-          </p:cNvSpPr>
-          <p:nvPr/>
-        </p:nvSpPr>
-        <p:spPr>
-          <a:xfrm xmlns:a="http://schemas.openxmlformats.org/drawingml/2006/main">
-            <a:off x="6572250" y="2543175"/>
-            <a:ext cx="5143500" cy="228600"/>
-          </a:xfrm>
-          <a:prstGeom xmlns:a="http://schemas.openxmlformats.org/drawingml/2006/main" prst="rect">
-            <a:avLst/>
-          </a:prstGeom>
-          <a:noFill xmlns:a="http://schemas.openxmlformats.org/drawingml/2006/main"/>
-          <a:ln xmlns:a="http://schemas.openxmlformats.org/drawingml/2006/main" w="0">
-            <a:noFill/>
-            <a:prstDash val="solid"/>
-          </a:ln>
-        </p:spPr>
-        <p:txBody>
-          <a:bodyPr xmlns:a="http://schemas.openxmlformats.org/drawingml/2006/main" wrap="square" lIns="0" tIns="0" rIns="0" bIns="0"/>
-          <a:lstStyle xmlns:a="http://schemas.openxmlformats.org/drawingml/2006/main"/>
-          <a:p xmlns:a="http://schemas.openxmlformats.org/drawingml/2006/main">
-            <a:pPr>
-              <a:defRPr sz="1200" b="0">
-                <a:solidFill>
-                  <a:srgbClr val="111827"/>
-                </a:solidFill>
-                <a:latin typeface="PingFang SC"/>
-                <a:ea typeface="PingFang SC"/>
-                <a:cs typeface="PingFang SC"/>
-              </a:defRPr>
-            </a:pPr>
-            <a:r>
-              <a:rPr sz="1200" b="0">
+              <a:rPr sz="1275" b="0">
                 <a:solidFill>
                   <a:srgbClr val="111827"/>
                 </a:solidFill>
@@ -3719,7 +3719,7 @@
           <p:cNvPr id="49" name="">
             <a:extLst xmlns:a="http://schemas.openxmlformats.org/drawingml/2006/main">
               <a:ext uri="{FF2B5EF4-FFF2-40B4-BE49-F238E27FC236}">
-                <a16:creationId xmlns:a16="http://schemas.microsoft.com/office/drawing/2014/main" id="{9F2112FD-4523-496B-9F30-8415E67266B9}"/>
+                <a16:creationId xmlns:a16="http://schemas.microsoft.com/office/drawing/2014/main" id="{27EBFE98-5900-41E6-B1C7-FA44AEBFF9A8}"/>
               </a:ext>
             </a:extLst>
           </p:cNvPr>
@@ -3752,7 +3752,7 @@
           <p:cNvPr id="50" name="">
             <a:extLst xmlns:a="http://schemas.openxmlformats.org/drawingml/2006/main">
               <a:ext uri="{FF2B5EF4-FFF2-40B4-BE49-F238E27FC236}">
-                <a16:creationId xmlns:a16="http://schemas.microsoft.com/office/drawing/2014/main" id="{BFE2EA26-404E-4A6A-8AF3-5CF14C22E1F7}"/>
+                <a16:creationId xmlns:a16="http://schemas.microsoft.com/office/drawing/2014/main" id="{36F83FB7-C402-446B-988F-E2BFAA0C50BD}"/>
               </a:ext>
             </a:extLst>
           </p:cNvPr>
@@ -3765,6 +3765,62 @@
           <a:xfrm xmlns:a="http://schemas.openxmlformats.org/drawingml/2006/main">
             <a:off x="4381500" y="3228975"/>
             <a:ext cx="1952625" cy="323850"/>
+          </a:xfrm>
+          <a:prstGeom xmlns:a="http://schemas.openxmlformats.org/drawingml/2006/main" prst="rect">
+            <a:avLst/>
+          </a:prstGeom>
+          <a:noFill xmlns:a="http://schemas.openxmlformats.org/drawingml/2006/main"/>
+          <a:ln xmlns:a="http://schemas.openxmlformats.org/drawingml/2006/main" w="0">
+            <a:noFill/>
+            <a:prstDash val="solid"/>
+          </a:ln>
+        </p:spPr>
+        <p:txBody>
+          <a:bodyPr xmlns:a="http://schemas.openxmlformats.org/drawingml/2006/main" wrap="square" lIns="0" tIns="0" rIns="0" bIns="0"/>
+          <a:lstStyle xmlns:a="http://schemas.openxmlformats.org/drawingml/2006/main"/>
+          <a:p xmlns:a="http://schemas.openxmlformats.org/drawingml/2006/main">
+            <a:pPr>
+              <a:defRPr sz="1650" b="0">
+                <a:solidFill>
+                  <a:srgbClr val="111827"/>
+                </a:solidFill>
+                <a:latin typeface="PingFang SC"/>
+                <a:ea typeface="PingFang SC"/>
+                <a:cs typeface="PingFang SC"/>
+              </a:defRPr>
+            </a:pPr>
+            <a:r>
+              <a:rPr sz="1650" b="0">
+                <a:solidFill>
+                  <a:srgbClr val="111827"/>
+                </a:solidFill>
+                <a:latin typeface="PingFang SC"/>
+                <a:ea typeface="PingFang SC"/>
+                <a:cs typeface="PingFang SC"/>
+              </a:rPr>
+              <a:t>2024.07–2025.03</a:t>
+            </a:r>
+          </a:p>
+        </p:txBody>
+      </p:sp>
+      <p:sp>
+        <p:nvSpPr>
+          <p:cNvPr id="51" name="">
+            <a:extLst xmlns:a="http://schemas.openxmlformats.org/drawingml/2006/main">
+              <a:ext uri="{FF2B5EF4-FFF2-40B4-BE49-F238E27FC236}">
+                <a16:creationId xmlns:a16="http://schemas.microsoft.com/office/drawing/2014/main" id="{BFC06C9C-63DF-4E02-BA73-FBEB04E77C29}"/>
+              </a:ext>
+            </a:extLst>
+          </p:cNvPr>
+          <p:cNvSpPr>
+            <a:spLocks xmlns:a="http://schemas.openxmlformats.org/drawingml/2006/main" noGrp="1"/>
+          </p:cNvSpPr>
+          <p:nvPr/>
+        </p:nvSpPr>
+        <p:spPr>
+          <a:xfrm xmlns:a="http://schemas.openxmlformats.org/drawingml/2006/main">
+            <a:off x="6572250" y="3152775"/>
+            <a:ext cx="5143500" cy="247650"/>
           </a:xfrm>
           <a:prstGeom xmlns:a="http://schemas.openxmlformats.org/drawingml/2006/main" prst="rect">
             <a:avLst/>
@@ -3798,29 +3854,29 @@
                 <a:ea typeface="PingFang SC"/>
                 <a:cs typeface="PingFang SC"/>
               </a:rPr>
-              <a:t>2024.07–2025.03</a:t>
+              <a:t>腾讯广告 —— 流量支持中心</a:t>
             </a:r>
           </a:p>
         </p:txBody>
       </p:sp>
       <p:sp>
         <p:nvSpPr>
-          <p:cNvPr id="51" name="">
-            <a:extLst xmlns:a="http://schemas.openxmlformats.org/drawingml/2006/main">
-              <a:ext uri="{FF2B5EF4-FFF2-40B4-BE49-F238E27FC236}">
-                <a16:creationId xmlns:a16="http://schemas.microsoft.com/office/drawing/2014/main" id="{0044D3FE-2565-4731-8467-A85C6F2F3BC8}"/>
-              </a:ext>
-            </a:extLst>
-          </p:cNvPr>
-          <p:cNvSpPr>
-            <a:spLocks xmlns:a="http://schemas.openxmlformats.org/drawingml/2006/main" noGrp="1"/>
-          </p:cNvSpPr>
-          <p:nvPr/>
-        </p:nvSpPr>
-        <p:spPr>
-          <a:xfrm xmlns:a="http://schemas.openxmlformats.org/drawingml/2006/main">
-            <a:off x="6572250" y="3171825"/>
-            <a:ext cx="5143500" cy="228600"/>
+          <p:cNvPr id="52" name="">
+            <a:extLst xmlns:a="http://schemas.openxmlformats.org/drawingml/2006/main">
+              <a:ext uri="{FF2B5EF4-FFF2-40B4-BE49-F238E27FC236}">
+                <a16:creationId xmlns:a16="http://schemas.microsoft.com/office/drawing/2014/main" id="{EBC92E67-69F6-4E2C-ACC6-56E9A4A50922}"/>
+              </a:ext>
+            </a:extLst>
+          </p:cNvPr>
+          <p:cNvSpPr>
+            <a:spLocks xmlns:a="http://schemas.openxmlformats.org/drawingml/2006/main" noGrp="1"/>
+          </p:cNvSpPr>
+          <p:nvPr/>
+        </p:nvSpPr>
+        <p:spPr>
+          <a:xfrm xmlns:a="http://schemas.openxmlformats.org/drawingml/2006/main">
+            <a:off x="6572250" y="3429000"/>
+            <a:ext cx="5143500" cy="238125"/>
           </a:xfrm>
           <a:prstGeom xmlns:a="http://schemas.openxmlformats.org/drawingml/2006/main" prst="rect">
             <a:avLst/>
@@ -3836,7 +3892,7 @@
           <a:lstStyle xmlns:a="http://schemas.openxmlformats.org/drawingml/2006/main"/>
           <a:p xmlns:a="http://schemas.openxmlformats.org/drawingml/2006/main">
             <a:pPr>
-              <a:defRPr sz="1350" b="0">
+              <a:defRPr sz="1275" b="0">
                 <a:solidFill>
                   <a:srgbClr val="111827"/>
                 </a:solidFill>
@@ -3846,63 +3902,7 @@
               </a:defRPr>
             </a:pPr>
             <a:r>
-              <a:rPr sz="1350" b="0">
-                <a:solidFill>
-                  <a:srgbClr val="111827"/>
-                </a:solidFill>
-                <a:latin typeface="PingFang SC"/>
-                <a:ea typeface="PingFang SC"/>
-                <a:cs typeface="PingFang SC"/>
-              </a:rPr>
-              <a:t>腾讯广告 —— 流量支持中心</a:t>
-            </a:r>
-          </a:p>
-        </p:txBody>
-      </p:sp>
-      <p:sp>
-        <p:nvSpPr>
-          <p:cNvPr id="52" name="">
-            <a:extLst xmlns:a="http://schemas.openxmlformats.org/drawingml/2006/main">
-              <a:ext uri="{FF2B5EF4-FFF2-40B4-BE49-F238E27FC236}">
-                <a16:creationId xmlns:a16="http://schemas.microsoft.com/office/drawing/2014/main" id="{A763EF96-49FE-447F-B392-08B1F9CAC01A}"/>
-              </a:ext>
-            </a:extLst>
-          </p:cNvPr>
-          <p:cNvSpPr>
-            <a:spLocks xmlns:a="http://schemas.openxmlformats.org/drawingml/2006/main" noGrp="1"/>
-          </p:cNvSpPr>
-          <p:nvPr/>
-        </p:nvSpPr>
-        <p:spPr>
-          <a:xfrm xmlns:a="http://schemas.openxmlformats.org/drawingml/2006/main">
-            <a:off x="6572250" y="3419475"/>
-            <a:ext cx="5143500" cy="228600"/>
-          </a:xfrm>
-          <a:prstGeom xmlns:a="http://schemas.openxmlformats.org/drawingml/2006/main" prst="rect">
-            <a:avLst/>
-          </a:prstGeom>
-          <a:noFill xmlns:a="http://schemas.openxmlformats.org/drawingml/2006/main"/>
-          <a:ln xmlns:a="http://schemas.openxmlformats.org/drawingml/2006/main" w="0">
-            <a:noFill/>
-            <a:prstDash val="solid"/>
-          </a:ln>
-        </p:spPr>
-        <p:txBody>
-          <a:bodyPr xmlns:a="http://schemas.openxmlformats.org/drawingml/2006/main" wrap="square" lIns="0" tIns="0" rIns="0" bIns="0"/>
-          <a:lstStyle xmlns:a="http://schemas.openxmlformats.org/drawingml/2006/main"/>
-          <a:p xmlns:a="http://schemas.openxmlformats.org/drawingml/2006/main">
-            <a:pPr>
-              <a:defRPr sz="1200" b="0">
-                <a:solidFill>
-                  <a:srgbClr val="111827"/>
-                </a:solidFill>
-                <a:latin typeface="PingFang SC"/>
-                <a:ea typeface="PingFang SC"/>
-                <a:cs typeface="PingFang SC"/>
-              </a:defRPr>
-            </a:pPr>
-            <a:r>
-              <a:rPr sz="1200" b="0">
+              <a:rPr sz="1275" b="0">
                 <a:solidFill>
                   <a:srgbClr val="111827"/>
                 </a:solidFill>
@@ -3920,7 +3920,7 @@
           <p:cNvPr id="53" name="">
             <a:extLst xmlns:a="http://schemas.openxmlformats.org/drawingml/2006/main">
               <a:ext uri="{FF2B5EF4-FFF2-40B4-BE49-F238E27FC236}">
-                <a16:creationId xmlns:a16="http://schemas.microsoft.com/office/drawing/2014/main" id="{55E838C8-D98F-4A71-AA16-A9AE8487B1FB}"/>
+                <a16:creationId xmlns:a16="http://schemas.microsoft.com/office/drawing/2014/main" id="{1EF27BC9-18D4-48A2-9AC5-78CFEA124E6E}"/>
               </a:ext>
             </a:extLst>
           </p:cNvPr>
@@ -3953,7 +3953,7 @@
           <p:cNvPr id="54" name="">
             <a:extLst xmlns:a="http://schemas.openxmlformats.org/drawingml/2006/main">
               <a:ext uri="{FF2B5EF4-FFF2-40B4-BE49-F238E27FC236}">
-                <a16:creationId xmlns:a16="http://schemas.microsoft.com/office/drawing/2014/main" id="{2E29A591-7341-4027-93BA-89B5B2D262C5}"/>
+                <a16:creationId xmlns:a16="http://schemas.microsoft.com/office/drawing/2014/main" id="{43AD1B9F-EF67-4D21-8D9E-F5AA052A0978}"/>
               </a:ext>
             </a:extLst>
           </p:cNvPr>
@@ -3966,6 +3966,62 @@
           <a:xfrm xmlns:a="http://schemas.openxmlformats.org/drawingml/2006/main">
             <a:off x="4381500" y="4105275"/>
             <a:ext cx="1952625" cy="323850"/>
+          </a:xfrm>
+          <a:prstGeom xmlns:a="http://schemas.openxmlformats.org/drawingml/2006/main" prst="rect">
+            <a:avLst/>
+          </a:prstGeom>
+          <a:noFill xmlns:a="http://schemas.openxmlformats.org/drawingml/2006/main"/>
+          <a:ln xmlns:a="http://schemas.openxmlformats.org/drawingml/2006/main" w="0">
+            <a:noFill/>
+            <a:prstDash val="solid"/>
+          </a:ln>
+        </p:spPr>
+        <p:txBody>
+          <a:bodyPr xmlns:a="http://schemas.openxmlformats.org/drawingml/2006/main" wrap="square" lIns="0" tIns="0" rIns="0" bIns="0"/>
+          <a:lstStyle xmlns:a="http://schemas.openxmlformats.org/drawingml/2006/main"/>
+          <a:p xmlns:a="http://schemas.openxmlformats.org/drawingml/2006/main">
+            <a:pPr>
+              <a:defRPr sz="1650" b="0">
+                <a:solidFill>
+                  <a:srgbClr val="111827"/>
+                </a:solidFill>
+                <a:latin typeface="PingFang SC"/>
+                <a:ea typeface="PingFang SC"/>
+                <a:cs typeface="PingFang SC"/>
+              </a:defRPr>
+            </a:pPr>
+            <a:r>
+              <a:rPr sz="1650" b="0">
+                <a:solidFill>
+                  <a:srgbClr val="111827"/>
+                </a:solidFill>
+                <a:latin typeface="PingFang SC"/>
+                <a:ea typeface="PingFang SC"/>
+                <a:cs typeface="PingFang SC"/>
+              </a:rPr>
+              <a:t>2025.04–2026.03</a:t>
+            </a:r>
+          </a:p>
+        </p:txBody>
+      </p:sp>
+      <p:sp>
+        <p:nvSpPr>
+          <p:cNvPr id="55" name="">
+            <a:extLst xmlns:a="http://schemas.openxmlformats.org/drawingml/2006/main">
+              <a:ext uri="{FF2B5EF4-FFF2-40B4-BE49-F238E27FC236}">
+                <a16:creationId xmlns:a16="http://schemas.microsoft.com/office/drawing/2014/main" id="{76418A4D-CFE6-44F1-8566-B076BFF626E0}"/>
+              </a:ext>
+            </a:extLst>
+          </p:cNvPr>
+          <p:cNvSpPr>
+            <a:spLocks xmlns:a="http://schemas.openxmlformats.org/drawingml/2006/main" noGrp="1"/>
+          </p:cNvSpPr>
+          <p:nvPr/>
+        </p:nvSpPr>
+        <p:spPr>
+          <a:xfrm xmlns:a="http://schemas.openxmlformats.org/drawingml/2006/main">
+            <a:off x="6572250" y="4029075"/>
+            <a:ext cx="5143500" cy="247650"/>
           </a:xfrm>
           <a:prstGeom xmlns:a="http://schemas.openxmlformats.org/drawingml/2006/main" prst="rect">
             <a:avLst/>
@@ -3999,29 +4055,29 @@
                 <a:ea typeface="PingFang SC"/>
                 <a:cs typeface="PingFang SC"/>
               </a:rPr>
-              <a:t>2025.04–2026.03</a:t>
+              <a:t>腾讯广告 —— AI 推荐中心</a:t>
             </a:r>
           </a:p>
         </p:txBody>
       </p:sp>
       <p:sp>
         <p:nvSpPr>
-          <p:cNvPr id="55" name="">
-            <a:extLst xmlns:a="http://schemas.openxmlformats.org/drawingml/2006/main">
-              <a:ext uri="{FF2B5EF4-FFF2-40B4-BE49-F238E27FC236}">
-                <a16:creationId xmlns:a16="http://schemas.microsoft.com/office/drawing/2014/main" id="{51CFC09D-15BE-405D-88BE-D6E1EB9A6473}"/>
-              </a:ext>
-            </a:extLst>
-          </p:cNvPr>
-          <p:cNvSpPr>
-            <a:spLocks xmlns:a="http://schemas.openxmlformats.org/drawingml/2006/main" noGrp="1"/>
-          </p:cNvSpPr>
-          <p:nvPr/>
-        </p:nvSpPr>
-        <p:spPr>
-          <a:xfrm xmlns:a="http://schemas.openxmlformats.org/drawingml/2006/main">
-            <a:off x="6572250" y="4048125"/>
-            <a:ext cx="5143500" cy="228600"/>
+          <p:cNvPr id="56" name="">
+            <a:extLst xmlns:a="http://schemas.openxmlformats.org/drawingml/2006/main">
+              <a:ext uri="{FF2B5EF4-FFF2-40B4-BE49-F238E27FC236}">
+                <a16:creationId xmlns:a16="http://schemas.microsoft.com/office/drawing/2014/main" id="{B9EF8663-122C-44CB-AD36-14281CF52A0A}"/>
+              </a:ext>
+            </a:extLst>
+          </p:cNvPr>
+          <p:cNvSpPr>
+            <a:spLocks xmlns:a="http://schemas.openxmlformats.org/drawingml/2006/main" noGrp="1"/>
+          </p:cNvSpPr>
+          <p:nvPr/>
+        </p:nvSpPr>
+        <p:spPr>
+          <a:xfrm xmlns:a="http://schemas.openxmlformats.org/drawingml/2006/main">
+            <a:off x="6572250" y="4305300"/>
+            <a:ext cx="5143500" cy="238125"/>
           </a:xfrm>
           <a:prstGeom xmlns:a="http://schemas.openxmlformats.org/drawingml/2006/main" prst="rect">
             <a:avLst/>
@@ -4037,7 +4093,7 @@
           <a:lstStyle xmlns:a="http://schemas.openxmlformats.org/drawingml/2006/main"/>
           <a:p xmlns:a="http://schemas.openxmlformats.org/drawingml/2006/main">
             <a:pPr>
-              <a:defRPr sz="1350" b="0">
+              <a:defRPr sz="1275" b="0">
                 <a:solidFill>
                   <a:srgbClr val="111827"/>
                 </a:solidFill>
@@ -4047,63 +4103,7 @@
               </a:defRPr>
             </a:pPr>
             <a:r>
-              <a:rPr sz="1350" b="0">
-                <a:solidFill>
-                  <a:srgbClr val="111827"/>
-                </a:solidFill>
-                <a:latin typeface="PingFang SC"/>
-                <a:ea typeface="PingFang SC"/>
-                <a:cs typeface="PingFang SC"/>
-              </a:rPr>
-              <a:t>腾讯广告 —— AI 推荐中心</a:t>
-            </a:r>
-          </a:p>
-        </p:txBody>
-      </p:sp>
-      <p:sp>
-        <p:nvSpPr>
-          <p:cNvPr id="56" name="">
-            <a:extLst xmlns:a="http://schemas.openxmlformats.org/drawingml/2006/main">
-              <a:ext uri="{FF2B5EF4-FFF2-40B4-BE49-F238E27FC236}">
-                <a16:creationId xmlns:a16="http://schemas.microsoft.com/office/drawing/2014/main" id="{07CFF037-300E-4D43-84BD-757894EC01EA}"/>
-              </a:ext>
-            </a:extLst>
-          </p:cNvPr>
-          <p:cNvSpPr>
-            <a:spLocks xmlns:a="http://schemas.openxmlformats.org/drawingml/2006/main" noGrp="1"/>
-          </p:cNvSpPr>
-          <p:nvPr/>
-        </p:nvSpPr>
-        <p:spPr>
-          <a:xfrm xmlns:a="http://schemas.openxmlformats.org/drawingml/2006/main">
-            <a:off x="6572250" y="4295775"/>
-            <a:ext cx="5143500" cy="228600"/>
-          </a:xfrm>
-          <a:prstGeom xmlns:a="http://schemas.openxmlformats.org/drawingml/2006/main" prst="rect">
-            <a:avLst/>
-          </a:prstGeom>
-          <a:noFill xmlns:a="http://schemas.openxmlformats.org/drawingml/2006/main"/>
-          <a:ln xmlns:a="http://schemas.openxmlformats.org/drawingml/2006/main" w="0">
-            <a:noFill/>
-            <a:prstDash val="solid"/>
-          </a:ln>
-        </p:spPr>
-        <p:txBody>
-          <a:bodyPr xmlns:a="http://schemas.openxmlformats.org/drawingml/2006/main" wrap="square" lIns="0" tIns="0" rIns="0" bIns="0"/>
-          <a:lstStyle xmlns:a="http://schemas.openxmlformats.org/drawingml/2006/main"/>
-          <a:p xmlns:a="http://schemas.openxmlformats.org/drawingml/2006/main">
-            <a:pPr>
-              <a:defRPr sz="1200" b="0">
-                <a:solidFill>
-                  <a:srgbClr val="111827"/>
-                </a:solidFill>
-                <a:latin typeface="PingFang SC"/>
-                <a:ea typeface="PingFang SC"/>
-                <a:cs typeface="PingFang SC"/>
-              </a:defRPr>
-            </a:pPr>
-            <a:r>
-              <a:rPr sz="1200" b="0">
+              <a:rPr sz="1275" b="0">
                 <a:solidFill>
                   <a:srgbClr val="111827"/>
                 </a:solidFill>
@@ -4121,7 +4121,7 @@
           <p:cNvPr id="57" name="">
             <a:extLst xmlns:a="http://schemas.openxmlformats.org/drawingml/2006/main">
               <a:ext uri="{FF2B5EF4-FFF2-40B4-BE49-F238E27FC236}">
-                <a16:creationId xmlns:a16="http://schemas.microsoft.com/office/drawing/2014/main" id="{7D33130E-7117-483C-B5E4-AF1BE2E7B001}"/>
+                <a16:creationId xmlns:a16="http://schemas.microsoft.com/office/drawing/2014/main" id="{8BFF2477-E1DA-431D-A7AB-1899D0748610}"/>
               </a:ext>
             </a:extLst>
           </p:cNvPr>
@@ -4154,7 +4154,7 @@
           <p:cNvPr id="58" name="">
             <a:extLst xmlns:a="http://schemas.openxmlformats.org/drawingml/2006/main">
               <a:ext uri="{FF2B5EF4-FFF2-40B4-BE49-F238E27FC236}">
-                <a16:creationId xmlns:a16="http://schemas.microsoft.com/office/drawing/2014/main" id="{1CB8619E-77D9-4252-9ED8-F0738F1C50E8}"/>
+                <a16:creationId xmlns:a16="http://schemas.microsoft.com/office/drawing/2014/main" id="{26BCE0FF-A717-4010-B4D0-846D1EE5329A}"/>
               </a:ext>
             </a:extLst>
           </p:cNvPr>
@@ -4167,6 +4167,62 @@
           <a:xfrm xmlns:a="http://schemas.openxmlformats.org/drawingml/2006/main">
             <a:off x="4381500" y="4981575"/>
             <a:ext cx="1952625" cy="323850"/>
+          </a:xfrm>
+          <a:prstGeom xmlns:a="http://schemas.openxmlformats.org/drawingml/2006/main" prst="rect">
+            <a:avLst/>
+          </a:prstGeom>
+          <a:noFill xmlns:a="http://schemas.openxmlformats.org/drawingml/2006/main"/>
+          <a:ln xmlns:a="http://schemas.openxmlformats.org/drawingml/2006/main" w="0">
+            <a:noFill/>
+            <a:prstDash val="solid"/>
+          </a:ln>
+        </p:spPr>
+        <p:txBody>
+          <a:bodyPr xmlns:a="http://schemas.openxmlformats.org/drawingml/2006/main" wrap="square" lIns="0" tIns="0" rIns="0" bIns="0"/>
+          <a:lstStyle xmlns:a="http://schemas.openxmlformats.org/drawingml/2006/main"/>
+          <a:p xmlns:a="http://schemas.openxmlformats.org/drawingml/2006/main">
+            <a:pPr>
+              <a:defRPr sz="1650" b="0">
+                <a:solidFill>
+                  <a:srgbClr val="111827"/>
+                </a:solidFill>
+                <a:latin typeface="PingFang SC"/>
+                <a:ea typeface="PingFang SC"/>
+                <a:cs typeface="PingFang SC"/>
+              </a:defRPr>
+            </a:pPr>
+            <a:r>
+              <a:rPr sz="1650" b="0">
+                <a:solidFill>
+                  <a:srgbClr val="111827"/>
+                </a:solidFill>
+                <a:latin typeface="PingFang SC"/>
+                <a:ea typeface="PingFang SC"/>
+                <a:cs typeface="PingFang SC"/>
+              </a:rPr>
+              <a:t>2026.04–至今</a:t>
+            </a:r>
+          </a:p>
+        </p:txBody>
+      </p:sp>
+      <p:sp>
+        <p:nvSpPr>
+          <p:cNvPr id="59" name="">
+            <a:extLst xmlns:a="http://schemas.openxmlformats.org/drawingml/2006/main">
+              <a:ext uri="{FF2B5EF4-FFF2-40B4-BE49-F238E27FC236}">
+                <a16:creationId xmlns:a16="http://schemas.microsoft.com/office/drawing/2014/main" id="{E8D9FCD6-BEF9-4295-B256-FB1D46291478}"/>
+              </a:ext>
+            </a:extLst>
+          </p:cNvPr>
+          <p:cNvSpPr>
+            <a:spLocks xmlns:a="http://schemas.openxmlformats.org/drawingml/2006/main" noGrp="1"/>
+          </p:cNvSpPr>
+          <p:nvPr/>
+        </p:nvSpPr>
+        <p:spPr>
+          <a:xfrm xmlns:a="http://schemas.openxmlformats.org/drawingml/2006/main">
+            <a:off x="6572250" y="4905375"/>
+            <a:ext cx="5143500" cy="247650"/>
           </a:xfrm>
           <a:prstGeom xmlns:a="http://schemas.openxmlformats.org/drawingml/2006/main" prst="rect">
             <a:avLst/>
@@ -4200,29 +4256,29 @@
                 <a:ea typeface="PingFang SC"/>
                 <a:cs typeface="PingFang SC"/>
               </a:rPr>
-              <a:t>2026.04–至今</a:t>
+              <a:t>阿里千问 —— 学习创新</a:t>
             </a:r>
           </a:p>
         </p:txBody>
       </p:sp>
       <p:sp>
         <p:nvSpPr>
-          <p:cNvPr id="59" name="">
-            <a:extLst xmlns:a="http://schemas.openxmlformats.org/drawingml/2006/main">
-              <a:ext uri="{FF2B5EF4-FFF2-40B4-BE49-F238E27FC236}">
-                <a16:creationId xmlns:a16="http://schemas.microsoft.com/office/drawing/2014/main" id="{4B2F3051-464A-41BC-BA21-36043F48FD72}"/>
-              </a:ext>
-            </a:extLst>
-          </p:cNvPr>
-          <p:cNvSpPr>
-            <a:spLocks xmlns:a="http://schemas.openxmlformats.org/drawingml/2006/main" noGrp="1"/>
-          </p:cNvSpPr>
-          <p:nvPr/>
-        </p:nvSpPr>
-        <p:spPr>
-          <a:xfrm xmlns:a="http://schemas.openxmlformats.org/drawingml/2006/main">
-            <a:off x="6572250" y="4924425"/>
-            <a:ext cx="5143500" cy="228600"/>
+          <p:cNvPr id="60" name="">
+            <a:extLst xmlns:a="http://schemas.openxmlformats.org/drawingml/2006/main">
+              <a:ext uri="{FF2B5EF4-FFF2-40B4-BE49-F238E27FC236}">
+                <a16:creationId xmlns:a16="http://schemas.microsoft.com/office/drawing/2014/main" id="{7B45AC84-C9AE-4435-B482-48EE7B9DD91D}"/>
+              </a:ext>
+            </a:extLst>
+          </p:cNvPr>
+          <p:cNvSpPr>
+            <a:spLocks xmlns:a="http://schemas.openxmlformats.org/drawingml/2006/main" noGrp="1"/>
+          </p:cNvSpPr>
+          <p:nvPr/>
+        </p:nvSpPr>
+        <p:spPr>
+          <a:xfrm xmlns:a="http://schemas.openxmlformats.org/drawingml/2006/main">
+            <a:off x="6572250" y="5181600"/>
+            <a:ext cx="5143500" cy="238125"/>
           </a:xfrm>
           <a:prstGeom xmlns:a="http://schemas.openxmlformats.org/drawingml/2006/main" prst="rect">
             <a:avLst/>
@@ -4238,7 +4294,7 @@
           <a:lstStyle xmlns:a="http://schemas.openxmlformats.org/drawingml/2006/main"/>
           <a:p xmlns:a="http://schemas.openxmlformats.org/drawingml/2006/main">
             <a:pPr>
-              <a:defRPr sz="1350" b="0">
+              <a:defRPr sz="1275" b="0">
                 <a:solidFill>
                   <a:srgbClr val="111827"/>
                 </a:solidFill>
@@ -4248,63 +4304,7 @@
               </a:defRPr>
             </a:pPr>
             <a:r>
-              <a:rPr sz="1350" b="0">
-                <a:solidFill>
-                  <a:srgbClr val="111827"/>
-                </a:solidFill>
-                <a:latin typeface="PingFang SC"/>
-                <a:ea typeface="PingFang SC"/>
-                <a:cs typeface="PingFang SC"/>
-              </a:rPr>
-              <a:t>阿里千问 —— 学习创新</a:t>
-            </a:r>
-          </a:p>
-        </p:txBody>
-      </p:sp>
-      <p:sp>
-        <p:nvSpPr>
-          <p:cNvPr id="60" name="">
-            <a:extLst xmlns:a="http://schemas.openxmlformats.org/drawingml/2006/main">
-              <a:ext uri="{FF2B5EF4-FFF2-40B4-BE49-F238E27FC236}">
-                <a16:creationId xmlns:a16="http://schemas.microsoft.com/office/drawing/2014/main" id="{CE56EBE5-2B70-44F3-9025-2EE638DB0A1D}"/>
-              </a:ext>
-            </a:extLst>
-          </p:cNvPr>
-          <p:cNvSpPr>
-            <a:spLocks xmlns:a="http://schemas.openxmlformats.org/drawingml/2006/main" noGrp="1"/>
-          </p:cNvSpPr>
-          <p:nvPr/>
-        </p:nvSpPr>
-        <p:spPr>
-          <a:xfrm xmlns:a="http://schemas.openxmlformats.org/drawingml/2006/main">
-            <a:off x="6572250" y="5172075"/>
-            <a:ext cx="5143500" cy="228600"/>
-          </a:xfrm>
-          <a:prstGeom xmlns:a="http://schemas.openxmlformats.org/drawingml/2006/main" prst="rect">
-            <a:avLst/>
-          </a:prstGeom>
-          <a:noFill xmlns:a="http://schemas.openxmlformats.org/drawingml/2006/main"/>
-          <a:ln xmlns:a="http://schemas.openxmlformats.org/drawingml/2006/main" w="0">
-            <a:noFill/>
-            <a:prstDash val="solid"/>
-          </a:ln>
-        </p:spPr>
-        <p:txBody>
-          <a:bodyPr xmlns:a="http://schemas.openxmlformats.org/drawingml/2006/main" wrap="square" lIns="0" tIns="0" rIns="0" bIns="0"/>
-          <a:lstStyle xmlns:a="http://schemas.openxmlformats.org/drawingml/2006/main"/>
-          <a:p xmlns:a="http://schemas.openxmlformats.org/drawingml/2006/main">
-            <a:pPr>
-              <a:defRPr sz="1200" b="0">
-                <a:solidFill>
-                  <a:srgbClr val="111827"/>
-                </a:solidFill>
-                <a:latin typeface="PingFang SC"/>
-                <a:ea typeface="PingFang SC"/>
-                <a:cs typeface="PingFang SC"/>
-              </a:defRPr>
-            </a:pPr>
-            <a:r>
-              <a:rPr sz="1200" b="0">
+              <a:rPr sz="1275" b="0">
                 <a:solidFill>
                   <a:srgbClr val="111827"/>
                 </a:solidFill>
@@ -4317,6 +4317,28 @@
           </a:p>
         </p:txBody>
       </p:sp>
+      <p:pic>
+        <p:nvPicPr>
+          <p:cNvPr id="92" name=""/>
+          <p:cNvPicPr>
+            <a:picLocks xmlns:a="http://schemas.openxmlformats.org/drawingml/2006/main" noChangeAspect="1"/>
+          </p:cNvPicPr>
+          <p:nvPr/>
+        </p:nvPicPr>
+        <p:blipFill>
+          <a:blip xmlns:r="http://schemas.openxmlformats.org/officeDocument/2006/relationships" xmlns:a="http://schemas.openxmlformats.org/drawingml/2006/main" r:embed="Rf9d5bbf66ecd4bb3"/>
+          <a:stretch xmlns:a="http://schemas.openxmlformats.org/drawingml/2006/main"/>
+        </p:blipFill>
+        <p:spPr>
+          <a:xfrm xmlns:a="http://schemas.openxmlformats.org/drawingml/2006/main">
+            <a:off x="2114550" y="2228850"/>
+            <a:ext cx="647700" cy="647700"/>
+          </a:xfrm>
+          <a:prstGeom xmlns:a="http://schemas.openxmlformats.org/drawingml/2006/main" prst="rect">
+            <a:avLst/>
+          </a:prstGeom>
+        </p:spPr>
+      </p:pic>
       <p:pic>
         <p:nvPicPr>
           <p:cNvPr id="93" name=""/>
@@ -4326,13 +4348,13 @@
           <p:nvPr/>
         </p:nvPicPr>
         <p:blipFill>
-          <a:blip xmlns:r="http://schemas.openxmlformats.org/officeDocument/2006/relationships" xmlns:a="http://schemas.openxmlformats.org/drawingml/2006/main" r:embed="R93d951d38f8a4da8"/>
+          <a:blip xmlns:r="http://schemas.openxmlformats.org/officeDocument/2006/relationships" xmlns:a="http://schemas.openxmlformats.org/drawingml/2006/main" r:embed="Rd92aae0771a3470f"/>
           <a:stretch xmlns:a="http://schemas.openxmlformats.org/drawingml/2006/main"/>
         </p:blipFill>
         <p:spPr>
           <a:xfrm xmlns:a="http://schemas.openxmlformats.org/drawingml/2006/main">
-            <a:off x="1962150" y="2257425"/>
-            <a:ext cx="590550" cy="590550"/>
+            <a:off x="1733550" y="3724221"/>
+            <a:ext cx="1581150" cy="285858"/>
           </a:xfrm>
           <a:prstGeom xmlns:a="http://schemas.openxmlformats.org/drawingml/2006/main" prst="rect">
             <a:avLst/>
@@ -4348,57 +4370,13 @@
           <p:nvPr/>
         </p:nvPicPr>
         <p:blipFill>
-          <a:blip xmlns:r="http://schemas.openxmlformats.org/officeDocument/2006/relationships" xmlns:a="http://schemas.openxmlformats.org/drawingml/2006/main" r:embed="R346c5210f21c4048"/>
+          <a:blip xmlns:r="http://schemas.openxmlformats.org/officeDocument/2006/relationships" xmlns:a="http://schemas.openxmlformats.org/drawingml/2006/main" r:embed="Rbd44de07289c4a8b"/>
           <a:stretch xmlns:a="http://schemas.openxmlformats.org/drawingml/2006/main"/>
         </p:blipFill>
         <p:spPr>
           <a:xfrm xmlns:a="http://schemas.openxmlformats.org/drawingml/2006/main">
-            <a:off x="1524000" y="3298125"/>
-            <a:ext cx="1447800" cy="261749"/>
-          </a:xfrm>
-          <a:prstGeom xmlns:a="http://schemas.openxmlformats.org/drawingml/2006/main" prst="rect">
-            <a:avLst/>
-          </a:prstGeom>
-        </p:spPr>
-      </p:pic>
-      <p:pic>
-        <p:nvPicPr>
-          <p:cNvPr id="95" name=""/>
-          <p:cNvPicPr>
-            <a:picLocks xmlns:a="http://schemas.openxmlformats.org/drawingml/2006/main" noChangeAspect="1"/>
-          </p:cNvPicPr>
-          <p:nvPr/>
-        </p:nvPicPr>
-        <p:blipFill>
-          <a:blip xmlns:r="http://schemas.openxmlformats.org/officeDocument/2006/relationships" xmlns:a="http://schemas.openxmlformats.org/drawingml/2006/main" r:embed="R273df0f17df14780"/>
-          <a:stretch xmlns:a="http://schemas.openxmlformats.org/drawingml/2006/main"/>
-        </p:blipFill>
-        <p:spPr>
-          <a:xfrm xmlns:a="http://schemas.openxmlformats.org/drawingml/2006/main">
-            <a:off x="1524000" y="4174425"/>
-            <a:ext cx="1447800" cy="261749"/>
-          </a:xfrm>
-          <a:prstGeom xmlns:a="http://schemas.openxmlformats.org/drawingml/2006/main" prst="rect">
-            <a:avLst/>
-          </a:prstGeom>
-        </p:spPr>
-      </p:pic>
-      <p:pic>
-        <p:nvPicPr>
-          <p:cNvPr id="96" name=""/>
-          <p:cNvPicPr>
-            <a:picLocks xmlns:a="http://schemas.openxmlformats.org/drawingml/2006/main" noChangeAspect="1"/>
-          </p:cNvPicPr>
-          <p:nvPr/>
-        </p:nvPicPr>
-        <p:blipFill>
-          <a:blip xmlns:r="http://schemas.openxmlformats.org/officeDocument/2006/relationships" xmlns:a="http://schemas.openxmlformats.org/drawingml/2006/main" r:embed="R9ec1dd687956481f"/>
-          <a:stretch xmlns:a="http://schemas.openxmlformats.org/drawingml/2006/main"/>
-        </p:blipFill>
-        <p:spPr>
-          <a:xfrm xmlns:a="http://schemas.openxmlformats.org/drawingml/2006/main">
-            <a:off x="2000250" y="4917431"/>
-            <a:ext cx="533400" cy="528338"/>
+            <a:off x="2133600" y="4879693"/>
+            <a:ext cx="609600" cy="603815"/>
           </a:xfrm>
           <a:prstGeom xmlns:a="http://schemas.openxmlformats.org/drawingml/2006/main" prst="rect">
             <a:avLst/>

</xml_diff>

<commit_message>
Merge third-round Qwen deck refinements
</commit_message>
<xml_diff>
--- a/output/sections/01-个人介绍.pptx
+++ b/output/sections/01-个人介绍.pptx
@@ -2,15 +2,15 @@
 <file path=ppt/presentation.xml><?xml version="1.0" encoding="utf-8"?>
 <p:presentation xmlns:p="http://schemas.openxmlformats.org/presentationml/2006/main">
   <p:sldMasterIdLst>
-    <p:sldMasterId xmlns:r="http://schemas.openxmlformats.org/officeDocument/2006/relationships" id="2147483648" r:id="Rcc2a564f8b3f4014"/>
+    <p:sldMasterId xmlns:r="http://schemas.openxmlformats.org/officeDocument/2006/relationships" id="2147483648" r:id="Rebf567e978654a8b"/>
   </p:sldMasterIdLst>
   <p:notesMasterIdLst>
-    <p:notesMasterId xmlns:r="http://schemas.openxmlformats.org/officeDocument/2006/relationships" r:id="R07266e1986ad4af7"/>
+    <p:notesMasterId xmlns:r="http://schemas.openxmlformats.org/officeDocument/2006/relationships" r:id="R33e6d46bffd04bc0"/>
   </p:notesMasterIdLst>
   <p:sldIdLst>
-    <p:sldId xmlns:r="http://schemas.openxmlformats.org/officeDocument/2006/relationships" id="256" r:id="Re0d4dded7c1d4175"/>
-    <p:sldId xmlns:r="http://schemas.openxmlformats.org/officeDocument/2006/relationships" id="257" r:id="Rf8ca3fdca0724f41"/>
-    <p:sldId xmlns:r="http://schemas.openxmlformats.org/officeDocument/2006/relationships" id="258" r:id="Rcf665e7e23d946a9"/>
+    <p:sldId xmlns:r="http://schemas.openxmlformats.org/officeDocument/2006/relationships" id="256" r:id="Re5d0201939374eb7"/>
+    <p:sldId xmlns:r="http://schemas.openxmlformats.org/officeDocument/2006/relationships" id="257" r:id="Re47d3b5ddf5c4016"/>
+    <p:sldId xmlns:r="http://schemas.openxmlformats.org/officeDocument/2006/relationships" id="258" r:id="Rff177f616e464da7"/>
   </p:sldIdLst>
   <p:sldSz cx="12192000" cy="6858000"/>
   <p:notesSz cx="6858000" cy="9144000"/>
@@ -735,7 +735,7 @@
   </p:cSld>
   <p:clrMap bg1="lt1" tx1="dk1" bg2="lt2" tx2="dk2" accent1="accent1" accent2="accent2" accent3="accent3" accent4="accent4" accent5="accent5" accent6="accent6" hlink="hlink" folHlink="folHlink"/>
   <p:sldLayoutIdLst>
-    <p:sldLayoutId xmlns:r="http://schemas.openxmlformats.org/officeDocument/2006/relationships" id="2147483649" r:id="R715c7748bb04481d"/>
+    <p:sldLayoutId xmlns:r="http://schemas.openxmlformats.org/officeDocument/2006/relationships" id="2147483649" r:id="R3107333bc9864fa6"/>
   </p:sldLayoutIdLst>
   <p:txStyles>
     <p:titleStyle>
@@ -1343,47 +1343,16 @@
           </a:ln>
         </p:spPr>
       </p:sp>
-      <p:sp>
-        <p:nvSpPr>
-          <p:cNvPr id="3" name="">
-            <a:extLst xmlns:a="http://schemas.openxmlformats.org/drawingml/2006/main">
-              <a:ext uri="{FF2B5EF4-FFF2-40B4-BE49-F238E27FC236}">
-                <a16:creationId xmlns:a16="http://schemas.microsoft.com/office/drawing/2014/main" id="{60855114-FD93-48B4-B10D-076B86DB2214}"/>
-              </a:ext>
-            </a:extLst>
-          </p:cNvPr>
-          <p:cNvSpPr>
-            <a:spLocks xmlns:a="http://schemas.openxmlformats.org/drawingml/2006/main" noGrp="1"/>
-          </p:cNvSpPr>
-          <p:nvPr/>
-        </p:nvSpPr>
-        <p:spPr>
-          <a:xfrm xmlns:a="http://schemas.openxmlformats.org/drawingml/2006/main">
-            <a:off x="9858375" y="2286000"/>
-            <a:ext cx="400050" cy="400050"/>
-          </a:xfrm>
-          <a:prstGeom xmlns:a="http://schemas.openxmlformats.org/drawingml/2006/main" prst="ellipse">
-            <a:avLst/>
-          </a:prstGeom>
-          <a:solidFill xmlns:a="http://schemas.openxmlformats.org/drawingml/2006/main">
-            <a:srgbClr val="00A8FF"/>
-          </a:solidFill>
-          <a:ln xmlns:a="http://schemas.openxmlformats.org/drawingml/2006/main" w="0">
-            <a:noFill/>
-            <a:prstDash val="solid"/>
-          </a:ln>
-        </p:spPr>
-      </p:sp>
       <p:pic>
         <p:nvPicPr>
-          <p:cNvPr id="17" name=""/>
+          <p:cNvPr id="27" name=""/>
           <p:cNvPicPr>
             <a:picLocks xmlns:a="http://schemas.openxmlformats.org/drawingml/2006/main" noChangeAspect="1"/>
           </p:cNvPicPr>
           <p:nvPr/>
         </p:nvPicPr>
         <p:blipFill>
-          <a:blip xmlns:r="http://schemas.openxmlformats.org/officeDocument/2006/relationships" xmlns:a="http://schemas.openxmlformats.org/drawingml/2006/main" r:embed="R812b0349ee8e4ef4"/>
+          <a:blip xmlns:r="http://schemas.openxmlformats.org/officeDocument/2006/relationships" xmlns:a="http://schemas.openxmlformats.org/drawingml/2006/main" r:embed="R960bad5a4d5e4804"/>
           <a:stretch xmlns:a="http://schemas.openxmlformats.org/drawingml/2006/main"/>
         </p:blipFill>
         <p:spPr>
@@ -1455,22 +1424,53 @@
       </p:sp>
       <p:sp>
         <p:nvSpPr>
-          <p:cNvPr id="6" name="">
-            <a:extLst xmlns:a="http://schemas.openxmlformats.org/drawingml/2006/main">
-              <a:ext uri="{FF2B5EF4-FFF2-40B4-BE49-F238E27FC236}">
-                <a16:creationId xmlns:a16="http://schemas.microsoft.com/office/drawing/2014/main" id="{5DC98AD4-084D-4525-810F-C1768570DACC}"/>
-              </a:ext>
-            </a:extLst>
-          </p:cNvPr>
-          <p:cNvSpPr>
-            <a:spLocks xmlns:a="http://schemas.openxmlformats.org/drawingml/2006/main" noGrp="1"/>
-          </p:cNvSpPr>
-          <p:nvPr/>
-        </p:nvSpPr>
-        <p:spPr>
-          <a:xfrm xmlns:a="http://schemas.openxmlformats.org/drawingml/2006/main">
-            <a:off x="914400" y="2476500"/>
-            <a:ext cx="5715000" cy="533400"/>
+          <p:cNvPr id="14" name="">
+            <a:extLst xmlns:a="http://schemas.openxmlformats.org/drawingml/2006/main">
+              <a:ext uri="{FF2B5EF4-FFF2-40B4-BE49-F238E27FC236}">
+                <a16:creationId xmlns:a16="http://schemas.microsoft.com/office/drawing/2014/main" id="{5A7BA419-21AF-4DD4-8BE4-3C2FDF646015}"/>
+              </a:ext>
+            </a:extLst>
+          </p:cNvPr>
+          <p:cNvSpPr>
+            <a:spLocks xmlns:a="http://schemas.openxmlformats.org/drawingml/2006/main" noGrp="1"/>
+          </p:cNvSpPr>
+          <p:nvPr/>
+        </p:nvSpPr>
+        <p:spPr>
+          <a:xfrm xmlns:a="http://schemas.openxmlformats.org/drawingml/2006/main">
+            <a:off x="914400" y="2343150"/>
+            <a:ext cx="838200" cy="57150"/>
+          </a:xfrm>
+          <a:prstGeom xmlns:a="http://schemas.openxmlformats.org/drawingml/2006/main" prst="rect">
+            <a:avLst/>
+          </a:prstGeom>
+          <a:solidFill xmlns:a="http://schemas.openxmlformats.org/drawingml/2006/main">
+            <a:srgbClr val="635BFF"/>
+          </a:solidFill>
+          <a:ln xmlns:a="http://schemas.openxmlformats.org/drawingml/2006/main" w="0">
+            <a:noFill/>
+            <a:prstDash val="solid"/>
+          </a:ln>
+        </p:spPr>
+      </p:sp>
+      <p:sp>
+        <p:nvSpPr>
+          <p:cNvPr id="15" name="">
+            <a:extLst xmlns:a="http://schemas.openxmlformats.org/drawingml/2006/main">
+              <a:ext uri="{FF2B5EF4-FFF2-40B4-BE49-F238E27FC236}">
+                <a16:creationId xmlns:a16="http://schemas.microsoft.com/office/drawing/2014/main" id="{62768D0A-4E7B-4235-AE84-C00EEA1CF149}"/>
+              </a:ext>
+            </a:extLst>
+          </p:cNvPr>
+          <p:cNvSpPr>
+            <a:spLocks xmlns:a="http://schemas.openxmlformats.org/drawingml/2006/main" noGrp="1"/>
+          </p:cNvSpPr>
+          <p:nvPr/>
+        </p:nvSpPr>
+        <p:spPr>
+          <a:xfrm xmlns:a="http://schemas.openxmlformats.org/drawingml/2006/main">
+            <a:off x="914400" y="2571750"/>
+            <a:ext cx="6286500" cy="552450"/>
           </a:xfrm>
           <a:prstGeom xmlns:a="http://schemas.openxmlformats.org/drawingml/2006/main" prst="rect">
             <a:avLst/>
@@ -1486,8 +1486,7 @@
           <a:lstStyle xmlns:a="http://schemas.openxmlformats.org/drawingml/2006/main"/>
           <a:p xmlns:a="http://schemas.openxmlformats.org/drawingml/2006/main">
             <a:pPr>
-              <a:buNone/>
-              <a:defRPr sz="3150" b="1">
+              <a:defRPr sz="3300" b="1">
                 <a:solidFill>
                   <a:srgbClr val="111827"/>
                 </a:solidFill>
@@ -1497,7 +1496,7 @@
               </a:defRPr>
             </a:pPr>
             <a:r>
-              <a:rPr sz="3150" b="1">
+              <a:rPr sz="3300" b="1">
                 <a:solidFill>
                   <a:srgbClr val="111827"/>
                 </a:solidFill>
@@ -1512,22 +1511,22 @@
       </p:sp>
       <p:sp>
         <p:nvSpPr>
-          <p:cNvPr id="7" name="">
-            <a:extLst xmlns:a="http://schemas.openxmlformats.org/drawingml/2006/main">
-              <a:ext uri="{FF2B5EF4-FFF2-40B4-BE49-F238E27FC236}">
-                <a16:creationId xmlns:a16="http://schemas.microsoft.com/office/drawing/2014/main" id="{C2FA153F-B823-45A3-B09F-7EA34F4F3445}"/>
-              </a:ext>
-            </a:extLst>
-          </p:cNvPr>
-          <p:cNvSpPr>
-            <a:spLocks xmlns:a="http://schemas.openxmlformats.org/drawingml/2006/main" noGrp="1"/>
-          </p:cNvSpPr>
-          <p:nvPr/>
-        </p:nvSpPr>
-        <p:spPr>
-          <a:xfrm xmlns:a="http://schemas.openxmlformats.org/drawingml/2006/main">
-            <a:off x="914400" y="3124200"/>
-            <a:ext cx="3429000" cy="266700"/>
+          <p:cNvPr id="16" name="">
+            <a:extLst xmlns:a="http://schemas.openxmlformats.org/drawingml/2006/main">
+              <a:ext uri="{FF2B5EF4-FFF2-40B4-BE49-F238E27FC236}">
+                <a16:creationId xmlns:a16="http://schemas.microsoft.com/office/drawing/2014/main" id="{D40DA2E4-0C18-4E95-B888-453E2799FD14}"/>
+              </a:ext>
+            </a:extLst>
+          </p:cNvPr>
+          <p:cNvSpPr>
+            <a:spLocks xmlns:a="http://schemas.openxmlformats.org/drawingml/2006/main" noGrp="1"/>
+          </p:cNvSpPr>
+          <p:nvPr/>
+        </p:nvSpPr>
+        <p:spPr>
+          <a:xfrm xmlns:a="http://schemas.openxmlformats.org/drawingml/2006/main">
+            <a:off x="933450" y="3257550"/>
+            <a:ext cx="4000500" cy="342900"/>
           </a:xfrm>
           <a:prstGeom xmlns:a="http://schemas.openxmlformats.org/drawingml/2006/main" prst="rect">
             <a:avLst/>
@@ -1543,8 +1542,7 @@
           <a:lstStyle xmlns:a="http://schemas.openxmlformats.org/drawingml/2006/main"/>
           <a:p xmlns:a="http://schemas.openxmlformats.org/drawingml/2006/main">
             <a:pPr>
-              <a:buNone/>
-              <a:defRPr sz="1500" b="1">
+              <a:defRPr sz="2100" b="1">
                 <a:solidFill>
                   <a:srgbClr val="635BFF"/>
                 </a:solidFill>
@@ -1554,7 +1552,7 @@
               </a:defRPr>
             </a:pPr>
             <a:r>
-              <a:rPr sz="1500" b="1">
+              <a:rPr sz="2100" b="1">
                 <a:solidFill>
                   <a:srgbClr val="635BFF"/>
                 </a:solidFill>
@@ -1569,53 +1567,53 @@
       </p:sp>
       <p:sp>
         <p:nvSpPr>
-          <p:cNvPr id="8" name="">
-            <a:extLst xmlns:a="http://schemas.openxmlformats.org/drawingml/2006/main">
-              <a:ext uri="{FF2B5EF4-FFF2-40B4-BE49-F238E27FC236}">
-                <a16:creationId xmlns:a16="http://schemas.microsoft.com/office/drawing/2014/main" id="{03D70A83-F8DB-4BFF-BFF6-68D6C98A97BA}"/>
-              </a:ext>
-            </a:extLst>
-          </p:cNvPr>
-          <p:cNvSpPr>
-            <a:spLocks xmlns:a="http://schemas.openxmlformats.org/drawingml/2006/main" noGrp="1"/>
-          </p:cNvSpPr>
-          <p:nvPr/>
-        </p:nvSpPr>
-        <p:spPr>
-          <a:xfrm xmlns:a="http://schemas.openxmlformats.org/drawingml/2006/main">
-            <a:off x="914400" y="3562350"/>
-            <a:ext cx="4000500" cy="28575"/>
+          <p:cNvPr id="17" name="">
+            <a:extLst xmlns:a="http://schemas.openxmlformats.org/drawingml/2006/main">
+              <a:ext uri="{FF2B5EF4-FFF2-40B4-BE49-F238E27FC236}">
+                <a16:creationId xmlns:a16="http://schemas.microsoft.com/office/drawing/2014/main" id="{3324BB64-CADA-4C00-81E2-2810CCCD5371}"/>
+              </a:ext>
+            </a:extLst>
+          </p:cNvPr>
+          <p:cNvSpPr>
+            <a:spLocks xmlns:a="http://schemas.openxmlformats.org/drawingml/2006/main" noGrp="1"/>
+          </p:cNvSpPr>
+          <p:nvPr/>
+        </p:nvSpPr>
+        <p:spPr>
+          <a:xfrm xmlns:a="http://schemas.openxmlformats.org/drawingml/2006/main">
+            <a:off x="933450" y="3790950"/>
+            <a:ext cx="4953000" cy="19050"/>
           </a:xfrm>
           <a:prstGeom xmlns:a="http://schemas.openxmlformats.org/drawingml/2006/main" prst="rect">
             <a:avLst/>
           </a:prstGeom>
           <a:solidFill xmlns:a="http://schemas.openxmlformats.org/drawingml/2006/main">
-            <a:srgbClr val="635BFF"/>
-          </a:solidFill>
-          <a:ln xmlns:a="http://schemas.openxmlformats.org/drawingml/2006/main" w="0">
-            <a:noFill/>
-            <a:prstDash val="solid"/>
-          </a:ln>
-        </p:spPr>
-      </p:sp>
-      <p:sp>
-        <p:nvSpPr>
-          <p:cNvPr id="9" name="">
-            <a:extLst xmlns:a="http://schemas.openxmlformats.org/drawingml/2006/main">
-              <a:ext uri="{FF2B5EF4-FFF2-40B4-BE49-F238E27FC236}">
-                <a16:creationId xmlns:a16="http://schemas.microsoft.com/office/drawing/2014/main" id="{063C31F3-291F-45D0-BB8C-32B06B892D2E}"/>
-              </a:ext>
-            </a:extLst>
-          </p:cNvPr>
-          <p:cNvSpPr>
-            <a:spLocks xmlns:a="http://schemas.openxmlformats.org/drawingml/2006/main" noGrp="1"/>
-          </p:cNvSpPr>
-          <p:nvPr/>
-        </p:nvSpPr>
-        <p:spPr>
-          <a:xfrm xmlns:a="http://schemas.openxmlformats.org/drawingml/2006/main">
-            <a:off x="914400" y="4229100"/>
-            <a:ext cx="3429000" cy="228600"/>
+            <a:srgbClr val="B9C2E8"/>
+          </a:solidFill>
+          <a:ln xmlns:a="http://schemas.openxmlformats.org/drawingml/2006/main" w="0">
+            <a:noFill/>
+            <a:prstDash val="solid"/>
+          </a:ln>
+        </p:spPr>
+      </p:sp>
+      <p:sp>
+        <p:nvSpPr>
+          <p:cNvPr id="18" name="">
+            <a:extLst xmlns:a="http://schemas.openxmlformats.org/drawingml/2006/main">
+              <a:ext uri="{FF2B5EF4-FFF2-40B4-BE49-F238E27FC236}">
+                <a16:creationId xmlns:a16="http://schemas.microsoft.com/office/drawing/2014/main" id="{5F16A70A-F1F3-4DC9-9393-F3E4E83966EA}"/>
+              </a:ext>
+            </a:extLst>
+          </p:cNvPr>
+          <p:cNvSpPr>
+            <a:spLocks xmlns:a="http://schemas.openxmlformats.org/drawingml/2006/main" noGrp="1"/>
+          </p:cNvSpPr>
+          <p:nvPr/>
+        </p:nvSpPr>
+        <p:spPr>
+          <a:xfrm xmlns:a="http://schemas.openxmlformats.org/drawingml/2006/main">
+            <a:off x="933450" y="4191000"/>
+            <a:ext cx="3429000" cy="266700"/>
           </a:xfrm>
           <a:prstGeom xmlns:a="http://schemas.openxmlformats.org/drawingml/2006/main" prst="rect">
             <a:avLst/>
@@ -1631,8 +1629,7 @@
           <a:lstStyle xmlns:a="http://schemas.openxmlformats.org/drawingml/2006/main"/>
           <a:p xmlns:a="http://schemas.openxmlformats.org/drawingml/2006/main">
             <a:pPr>
-              <a:buNone/>
-              <a:defRPr sz="1275" b="1">
+              <a:defRPr sz="1650" b="1">
                 <a:solidFill>
                   <a:srgbClr val="111827"/>
                 </a:solidFill>
@@ -1642,7 +1639,7 @@
               </a:defRPr>
             </a:pPr>
             <a:r>
-              <a:rPr sz="1275" b="1">
+              <a:rPr sz="1650" b="1">
                 <a:solidFill>
                   <a:srgbClr val="111827"/>
                 </a:solidFill>
@@ -1657,22 +1654,22 @@
       </p:sp>
       <p:sp>
         <p:nvSpPr>
-          <p:cNvPr id="10" name="">
-            <a:extLst xmlns:a="http://schemas.openxmlformats.org/drawingml/2006/main">
-              <a:ext uri="{FF2B5EF4-FFF2-40B4-BE49-F238E27FC236}">
-                <a16:creationId xmlns:a16="http://schemas.microsoft.com/office/drawing/2014/main" id="{0CCC9D1A-806D-4638-B82F-3195AD6B80D5}"/>
-              </a:ext>
-            </a:extLst>
-          </p:cNvPr>
-          <p:cNvSpPr>
-            <a:spLocks xmlns:a="http://schemas.openxmlformats.org/drawingml/2006/main" noGrp="1"/>
-          </p:cNvSpPr>
-          <p:nvPr/>
-        </p:nvSpPr>
-        <p:spPr>
-          <a:xfrm xmlns:a="http://schemas.openxmlformats.org/drawingml/2006/main">
-            <a:off x="914400" y="4552950"/>
-            <a:ext cx="3048000" cy="190500"/>
+          <p:cNvPr id="19" name="">
+            <a:extLst xmlns:a="http://schemas.openxmlformats.org/drawingml/2006/main">
+              <a:ext uri="{FF2B5EF4-FFF2-40B4-BE49-F238E27FC236}">
+                <a16:creationId xmlns:a16="http://schemas.microsoft.com/office/drawing/2014/main" id="{17531FD1-400D-4D36-B4A0-ECA3A4ACB854}"/>
+              </a:ext>
+            </a:extLst>
+          </p:cNvPr>
+          <p:cNvSpPr>
+            <a:spLocks xmlns:a="http://schemas.openxmlformats.org/drawingml/2006/main" noGrp="1"/>
+          </p:cNvSpPr>
+          <p:nvPr/>
+        </p:nvSpPr>
+        <p:spPr>
+          <a:xfrm xmlns:a="http://schemas.openxmlformats.org/drawingml/2006/main">
+            <a:off x="933450" y="4533900"/>
+            <a:ext cx="3429000" cy="228600"/>
           </a:xfrm>
           <a:prstGeom xmlns:a="http://schemas.openxmlformats.org/drawingml/2006/main" prst="rect">
             <a:avLst/>
@@ -1688,10 +1685,9 @@
           <a:lstStyle xmlns:a="http://schemas.openxmlformats.org/drawingml/2006/main"/>
           <a:p xmlns:a="http://schemas.openxmlformats.org/drawingml/2006/main">
             <a:pPr>
-              <a:buNone/>
-              <a:defRPr sz="1050" b="0">
-                <a:solidFill>
-                  <a:srgbClr val="667085"/>
+              <a:defRPr sz="1275" b="0">
+                <a:solidFill>
+                  <a:srgbClr val="344054"/>
                 </a:solidFill>
                 <a:latin typeface="PingFang SC"/>
                 <a:ea typeface="PingFang SC"/>
@@ -1699,37 +1695,37 @@
               </a:defRPr>
             </a:pPr>
             <a:r>
-              <a:rPr sz="1050" b="0">
-                <a:solidFill>
-                  <a:srgbClr val="667085"/>
+              <a:rPr sz="1275" b="0">
+                <a:solidFill>
+                  <a:srgbClr val="344054"/>
                 </a:solidFill>
                 <a:latin typeface="PingFang SC"/>
                 <a:ea typeface="PingFang SC"/>
                 <a:cs typeface="PingFang SC"/>
               </a:rPr>
-              <a:t>2026.04.13 - 2026.07.12</a:t>
+              <a:t>2026.04.13 – 2026.07.12</a:t>
             </a:r>
           </a:p>
         </p:txBody>
       </p:sp>
       <p:sp>
         <p:nvSpPr>
-          <p:cNvPr id="11" name="">
-            <a:extLst xmlns:a="http://schemas.openxmlformats.org/drawingml/2006/main">
-              <a:ext uri="{FF2B5EF4-FFF2-40B4-BE49-F238E27FC236}">
-                <a16:creationId xmlns:a16="http://schemas.microsoft.com/office/drawing/2014/main" id="{1134D010-8F2A-4E98-BB45-0CA3411E693E}"/>
-              </a:ext>
-            </a:extLst>
-          </p:cNvPr>
-          <p:cNvSpPr>
-            <a:spLocks xmlns:a="http://schemas.openxmlformats.org/drawingml/2006/main" noGrp="1"/>
-          </p:cNvSpPr>
-          <p:nvPr/>
-        </p:nvSpPr>
-        <p:spPr>
-          <a:xfrm xmlns:a="http://schemas.openxmlformats.org/drawingml/2006/main">
-            <a:off x="914400" y="5105400"/>
-            <a:ext cx="5905500" cy="266700"/>
+          <p:cNvPr id="20" name="">
+            <a:extLst xmlns:a="http://schemas.openxmlformats.org/drawingml/2006/main">
+              <a:ext uri="{FF2B5EF4-FFF2-40B4-BE49-F238E27FC236}">
+                <a16:creationId xmlns:a16="http://schemas.microsoft.com/office/drawing/2014/main" id="{B9214404-41F1-4F28-9140-19CE15818660}"/>
+              </a:ext>
+            </a:extLst>
+          </p:cNvPr>
+          <p:cNvSpPr>
+            <a:spLocks xmlns:a="http://schemas.openxmlformats.org/drawingml/2006/main" noGrp="1"/>
+          </p:cNvSpPr>
+          <p:nvPr/>
+        </p:nvSpPr>
+        <p:spPr>
+          <a:xfrm xmlns:a="http://schemas.openxmlformats.org/drawingml/2006/main">
+            <a:off x="933450" y="5162550"/>
+            <a:ext cx="6286500" cy="304800"/>
           </a:xfrm>
           <a:prstGeom xmlns:a="http://schemas.openxmlformats.org/drawingml/2006/main" prst="rect">
             <a:avLst/>
@@ -1745,10 +1741,9 @@
           <a:lstStyle xmlns:a="http://schemas.openxmlformats.org/drawingml/2006/main"/>
           <a:p xmlns:a="http://schemas.openxmlformats.org/drawingml/2006/main">
             <a:pPr>
-              <a:buNone/>
-              <a:defRPr sz="1350" b="0">
-                <a:solidFill>
-                  <a:srgbClr val="344054"/>
+              <a:defRPr sz="1650" b="0">
+                <a:solidFill>
+                  <a:srgbClr val="111827"/>
                 </a:solidFill>
                 <a:latin typeface="PingFang SC"/>
                 <a:ea typeface="PingFang SC"/>
@@ -1756,9 +1751,9 @@
               </a:defRPr>
             </a:pPr>
             <a:r>
-              <a:rPr sz="1350" b="0">
-                <a:solidFill>
-                  <a:srgbClr val="344054"/>
+              <a:rPr sz="1650" b="0">
+                <a:solidFill>
+                  <a:srgbClr val="111827"/>
                 </a:solidFill>
                 <a:latin typeface="PingFang SC"/>
                 <a:ea typeface="PingFang SC"/>
@@ -1771,22 +1766,84 @@
       </p:sp>
       <p:sp>
         <p:nvSpPr>
-          <p:cNvPr id="12" name="">
-            <a:extLst xmlns:a="http://schemas.openxmlformats.org/drawingml/2006/main">
-              <a:ext uri="{FF2B5EF4-FFF2-40B4-BE49-F238E27FC236}">
-                <a16:creationId xmlns:a16="http://schemas.microsoft.com/office/drawing/2014/main" id="{F600EF7B-A614-4D3A-B67A-9E568F665697}"/>
-              </a:ext>
-            </a:extLst>
-          </p:cNvPr>
-          <p:cNvSpPr>
-            <a:spLocks xmlns:a="http://schemas.openxmlformats.org/drawingml/2006/main" noGrp="1"/>
-          </p:cNvSpPr>
-          <p:nvPr/>
-        </p:nvSpPr>
-        <p:spPr>
-          <a:xfrm xmlns:a="http://schemas.openxmlformats.org/drawingml/2006/main">
-            <a:off x="8686800" y="6134100"/>
-            <a:ext cx="1428750" cy="171450"/>
+          <p:cNvPr id="21" name="">
+            <a:extLst xmlns:a="http://schemas.openxmlformats.org/drawingml/2006/main">
+              <a:ext uri="{FF2B5EF4-FFF2-40B4-BE49-F238E27FC236}">
+                <a16:creationId xmlns:a16="http://schemas.microsoft.com/office/drawing/2014/main" id="{A1F31BF6-FC63-402A-95E8-DB69A21DB9ED}"/>
+              </a:ext>
+            </a:extLst>
+          </p:cNvPr>
+          <p:cNvSpPr>
+            <a:spLocks xmlns:a="http://schemas.openxmlformats.org/drawingml/2006/main" noGrp="1"/>
+          </p:cNvSpPr>
+          <p:nvPr/>
+        </p:nvSpPr>
+        <p:spPr>
+          <a:xfrm xmlns:a="http://schemas.openxmlformats.org/drawingml/2006/main">
+            <a:off x="9925050" y="2266950"/>
+            <a:ext cx="533400" cy="533400"/>
+          </a:xfrm>
+          <a:prstGeom xmlns:a="http://schemas.openxmlformats.org/drawingml/2006/main" prst="ellipse">
+            <a:avLst/>
+          </a:prstGeom>
+          <a:solidFill xmlns:a="http://schemas.openxmlformats.org/drawingml/2006/main">
+            <a:srgbClr val="00A8FF"/>
+          </a:solidFill>
+          <a:ln xmlns:a="http://schemas.openxmlformats.org/drawingml/2006/main" w="0">
+            <a:noFill/>
+            <a:prstDash val="solid"/>
+          </a:ln>
+        </p:spPr>
+      </p:sp>
+      <p:sp>
+        <p:nvSpPr>
+          <p:cNvPr id="22" name="">
+            <a:extLst xmlns:a="http://schemas.openxmlformats.org/drawingml/2006/main">
+              <a:ext uri="{FF2B5EF4-FFF2-40B4-BE49-F238E27FC236}">
+                <a16:creationId xmlns:a16="http://schemas.microsoft.com/office/drawing/2014/main" id="{80DB5626-608E-4A6A-B852-7041EF3FEDEF}"/>
+              </a:ext>
+            </a:extLst>
+          </p:cNvPr>
+          <p:cNvSpPr>
+            <a:spLocks xmlns:a="http://schemas.openxmlformats.org/drawingml/2006/main" noGrp="1"/>
+          </p:cNvSpPr>
+          <p:nvPr/>
+        </p:nvSpPr>
+        <p:spPr>
+          <a:xfrm xmlns:a="http://schemas.openxmlformats.org/drawingml/2006/main">
+            <a:off x="9258300" y="1390650"/>
+            <a:ext cx="1104900" cy="1104900"/>
+          </a:xfrm>
+          <a:prstGeom xmlns:a="http://schemas.openxmlformats.org/drawingml/2006/main" prst="ellipse">
+            <a:avLst/>
+          </a:prstGeom>
+          <a:solidFill xmlns:a="http://schemas.openxmlformats.org/drawingml/2006/main">
+            <a:srgbClr val="D9D7FF"/>
+          </a:solidFill>
+          <a:ln xmlns:a="http://schemas.openxmlformats.org/drawingml/2006/main" w="0">
+            <a:noFill/>
+            <a:prstDash val="solid"/>
+          </a:ln>
+        </p:spPr>
+      </p:sp>
+      <p:sp>
+        <p:nvSpPr>
+          <p:cNvPr id="23" name="">
+            <a:extLst xmlns:a="http://schemas.openxmlformats.org/drawingml/2006/main">
+              <a:ext uri="{FF2B5EF4-FFF2-40B4-BE49-F238E27FC236}">
+                <a16:creationId xmlns:a16="http://schemas.microsoft.com/office/drawing/2014/main" id="{638A8694-A13E-4AA9-84CD-118F6CB6297F}"/>
+              </a:ext>
+            </a:extLst>
+          </p:cNvPr>
+          <p:cNvSpPr>
+            <a:spLocks xmlns:a="http://schemas.openxmlformats.org/drawingml/2006/main" noGrp="1"/>
+          </p:cNvSpPr>
+          <p:nvPr/>
+        </p:nvSpPr>
+        <p:spPr>
+          <a:xfrm xmlns:a="http://schemas.openxmlformats.org/drawingml/2006/main">
+            <a:off x="8972550" y="4895850"/>
+            <a:ext cx="2476500" cy="419100"/>
           </a:xfrm>
           <a:prstGeom xmlns:a="http://schemas.openxmlformats.org/drawingml/2006/main" prst="rect">
             <a:avLst/>
@@ -1801,9 +1858,8 @@
           <a:bodyPr xmlns:a="http://schemas.openxmlformats.org/drawingml/2006/main" wrap="square" lIns="0" tIns="0" rIns="0" bIns="0"/>
           <a:lstStyle xmlns:a="http://schemas.openxmlformats.org/drawingml/2006/main"/>
           <a:p xmlns:a="http://schemas.openxmlformats.org/drawingml/2006/main">
-            <a:pPr>
-              <a:buNone/>
-              <a:defRPr sz="900" b="0">
+            <a:pPr algn="ctr">
+              <a:defRPr sz="2550" b="1">
                 <a:solidFill>
                   <a:srgbClr val="FFFFFF"/>
                 </a:solidFill>
@@ -1813,7 +1869,63 @@
               </a:defRPr>
             </a:pPr>
             <a:r>
-              <a:rPr sz="900" b="0">
+              <a:rPr sz="2550" b="1">
+                <a:solidFill>
+                  <a:srgbClr val="FFFFFF"/>
+                </a:solidFill>
+                <a:latin typeface="PingFang SC"/>
+                <a:ea typeface="PingFang SC"/>
+                <a:cs typeface="PingFang SC"/>
+              </a:rPr>
+              <a:t>OneRec</a:t>
+            </a:r>
+          </a:p>
+        </p:txBody>
+      </p:sp>
+      <p:sp>
+        <p:nvSpPr>
+          <p:cNvPr id="24" name="">
+            <a:extLst xmlns:a="http://schemas.openxmlformats.org/drawingml/2006/main">
+              <a:ext uri="{FF2B5EF4-FFF2-40B4-BE49-F238E27FC236}">
+                <a16:creationId xmlns:a16="http://schemas.microsoft.com/office/drawing/2014/main" id="{91ACF09A-4B7F-4F88-8995-F2A6FEE93D7B}"/>
+              </a:ext>
+            </a:extLst>
+          </p:cNvPr>
+          <p:cNvSpPr>
+            <a:spLocks xmlns:a="http://schemas.openxmlformats.org/drawingml/2006/main" noGrp="1"/>
+          </p:cNvSpPr>
+          <p:nvPr/>
+        </p:nvSpPr>
+        <p:spPr>
+          <a:xfrm xmlns:a="http://schemas.openxmlformats.org/drawingml/2006/main">
+            <a:off x="8972550" y="5391150"/>
+            <a:ext cx="2476500" cy="209550"/>
+          </a:xfrm>
+          <a:prstGeom xmlns:a="http://schemas.openxmlformats.org/drawingml/2006/main" prst="rect">
+            <a:avLst/>
+          </a:prstGeom>
+          <a:noFill xmlns:a="http://schemas.openxmlformats.org/drawingml/2006/main"/>
+          <a:ln xmlns:a="http://schemas.openxmlformats.org/drawingml/2006/main" w="0">
+            <a:noFill/>
+            <a:prstDash val="solid"/>
+          </a:ln>
+        </p:spPr>
+        <p:txBody>
+          <a:bodyPr xmlns:a="http://schemas.openxmlformats.org/drawingml/2006/main" wrap="square" lIns="0" tIns="0" rIns="0" bIns="0"/>
+          <a:lstStyle xmlns:a="http://schemas.openxmlformats.org/drawingml/2006/main"/>
+          <a:p xmlns:a="http://schemas.openxmlformats.org/drawingml/2006/main">
+            <a:pPr algn="ctr">
+              <a:defRPr sz="1125" b="1">
+                <a:solidFill>
+                  <a:srgbClr val="FFFFFF"/>
+                </a:solidFill>
+                <a:latin typeface="PingFang SC"/>
+                <a:ea typeface="PingFang SC"/>
+                <a:cs typeface="PingFang SC"/>
+              </a:defRPr>
+            </a:pPr>
+            <a:r>
+              <a:rPr sz="1125" b="1">
                 <a:solidFill>
                   <a:srgbClr val="FFFFFF"/>
                 </a:solidFill>
@@ -1864,7 +1976,7 @@
           <p:nvPr/>
         </p:nvPicPr>
         <p:blipFill>
-          <a:blip xmlns:r="http://schemas.openxmlformats.org/officeDocument/2006/relationships" xmlns:a="http://schemas.openxmlformats.org/drawingml/2006/main" r:embed="Re2f9f196c9924ecc"/>
+          <a:blip xmlns:r="http://schemas.openxmlformats.org/officeDocument/2006/relationships" xmlns:a="http://schemas.openxmlformats.org/drawingml/2006/main" r:embed="Ra0c4711df52a448f"/>
           <a:stretch xmlns:a="http://schemas.openxmlformats.org/drawingml/2006/main"/>
         </p:blipFill>
         <p:spPr>
@@ -2084,7 +2196,7 @@
           <p:cNvPr id="32" name="">
             <a:extLst xmlns:a="http://schemas.openxmlformats.org/drawingml/2006/main">
               <a:ext uri="{FF2B5EF4-FFF2-40B4-BE49-F238E27FC236}">
-                <a16:creationId xmlns:a16="http://schemas.microsoft.com/office/drawing/2014/main" id="{ACE72426-046F-442F-8552-524ECBF9BD9F}"/>
+                <a16:creationId xmlns:a16="http://schemas.microsoft.com/office/drawing/2014/main" id="{D86847B5-3D46-4892-80BC-57286556D550}"/>
               </a:ext>
             </a:extLst>
           </p:cNvPr>
@@ -2115,7 +2227,7 @@
           <p:cNvPr id="33" name="">
             <a:extLst xmlns:a="http://schemas.openxmlformats.org/drawingml/2006/main">
               <a:ext uri="{FF2B5EF4-FFF2-40B4-BE49-F238E27FC236}">
-                <a16:creationId xmlns:a16="http://schemas.microsoft.com/office/drawing/2014/main" id="{79273447-BE47-4805-BB99-FA3AD7FEC9C8}"/>
+                <a16:creationId xmlns:a16="http://schemas.microsoft.com/office/drawing/2014/main" id="{C0B0BEAD-21B6-4E44-8CE2-E5D4E83154C2}"/>
               </a:ext>
             </a:extLst>
           </p:cNvPr>
@@ -2148,7 +2260,7 @@
           <p:cNvPr id="34" name="">
             <a:extLst xmlns:a="http://schemas.openxmlformats.org/drawingml/2006/main">
               <a:ext uri="{FF2B5EF4-FFF2-40B4-BE49-F238E27FC236}">
-                <a16:creationId xmlns:a16="http://schemas.microsoft.com/office/drawing/2014/main" id="{9B75B555-7AF3-44FA-A108-E2657A2B8689}"/>
+                <a16:creationId xmlns:a16="http://schemas.microsoft.com/office/drawing/2014/main" id="{BFCE4C6E-0CF3-4550-B0A4-E8232B9443E7}"/>
               </a:ext>
             </a:extLst>
           </p:cNvPr>
@@ -2204,7 +2316,7 @@
           <p:cNvPr id="35" name="">
             <a:extLst xmlns:a="http://schemas.openxmlformats.org/drawingml/2006/main">
               <a:ext uri="{FF2B5EF4-FFF2-40B4-BE49-F238E27FC236}">
-                <a16:creationId xmlns:a16="http://schemas.microsoft.com/office/drawing/2014/main" id="{1918D7CE-D888-4DD4-A5E8-CE3EF4098FCC}"/>
+                <a16:creationId xmlns:a16="http://schemas.microsoft.com/office/drawing/2014/main" id="{FB5082E7-7869-41C6-AAF5-7F32CB9ECACE}"/>
               </a:ext>
             </a:extLst>
           </p:cNvPr>
@@ -2260,7 +2372,7 @@
           <p:cNvPr id="36" name="">
             <a:extLst xmlns:a="http://schemas.openxmlformats.org/drawingml/2006/main">
               <a:ext uri="{FF2B5EF4-FFF2-40B4-BE49-F238E27FC236}">
-                <a16:creationId xmlns:a16="http://schemas.microsoft.com/office/drawing/2014/main" id="{57067804-6BDF-44AA-BD81-AE7E14973EE2}"/>
+                <a16:creationId xmlns:a16="http://schemas.microsoft.com/office/drawing/2014/main" id="{087B2C24-BC07-4EBD-BBF7-B599644ED22E}"/>
               </a:ext>
             </a:extLst>
           </p:cNvPr>
@@ -2291,7 +2403,7 @@
           <p:cNvPr id="37" name="">
             <a:extLst xmlns:a="http://schemas.openxmlformats.org/drawingml/2006/main">
               <a:ext uri="{FF2B5EF4-FFF2-40B4-BE49-F238E27FC236}">
-                <a16:creationId xmlns:a16="http://schemas.microsoft.com/office/drawing/2014/main" id="{1F06FEFA-7EA5-4C3A-B6D9-939DD2B18E77}"/>
+                <a16:creationId xmlns:a16="http://schemas.microsoft.com/office/drawing/2014/main" id="{1D9BB71A-6AB7-4EB4-851D-3513CDAD28F2}"/>
               </a:ext>
             </a:extLst>
           </p:cNvPr>
@@ -2324,7 +2436,7 @@
           <p:cNvPr id="38" name="">
             <a:extLst xmlns:a="http://schemas.openxmlformats.org/drawingml/2006/main">
               <a:ext uri="{FF2B5EF4-FFF2-40B4-BE49-F238E27FC236}">
-                <a16:creationId xmlns:a16="http://schemas.microsoft.com/office/drawing/2014/main" id="{DA7FB69E-CD70-420D-9169-9E867C51DF5D}"/>
+                <a16:creationId xmlns:a16="http://schemas.microsoft.com/office/drawing/2014/main" id="{D033CB2B-AEBD-47D1-A7EF-D94A62604D71}"/>
               </a:ext>
             </a:extLst>
           </p:cNvPr>
@@ -2380,7 +2492,7 @@
           <p:cNvPr id="39" name="">
             <a:extLst xmlns:a="http://schemas.openxmlformats.org/drawingml/2006/main">
               <a:ext uri="{FF2B5EF4-FFF2-40B4-BE49-F238E27FC236}">
-                <a16:creationId xmlns:a16="http://schemas.microsoft.com/office/drawing/2014/main" id="{6F50B901-4D6E-4419-B6C3-5200CEDA13FD}"/>
+                <a16:creationId xmlns:a16="http://schemas.microsoft.com/office/drawing/2014/main" id="{002D862A-4C2B-4E40-8AAA-B399A661D8BC}"/>
               </a:ext>
             </a:extLst>
           </p:cNvPr>
@@ -2436,7 +2548,7 @@
           <p:cNvPr id="40" name="">
             <a:extLst xmlns:a="http://schemas.openxmlformats.org/drawingml/2006/main">
               <a:ext uri="{FF2B5EF4-FFF2-40B4-BE49-F238E27FC236}">
-                <a16:creationId xmlns:a16="http://schemas.microsoft.com/office/drawing/2014/main" id="{391B4C53-08C9-462F-A272-C30E586D8B66}"/>
+                <a16:creationId xmlns:a16="http://schemas.microsoft.com/office/drawing/2014/main" id="{F842EA0F-9B3B-46B9-94D8-8D14887A4DE2}"/>
               </a:ext>
             </a:extLst>
           </p:cNvPr>
@@ -2467,7 +2579,7 @@
           <p:cNvPr id="41" name="">
             <a:extLst xmlns:a="http://schemas.openxmlformats.org/drawingml/2006/main">
               <a:ext uri="{FF2B5EF4-FFF2-40B4-BE49-F238E27FC236}">
-                <a16:creationId xmlns:a16="http://schemas.microsoft.com/office/drawing/2014/main" id="{2BC0C2B5-257E-43D2-9D42-8C46BE862D02}"/>
+                <a16:creationId xmlns:a16="http://schemas.microsoft.com/office/drawing/2014/main" id="{15374795-F3E4-4D9A-9070-E1F2C564CF7F}"/>
               </a:ext>
             </a:extLst>
           </p:cNvPr>
@@ -2500,7 +2612,7 @@
           <p:cNvPr id="42" name="">
             <a:extLst xmlns:a="http://schemas.openxmlformats.org/drawingml/2006/main">
               <a:ext uri="{FF2B5EF4-FFF2-40B4-BE49-F238E27FC236}">
-                <a16:creationId xmlns:a16="http://schemas.microsoft.com/office/drawing/2014/main" id="{87640CED-184A-4A08-9F55-5FC03A2D649C}"/>
+                <a16:creationId xmlns:a16="http://schemas.microsoft.com/office/drawing/2014/main" id="{2BBF123A-F585-401B-B21A-A08F551143F4}"/>
               </a:ext>
             </a:extLst>
           </p:cNvPr>
@@ -2556,7 +2668,7 @@
           <p:cNvPr id="43" name="">
             <a:extLst xmlns:a="http://schemas.openxmlformats.org/drawingml/2006/main">
               <a:ext uri="{FF2B5EF4-FFF2-40B4-BE49-F238E27FC236}">
-                <a16:creationId xmlns:a16="http://schemas.microsoft.com/office/drawing/2014/main" id="{69CD02B5-7CE3-461E-A62F-A5999EF7DF51}"/>
+                <a16:creationId xmlns:a16="http://schemas.microsoft.com/office/drawing/2014/main" id="{9F2C1BCC-D4BA-4E2A-9428-2FD4CAE5CBF5}"/>
               </a:ext>
             </a:extLst>
           </p:cNvPr>
@@ -2612,7 +2724,7 @@
           <p:cNvPr id="44" name="">
             <a:extLst xmlns:a="http://schemas.openxmlformats.org/drawingml/2006/main">
               <a:ext uri="{FF2B5EF4-FFF2-40B4-BE49-F238E27FC236}">
-                <a16:creationId xmlns:a16="http://schemas.microsoft.com/office/drawing/2014/main" id="{A00C9144-8100-476C-B228-4BF8102426EA}"/>
+                <a16:creationId xmlns:a16="http://schemas.microsoft.com/office/drawing/2014/main" id="{3B795F11-CD17-4BD2-8305-FE410BC33788}"/>
               </a:ext>
             </a:extLst>
           </p:cNvPr>
@@ -2643,7 +2755,7 @@
           <p:cNvPr id="45" name="">
             <a:extLst xmlns:a="http://schemas.openxmlformats.org/drawingml/2006/main">
               <a:ext uri="{FF2B5EF4-FFF2-40B4-BE49-F238E27FC236}">
-                <a16:creationId xmlns:a16="http://schemas.microsoft.com/office/drawing/2014/main" id="{17A0B47C-1B73-4B07-AE3A-B55FE17FA33D}"/>
+                <a16:creationId xmlns:a16="http://schemas.microsoft.com/office/drawing/2014/main" id="{114EA26B-3ED5-4D9C-A4BB-04E55B6C52B5}"/>
               </a:ext>
             </a:extLst>
           </p:cNvPr>
@@ -2676,7 +2788,7 @@
           <p:cNvPr id="46" name="">
             <a:extLst xmlns:a="http://schemas.openxmlformats.org/drawingml/2006/main">
               <a:ext uri="{FF2B5EF4-FFF2-40B4-BE49-F238E27FC236}">
-                <a16:creationId xmlns:a16="http://schemas.microsoft.com/office/drawing/2014/main" id="{10AE5274-547C-4B25-B4C0-FEB5E6FAA1C2}"/>
+                <a16:creationId xmlns:a16="http://schemas.microsoft.com/office/drawing/2014/main" id="{43AA1C66-E232-4123-94F5-1F6EE2CD6663}"/>
               </a:ext>
             </a:extLst>
           </p:cNvPr>
@@ -2732,7 +2844,7 @@
           <p:cNvPr id="47" name="">
             <a:extLst xmlns:a="http://schemas.openxmlformats.org/drawingml/2006/main">
               <a:ext uri="{FF2B5EF4-FFF2-40B4-BE49-F238E27FC236}">
-                <a16:creationId xmlns:a16="http://schemas.microsoft.com/office/drawing/2014/main" id="{A7C375FA-2E10-4FE1-AD0A-F7B6934AA33A}"/>
+                <a16:creationId xmlns:a16="http://schemas.microsoft.com/office/drawing/2014/main" id="{8CE12C42-791D-4EDF-8FAB-535338836FD9}"/>
               </a:ext>
             </a:extLst>
           </p:cNvPr>
@@ -2788,7 +2900,7 @@
           <p:cNvPr id="48" name="">
             <a:extLst xmlns:a="http://schemas.openxmlformats.org/drawingml/2006/main">
               <a:ext uri="{FF2B5EF4-FFF2-40B4-BE49-F238E27FC236}">
-                <a16:creationId xmlns:a16="http://schemas.microsoft.com/office/drawing/2014/main" id="{B24CA0CF-84EF-4B40-87ED-45B326F4ACD8}"/>
+                <a16:creationId xmlns:a16="http://schemas.microsoft.com/office/drawing/2014/main" id="{7B367E6B-8CF3-4A18-82F5-12C09EDC66AA}"/>
               </a:ext>
             </a:extLst>
           </p:cNvPr>
@@ -2819,7 +2931,7 @@
           <p:cNvPr id="49" name="">
             <a:extLst xmlns:a="http://schemas.openxmlformats.org/drawingml/2006/main">
               <a:ext uri="{FF2B5EF4-FFF2-40B4-BE49-F238E27FC236}">
-                <a16:creationId xmlns:a16="http://schemas.microsoft.com/office/drawing/2014/main" id="{9084BE54-AE7C-47D6-B349-BB5C057B6119}"/>
+                <a16:creationId xmlns:a16="http://schemas.microsoft.com/office/drawing/2014/main" id="{283F6783-EA5F-4227-8BD9-5DA35A767330}"/>
               </a:ext>
             </a:extLst>
           </p:cNvPr>
@@ -2852,7 +2964,7 @@
           <p:cNvPr id="50" name="">
             <a:extLst xmlns:a="http://schemas.openxmlformats.org/drawingml/2006/main">
               <a:ext uri="{FF2B5EF4-FFF2-40B4-BE49-F238E27FC236}">
-                <a16:creationId xmlns:a16="http://schemas.microsoft.com/office/drawing/2014/main" id="{B041F87B-5964-460B-AA7A-B58D50A471E2}"/>
+                <a16:creationId xmlns:a16="http://schemas.microsoft.com/office/drawing/2014/main" id="{A8C386EF-FDD6-447D-9ED1-36B6428B2A0B}"/>
               </a:ext>
             </a:extLst>
           </p:cNvPr>
@@ -2908,7 +3020,7 @@
           <p:cNvPr id="51" name="">
             <a:extLst xmlns:a="http://schemas.openxmlformats.org/drawingml/2006/main">
               <a:ext uri="{FF2B5EF4-FFF2-40B4-BE49-F238E27FC236}">
-                <a16:creationId xmlns:a16="http://schemas.microsoft.com/office/drawing/2014/main" id="{E19C118F-5963-4A88-BB09-34940CF80F1E}"/>
+                <a16:creationId xmlns:a16="http://schemas.microsoft.com/office/drawing/2014/main" id="{3DFE3C94-33A1-4D5D-A4F5-098343E83E16}"/>
               </a:ext>
             </a:extLst>
           </p:cNvPr>
@@ -2997,7 +3109,7 @@
           <p:nvPr/>
         </p:nvPicPr>
         <p:blipFill>
-          <a:blip xmlns:r="http://schemas.openxmlformats.org/officeDocument/2006/relationships" xmlns:a="http://schemas.openxmlformats.org/drawingml/2006/main" r:embed="Rd03b4ea4fbd246e5"/>
+          <a:blip xmlns:r="http://schemas.openxmlformats.org/officeDocument/2006/relationships" xmlns:a="http://schemas.openxmlformats.org/drawingml/2006/main" r:embed="R85288a28c2c645a6"/>
           <a:stretch xmlns:a="http://schemas.openxmlformats.org/drawingml/2006/main"/>
         </p:blipFill>
         <p:spPr>
@@ -3344,7 +3456,7 @@
           <p:cNvPr id="41" name="">
             <a:extLst xmlns:a="http://schemas.openxmlformats.org/drawingml/2006/main">
               <a:ext uri="{FF2B5EF4-FFF2-40B4-BE49-F238E27FC236}">
-                <a16:creationId xmlns:a16="http://schemas.microsoft.com/office/drawing/2014/main" id="{BEAA1B6E-38B7-484A-A135-C56B87A890D9}"/>
+                <a16:creationId xmlns:a16="http://schemas.microsoft.com/office/drawing/2014/main" id="{D94333CA-575D-4C00-AAA5-B051CA30AC8D}"/>
               </a:ext>
             </a:extLst>
           </p:cNvPr>
@@ -3400,7 +3512,7 @@
           <p:cNvPr id="42" name="">
             <a:extLst xmlns:a="http://schemas.openxmlformats.org/drawingml/2006/main">
               <a:ext uri="{FF2B5EF4-FFF2-40B4-BE49-F238E27FC236}">
-                <a16:creationId xmlns:a16="http://schemas.microsoft.com/office/drawing/2014/main" id="{2CAC5EE5-4384-4980-B8EB-9CE72D7A7A51}"/>
+                <a16:creationId xmlns:a16="http://schemas.microsoft.com/office/drawing/2014/main" id="{8E24765B-45A9-4148-B9AD-3257E5584F90}"/>
               </a:ext>
             </a:extLst>
           </p:cNvPr>
@@ -3456,7 +3568,7 @@
           <p:cNvPr id="43" name="">
             <a:extLst xmlns:a="http://schemas.openxmlformats.org/drawingml/2006/main">
               <a:ext uri="{FF2B5EF4-FFF2-40B4-BE49-F238E27FC236}">
-                <a16:creationId xmlns:a16="http://schemas.microsoft.com/office/drawing/2014/main" id="{7C33DCEB-328F-422A-BACD-1CF12DF3C860}"/>
+                <a16:creationId xmlns:a16="http://schemas.microsoft.com/office/drawing/2014/main" id="{97D6EF02-4A39-4E0B-B1A8-F31211EB792E}"/>
               </a:ext>
             </a:extLst>
           </p:cNvPr>
@@ -3487,7 +3599,7 @@
           <p:cNvPr id="44" name="">
             <a:extLst xmlns:a="http://schemas.openxmlformats.org/drawingml/2006/main">
               <a:ext uri="{FF2B5EF4-FFF2-40B4-BE49-F238E27FC236}">
-                <a16:creationId xmlns:a16="http://schemas.microsoft.com/office/drawing/2014/main" id="{CF52CB3F-51E1-4876-A434-00003EA51482}"/>
+                <a16:creationId xmlns:a16="http://schemas.microsoft.com/office/drawing/2014/main" id="{6ED8811E-B5D0-4B87-84DB-6605FC4F74CB}"/>
               </a:ext>
             </a:extLst>
           </p:cNvPr>
@@ -3518,7 +3630,7 @@
           <p:cNvPr id="45" name="">
             <a:extLst xmlns:a="http://schemas.openxmlformats.org/drawingml/2006/main">
               <a:ext uri="{FF2B5EF4-FFF2-40B4-BE49-F238E27FC236}">
-                <a16:creationId xmlns:a16="http://schemas.microsoft.com/office/drawing/2014/main" id="{D04C12BA-29BA-4EBD-8518-9045DFC07CC9}"/>
+                <a16:creationId xmlns:a16="http://schemas.microsoft.com/office/drawing/2014/main" id="{0D64A576-C1AE-4BBE-BC32-7BB60B9B7DB8}"/>
               </a:ext>
             </a:extLst>
           </p:cNvPr>
@@ -3551,7 +3663,7 @@
           <p:cNvPr id="46" name="">
             <a:extLst xmlns:a="http://schemas.openxmlformats.org/drawingml/2006/main">
               <a:ext uri="{FF2B5EF4-FFF2-40B4-BE49-F238E27FC236}">
-                <a16:creationId xmlns:a16="http://schemas.microsoft.com/office/drawing/2014/main" id="{FFCCE9F0-2FFB-4D6C-A08A-03C6F02EB9EF}"/>
+                <a16:creationId xmlns:a16="http://schemas.microsoft.com/office/drawing/2014/main" id="{51D768F6-BE63-44D0-A2A8-02D56F39C0D0}"/>
               </a:ext>
             </a:extLst>
           </p:cNvPr>
@@ -3607,7 +3719,7 @@
           <p:cNvPr id="47" name="">
             <a:extLst xmlns:a="http://schemas.openxmlformats.org/drawingml/2006/main">
               <a:ext uri="{FF2B5EF4-FFF2-40B4-BE49-F238E27FC236}">
-                <a16:creationId xmlns:a16="http://schemas.microsoft.com/office/drawing/2014/main" id="{0BAD07E4-E211-46E6-844E-4FAD798F0B03}"/>
+                <a16:creationId xmlns:a16="http://schemas.microsoft.com/office/drawing/2014/main" id="{20C7D5E3-26C7-46BA-803A-83E81D3A2759}"/>
               </a:ext>
             </a:extLst>
           </p:cNvPr>
@@ -3663,7 +3775,7 @@
           <p:cNvPr id="48" name="">
             <a:extLst xmlns:a="http://schemas.openxmlformats.org/drawingml/2006/main">
               <a:ext uri="{FF2B5EF4-FFF2-40B4-BE49-F238E27FC236}">
-                <a16:creationId xmlns:a16="http://schemas.microsoft.com/office/drawing/2014/main" id="{C18A1017-E364-4F2B-A98E-ABB4AE618291}"/>
+                <a16:creationId xmlns:a16="http://schemas.microsoft.com/office/drawing/2014/main" id="{CEDB4F8C-01A5-4515-878B-A878523ADBB1}"/>
               </a:ext>
             </a:extLst>
           </p:cNvPr>
@@ -3719,7 +3831,7 @@
           <p:cNvPr id="49" name="">
             <a:extLst xmlns:a="http://schemas.openxmlformats.org/drawingml/2006/main">
               <a:ext uri="{FF2B5EF4-FFF2-40B4-BE49-F238E27FC236}">
-                <a16:creationId xmlns:a16="http://schemas.microsoft.com/office/drawing/2014/main" id="{27EBFE98-5900-41E6-B1C7-FA44AEBFF9A8}"/>
+                <a16:creationId xmlns:a16="http://schemas.microsoft.com/office/drawing/2014/main" id="{6F428BCD-A263-40A3-989B-DD4F32AEBB52}"/>
               </a:ext>
             </a:extLst>
           </p:cNvPr>
@@ -3752,7 +3864,7 @@
           <p:cNvPr id="50" name="">
             <a:extLst xmlns:a="http://schemas.openxmlformats.org/drawingml/2006/main">
               <a:ext uri="{FF2B5EF4-FFF2-40B4-BE49-F238E27FC236}">
-                <a16:creationId xmlns:a16="http://schemas.microsoft.com/office/drawing/2014/main" id="{36F83FB7-C402-446B-988F-E2BFAA0C50BD}"/>
+                <a16:creationId xmlns:a16="http://schemas.microsoft.com/office/drawing/2014/main" id="{6BE6D66D-DF33-46CE-8046-07CFF9DB66E2}"/>
               </a:ext>
             </a:extLst>
           </p:cNvPr>
@@ -3808,7 +3920,7 @@
           <p:cNvPr id="51" name="">
             <a:extLst xmlns:a="http://schemas.openxmlformats.org/drawingml/2006/main">
               <a:ext uri="{FF2B5EF4-FFF2-40B4-BE49-F238E27FC236}">
-                <a16:creationId xmlns:a16="http://schemas.microsoft.com/office/drawing/2014/main" id="{BFC06C9C-63DF-4E02-BA73-FBEB04E77C29}"/>
+                <a16:creationId xmlns:a16="http://schemas.microsoft.com/office/drawing/2014/main" id="{590A08FF-F87D-4C85-A4CF-4DA6BEA765A8}"/>
               </a:ext>
             </a:extLst>
           </p:cNvPr>
@@ -3864,7 +3976,7 @@
           <p:cNvPr id="52" name="">
             <a:extLst xmlns:a="http://schemas.openxmlformats.org/drawingml/2006/main">
               <a:ext uri="{FF2B5EF4-FFF2-40B4-BE49-F238E27FC236}">
-                <a16:creationId xmlns:a16="http://schemas.microsoft.com/office/drawing/2014/main" id="{EBC92E67-69F6-4E2C-ACC6-56E9A4A50922}"/>
+                <a16:creationId xmlns:a16="http://schemas.microsoft.com/office/drawing/2014/main" id="{CA77FD6C-7927-4F13-8808-D4A23589F3FB}"/>
               </a:ext>
             </a:extLst>
           </p:cNvPr>
@@ -3920,7 +4032,7 @@
           <p:cNvPr id="53" name="">
             <a:extLst xmlns:a="http://schemas.openxmlformats.org/drawingml/2006/main">
               <a:ext uri="{FF2B5EF4-FFF2-40B4-BE49-F238E27FC236}">
-                <a16:creationId xmlns:a16="http://schemas.microsoft.com/office/drawing/2014/main" id="{1EF27BC9-18D4-48A2-9AC5-78CFEA124E6E}"/>
+                <a16:creationId xmlns:a16="http://schemas.microsoft.com/office/drawing/2014/main" id="{E0118196-4274-4D3B-9991-27F8CC7B569B}"/>
               </a:ext>
             </a:extLst>
           </p:cNvPr>
@@ -3953,7 +4065,7 @@
           <p:cNvPr id="54" name="">
             <a:extLst xmlns:a="http://schemas.openxmlformats.org/drawingml/2006/main">
               <a:ext uri="{FF2B5EF4-FFF2-40B4-BE49-F238E27FC236}">
-                <a16:creationId xmlns:a16="http://schemas.microsoft.com/office/drawing/2014/main" id="{43AD1B9F-EF67-4D21-8D9E-F5AA052A0978}"/>
+                <a16:creationId xmlns:a16="http://schemas.microsoft.com/office/drawing/2014/main" id="{A90397BD-845A-4CAA-8C2F-A71DD3F4E3E6}"/>
               </a:ext>
             </a:extLst>
           </p:cNvPr>
@@ -4009,7 +4121,7 @@
           <p:cNvPr id="55" name="">
             <a:extLst xmlns:a="http://schemas.openxmlformats.org/drawingml/2006/main">
               <a:ext uri="{FF2B5EF4-FFF2-40B4-BE49-F238E27FC236}">
-                <a16:creationId xmlns:a16="http://schemas.microsoft.com/office/drawing/2014/main" id="{76418A4D-CFE6-44F1-8566-B076BFF626E0}"/>
+                <a16:creationId xmlns:a16="http://schemas.microsoft.com/office/drawing/2014/main" id="{2196F9FE-74C2-4F87-86B7-F8DCC28C477D}"/>
               </a:ext>
             </a:extLst>
           </p:cNvPr>
@@ -4065,7 +4177,7 @@
           <p:cNvPr id="56" name="">
             <a:extLst xmlns:a="http://schemas.openxmlformats.org/drawingml/2006/main">
               <a:ext uri="{FF2B5EF4-FFF2-40B4-BE49-F238E27FC236}">
-                <a16:creationId xmlns:a16="http://schemas.microsoft.com/office/drawing/2014/main" id="{B9EF8663-122C-44CB-AD36-14281CF52A0A}"/>
+                <a16:creationId xmlns:a16="http://schemas.microsoft.com/office/drawing/2014/main" id="{05E49F69-D8E1-4ED7-8D14-DC46AF86FA2D}"/>
               </a:ext>
             </a:extLst>
           </p:cNvPr>
@@ -4121,7 +4233,7 @@
           <p:cNvPr id="57" name="">
             <a:extLst xmlns:a="http://schemas.openxmlformats.org/drawingml/2006/main">
               <a:ext uri="{FF2B5EF4-FFF2-40B4-BE49-F238E27FC236}">
-                <a16:creationId xmlns:a16="http://schemas.microsoft.com/office/drawing/2014/main" id="{8BFF2477-E1DA-431D-A7AB-1899D0748610}"/>
+                <a16:creationId xmlns:a16="http://schemas.microsoft.com/office/drawing/2014/main" id="{D91A362F-75D7-4B5A-8F2B-E2D55FA2C49A}"/>
               </a:ext>
             </a:extLst>
           </p:cNvPr>
@@ -4154,7 +4266,7 @@
           <p:cNvPr id="58" name="">
             <a:extLst xmlns:a="http://schemas.openxmlformats.org/drawingml/2006/main">
               <a:ext uri="{FF2B5EF4-FFF2-40B4-BE49-F238E27FC236}">
-                <a16:creationId xmlns:a16="http://schemas.microsoft.com/office/drawing/2014/main" id="{26BCE0FF-A717-4010-B4D0-846D1EE5329A}"/>
+                <a16:creationId xmlns:a16="http://schemas.microsoft.com/office/drawing/2014/main" id="{52BEBF0D-3493-4B65-B670-68F22683191F}"/>
               </a:ext>
             </a:extLst>
           </p:cNvPr>
@@ -4210,7 +4322,7 @@
           <p:cNvPr id="59" name="">
             <a:extLst xmlns:a="http://schemas.openxmlformats.org/drawingml/2006/main">
               <a:ext uri="{FF2B5EF4-FFF2-40B4-BE49-F238E27FC236}">
-                <a16:creationId xmlns:a16="http://schemas.microsoft.com/office/drawing/2014/main" id="{E8D9FCD6-BEF9-4295-B256-FB1D46291478}"/>
+                <a16:creationId xmlns:a16="http://schemas.microsoft.com/office/drawing/2014/main" id="{E864589B-D946-4CEC-A543-4096508B7EB9}"/>
               </a:ext>
             </a:extLst>
           </p:cNvPr>
@@ -4266,7 +4378,7 @@
           <p:cNvPr id="60" name="">
             <a:extLst xmlns:a="http://schemas.openxmlformats.org/drawingml/2006/main">
               <a:ext uri="{FF2B5EF4-FFF2-40B4-BE49-F238E27FC236}">
-                <a16:creationId xmlns:a16="http://schemas.microsoft.com/office/drawing/2014/main" id="{7B45AC84-C9AE-4435-B482-48EE7B9DD91D}"/>
+                <a16:creationId xmlns:a16="http://schemas.microsoft.com/office/drawing/2014/main" id="{7F2739EE-F2B5-4F89-9B51-98E6F701198A}"/>
               </a:ext>
             </a:extLst>
           </p:cNvPr>
@@ -4326,7 +4438,7 @@
           <p:nvPr/>
         </p:nvPicPr>
         <p:blipFill>
-          <a:blip xmlns:r="http://schemas.openxmlformats.org/officeDocument/2006/relationships" xmlns:a="http://schemas.openxmlformats.org/drawingml/2006/main" r:embed="Rf9d5bbf66ecd4bb3"/>
+          <a:blip xmlns:r="http://schemas.openxmlformats.org/officeDocument/2006/relationships" xmlns:a="http://schemas.openxmlformats.org/drawingml/2006/main" r:embed="R68a382957f6544b7"/>
           <a:stretch xmlns:a="http://schemas.openxmlformats.org/drawingml/2006/main"/>
         </p:blipFill>
         <p:spPr>
@@ -4348,7 +4460,7 @@
           <p:nvPr/>
         </p:nvPicPr>
         <p:blipFill>
-          <a:blip xmlns:r="http://schemas.openxmlformats.org/officeDocument/2006/relationships" xmlns:a="http://schemas.openxmlformats.org/drawingml/2006/main" r:embed="Rd92aae0771a3470f"/>
+          <a:blip xmlns:r="http://schemas.openxmlformats.org/officeDocument/2006/relationships" xmlns:a="http://schemas.openxmlformats.org/drawingml/2006/main" r:embed="R153754e11e9e4d8e"/>
           <a:stretch xmlns:a="http://schemas.openxmlformats.org/drawingml/2006/main"/>
         </p:blipFill>
         <p:spPr>
@@ -4370,7 +4482,7 @@
           <p:nvPr/>
         </p:nvPicPr>
         <p:blipFill>
-          <a:blip xmlns:r="http://schemas.openxmlformats.org/officeDocument/2006/relationships" xmlns:a="http://schemas.openxmlformats.org/drawingml/2006/main" r:embed="Rbd44de07289c4a8b"/>
+          <a:blip xmlns:r="http://schemas.openxmlformats.org/officeDocument/2006/relationships" xmlns:a="http://schemas.openxmlformats.org/drawingml/2006/main" r:embed="R5945291da2334dbd"/>
           <a:stretch xmlns:a="http://schemas.openxmlformats.org/drawingml/2006/main"/>
         </p:blipFill>
         <p:spPr>

</xml_diff>

<commit_message>
Merge latest Qwen deck refinements
</commit_message>
<xml_diff>
--- a/output/sections/01-个人介绍.pptx
+++ b/output/sections/01-个人介绍.pptx
@@ -2,15 +2,15 @@
 <file path=ppt/presentation.xml><?xml version="1.0" encoding="utf-8"?>
 <p:presentation xmlns:p="http://schemas.openxmlformats.org/presentationml/2006/main">
   <p:sldMasterIdLst>
-    <p:sldMasterId xmlns:r="http://schemas.openxmlformats.org/officeDocument/2006/relationships" id="2147483648" r:id="Rebf567e978654a8b"/>
+    <p:sldMasterId xmlns:r="http://schemas.openxmlformats.org/officeDocument/2006/relationships" id="2147483648" r:id="Rd6e2e73f9c61466a"/>
   </p:sldMasterIdLst>
   <p:notesMasterIdLst>
-    <p:notesMasterId xmlns:r="http://schemas.openxmlformats.org/officeDocument/2006/relationships" r:id="R33e6d46bffd04bc0"/>
+    <p:notesMasterId xmlns:r="http://schemas.openxmlformats.org/officeDocument/2006/relationships" r:id="R2812a782c0cf492b"/>
   </p:notesMasterIdLst>
   <p:sldIdLst>
-    <p:sldId xmlns:r="http://schemas.openxmlformats.org/officeDocument/2006/relationships" id="256" r:id="Re5d0201939374eb7"/>
-    <p:sldId xmlns:r="http://schemas.openxmlformats.org/officeDocument/2006/relationships" id="257" r:id="Re47d3b5ddf5c4016"/>
-    <p:sldId xmlns:r="http://schemas.openxmlformats.org/officeDocument/2006/relationships" id="258" r:id="Rff177f616e464da7"/>
+    <p:sldId xmlns:r="http://schemas.openxmlformats.org/officeDocument/2006/relationships" id="256" r:id="Rac164fc6a39749b7"/>
+    <p:sldId xmlns:r="http://schemas.openxmlformats.org/officeDocument/2006/relationships" id="257" r:id="Rfdc7237a04d44e79"/>
+    <p:sldId xmlns:r="http://schemas.openxmlformats.org/officeDocument/2006/relationships" id="258" r:id="R68e4e88293214aa2"/>
   </p:sldIdLst>
   <p:sldSz cx="12192000" cy="6858000"/>
   <p:notesSz cx="6858000" cy="9144000"/>
@@ -735,7 +735,7 @@
   </p:cSld>
   <p:clrMap bg1="lt1" tx1="dk1" bg2="lt2" tx2="dk2" accent1="accent1" accent2="accent2" accent3="accent3" accent4="accent4" accent5="accent5" accent6="accent6" hlink="hlink" folHlink="folHlink"/>
   <p:sldLayoutIdLst>
-    <p:sldLayoutId xmlns:r="http://schemas.openxmlformats.org/officeDocument/2006/relationships" id="2147483649" r:id="R3107333bc9864fa6"/>
+    <p:sldLayoutId xmlns:r="http://schemas.openxmlformats.org/officeDocument/2006/relationships" id="2147483649" r:id="R78d4b8be0de34c04"/>
   </p:sldLayoutIdLst>
   <p:txStyles>
     <p:titleStyle>
@@ -1352,7 +1352,7 @@
           <p:nvPr/>
         </p:nvPicPr>
         <p:blipFill>
-          <a:blip xmlns:r="http://schemas.openxmlformats.org/officeDocument/2006/relationships" xmlns:a="http://schemas.openxmlformats.org/drawingml/2006/main" r:embed="R960bad5a4d5e4804"/>
+          <a:blip xmlns:r="http://schemas.openxmlformats.org/officeDocument/2006/relationships" xmlns:a="http://schemas.openxmlformats.org/drawingml/2006/main" r:embed="Ree3f03fd092345df"/>
           <a:stretch xmlns:a="http://schemas.openxmlformats.org/drawingml/2006/main"/>
         </p:blipFill>
         <p:spPr>
@@ -1427,7 +1427,7 @@
           <p:cNvPr id="14" name="">
             <a:extLst xmlns:a="http://schemas.openxmlformats.org/drawingml/2006/main">
               <a:ext uri="{FF2B5EF4-FFF2-40B4-BE49-F238E27FC236}">
-                <a16:creationId xmlns:a16="http://schemas.microsoft.com/office/drawing/2014/main" id="{5A7BA419-21AF-4DD4-8BE4-3C2FDF646015}"/>
+                <a16:creationId xmlns:a16="http://schemas.microsoft.com/office/drawing/2014/main" id="{2CD15E2A-6D28-4143-885F-BECEB1007C74}"/>
               </a:ext>
             </a:extLst>
           </p:cNvPr>
@@ -1458,7 +1458,7 @@
           <p:cNvPr id="15" name="">
             <a:extLst xmlns:a="http://schemas.openxmlformats.org/drawingml/2006/main">
               <a:ext uri="{FF2B5EF4-FFF2-40B4-BE49-F238E27FC236}">
-                <a16:creationId xmlns:a16="http://schemas.microsoft.com/office/drawing/2014/main" id="{62768D0A-4E7B-4235-AE84-C00EEA1CF149}"/>
+                <a16:creationId xmlns:a16="http://schemas.microsoft.com/office/drawing/2014/main" id="{20E8DAD1-0179-4286-958B-323E12196705}"/>
               </a:ext>
             </a:extLst>
           </p:cNvPr>
@@ -1514,7 +1514,7 @@
           <p:cNvPr id="16" name="">
             <a:extLst xmlns:a="http://schemas.openxmlformats.org/drawingml/2006/main">
               <a:ext uri="{FF2B5EF4-FFF2-40B4-BE49-F238E27FC236}">
-                <a16:creationId xmlns:a16="http://schemas.microsoft.com/office/drawing/2014/main" id="{D40DA2E4-0C18-4E95-B888-453E2799FD14}"/>
+                <a16:creationId xmlns:a16="http://schemas.microsoft.com/office/drawing/2014/main" id="{28AD9279-F3C2-46A6-92BB-2F74FC2A396F}"/>
               </a:ext>
             </a:extLst>
           </p:cNvPr>
@@ -1570,7 +1570,7 @@
           <p:cNvPr id="17" name="">
             <a:extLst xmlns:a="http://schemas.openxmlformats.org/drawingml/2006/main">
               <a:ext uri="{FF2B5EF4-FFF2-40B4-BE49-F238E27FC236}">
-                <a16:creationId xmlns:a16="http://schemas.microsoft.com/office/drawing/2014/main" id="{3324BB64-CADA-4C00-81E2-2810CCCD5371}"/>
+                <a16:creationId xmlns:a16="http://schemas.microsoft.com/office/drawing/2014/main" id="{8787B36B-DFCF-4BA1-909C-1DA194968927}"/>
               </a:ext>
             </a:extLst>
           </p:cNvPr>
@@ -1601,7 +1601,7 @@
           <p:cNvPr id="18" name="">
             <a:extLst xmlns:a="http://schemas.openxmlformats.org/drawingml/2006/main">
               <a:ext uri="{FF2B5EF4-FFF2-40B4-BE49-F238E27FC236}">
-                <a16:creationId xmlns:a16="http://schemas.microsoft.com/office/drawing/2014/main" id="{5F16A70A-F1F3-4DC9-9393-F3E4E83966EA}"/>
+                <a16:creationId xmlns:a16="http://schemas.microsoft.com/office/drawing/2014/main" id="{81CCD9EC-2475-4DD5-A039-77D3156B6E17}"/>
               </a:ext>
             </a:extLst>
           </p:cNvPr>
@@ -1657,7 +1657,7 @@
           <p:cNvPr id="19" name="">
             <a:extLst xmlns:a="http://schemas.openxmlformats.org/drawingml/2006/main">
               <a:ext uri="{FF2B5EF4-FFF2-40B4-BE49-F238E27FC236}">
-                <a16:creationId xmlns:a16="http://schemas.microsoft.com/office/drawing/2014/main" id="{17531FD1-400D-4D36-B4A0-ECA3A4ACB854}"/>
+                <a16:creationId xmlns:a16="http://schemas.microsoft.com/office/drawing/2014/main" id="{94658346-41F8-42B4-9CBE-BC1C276279BD}"/>
               </a:ext>
             </a:extLst>
           </p:cNvPr>
@@ -1713,7 +1713,7 @@
           <p:cNvPr id="20" name="">
             <a:extLst xmlns:a="http://schemas.openxmlformats.org/drawingml/2006/main">
               <a:ext uri="{FF2B5EF4-FFF2-40B4-BE49-F238E27FC236}">
-                <a16:creationId xmlns:a16="http://schemas.microsoft.com/office/drawing/2014/main" id="{B9214404-41F1-4F28-9140-19CE15818660}"/>
+                <a16:creationId xmlns:a16="http://schemas.microsoft.com/office/drawing/2014/main" id="{DD6C2233-7895-40BD-9EFC-D793BD9BE78A}"/>
               </a:ext>
             </a:extLst>
           </p:cNvPr>
@@ -1769,7 +1769,7 @@
           <p:cNvPr id="21" name="">
             <a:extLst xmlns:a="http://schemas.openxmlformats.org/drawingml/2006/main">
               <a:ext uri="{FF2B5EF4-FFF2-40B4-BE49-F238E27FC236}">
-                <a16:creationId xmlns:a16="http://schemas.microsoft.com/office/drawing/2014/main" id="{A1F31BF6-FC63-402A-95E8-DB69A21DB9ED}"/>
+                <a16:creationId xmlns:a16="http://schemas.microsoft.com/office/drawing/2014/main" id="{62BE744B-DBE8-471F-81DC-CA027C13071E}"/>
               </a:ext>
             </a:extLst>
           </p:cNvPr>
@@ -1800,7 +1800,7 @@
           <p:cNvPr id="22" name="">
             <a:extLst xmlns:a="http://schemas.openxmlformats.org/drawingml/2006/main">
               <a:ext uri="{FF2B5EF4-FFF2-40B4-BE49-F238E27FC236}">
-                <a16:creationId xmlns:a16="http://schemas.microsoft.com/office/drawing/2014/main" id="{80DB5626-608E-4A6A-B852-7041EF3FEDEF}"/>
+                <a16:creationId xmlns:a16="http://schemas.microsoft.com/office/drawing/2014/main" id="{CE121A29-EB3A-432F-B8AF-D5329647ADAD}"/>
               </a:ext>
             </a:extLst>
           </p:cNvPr>
@@ -1831,7 +1831,7 @@
           <p:cNvPr id="23" name="">
             <a:extLst xmlns:a="http://schemas.openxmlformats.org/drawingml/2006/main">
               <a:ext uri="{FF2B5EF4-FFF2-40B4-BE49-F238E27FC236}">
-                <a16:creationId xmlns:a16="http://schemas.microsoft.com/office/drawing/2014/main" id="{638A8694-A13E-4AA9-84CD-118F6CB6297F}"/>
+                <a16:creationId xmlns:a16="http://schemas.microsoft.com/office/drawing/2014/main" id="{57CB0C6E-36FF-4F36-BCE0-420497965470}"/>
               </a:ext>
             </a:extLst>
           </p:cNvPr>
@@ -1887,7 +1887,7 @@
           <p:cNvPr id="24" name="">
             <a:extLst xmlns:a="http://schemas.openxmlformats.org/drawingml/2006/main">
               <a:ext uri="{FF2B5EF4-FFF2-40B4-BE49-F238E27FC236}">
-                <a16:creationId xmlns:a16="http://schemas.microsoft.com/office/drawing/2014/main" id="{91ACF09A-4B7F-4F88-8995-F2A6FEE93D7B}"/>
+                <a16:creationId xmlns:a16="http://schemas.microsoft.com/office/drawing/2014/main" id="{30E0CA58-59A3-43FD-9ADA-28C561A7C963}"/>
               </a:ext>
             </a:extLst>
           </p:cNvPr>
@@ -1976,7 +1976,7 @@
           <p:nvPr/>
         </p:nvPicPr>
         <p:blipFill>
-          <a:blip xmlns:r="http://schemas.openxmlformats.org/officeDocument/2006/relationships" xmlns:a="http://schemas.openxmlformats.org/drawingml/2006/main" r:embed="Ra0c4711df52a448f"/>
+          <a:blip xmlns:r="http://schemas.openxmlformats.org/officeDocument/2006/relationships" xmlns:a="http://schemas.openxmlformats.org/drawingml/2006/main" r:embed="R9040dead78244ed5"/>
           <a:stretch xmlns:a="http://schemas.openxmlformats.org/drawingml/2006/main"/>
         </p:blipFill>
         <p:spPr>
@@ -2196,7 +2196,7 @@
           <p:cNvPr id="32" name="">
             <a:extLst xmlns:a="http://schemas.openxmlformats.org/drawingml/2006/main">
               <a:ext uri="{FF2B5EF4-FFF2-40B4-BE49-F238E27FC236}">
-                <a16:creationId xmlns:a16="http://schemas.microsoft.com/office/drawing/2014/main" id="{D86847B5-3D46-4892-80BC-57286556D550}"/>
+                <a16:creationId xmlns:a16="http://schemas.microsoft.com/office/drawing/2014/main" id="{5CAB9BFE-ACE5-42B9-859E-14024D759E37}"/>
               </a:ext>
             </a:extLst>
           </p:cNvPr>
@@ -2227,7 +2227,7 @@
           <p:cNvPr id="33" name="">
             <a:extLst xmlns:a="http://schemas.openxmlformats.org/drawingml/2006/main">
               <a:ext uri="{FF2B5EF4-FFF2-40B4-BE49-F238E27FC236}">
-                <a16:creationId xmlns:a16="http://schemas.microsoft.com/office/drawing/2014/main" id="{C0B0BEAD-21B6-4E44-8CE2-E5D4E83154C2}"/>
+                <a16:creationId xmlns:a16="http://schemas.microsoft.com/office/drawing/2014/main" id="{7FCDA525-77FA-4893-BD86-D40BE8377816}"/>
               </a:ext>
             </a:extLst>
           </p:cNvPr>
@@ -2260,7 +2260,7 @@
           <p:cNvPr id="34" name="">
             <a:extLst xmlns:a="http://schemas.openxmlformats.org/drawingml/2006/main">
               <a:ext uri="{FF2B5EF4-FFF2-40B4-BE49-F238E27FC236}">
-                <a16:creationId xmlns:a16="http://schemas.microsoft.com/office/drawing/2014/main" id="{BFCE4C6E-0CF3-4550-B0A4-E8232B9443E7}"/>
+                <a16:creationId xmlns:a16="http://schemas.microsoft.com/office/drawing/2014/main" id="{72B4E68C-85B2-43C9-B3D4-E36CF1B8A03E}"/>
               </a:ext>
             </a:extLst>
           </p:cNvPr>
@@ -2316,7 +2316,7 @@
           <p:cNvPr id="35" name="">
             <a:extLst xmlns:a="http://schemas.openxmlformats.org/drawingml/2006/main">
               <a:ext uri="{FF2B5EF4-FFF2-40B4-BE49-F238E27FC236}">
-                <a16:creationId xmlns:a16="http://schemas.microsoft.com/office/drawing/2014/main" id="{FB5082E7-7869-41C6-AAF5-7F32CB9ECACE}"/>
+                <a16:creationId xmlns:a16="http://schemas.microsoft.com/office/drawing/2014/main" id="{09A13C29-27B9-4869-95AC-178627B6D164}"/>
               </a:ext>
             </a:extLst>
           </p:cNvPr>
@@ -2372,7 +2372,7 @@
           <p:cNvPr id="36" name="">
             <a:extLst xmlns:a="http://schemas.openxmlformats.org/drawingml/2006/main">
               <a:ext uri="{FF2B5EF4-FFF2-40B4-BE49-F238E27FC236}">
-                <a16:creationId xmlns:a16="http://schemas.microsoft.com/office/drawing/2014/main" id="{087B2C24-BC07-4EBD-BBF7-B599644ED22E}"/>
+                <a16:creationId xmlns:a16="http://schemas.microsoft.com/office/drawing/2014/main" id="{96BA1108-8F20-42CE-B725-40F7307764C2}"/>
               </a:ext>
             </a:extLst>
           </p:cNvPr>
@@ -2403,7 +2403,7 @@
           <p:cNvPr id="37" name="">
             <a:extLst xmlns:a="http://schemas.openxmlformats.org/drawingml/2006/main">
               <a:ext uri="{FF2B5EF4-FFF2-40B4-BE49-F238E27FC236}">
-                <a16:creationId xmlns:a16="http://schemas.microsoft.com/office/drawing/2014/main" id="{1D9BB71A-6AB7-4EB4-851D-3513CDAD28F2}"/>
+                <a16:creationId xmlns:a16="http://schemas.microsoft.com/office/drawing/2014/main" id="{8DA37658-E92C-4D67-9A49-C05F02D5B84A}"/>
               </a:ext>
             </a:extLst>
           </p:cNvPr>
@@ -2436,7 +2436,7 @@
           <p:cNvPr id="38" name="">
             <a:extLst xmlns:a="http://schemas.openxmlformats.org/drawingml/2006/main">
               <a:ext uri="{FF2B5EF4-FFF2-40B4-BE49-F238E27FC236}">
-                <a16:creationId xmlns:a16="http://schemas.microsoft.com/office/drawing/2014/main" id="{D033CB2B-AEBD-47D1-A7EF-D94A62604D71}"/>
+                <a16:creationId xmlns:a16="http://schemas.microsoft.com/office/drawing/2014/main" id="{8C96433C-1F0F-41E1-9C83-8A6AD68C254F}"/>
               </a:ext>
             </a:extLst>
           </p:cNvPr>
@@ -2492,7 +2492,7 @@
           <p:cNvPr id="39" name="">
             <a:extLst xmlns:a="http://schemas.openxmlformats.org/drawingml/2006/main">
               <a:ext uri="{FF2B5EF4-FFF2-40B4-BE49-F238E27FC236}">
-                <a16:creationId xmlns:a16="http://schemas.microsoft.com/office/drawing/2014/main" id="{002D862A-4C2B-4E40-8AAA-B399A661D8BC}"/>
+                <a16:creationId xmlns:a16="http://schemas.microsoft.com/office/drawing/2014/main" id="{BF6DBF9E-23D1-4416-ADCB-E180B3C6D1DE}"/>
               </a:ext>
             </a:extLst>
           </p:cNvPr>
@@ -2548,7 +2548,7 @@
           <p:cNvPr id="40" name="">
             <a:extLst xmlns:a="http://schemas.openxmlformats.org/drawingml/2006/main">
               <a:ext uri="{FF2B5EF4-FFF2-40B4-BE49-F238E27FC236}">
-                <a16:creationId xmlns:a16="http://schemas.microsoft.com/office/drawing/2014/main" id="{F842EA0F-9B3B-46B9-94D8-8D14887A4DE2}"/>
+                <a16:creationId xmlns:a16="http://schemas.microsoft.com/office/drawing/2014/main" id="{694399DB-4896-4CDD-A66F-29496F91DC4A}"/>
               </a:ext>
             </a:extLst>
           </p:cNvPr>
@@ -2579,7 +2579,7 @@
           <p:cNvPr id="41" name="">
             <a:extLst xmlns:a="http://schemas.openxmlformats.org/drawingml/2006/main">
               <a:ext uri="{FF2B5EF4-FFF2-40B4-BE49-F238E27FC236}">
-                <a16:creationId xmlns:a16="http://schemas.microsoft.com/office/drawing/2014/main" id="{15374795-F3E4-4D9A-9070-E1F2C564CF7F}"/>
+                <a16:creationId xmlns:a16="http://schemas.microsoft.com/office/drawing/2014/main" id="{8A7DA297-EEC2-482A-BC8E-9829673499C8}"/>
               </a:ext>
             </a:extLst>
           </p:cNvPr>
@@ -2612,7 +2612,7 @@
           <p:cNvPr id="42" name="">
             <a:extLst xmlns:a="http://schemas.openxmlformats.org/drawingml/2006/main">
               <a:ext uri="{FF2B5EF4-FFF2-40B4-BE49-F238E27FC236}">
-                <a16:creationId xmlns:a16="http://schemas.microsoft.com/office/drawing/2014/main" id="{2BBF123A-F585-401B-B21A-A08F551143F4}"/>
+                <a16:creationId xmlns:a16="http://schemas.microsoft.com/office/drawing/2014/main" id="{260235D6-4421-4B6C-B6E0-8E42207FB3C0}"/>
               </a:ext>
             </a:extLst>
           </p:cNvPr>
@@ -2668,7 +2668,7 @@
           <p:cNvPr id="43" name="">
             <a:extLst xmlns:a="http://schemas.openxmlformats.org/drawingml/2006/main">
               <a:ext uri="{FF2B5EF4-FFF2-40B4-BE49-F238E27FC236}">
-                <a16:creationId xmlns:a16="http://schemas.microsoft.com/office/drawing/2014/main" id="{9F2C1BCC-D4BA-4E2A-9428-2FD4CAE5CBF5}"/>
+                <a16:creationId xmlns:a16="http://schemas.microsoft.com/office/drawing/2014/main" id="{0D5A7496-7164-47E4-9364-1B94CA41996D}"/>
               </a:ext>
             </a:extLst>
           </p:cNvPr>
@@ -2724,7 +2724,7 @@
           <p:cNvPr id="44" name="">
             <a:extLst xmlns:a="http://schemas.openxmlformats.org/drawingml/2006/main">
               <a:ext uri="{FF2B5EF4-FFF2-40B4-BE49-F238E27FC236}">
-                <a16:creationId xmlns:a16="http://schemas.microsoft.com/office/drawing/2014/main" id="{3B795F11-CD17-4BD2-8305-FE410BC33788}"/>
+                <a16:creationId xmlns:a16="http://schemas.microsoft.com/office/drawing/2014/main" id="{14E19ABB-91CB-4C8B-A87F-8DCA3F924D70}"/>
               </a:ext>
             </a:extLst>
           </p:cNvPr>
@@ -2755,7 +2755,7 @@
           <p:cNvPr id="45" name="">
             <a:extLst xmlns:a="http://schemas.openxmlformats.org/drawingml/2006/main">
               <a:ext uri="{FF2B5EF4-FFF2-40B4-BE49-F238E27FC236}">
-                <a16:creationId xmlns:a16="http://schemas.microsoft.com/office/drawing/2014/main" id="{114EA26B-3ED5-4D9C-A4BB-04E55B6C52B5}"/>
+                <a16:creationId xmlns:a16="http://schemas.microsoft.com/office/drawing/2014/main" id="{B0C1B1B1-1976-4A55-97A5-21A53BDC4D11}"/>
               </a:ext>
             </a:extLst>
           </p:cNvPr>
@@ -2788,7 +2788,7 @@
           <p:cNvPr id="46" name="">
             <a:extLst xmlns:a="http://schemas.openxmlformats.org/drawingml/2006/main">
               <a:ext uri="{FF2B5EF4-FFF2-40B4-BE49-F238E27FC236}">
-                <a16:creationId xmlns:a16="http://schemas.microsoft.com/office/drawing/2014/main" id="{43AA1C66-E232-4123-94F5-1F6EE2CD6663}"/>
+                <a16:creationId xmlns:a16="http://schemas.microsoft.com/office/drawing/2014/main" id="{BFF57B4F-F88E-4573-A064-A3710604A578}"/>
               </a:ext>
             </a:extLst>
           </p:cNvPr>
@@ -2844,7 +2844,7 @@
           <p:cNvPr id="47" name="">
             <a:extLst xmlns:a="http://schemas.openxmlformats.org/drawingml/2006/main">
               <a:ext uri="{FF2B5EF4-FFF2-40B4-BE49-F238E27FC236}">
-                <a16:creationId xmlns:a16="http://schemas.microsoft.com/office/drawing/2014/main" id="{8CE12C42-791D-4EDF-8FAB-535338836FD9}"/>
+                <a16:creationId xmlns:a16="http://schemas.microsoft.com/office/drawing/2014/main" id="{D8ECBF46-BF43-4296-AA13-080B2B1CA9EA}"/>
               </a:ext>
             </a:extLst>
           </p:cNvPr>
@@ -2900,7 +2900,7 @@
           <p:cNvPr id="48" name="">
             <a:extLst xmlns:a="http://schemas.openxmlformats.org/drawingml/2006/main">
               <a:ext uri="{FF2B5EF4-FFF2-40B4-BE49-F238E27FC236}">
-                <a16:creationId xmlns:a16="http://schemas.microsoft.com/office/drawing/2014/main" id="{7B367E6B-8CF3-4A18-82F5-12C09EDC66AA}"/>
+                <a16:creationId xmlns:a16="http://schemas.microsoft.com/office/drawing/2014/main" id="{88C4049E-7D82-45CA-98B7-E397B5884C1E}"/>
               </a:ext>
             </a:extLst>
           </p:cNvPr>
@@ -2931,7 +2931,7 @@
           <p:cNvPr id="49" name="">
             <a:extLst xmlns:a="http://schemas.openxmlformats.org/drawingml/2006/main">
               <a:ext uri="{FF2B5EF4-FFF2-40B4-BE49-F238E27FC236}">
-                <a16:creationId xmlns:a16="http://schemas.microsoft.com/office/drawing/2014/main" id="{283F6783-EA5F-4227-8BD9-5DA35A767330}"/>
+                <a16:creationId xmlns:a16="http://schemas.microsoft.com/office/drawing/2014/main" id="{25541692-DED4-4D09-B745-2135558931CC}"/>
               </a:ext>
             </a:extLst>
           </p:cNvPr>
@@ -2964,7 +2964,7 @@
           <p:cNvPr id="50" name="">
             <a:extLst xmlns:a="http://schemas.openxmlformats.org/drawingml/2006/main">
               <a:ext uri="{FF2B5EF4-FFF2-40B4-BE49-F238E27FC236}">
-                <a16:creationId xmlns:a16="http://schemas.microsoft.com/office/drawing/2014/main" id="{A8C386EF-FDD6-447D-9ED1-36B6428B2A0B}"/>
+                <a16:creationId xmlns:a16="http://schemas.microsoft.com/office/drawing/2014/main" id="{7AD1D150-3A2D-4BD2-80B6-B865E3579902}"/>
               </a:ext>
             </a:extLst>
           </p:cNvPr>
@@ -3020,7 +3020,7 @@
           <p:cNvPr id="51" name="">
             <a:extLst xmlns:a="http://schemas.openxmlformats.org/drawingml/2006/main">
               <a:ext uri="{FF2B5EF4-FFF2-40B4-BE49-F238E27FC236}">
-                <a16:creationId xmlns:a16="http://schemas.microsoft.com/office/drawing/2014/main" id="{3DFE3C94-33A1-4D5D-A4F5-098343E83E16}"/>
+                <a16:creationId xmlns:a16="http://schemas.microsoft.com/office/drawing/2014/main" id="{51F3FF10-8D8E-4641-AE49-346819B56ABB}"/>
               </a:ext>
             </a:extLst>
           </p:cNvPr>
@@ -3109,7 +3109,7 @@
           <p:nvPr/>
         </p:nvPicPr>
         <p:blipFill>
-          <a:blip xmlns:r="http://schemas.openxmlformats.org/officeDocument/2006/relationships" xmlns:a="http://schemas.openxmlformats.org/drawingml/2006/main" r:embed="R85288a28c2c645a6"/>
+          <a:blip xmlns:r="http://schemas.openxmlformats.org/officeDocument/2006/relationships" xmlns:a="http://schemas.openxmlformats.org/drawingml/2006/main" r:embed="Rb298ec20aa2f4824"/>
           <a:stretch xmlns:a="http://schemas.openxmlformats.org/drawingml/2006/main"/>
         </p:blipFill>
         <p:spPr>
@@ -3456,7 +3456,7 @@
           <p:cNvPr id="41" name="">
             <a:extLst xmlns:a="http://schemas.openxmlformats.org/drawingml/2006/main">
               <a:ext uri="{FF2B5EF4-FFF2-40B4-BE49-F238E27FC236}">
-                <a16:creationId xmlns:a16="http://schemas.microsoft.com/office/drawing/2014/main" id="{D94333CA-575D-4C00-AAA5-B051CA30AC8D}"/>
+                <a16:creationId xmlns:a16="http://schemas.microsoft.com/office/drawing/2014/main" id="{8E6C3190-DF20-48AE-8599-B12BDFD79ACE}"/>
               </a:ext>
             </a:extLst>
           </p:cNvPr>
@@ -3512,7 +3512,7 @@
           <p:cNvPr id="42" name="">
             <a:extLst xmlns:a="http://schemas.openxmlformats.org/drawingml/2006/main">
               <a:ext uri="{FF2B5EF4-FFF2-40B4-BE49-F238E27FC236}">
-                <a16:creationId xmlns:a16="http://schemas.microsoft.com/office/drawing/2014/main" id="{8E24765B-45A9-4148-B9AD-3257E5584F90}"/>
+                <a16:creationId xmlns:a16="http://schemas.microsoft.com/office/drawing/2014/main" id="{C6BCC9A1-F5BF-49D9-8690-6E9CB8B9E28C}"/>
               </a:ext>
             </a:extLst>
           </p:cNvPr>
@@ -3568,7 +3568,7 @@
           <p:cNvPr id="43" name="">
             <a:extLst xmlns:a="http://schemas.openxmlformats.org/drawingml/2006/main">
               <a:ext uri="{FF2B5EF4-FFF2-40B4-BE49-F238E27FC236}">
-                <a16:creationId xmlns:a16="http://schemas.microsoft.com/office/drawing/2014/main" id="{97D6EF02-4A39-4E0B-B1A8-F31211EB792E}"/>
+                <a16:creationId xmlns:a16="http://schemas.microsoft.com/office/drawing/2014/main" id="{CBE55F47-6ECE-4C41-BBC0-CE755D509132}"/>
               </a:ext>
             </a:extLst>
           </p:cNvPr>
@@ -3599,7 +3599,7 @@
           <p:cNvPr id="44" name="">
             <a:extLst xmlns:a="http://schemas.openxmlformats.org/drawingml/2006/main">
               <a:ext uri="{FF2B5EF4-FFF2-40B4-BE49-F238E27FC236}">
-                <a16:creationId xmlns:a16="http://schemas.microsoft.com/office/drawing/2014/main" id="{6ED8811E-B5D0-4B87-84DB-6605FC4F74CB}"/>
+                <a16:creationId xmlns:a16="http://schemas.microsoft.com/office/drawing/2014/main" id="{5A75CD17-ECF2-4DB6-907F-340B3CDC79B2}"/>
               </a:ext>
             </a:extLst>
           </p:cNvPr>
@@ -3630,7 +3630,7 @@
           <p:cNvPr id="45" name="">
             <a:extLst xmlns:a="http://schemas.openxmlformats.org/drawingml/2006/main">
               <a:ext uri="{FF2B5EF4-FFF2-40B4-BE49-F238E27FC236}">
-                <a16:creationId xmlns:a16="http://schemas.microsoft.com/office/drawing/2014/main" id="{0D64A576-C1AE-4BBE-BC32-7BB60B9B7DB8}"/>
+                <a16:creationId xmlns:a16="http://schemas.microsoft.com/office/drawing/2014/main" id="{05AC51F4-9196-4235-AB14-7DBAD908CEAA}"/>
               </a:ext>
             </a:extLst>
           </p:cNvPr>
@@ -3663,7 +3663,7 @@
           <p:cNvPr id="46" name="">
             <a:extLst xmlns:a="http://schemas.openxmlformats.org/drawingml/2006/main">
               <a:ext uri="{FF2B5EF4-FFF2-40B4-BE49-F238E27FC236}">
-                <a16:creationId xmlns:a16="http://schemas.microsoft.com/office/drawing/2014/main" id="{51D768F6-BE63-44D0-A2A8-02D56F39C0D0}"/>
+                <a16:creationId xmlns:a16="http://schemas.microsoft.com/office/drawing/2014/main" id="{B911A015-D2F4-4620-9E66-A9437A5855A7}"/>
               </a:ext>
             </a:extLst>
           </p:cNvPr>
@@ -3719,7 +3719,7 @@
           <p:cNvPr id="47" name="">
             <a:extLst xmlns:a="http://schemas.openxmlformats.org/drawingml/2006/main">
               <a:ext uri="{FF2B5EF4-FFF2-40B4-BE49-F238E27FC236}">
-                <a16:creationId xmlns:a16="http://schemas.microsoft.com/office/drawing/2014/main" id="{20C7D5E3-26C7-46BA-803A-83E81D3A2759}"/>
+                <a16:creationId xmlns:a16="http://schemas.microsoft.com/office/drawing/2014/main" id="{00BB29CA-9867-43F4-9A6F-1AC61011B06F}"/>
               </a:ext>
             </a:extLst>
           </p:cNvPr>
@@ -3775,7 +3775,7 @@
           <p:cNvPr id="48" name="">
             <a:extLst xmlns:a="http://schemas.openxmlformats.org/drawingml/2006/main">
               <a:ext uri="{FF2B5EF4-FFF2-40B4-BE49-F238E27FC236}">
-                <a16:creationId xmlns:a16="http://schemas.microsoft.com/office/drawing/2014/main" id="{CEDB4F8C-01A5-4515-878B-A878523ADBB1}"/>
+                <a16:creationId xmlns:a16="http://schemas.microsoft.com/office/drawing/2014/main" id="{20ADFF5D-46B0-4B4D-AC83-1A02E9F65EA6}"/>
               </a:ext>
             </a:extLst>
           </p:cNvPr>
@@ -3831,7 +3831,7 @@
           <p:cNvPr id="49" name="">
             <a:extLst xmlns:a="http://schemas.openxmlformats.org/drawingml/2006/main">
               <a:ext uri="{FF2B5EF4-FFF2-40B4-BE49-F238E27FC236}">
-                <a16:creationId xmlns:a16="http://schemas.microsoft.com/office/drawing/2014/main" id="{6F428BCD-A263-40A3-989B-DD4F32AEBB52}"/>
+                <a16:creationId xmlns:a16="http://schemas.microsoft.com/office/drawing/2014/main" id="{84B82A4A-54F6-4E43-A22A-CCADFC07805B}"/>
               </a:ext>
             </a:extLst>
           </p:cNvPr>
@@ -3864,7 +3864,7 @@
           <p:cNvPr id="50" name="">
             <a:extLst xmlns:a="http://schemas.openxmlformats.org/drawingml/2006/main">
               <a:ext uri="{FF2B5EF4-FFF2-40B4-BE49-F238E27FC236}">
-                <a16:creationId xmlns:a16="http://schemas.microsoft.com/office/drawing/2014/main" id="{6BE6D66D-DF33-46CE-8046-07CFF9DB66E2}"/>
+                <a16:creationId xmlns:a16="http://schemas.microsoft.com/office/drawing/2014/main" id="{14907599-3AE4-4ACD-8F71-0AC0719380C8}"/>
               </a:ext>
             </a:extLst>
           </p:cNvPr>
@@ -3920,7 +3920,7 @@
           <p:cNvPr id="51" name="">
             <a:extLst xmlns:a="http://schemas.openxmlformats.org/drawingml/2006/main">
               <a:ext uri="{FF2B5EF4-FFF2-40B4-BE49-F238E27FC236}">
-                <a16:creationId xmlns:a16="http://schemas.microsoft.com/office/drawing/2014/main" id="{590A08FF-F87D-4C85-A4CF-4DA6BEA765A8}"/>
+                <a16:creationId xmlns:a16="http://schemas.microsoft.com/office/drawing/2014/main" id="{E5F41AFA-D4AA-4A5A-9449-919962B51E03}"/>
               </a:ext>
             </a:extLst>
           </p:cNvPr>
@@ -3976,7 +3976,7 @@
           <p:cNvPr id="52" name="">
             <a:extLst xmlns:a="http://schemas.openxmlformats.org/drawingml/2006/main">
               <a:ext uri="{FF2B5EF4-FFF2-40B4-BE49-F238E27FC236}">
-                <a16:creationId xmlns:a16="http://schemas.microsoft.com/office/drawing/2014/main" id="{CA77FD6C-7927-4F13-8808-D4A23589F3FB}"/>
+                <a16:creationId xmlns:a16="http://schemas.microsoft.com/office/drawing/2014/main" id="{7AAB9711-E852-4D81-BE07-91955C000995}"/>
               </a:ext>
             </a:extLst>
           </p:cNvPr>
@@ -4032,7 +4032,7 @@
           <p:cNvPr id="53" name="">
             <a:extLst xmlns:a="http://schemas.openxmlformats.org/drawingml/2006/main">
               <a:ext uri="{FF2B5EF4-FFF2-40B4-BE49-F238E27FC236}">
-                <a16:creationId xmlns:a16="http://schemas.microsoft.com/office/drawing/2014/main" id="{E0118196-4274-4D3B-9991-27F8CC7B569B}"/>
+                <a16:creationId xmlns:a16="http://schemas.microsoft.com/office/drawing/2014/main" id="{CCA0D984-91C0-4248-94DF-5D4009DE7887}"/>
               </a:ext>
             </a:extLst>
           </p:cNvPr>
@@ -4065,7 +4065,7 @@
           <p:cNvPr id="54" name="">
             <a:extLst xmlns:a="http://schemas.openxmlformats.org/drawingml/2006/main">
               <a:ext uri="{FF2B5EF4-FFF2-40B4-BE49-F238E27FC236}">
-                <a16:creationId xmlns:a16="http://schemas.microsoft.com/office/drawing/2014/main" id="{A90397BD-845A-4CAA-8C2F-A71DD3F4E3E6}"/>
+                <a16:creationId xmlns:a16="http://schemas.microsoft.com/office/drawing/2014/main" id="{EE4F2781-009F-4D64-B5CE-2560963838F0}"/>
               </a:ext>
             </a:extLst>
           </p:cNvPr>
@@ -4121,7 +4121,7 @@
           <p:cNvPr id="55" name="">
             <a:extLst xmlns:a="http://schemas.openxmlformats.org/drawingml/2006/main">
               <a:ext uri="{FF2B5EF4-FFF2-40B4-BE49-F238E27FC236}">
-                <a16:creationId xmlns:a16="http://schemas.microsoft.com/office/drawing/2014/main" id="{2196F9FE-74C2-4F87-86B7-F8DCC28C477D}"/>
+                <a16:creationId xmlns:a16="http://schemas.microsoft.com/office/drawing/2014/main" id="{C6D30414-23D8-4B6A-A53B-522740B8EB9A}"/>
               </a:ext>
             </a:extLst>
           </p:cNvPr>
@@ -4177,7 +4177,7 @@
           <p:cNvPr id="56" name="">
             <a:extLst xmlns:a="http://schemas.openxmlformats.org/drawingml/2006/main">
               <a:ext uri="{FF2B5EF4-FFF2-40B4-BE49-F238E27FC236}">
-                <a16:creationId xmlns:a16="http://schemas.microsoft.com/office/drawing/2014/main" id="{05E49F69-D8E1-4ED7-8D14-DC46AF86FA2D}"/>
+                <a16:creationId xmlns:a16="http://schemas.microsoft.com/office/drawing/2014/main" id="{2B3189CF-A712-45F1-9461-573E718A85F9}"/>
               </a:ext>
             </a:extLst>
           </p:cNvPr>
@@ -4233,7 +4233,7 @@
           <p:cNvPr id="57" name="">
             <a:extLst xmlns:a="http://schemas.openxmlformats.org/drawingml/2006/main">
               <a:ext uri="{FF2B5EF4-FFF2-40B4-BE49-F238E27FC236}">
-                <a16:creationId xmlns:a16="http://schemas.microsoft.com/office/drawing/2014/main" id="{D91A362F-75D7-4B5A-8F2B-E2D55FA2C49A}"/>
+                <a16:creationId xmlns:a16="http://schemas.microsoft.com/office/drawing/2014/main" id="{A748BC5B-2D1C-4073-8853-E631D09DB3A7}"/>
               </a:ext>
             </a:extLst>
           </p:cNvPr>
@@ -4266,7 +4266,7 @@
           <p:cNvPr id="58" name="">
             <a:extLst xmlns:a="http://schemas.openxmlformats.org/drawingml/2006/main">
               <a:ext uri="{FF2B5EF4-FFF2-40B4-BE49-F238E27FC236}">
-                <a16:creationId xmlns:a16="http://schemas.microsoft.com/office/drawing/2014/main" id="{52BEBF0D-3493-4B65-B670-68F22683191F}"/>
+                <a16:creationId xmlns:a16="http://schemas.microsoft.com/office/drawing/2014/main" id="{C98889B5-92FA-4E30-811D-750E441B017D}"/>
               </a:ext>
             </a:extLst>
           </p:cNvPr>
@@ -4322,7 +4322,7 @@
           <p:cNvPr id="59" name="">
             <a:extLst xmlns:a="http://schemas.openxmlformats.org/drawingml/2006/main">
               <a:ext uri="{FF2B5EF4-FFF2-40B4-BE49-F238E27FC236}">
-                <a16:creationId xmlns:a16="http://schemas.microsoft.com/office/drawing/2014/main" id="{E864589B-D946-4CEC-A543-4096508B7EB9}"/>
+                <a16:creationId xmlns:a16="http://schemas.microsoft.com/office/drawing/2014/main" id="{2A988CD5-8C4E-41A3-97F2-591D1F3908C7}"/>
               </a:ext>
             </a:extLst>
           </p:cNvPr>
@@ -4378,7 +4378,7 @@
           <p:cNvPr id="60" name="">
             <a:extLst xmlns:a="http://schemas.openxmlformats.org/drawingml/2006/main">
               <a:ext uri="{FF2B5EF4-FFF2-40B4-BE49-F238E27FC236}">
-                <a16:creationId xmlns:a16="http://schemas.microsoft.com/office/drawing/2014/main" id="{7F2739EE-F2B5-4F89-9B51-98E6F701198A}"/>
+                <a16:creationId xmlns:a16="http://schemas.microsoft.com/office/drawing/2014/main" id="{48461C02-E6FB-422C-B8CB-6FB6AFEF2F18}"/>
               </a:ext>
             </a:extLst>
           </p:cNvPr>
@@ -4438,7 +4438,7 @@
           <p:nvPr/>
         </p:nvPicPr>
         <p:blipFill>
-          <a:blip xmlns:r="http://schemas.openxmlformats.org/officeDocument/2006/relationships" xmlns:a="http://schemas.openxmlformats.org/drawingml/2006/main" r:embed="R68a382957f6544b7"/>
+          <a:blip xmlns:r="http://schemas.openxmlformats.org/officeDocument/2006/relationships" xmlns:a="http://schemas.openxmlformats.org/drawingml/2006/main" r:embed="R8fec904f4fbd4d8f"/>
           <a:stretch xmlns:a="http://schemas.openxmlformats.org/drawingml/2006/main"/>
         </p:blipFill>
         <p:spPr>
@@ -4460,7 +4460,7 @@
           <p:nvPr/>
         </p:nvPicPr>
         <p:blipFill>
-          <a:blip xmlns:r="http://schemas.openxmlformats.org/officeDocument/2006/relationships" xmlns:a="http://schemas.openxmlformats.org/drawingml/2006/main" r:embed="R153754e11e9e4d8e"/>
+          <a:blip xmlns:r="http://schemas.openxmlformats.org/officeDocument/2006/relationships" xmlns:a="http://schemas.openxmlformats.org/drawingml/2006/main" r:embed="R5f970bc1712342a2"/>
           <a:stretch xmlns:a="http://schemas.openxmlformats.org/drawingml/2006/main"/>
         </p:blipFill>
         <p:spPr>
@@ -4482,7 +4482,7 @@
           <p:nvPr/>
         </p:nvPicPr>
         <p:blipFill>
-          <a:blip xmlns:r="http://schemas.openxmlformats.org/officeDocument/2006/relationships" xmlns:a="http://schemas.openxmlformats.org/drawingml/2006/main" r:embed="R5945291da2334dbd"/>
+          <a:blip xmlns:r="http://schemas.openxmlformats.org/officeDocument/2006/relationships" xmlns:a="http://schemas.openxmlformats.org/drawingml/2006/main" r:embed="R071d90089de74cb2"/>
           <a:stretch xmlns:a="http://schemas.openxmlformats.org/drawingml/2006/main"/>
         </p:blipFill>
         <p:spPr>

</xml_diff>

<commit_message>
Merge latest presentation updates
</commit_message>
<xml_diff>
--- a/output/sections/01-个人介绍.pptx
+++ b/output/sections/01-个人介绍.pptx
@@ -2,15 +2,15 @@
 <file path=ppt/presentation.xml><?xml version="1.0" encoding="utf-8"?>
 <p:presentation xmlns:p="http://schemas.openxmlformats.org/presentationml/2006/main">
   <p:sldMasterIdLst>
-    <p:sldMasterId xmlns:r="http://schemas.openxmlformats.org/officeDocument/2006/relationships" id="2147483648" r:id="Rd6e2e73f9c61466a"/>
+    <p:sldMasterId xmlns:r="http://schemas.openxmlformats.org/officeDocument/2006/relationships" id="2147483648" r:id="Rdf0973935e8a4be3"/>
   </p:sldMasterIdLst>
   <p:notesMasterIdLst>
-    <p:notesMasterId xmlns:r="http://schemas.openxmlformats.org/officeDocument/2006/relationships" r:id="R2812a782c0cf492b"/>
+    <p:notesMasterId xmlns:r="http://schemas.openxmlformats.org/officeDocument/2006/relationships" r:id="Rabf79f3a1ef14656"/>
   </p:notesMasterIdLst>
   <p:sldIdLst>
-    <p:sldId xmlns:r="http://schemas.openxmlformats.org/officeDocument/2006/relationships" id="256" r:id="Rac164fc6a39749b7"/>
-    <p:sldId xmlns:r="http://schemas.openxmlformats.org/officeDocument/2006/relationships" id="257" r:id="Rfdc7237a04d44e79"/>
-    <p:sldId xmlns:r="http://schemas.openxmlformats.org/officeDocument/2006/relationships" id="258" r:id="R68e4e88293214aa2"/>
+    <p:sldId xmlns:r="http://schemas.openxmlformats.org/officeDocument/2006/relationships" id="256" r:id="Rd4b6f63b757d4cb6"/>
+    <p:sldId xmlns:r="http://schemas.openxmlformats.org/officeDocument/2006/relationships" id="257" r:id="R9c12a26a5c5c4361"/>
+    <p:sldId xmlns:r="http://schemas.openxmlformats.org/officeDocument/2006/relationships" id="258" r:id="Ra8346eee93024065"/>
   </p:sldIdLst>
   <p:sldSz cx="12192000" cy="6858000"/>
   <p:notesSz cx="6858000" cy="9144000"/>
@@ -735,7 +735,7 @@
   </p:cSld>
   <p:clrMap bg1="lt1" tx1="dk1" bg2="lt2" tx2="dk2" accent1="accent1" accent2="accent2" accent3="accent3" accent4="accent4" accent5="accent5" accent6="accent6" hlink="hlink" folHlink="folHlink"/>
   <p:sldLayoutIdLst>
-    <p:sldLayoutId xmlns:r="http://schemas.openxmlformats.org/officeDocument/2006/relationships" id="2147483649" r:id="R78d4b8be0de34c04"/>
+    <p:sldLayoutId xmlns:r="http://schemas.openxmlformats.org/officeDocument/2006/relationships" id="2147483649" r:id="Rf65b422d54044c0c"/>
   </p:sldLayoutIdLst>
   <p:txStyles>
     <p:titleStyle>
@@ -1352,7 +1352,7 @@
           <p:nvPr/>
         </p:nvPicPr>
         <p:blipFill>
-          <a:blip xmlns:r="http://schemas.openxmlformats.org/officeDocument/2006/relationships" xmlns:a="http://schemas.openxmlformats.org/drawingml/2006/main" r:embed="Ree3f03fd092345df"/>
+          <a:blip xmlns:r="http://schemas.openxmlformats.org/officeDocument/2006/relationships" xmlns:a="http://schemas.openxmlformats.org/drawingml/2006/main" r:embed="Rae7c05efdc3144b8"/>
           <a:stretch xmlns:a="http://schemas.openxmlformats.org/drawingml/2006/main"/>
         </p:blipFill>
         <p:spPr>
@@ -1427,7 +1427,7 @@
           <p:cNvPr id="14" name="">
             <a:extLst xmlns:a="http://schemas.openxmlformats.org/drawingml/2006/main">
               <a:ext uri="{FF2B5EF4-FFF2-40B4-BE49-F238E27FC236}">
-                <a16:creationId xmlns:a16="http://schemas.microsoft.com/office/drawing/2014/main" id="{2CD15E2A-6D28-4143-885F-BECEB1007C74}"/>
+                <a16:creationId xmlns:a16="http://schemas.microsoft.com/office/drawing/2014/main" id="{2987E94D-1273-4986-844D-ED5DCDCE5927}"/>
               </a:ext>
             </a:extLst>
           </p:cNvPr>
@@ -1458,7 +1458,7 @@
           <p:cNvPr id="15" name="">
             <a:extLst xmlns:a="http://schemas.openxmlformats.org/drawingml/2006/main">
               <a:ext uri="{FF2B5EF4-FFF2-40B4-BE49-F238E27FC236}">
-                <a16:creationId xmlns:a16="http://schemas.microsoft.com/office/drawing/2014/main" id="{20E8DAD1-0179-4286-958B-323E12196705}"/>
+                <a16:creationId xmlns:a16="http://schemas.microsoft.com/office/drawing/2014/main" id="{98CF785B-B4D1-40D9-8FE6-0287E4A0D4DC}"/>
               </a:ext>
             </a:extLst>
           </p:cNvPr>
@@ -1514,7 +1514,7 @@
           <p:cNvPr id="16" name="">
             <a:extLst xmlns:a="http://schemas.openxmlformats.org/drawingml/2006/main">
               <a:ext uri="{FF2B5EF4-FFF2-40B4-BE49-F238E27FC236}">
-                <a16:creationId xmlns:a16="http://schemas.microsoft.com/office/drawing/2014/main" id="{28AD9279-F3C2-46A6-92BB-2F74FC2A396F}"/>
+                <a16:creationId xmlns:a16="http://schemas.microsoft.com/office/drawing/2014/main" id="{6A9AC68A-EF07-47E7-B3E0-040F0F735E92}"/>
               </a:ext>
             </a:extLst>
           </p:cNvPr>
@@ -1570,7 +1570,7 @@
           <p:cNvPr id="17" name="">
             <a:extLst xmlns:a="http://schemas.openxmlformats.org/drawingml/2006/main">
               <a:ext uri="{FF2B5EF4-FFF2-40B4-BE49-F238E27FC236}">
-                <a16:creationId xmlns:a16="http://schemas.microsoft.com/office/drawing/2014/main" id="{8787B36B-DFCF-4BA1-909C-1DA194968927}"/>
+                <a16:creationId xmlns:a16="http://schemas.microsoft.com/office/drawing/2014/main" id="{9338C4FC-BD67-4A26-B1E0-A0E5FE4E201F}"/>
               </a:ext>
             </a:extLst>
           </p:cNvPr>
@@ -1601,7 +1601,7 @@
           <p:cNvPr id="18" name="">
             <a:extLst xmlns:a="http://schemas.openxmlformats.org/drawingml/2006/main">
               <a:ext uri="{FF2B5EF4-FFF2-40B4-BE49-F238E27FC236}">
-                <a16:creationId xmlns:a16="http://schemas.microsoft.com/office/drawing/2014/main" id="{81CCD9EC-2475-4DD5-A039-77D3156B6E17}"/>
+                <a16:creationId xmlns:a16="http://schemas.microsoft.com/office/drawing/2014/main" id="{7EA4820E-CBAC-441C-9D8A-64E94672EF64}"/>
               </a:ext>
             </a:extLst>
           </p:cNvPr>
@@ -1657,7 +1657,7 @@
           <p:cNvPr id="19" name="">
             <a:extLst xmlns:a="http://schemas.openxmlformats.org/drawingml/2006/main">
               <a:ext uri="{FF2B5EF4-FFF2-40B4-BE49-F238E27FC236}">
-                <a16:creationId xmlns:a16="http://schemas.microsoft.com/office/drawing/2014/main" id="{94658346-41F8-42B4-9CBE-BC1C276279BD}"/>
+                <a16:creationId xmlns:a16="http://schemas.microsoft.com/office/drawing/2014/main" id="{DC857404-3ADD-43EB-A332-EF6E77247438}"/>
               </a:ext>
             </a:extLst>
           </p:cNvPr>
@@ -1713,7 +1713,7 @@
           <p:cNvPr id="20" name="">
             <a:extLst xmlns:a="http://schemas.openxmlformats.org/drawingml/2006/main">
               <a:ext uri="{FF2B5EF4-FFF2-40B4-BE49-F238E27FC236}">
-                <a16:creationId xmlns:a16="http://schemas.microsoft.com/office/drawing/2014/main" id="{DD6C2233-7895-40BD-9EFC-D793BD9BE78A}"/>
+                <a16:creationId xmlns:a16="http://schemas.microsoft.com/office/drawing/2014/main" id="{C1892D26-BB1B-4BCB-B826-C021EA9F5A66}"/>
               </a:ext>
             </a:extLst>
           </p:cNvPr>
@@ -1769,7 +1769,7 @@
           <p:cNvPr id="21" name="">
             <a:extLst xmlns:a="http://schemas.openxmlformats.org/drawingml/2006/main">
               <a:ext uri="{FF2B5EF4-FFF2-40B4-BE49-F238E27FC236}">
-                <a16:creationId xmlns:a16="http://schemas.microsoft.com/office/drawing/2014/main" id="{62BE744B-DBE8-471F-81DC-CA027C13071E}"/>
+                <a16:creationId xmlns:a16="http://schemas.microsoft.com/office/drawing/2014/main" id="{5F9E95DE-EC8D-4CAA-8737-4E31510E1B41}"/>
               </a:ext>
             </a:extLst>
           </p:cNvPr>
@@ -1800,7 +1800,7 @@
           <p:cNvPr id="22" name="">
             <a:extLst xmlns:a="http://schemas.openxmlformats.org/drawingml/2006/main">
               <a:ext uri="{FF2B5EF4-FFF2-40B4-BE49-F238E27FC236}">
-                <a16:creationId xmlns:a16="http://schemas.microsoft.com/office/drawing/2014/main" id="{CE121A29-EB3A-432F-B8AF-D5329647ADAD}"/>
+                <a16:creationId xmlns:a16="http://schemas.microsoft.com/office/drawing/2014/main" id="{899BF721-C97F-4899-BA0D-0A0E870AC1AC}"/>
               </a:ext>
             </a:extLst>
           </p:cNvPr>
@@ -1831,7 +1831,7 @@
           <p:cNvPr id="23" name="">
             <a:extLst xmlns:a="http://schemas.openxmlformats.org/drawingml/2006/main">
               <a:ext uri="{FF2B5EF4-FFF2-40B4-BE49-F238E27FC236}">
-                <a16:creationId xmlns:a16="http://schemas.microsoft.com/office/drawing/2014/main" id="{57CB0C6E-36FF-4F36-BCE0-420497965470}"/>
+                <a16:creationId xmlns:a16="http://schemas.microsoft.com/office/drawing/2014/main" id="{1CB5850A-5AB3-4AF7-83BB-73B452CA526E}"/>
               </a:ext>
             </a:extLst>
           </p:cNvPr>
@@ -1887,7 +1887,7 @@
           <p:cNvPr id="24" name="">
             <a:extLst xmlns:a="http://schemas.openxmlformats.org/drawingml/2006/main">
               <a:ext uri="{FF2B5EF4-FFF2-40B4-BE49-F238E27FC236}">
-                <a16:creationId xmlns:a16="http://schemas.microsoft.com/office/drawing/2014/main" id="{30E0CA58-59A3-43FD-9ADA-28C561A7C963}"/>
+                <a16:creationId xmlns:a16="http://schemas.microsoft.com/office/drawing/2014/main" id="{C7D6BE6C-1706-487E-B0B4-40B1DBE729E6}"/>
               </a:ext>
             </a:extLst>
           </p:cNvPr>
@@ -1976,7 +1976,7 @@
           <p:nvPr/>
         </p:nvPicPr>
         <p:blipFill>
-          <a:blip xmlns:r="http://schemas.openxmlformats.org/officeDocument/2006/relationships" xmlns:a="http://schemas.openxmlformats.org/drawingml/2006/main" r:embed="R9040dead78244ed5"/>
+          <a:blip xmlns:r="http://schemas.openxmlformats.org/officeDocument/2006/relationships" xmlns:a="http://schemas.openxmlformats.org/drawingml/2006/main" r:embed="R7172acc2ecc041bf"/>
           <a:stretch xmlns:a="http://schemas.openxmlformats.org/drawingml/2006/main"/>
         </p:blipFill>
         <p:spPr>
@@ -2196,22 +2196,24 @@
           <p:cNvPr id="32" name="">
             <a:extLst xmlns:a="http://schemas.openxmlformats.org/drawingml/2006/main">
               <a:ext uri="{FF2B5EF4-FFF2-40B4-BE49-F238E27FC236}">
-                <a16:creationId xmlns:a16="http://schemas.microsoft.com/office/drawing/2014/main" id="{5CAB9BFE-ACE5-42B9-859E-14024D759E37}"/>
-              </a:ext>
-            </a:extLst>
-          </p:cNvPr>
-          <p:cNvSpPr>
-            <a:spLocks xmlns:a="http://schemas.openxmlformats.org/drawingml/2006/main" noGrp="1"/>
-          </p:cNvSpPr>
-          <p:nvPr/>
-        </p:nvSpPr>
-        <p:spPr>
-          <a:xfrm xmlns:a="http://schemas.openxmlformats.org/drawingml/2006/main">
-            <a:off x="3629025" y="1762125"/>
-            <a:ext cx="5581650" cy="476250"/>
-          </a:xfrm>
-          <a:prstGeom xmlns:a="http://schemas.openxmlformats.org/drawingml/2006/main" prst="rect">
-            <a:avLst/>
+                <a16:creationId xmlns:a16="http://schemas.microsoft.com/office/drawing/2014/main" id="{F16D27AC-19A9-4C93-96D8-4750F67C067C}"/>
+              </a:ext>
+            </a:extLst>
+          </p:cNvPr>
+          <p:cNvSpPr>
+            <a:spLocks xmlns:a="http://schemas.openxmlformats.org/drawingml/2006/main" noGrp="1"/>
+          </p:cNvSpPr>
+          <p:nvPr/>
+        </p:nvSpPr>
+        <p:spPr>
+          <a:xfrm xmlns:a="http://schemas.openxmlformats.org/drawingml/2006/main">
+            <a:off x="3705225" y="1762125"/>
+            <a:ext cx="5505450" cy="476250"/>
+          </a:xfrm>
+          <a:prstGeom xmlns:a="http://schemas.openxmlformats.org/drawingml/2006/main" prst="roundRect">
+            <a:avLst>
+              <a:gd name="adj" fmla="val 16000"/>
+            </a:avLst>
           </a:prstGeom>
           <a:solidFill xmlns:a="http://schemas.openxmlformats.org/drawingml/2006/main">
             <a:srgbClr val="635BFF"/>
@@ -2227,7 +2229,7 @@
           <p:cNvPr id="33" name="">
             <a:extLst xmlns:a="http://schemas.openxmlformats.org/drawingml/2006/main">
               <a:ext uri="{FF2B5EF4-FFF2-40B4-BE49-F238E27FC236}">
-                <a16:creationId xmlns:a16="http://schemas.microsoft.com/office/drawing/2014/main" id="{7FCDA525-77FA-4893-BD86-D40BE8377816}"/>
+                <a16:creationId xmlns:a16="http://schemas.microsoft.com/office/drawing/2014/main" id="{FD3D387D-E54C-4607-87FF-89BB8A33A0C1}"/>
               </a:ext>
             </a:extLst>
           </p:cNvPr>
@@ -2260,7 +2262,7 @@
           <p:cNvPr id="34" name="">
             <a:extLst xmlns:a="http://schemas.openxmlformats.org/drawingml/2006/main">
               <a:ext uri="{FF2B5EF4-FFF2-40B4-BE49-F238E27FC236}">
-                <a16:creationId xmlns:a16="http://schemas.microsoft.com/office/drawing/2014/main" id="{72B4E68C-85B2-43C9-B3D4-E36CF1B8A03E}"/>
+                <a16:creationId xmlns:a16="http://schemas.microsoft.com/office/drawing/2014/main" id="{BC55A9E8-D287-4638-A3AA-2236B1FB60A3}"/>
               </a:ext>
             </a:extLst>
           </p:cNvPr>
@@ -2316,19 +2318,19 @@
           <p:cNvPr id="35" name="">
             <a:extLst xmlns:a="http://schemas.openxmlformats.org/drawingml/2006/main">
               <a:ext uri="{FF2B5EF4-FFF2-40B4-BE49-F238E27FC236}">
-                <a16:creationId xmlns:a16="http://schemas.microsoft.com/office/drawing/2014/main" id="{09A13C29-27B9-4869-95AC-178627B6D164}"/>
-              </a:ext>
-            </a:extLst>
-          </p:cNvPr>
-          <p:cNvSpPr>
-            <a:spLocks xmlns:a="http://schemas.openxmlformats.org/drawingml/2006/main" noGrp="1"/>
-          </p:cNvSpPr>
-          <p:nvPr/>
-        </p:nvSpPr>
-        <p:spPr>
-          <a:xfrm xmlns:a="http://schemas.openxmlformats.org/drawingml/2006/main">
-            <a:off x="3629025" y="1866900"/>
-            <a:ext cx="5581650" cy="266700"/>
+                <a16:creationId xmlns:a16="http://schemas.microsoft.com/office/drawing/2014/main" id="{5961F8CD-7DBA-4B8B-85D5-000F784ED6DA}"/>
+              </a:ext>
+            </a:extLst>
+          </p:cNvPr>
+          <p:cNvSpPr>
+            <a:spLocks xmlns:a="http://schemas.openxmlformats.org/drawingml/2006/main" noGrp="1"/>
+          </p:cNvSpPr>
+          <p:nvPr/>
+        </p:nvSpPr>
+        <p:spPr>
+          <a:xfrm xmlns:a="http://schemas.openxmlformats.org/drawingml/2006/main">
+            <a:off x="3705225" y="1866900"/>
+            <a:ext cx="5505450" cy="266700"/>
           </a:xfrm>
           <a:prstGeom xmlns:a="http://schemas.openxmlformats.org/drawingml/2006/main" prst="rect">
             <a:avLst/>
@@ -2372,22 +2374,24 @@
           <p:cNvPr id="36" name="">
             <a:extLst xmlns:a="http://schemas.openxmlformats.org/drawingml/2006/main">
               <a:ext uri="{FF2B5EF4-FFF2-40B4-BE49-F238E27FC236}">
-                <a16:creationId xmlns:a16="http://schemas.microsoft.com/office/drawing/2014/main" id="{96BA1108-8F20-42CE-B725-40F7307764C2}"/>
-              </a:ext>
-            </a:extLst>
-          </p:cNvPr>
-          <p:cNvSpPr>
-            <a:spLocks xmlns:a="http://schemas.openxmlformats.org/drawingml/2006/main" noGrp="1"/>
-          </p:cNvSpPr>
-          <p:nvPr/>
-        </p:nvSpPr>
-        <p:spPr>
-          <a:xfrm xmlns:a="http://schemas.openxmlformats.org/drawingml/2006/main">
-            <a:off x="3629025" y="2600325"/>
-            <a:ext cx="5581650" cy="476250"/>
-          </a:xfrm>
-          <a:prstGeom xmlns:a="http://schemas.openxmlformats.org/drawingml/2006/main" prst="rect">
-            <a:avLst/>
+                <a16:creationId xmlns:a16="http://schemas.microsoft.com/office/drawing/2014/main" id="{F3F0F92B-6DE1-41F4-999C-90FB47AF7EE4}"/>
+              </a:ext>
+            </a:extLst>
+          </p:cNvPr>
+          <p:cNvSpPr>
+            <a:spLocks xmlns:a="http://schemas.openxmlformats.org/drawingml/2006/main" noGrp="1"/>
+          </p:cNvSpPr>
+          <p:nvPr/>
+        </p:nvSpPr>
+        <p:spPr>
+          <a:xfrm xmlns:a="http://schemas.openxmlformats.org/drawingml/2006/main">
+            <a:off x="3705225" y="2600325"/>
+            <a:ext cx="5505450" cy="476250"/>
+          </a:xfrm>
+          <a:prstGeom xmlns:a="http://schemas.openxmlformats.org/drawingml/2006/main" prst="roundRect">
+            <a:avLst>
+              <a:gd name="adj" fmla="val 16000"/>
+            </a:avLst>
           </a:prstGeom>
           <a:solidFill xmlns:a="http://schemas.openxmlformats.org/drawingml/2006/main">
             <a:srgbClr val="635BFF"/>
@@ -2403,7 +2407,7 @@
           <p:cNvPr id="37" name="">
             <a:extLst xmlns:a="http://schemas.openxmlformats.org/drawingml/2006/main">
               <a:ext uri="{FF2B5EF4-FFF2-40B4-BE49-F238E27FC236}">
-                <a16:creationId xmlns:a16="http://schemas.microsoft.com/office/drawing/2014/main" id="{8DA37658-E92C-4D67-9A49-C05F02D5B84A}"/>
+                <a16:creationId xmlns:a16="http://schemas.microsoft.com/office/drawing/2014/main" id="{7A8EE630-C959-42C0-9054-F18DC410DC8E}"/>
               </a:ext>
             </a:extLst>
           </p:cNvPr>
@@ -2436,7 +2440,7 @@
           <p:cNvPr id="38" name="">
             <a:extLst xmlns:a="http://schemas.openxmlformats.org/drawingml/2006/main">
               <a:ext uri="{FF2B5EF4-FFF2-40B4-BE49-F238E27FC236}">
-                <a16:creationId xmlns:a16="http://schemas.microsoft.com/office/drawing/2014/main" id="{8C96433C-1F0F-41E1-9C83-8A6AD68C254F}"/>
+                <a16:creationId xmlns:a16="http://schemas.microsoft.com/office/drawing/2014/main" id="{E5812703-78A4-43E1-87AD-2247E2336F03}"/>
               </a:ext>
             </a:extLst>
           </p:cNvPr>
@@ -2492,19 +2496,19 @@
           <p:cNvPr id="39" name="">
             <a:extLst xmlns:a="http://schemas.openxmlformats.org/drawingml/2006/main">
               <a:ext uri="{FF2B5EF4-FFF2-40B4-BE49-F238E27FC236}">
-                <a16:creationId xmlns:a16="http://schemas.microsoft.com/office/drawing/2014/main" id="{BF6DBF9E-23D1-4416-ADCB-E180B3C6D1DE}"/>
-              </a:ext>
-            </a:extLst>
-          </p:cNvPr>
-          <p:cNvSpPr>
-            <a:spLocks xmlns:a="http://schemas.openxmlformats.org/drawingml/2006/main" noGrp="1"/>
-          </p:cNvSpPr>
-          <p:nvPr/>
-        </p:nvSpPr>
-        <p:spPr>
-          <a:xfrm xmlns:a="http://schemas.openxmlformats.org/drawingml/2006/main">
-            <a:off x="3629025" y="2705100"/>
-            <a:ext cx="5581650" cy="266700"/>
+                <a16:creationId xmlns:a16="http://schemas.microsoft.com/office/drawing/2014/main" id="{25D6F881-65C1-4650-AA15-ECAF03894BAD}"/>
+              </a:ext>
+            </a:extLst>
+          </p:cNvPr>
+          <p:cNvSpPr>
+            <a:spLocks xmlns:a="http://schemas.openxmlformats.org/drawingml/2006/main" noGrp="1"/>
+          </p:cNvSpPr>
+          <p:nvPr/>
+        </p:nvSpPr>
+        <p:spPr>
+          <a:xfrm xmlns:a="http://schemas.openxmlformats.org/drawingml/2006/main">
+            <a:off x="3705225" y="2705100"/>
+            <a:ext cx="5505450" cy="266700"/>
           </a:xfrm>
           <a:prstGeom xmlns:a="http://schemas.openxmlformats.org/drawingml/2006/main" prst="rect">
             <a:avLst/>
@@ -2548,22 +2552,24 @@
           <p:cNvPr id="40" name="">
             <a:extLst xmlns:a="http://schemas.openxmlformats.org/drawingml/2006/main">
               <a:ext uri="{FF2B5EF4-FFF2-40B4-BE49-F238E27FC236}">
-                <a16:creationId xmlns:a16="http://schemas.microsoft.com/office/drawing/2014/main" id="{694399DB-4896-4CDD-A66F-29496F91DC4A}"/>
-              </a:ext>
-            </a:extLst>
-          </p:cNvPr>
-          <p:cNvSpPr>
-            <a:spLocks xmlns:a="http://schemas.openxmlformats.org/drawingml/2006/main" noGrp="1"/>
-          </p:cNvSpPr>
-          <p:nvPr/>
-        </p:nvSpPr>
-        <p:spPr>
-          <a:xfrm xmlns:a="http://schemas.openxmlformats.org/drawingml/2006/main">
-            <a:off x="3629025" y="3438525"/>
-            <a:ext cx="5581650" cy="476250"/>
-          </a:xfrm>
-          <a:prstGeom xmlns:a="http://schemas.openxmlformats.org/drawingml/2006/main" prst="rect">
-            <a:avLst/>
+                <a16:creationId xmlns:a16="http://schemas.microsoft.com/office/drawing/2014/main" id="{D4A48415-0D44-4361-80DF-ADD23FA5C4B1}"/>
+              </a:ext>
+            </a:extLst>
+          </p:cNvPr>
+          <p:cNvSpPr>
+            <a:spLocks xmlns:a="http://schemas.openxmlformats.org/drawingml/2006/main" noGrp="1"/>
+          </p:cNvSpPr>
+          <p:nvPr/>
+        </p:nvSpPr>
+        <p:spPr>
+          <a:xfrm xmlns:a="http://schemas.openxmlformats.org/drawingml/2006/main">
+            <a:off x="3705225" y="3438525"/>
+            <a:ext cx="5505450" cy="476250"/>
+          </a:xfrm>
+          <a:prstGeom xmlns:a="http://schemas.openxmlformats.org/drawingml/2006/main" prst="roundRect">
+            <a:avLst>
+              <a:gd name="adj" fmla="val 16000"/>
+            </a:avLst>
           </a:prstGeom>
           <a:solidFill xmlns:a="http://schemas.openxmlformats.org/drawingml/2006/main">
             <a:srgbClr val="635BFF"/>
@@ -2579,7 +2585,7 @@
           <p:cNvPr id="41" name="">
             <a:extLst xmlns:a="http://schemas.openxmlformats.org/drawingml/2006/main">
               <a:ext uri="{FF2B5EF4-FFF2-40B4-BE49-F238E27FC236}">
-                <a16:creationId xmlns:a16="http://schemas.microsoft.com/office/drawing/2014/main" id="{8A7DA297-EEC2-482A-BC8E-9829673499C8}"/>
+                <a16:creationId xmlns:a16="http://schemas.microsoft.com/office/drawing/2014/main" id="{FD545873-A43F-4D45-B0FD-DEF3DA9CFF4E}"/>
               </a:ext>
             </a:extLst>
           </p:cNvPr>
@@ -2612,7 +2618,7 @@
           <p:cNvPr id="42" name="">
             <a:extLst xmlns:a="http://schemas.openxmlformats.org/drawingml/2006/main">
               <a:ext uri="{FF2B5EF4-FFF2-40B4-BE49-F238E27FC236}">
-                <a16:creationId xmlns:a16="http://schemas.microsoft.com/office/drawing/2014/main" id="{260235D6-4421-4B6C-B6E0-8E42207FB3C0}"/>
+                <a16:creationId xmlns:a16="http://schemas.microsoft.com/office/drawing/2014/main" id="{29402EDF-8521-4BB9-BB50-50BC965A2899}"/>
               </a:ext>
             </a:extLst>
           </p:cNvPr>
@@ -2668,19 +2674,19 @@
           <p:cNvPr id="43" name="">
             <a:extLst xmlns:a="http://schemas.openxmlformats.org/drawingml/2006/main">
               <a:ext uri="{FF2B5EF4-FFF2-40B4-BE49-F238E27FC236}">
-                <a16:creationId xmlns:a16="http://schemas.microsoft.com/office/drawing/2014/main" id="{0D5A7496-7164-47E4-9364-1B94CA41996D}"/>
-              </a:ext>
-            </a:extLst>
-          </p:cNvPr>
-          <p:cNvSpPr>
-            <a:spLocks xmlns:a="http://schemas.openxmlformats.org/drawingml/2006/main" noGrp="1"/>
-          </p:cNvSpPr>
-          <p:nvPr/>
-        </p:nvSpPr>
-        <p:spPr>
-          <a:xfrm xmlns:a="http://schemas.openxmlformats.org/drawingml/2006/main">
-            <a:off x="3629025" y="3543300"/>
-            <a:ext cx="5581650" cy="266700"/>
+                <a16:creationId xmlns:a16="http://schemas.microsoft.com/office/drawing/2014/main" id="{8764DB23-6E76-45FE-BDE9-35691D468DD1}"/>
+              </a:ext>
+            </a:extLst>
+          </p:cNvPr>
+          <p:cNvSpPr>
+            <a:spLocks xmlns:a="http://schemas.openxmlformats.org/drawingml/2006/main" noGrp="1"/>
+          </p:cNvSpPr>
+          <p:nvPr/>
+        </p:nvSpPr>
+        <p:spPr>
+          <a:xfrm xmlns:a="http://schemas.openxmlformats.org/drawingml/2006/main">
+            <a:off x="3705225" y="3543300"/>
+            <a:ext cx="5505450" cy="266700"/>
           </a:xfrm>
           <a:prstGeom xmlns:a="http://schemas.openxmlformats.org/drawingml/2006/main" prst="rect">
             <a:avLst/>
@@ -2724,22 +2730,24 @@
           <p:cNvPr id="44" name="">
             <a:extLst xmlns:a="http://schemas.openxmlformats.org/drawingml/2006/main">
               <a:ext uri="{FF2B5EF4-FFF2-40B4-BE49-F238E27FC236}">
-                <a16:creationId xmlns:a16="http://schemas.microsoft.com/office/drawing/2014/main" id="{14E19ABB-91CB-4C8B-A87F-8DCA3F924D70}"/>
-              </a:ext>
-            </a:extLst>
-          </p:cNvPr>
-          <p:cNvSpPr>
-            <a:spLocks xmlns:a="http://schemas.openxmlformats.org/drawingml/2006/main" noGrp="1"/>
-          </p:cNvSpPr>
-          <p:nvPr/>
-        </p:nvSpPr>
-        <p:spPr>
-          <a:xfrm xmlns:a="http://schemas.openxmlformats.org/drawingml/2006/main">
-            <a:off x="3629025" y="4276725"/>
-            <a:ext cx="5581650" cy="476250"/>
-          </a:xfrm>
-          <a:prstGeom xmlns:a="http://schemas.openxmlformats.org/drawingml/2006/main" prst="rect">
-            <a:avLst/>
+                <a16:creationId xmlns:a16="http://schemas.microsoft.com/office/drawing/2014/main" id="{73C655CD-E016-4E1E-930E-3041075CB888}"/>
+              </a:ext>
+            </a:extLst>
+          </p:cNvPr>
+          <p:cNvSpPr>
+            <a:spLocks xmlns:a="http://schemas.openxmlformats.org/drawingml/2006/main" noGrp="1"/>
+          </p:cNvSpPr>
+          <p:nvPr/>
+        </p:nvSpPr>
+        <p:spPr>
+          <a:xfrm xmlns:a="http://schemas.openxmlformats.org/drawingml/2006/main">
+            <a:off x="3705225" y="4276725"/>
+            <a:ext cx="5505450" cy="476250"/>
+          </a:xfrm>
+          <a:prstGeom xmlns:a="http://schemas.openxmlformats.org/drawingml/2006/main" prst="roundRect">
+            <a:avLst>
+              <a:gd name="adj" fmla="val 16000"/>
+            </a:avLst>
           </a:prstGeom>
           <a:solidFill xmlns:a="http://schemas.openxmlformats.org/drawingml/2006/main">
             <a:srgbClr val="635BFF"/>
@@ -2755,7 +2763,7 @@
           <p:cNvPr id="45" name="">
             <a:extLst xmlns:a="http://schemas.openxmlformats.org/drawingml/2006/main">
               <a:ext uri="{FF2B5EF4-FFF2-40B4-BE49-F238E27FC236}">
-                <a16:creationId xmlns:a16="http://schemas.microsoft.com/office/drawing/2014/main" id="{B0C1B1B1-1976-4A55-97A5-21A53BDC4D11}"/>
+                <a16:creationId xmlns:a16="http://schemas.microsoft.com/office/drawing/2014/main" id="{FBD50473-296C-498A-ABF4-032132B80E39}"/>
               </a:ext>
             </a:extLst>
           </p:cNvPr>
@@ -2788,7 +2796,7 @@
           <p:cNvPr id="46" name="">
             <a:extLst xmlns:a="http://schemas.openxmlformats.org/drawingml/2006/main">
               <a:ext uri="{FF2B5EF4-FFF2-40B4-BE49-F238E27FC236}">
-                <a16:creationId xmlns:a16="http://schemas.microsoft.com/office/drawing/2014/main" id="{BFF57B4F-F88E-4573-A064-A3710604A578}"/>
+                <a16:creationId xmlns:a16="http://schemas.microsoft.com/office/drawing/2014/main" id="{ECAD5998-BA1E-46E8-B826-4B589842E69B}"/>
               </a:ext>
             </a:extLst>
           </p:cNvPr>
@@ -2844,19 +2852,19 @@
           <p:cNvPr id="47" name="">
             <a:extLst xmlns:a="http://schemas.openxmlformats.org/drawingml/2006/main">
               <a:ext uri="{FF2B5EF4-FFF2-40B4-BE49-F238E27FC236}">
-                <a16:creationId xmlns:a16="http://schemas.microsoft.com/office/drawing/2014/main" id="{D8ECBF46-BF43-4296-AA13-080B2B1CA9EA}"/>
-              </a:ext>
-            </a:extLst>
-          </p:cNvPr>
-          <p:cNvSpPr>
-            <a:spLocks xmlns:a="http://schemas.openxmlformats.org/drawingml/2006/main" noGrp="1"/>
-          </p:cNvSpPr>
-          <p:nvPr/>
-        </p:nvSpPr>
-        <p:spPr>
-          <a:xfrm xmlns:a="http://schemas.openxmlformats.org/drawingml/2006/main">
-            <a:off x="3629025" y="4381500"/>
-            <a:ext cx="5581650" cy="266700"/>
+                <a16:creationId xmlns:a16="http://schemas.microsoft.com/office/drawing/2014/main" id="{DF92BD1D-83AF-4833-AECC-696BC97B08D1}"/>
+              </a:ext>
+            </a:extLst>
+          </p:cNvPr>
+          <p:cNvSpPr>
+            <a:spLocks xmlns:a="http://schemas.openxmlformats.org/drawingml/2006/main" noGrp="1"/>
+          </p:cNvSpPr>
+          <p:nvPr/>
+        </p:nvSpPr>
+        <p:spPr>
+          <a:xfrm xmlns:a="http://schemas.openxmlformats.org/drawingml/2006/main">
+            <a:off x="3705225" y="4381500"/>
+            <a:ext cx="5505450" cy="266700"/>
           </a:xfrm>
           <a:prstGeom xmlns:a="http://schemas.openxmlformats.org/drawingml/2006/main" prst="rect">
             <a:avLst/>
@@ -2900,22 +2908,24 @@
           <p:cNvPr id="48" name="">
             <a:extLst xmlns:a="http://schemas.openxmlformats.org/drawingml/2006/main">
               <a:ext uri="{FF2B5EF4-FFF2-40B4-BE49-F238E27FC236}">
-                <a16:creationId xmlns:a16="http://schemas.microsoft.com/office/drawing/2014/main" id="{88C4049E-7D82-45CA-98B7-E397B5884C1E}"/>
-              </a:ext>
-            </a:extLst>
-          </p:cNvPr>
-          <p:cNvSpPr>
-            <a:spLocks xmlns:a="http://schemas.openxmlformats.org/drawingml/2006/main" noGrp="1"/>
-          </p:cNvSpPr>
-          <p:nvPr/>
-        </p:nvSpPr>
-        <p:spPr>
-          <a:xfrm xmlns:a="http://schemas.openxmlformats.org/drawingml/2006/main">
-            <a:off x="3629025" y="5114925"/>
-            <a:ext cx="5581650" cy="476250"/>
-          </a:xfrm>
-          <a:prstGeom xmlns:a="http://schemas.openxmlformats.org/drawingml/2006/main" prst="rect">
-            <a:avLst/>
+                <a16:creationId xmlns:a16="http://schemas.microsoft.com/office/drawing/2014/main" id="{8D7D96B7-A54A-4555-BBD1-4338673F1F63}"/>
+              </a:ext>
+            </a:extLst>
+          </p:cNvPr>
+          <p:cNvSpPr>
+            <a:spLocks xmlns:a="http://schemas.openxmlformats.org/drawingml/2006/main" noGrp="1"/>
+          </p:cNvSpPr>
+          <p:nvPr/>
+        </p:nvSpPr>
+        <p:spPr>
+          <a:xfrm xmlns:a="http://schemas.openxmlformats.org/drawingml/2006/main">
+            <a:off x="3705225" y="5114925"/>
+            <a:ext cx="5505450" cy="476250"/>
+          </a:xfrm>
+          <a:prstGeom xmlns:a="http://schemas.openxmlformats.org/drawingml/2006/main" prst="roundRect">
+            <a:avLst>
+              <a:gd name="adj" fmla="val 16000"/>
+            </a:avLst>
           </a:prstGeom>
           <a:solidFill xmlns:a="http://schemas.openxmlformats.org/drawingml/2006/main">
             <a:srgbClr val="635BFF"/>
@@ -2931,7 +2941,7 @@
           <p:cNvPr id="49" name="">
             <a:extLst xmlns:a="http://schemas.openxmlformats.org/drawingml/2006/main">
               <a:ext uri="{FF2B5EF4-FFF2-40B4-BE49-F238E27FC236}">
-                <a16:creationId xmlns:a16="http://schemas.microsoft.com/office/drawing/2014/main" id="{25541692-DED4-4D09-B745-2135558931CC}"/>
+                <a16:creationId xmlns:a16="http://schemas.microsoft.com/office/drawing/2014/main" id="{001E5C0B-4FE5-499C-B3E0-3E43311E74D3}"/>
               </a:ext>
             </a:extLst>
           </p:cNvPr>
@@ -2964,7 +2974,7 @@
           <p:cNvPr id="50" name="">
             <a:extLst xmlns:a="http://schemas.openxmlformats.org/drawingml/2006/main">
               <a:ext uri="{FF2B5EF4-FFF2-40B4-BE49-F238E27FC236}">
-                <a16:creationId xmlns:a16="http://schemas.microsoft.com/office/drawing/2014/main" id="{7AD1D150-3A2D-4BD2-80B6-B865E3579902}"/>
+                <a16:creationId xmlns:a16="http://schemas.microsoft.com/office/drawing/2014/main" id="{6A47921F-6E8A-4602-BAAD-29DDCE60CB03}"/>
               </a:ext>
             </a:extLst>
           </p:cNvPr>
@@ -3020,19 +3030,19 @@
           <p:cNvPr id="51" name="">
             <a:extLst xmlns:a="http://schemas.openxmlformats.org/drawingml/2006/main">
               <a:ext uri="{FF2B5EF4-FFF2-40B4-BE49-F238E27FC236}">
-                <a16:creationId xmlns:a16="http://schemas.microsoft.com/office/drawing/2014/main" id="{51F3FF10-8D8E-4641-AE49-346819B56ABB}"/>
-              </a:ext>
-            </a:extLst>
-          </p:cNvPr>
-          <p:cNvSpPr>
-            <a:spLocks xmlns:a="http://schemas.openxmlformats.org/drawingml/2006/main" noGrp="1"/>
-          </p:cNvSpPr>
-          <p:nvPr/>
-        </p:nvSpPr>
-        <p:spPr>
-          <a:xfrm xmlns:a="http://schemas.openxmlformats.org/drawingml/2006/main">
-            <a:off x="3629025" y="5219700"/>
-            <a:ext cx="5581650" cy="266700"/>
+                <a16:creationId xmlns:a16="http://schemas.microsoft.com/office/drawing/2014/main" id="{B3A0DF90-6003-4E14-AB69-F70D67C07375}"/>
+              </a:ext>
+            </a:extLst>
+          </p:cNvPr>
+          <p:cNvSpPr>
+            <a:spLocks xmlns:a="http://schemas.openxmlformats.org/drawingml/2006/main" noGrp="1"/>
+          </p:cNvSpPr>
+          <p:nvPr/>
+        </p:nvSpPr>
+        <p:spPr>
+          <a:xfrm xmlns:a="http://schemas.openxmlformats.org/drawingml/2006/main">
+            <a:off x="3705225" y="5219700"/>
+            <a:ext cx="5505450" cy="266700"/>
           </a:xfrm>
           <a:prstGeom xmlns:a="http://schemas.openxmlformats.org/drawingml/2006/main" prst="rect">
             <a:avLst/>
@@ -3102,14 +3112,14 @@
       </p:grpSpPr>
       <p:pic>
         <p:nvPicPr>
-          <p:cNvPr id="64" name=""/>
+          <p:cNvPr id="66" name=""/>
           <p:cNvPicPr>
             <a:picLocks xmlns:a="http://schemas.openxmlformats.org/drawingml/2006/main" noChangeAspect="1"/>
           </p:cNvPicPr>
           <p:nvPr/>
         </p:nvPicPr>
         <p:blipFill>
-          <a:blip xmlns:r="http://schemas.openxmlformats.org/officeDocument/2006/relationships" xmlns:a="http://schemas.openxmlformats.org/drawingml/2006/main" r:embed="Rb298ec20aa2f4824"/>
+          <a:blip xmlns:r="http://schemas.openxmlformats.org/officeDocument/2006/relationships" xmlns:a="http://schemas.openxmlformats.org/drawingml/2006/main" r:embed="R025cadecbfdf4d87"/>
           <a:stretch xmlns:a="http://schemas.openxmlformats.org/drawingml/2006/main"/>
         </p:blipFill>
         <p:spPr>
@@ -3334,37 +3344,6 @@
       </p:sp>
       <p:sp>
         <p:nvSpPr>
-          <p:cNvPr id="6" name="">
-            <a:extLst xmlns:a="http://schemas.openxmlformats.org/drawingml/2006/main">
-              <a:ext uri="{FF2B5EF4-FFF2-40B4-BE49-F238E27FC236}">
-                <a16:creationId xmlns:a16="http://schemas.microsoft.com/office/drawing/2014/main" id="{96E26223-44E0-4D86-8D18-C43FCABB55D1}"/>
-              </a:ext>
-            </a:extLst>
-          </p:cNvPr>
-          <p:cNvSpPr>
-            <a:spLocks xmlns:a="http://schemas.openxmlformats.org/drawingml/2006/main" noGrp="1"/>
-          </p:cNvSpPr>
-          <p:nvPr/>
-        </p:nvSpPr>
-        <p:spPr>
-          <a:xfrm xmlns:a="http://schemas.openxmlformats.org/drawingml/2006/main">
-            <a:off x="990600" y="400050"/>
-            <a:ext cx="6572250" cy="419100"/>
-          </a:xfrm>
-          <a:prstGeom xmlns:a="http://schemas.openxmlformats.org/drawingml/2006/main" prst="rect">
-            <a:avLst/>
-          </a:prstGeom>
-          <a:solidFill xmlns:a="http://schemas.openxmlformats.org/drawingml/2006/main">
-            <a:srgbClr val="635BFF"/>
-          </a:solidFill>
-          <a:ln xmlns:a="http://schemas.openxmlformats.org/drawingml/2006/main" w="0">
-            <a:noFill/>
-            <a:prstDash val="solid"/>
-          </a:ln>
-        </p:spPr>
-      </p:sp>
-      <p:sp>
-        <p:nvSpPr>
           <p:cNvPr id="8" name="">
             <a:extLst xmlns:a="http://schemas.openxmlformats.org/drawingml/2006/main">
               <a:ext uri="{FF2B5EF4-FFF2-40B4-BE49-F238E27FC236}">
@@ -3453,77 +3432,21 @@
       </p:sp>
       <p:sp>
         <p:nvSpPr>
-          <p:cNvPr id="41" name="">
-            <a:extLst xmlns:a="http://schemas.openxmlformats.org/drawingml/2006/main">
-              <a:ext uri="{FF2B5EF4-FFF2-40B4-BE49-F238E27FC236}">
-                <a16:creationId xmlns:a16="http://schemas.microsoft.com/office/drawing/2014/main" id="{8E6C3190-DF20-48AE-8599-B12BDFD79ACE}"/>
-              </a:ext>
-            </a:extLst>
-          </p:cNvPr>
-          <p:cNvSpPr>
-            <a:spLocks xmlns:a="http://schemas.openxmlformats.org/drawingml/2006/main" noGrp="1"/>
-          </p:cNvSpPr>
-          <p:nvPr/>
-        </p:nvSpPr>
-        <p:spPr>
-          <a:xfrm xmlns:a="http://schemas.openxmlformats.org/drawingml/2006/main">
-            <a:off x="1257300" y="466725"/>
-            <a:ext cx="6038850" cy="266700"/>
-          </a:xfrm>
-          <a:prstGeom xmlns:a="http://schemas.openxmlformats.org/drawingml/2006/main" prst="rect">
-            <a:avLst/>
-          </a:prstGeom>
-          <a:noFill xmlns:a="http://schemas.openxmlformats.org/drawingml/2006/main"/>
-          <a:ln xmlns:a="http://schemas.openxmlformats.org/drawingml/2006/main" w="0">
-            <a:noFill/>
-            <a:prstDash val="solid"/>
-          </a:ln>
-        </p:spPr>
-        <p:txBody>
-          <a:bodyPr xmlns:a="http://schemas.openxmlformats.org/drawingml/2006/main" wrap="square" lIns="0" tIns="0" rIns="0" bIns="0"/>
-          <a:lstStyle xmlns:a="http://schemas.openxmlformats.org/drawingml/2006/main"/>
-          <a:p xmlns:a="http://schemas.openxmlformats.org/drawingml/2006/main">
-            <a:pPr algn="ctr">
-              <a:defRPr sz="1800" b="1">
-                <a:solidFill>
-                  <a:srgbClr val="FFFFFF"/>
-                </a:solidFill>
-                <a:latin typeface="PingFang SC"/>
-                <a:ea typeface="PingFang SC"/>
-                <a:cs typeface="PingFang SC"/>
-              </a:defRPr>
-            </a:pPr>
-            <a:r>
-              <a:rPr sz="1800" b="1">
-                <a:solidFill>
-                  <a:srgbClr val="FFFFFF"/>
-                </a:solidFill>
-                <a:latin typeface="PingFang SC"/>
-                <a:ea typeface="PingFang SC"/>
-                <a:cs typeface="PingFang SC"/>
-              </a:rPr>
-              <a:t>个人介绍</a:t>
-            </a:r>
-          </a:p>
-        </p:txBody>
-      </p:sp>
-      <p:sp>
-        <p:nvSpPr>
           <p:cNvPr id="42" name="">
             <a:extLst xmlns:a="http://schemas.openxmlformats.org/drawingml/2006/main">
               <a:ext uri="{FF2B5EF4-FFF2-40B4-BE49-F238E27FC236}">
-                <a16:creationId xmlns:a16="http://schemas.microsoft.com/office/drawing/2014/main" id="{C6BCC9A1-F5BF-49D9-8690-6E9CB8B9E28C}"/>
-              </a:ext>
-            </a:extLst>
-          </p:cNvPr>
-          <p:cNvSpPr>
-            <a:spLocks xmlns:a="http://schemas.openxmlformats.org/drawingml/2006/main" noGrp="1"/>
-          </p:cNvSpPr>
-          <p:nvPr/>
-        </p:nvSpPr>
-        <p:spPr>
-          <a:xfrm xmlns:a="http://schemas.openxmlformats.org/drawingml/2006/main">
-            <a:off x="762000" y="1409700"/>
+                <a16:creationId xmlns:a16="http://schemas.microsoft.com/office/drawing/2014/main" id="{D1244D01-F644-4603-9478-796BF56FA386}"/>
+              </a:ext>
+            </a:extLst>
+          </p:cNvPr>
+          <p:cNvSpPr>
+            <a:spLocks xmlns:a="http://schemas.openxmlformats.org/drawingml/2006/main" noGrp="1"/>
+          </p:cNvSpPr>
+          <p:nvPr/>
+        </p:nvSpPr>
+        <p:spPr>
+          <a:xfrm xmlns:a="http://schemas.openxmlformats.org/drawingml/2006/main">
+            <a:off x="1047750" y="1562100"/>
             <a:ext cx="10668000" cy="457200"/>
           </a:xfrm>
           <a:prstGeom xmlns:a="http://schemas.openxmlformats.org/drawingml/2006/main" prst="rect">
@@ -3568,18 +3491,18 @@
           <p:cNvPr id="43" name="">
             <a:extLst xmlns:a="http://schemas.openxmlformats.org/drawingml/2006/main">
               <a:ext uri="{FF2B5EF4-FFF2-40B4-BE49-F238E27FC236}">
-                <a16:creationId xmlns:a16="http://schemas.microsoft.com/office/drawing/2014/main" id="{CBE55F47-6ECE-4C41-BBC0-CE755D509132}"/>
-              </a:ext>
-            </a:extLst>
-          </p:cNvPr>
-          <p:cNvSpPr>
-            <a:spLocks xmlns:a="http://schemas.openxmlformats.org/drawingml/2006/main" noGrp="1"/>
-          </p:cNvSpPr>
-          <p:nvPr/>
-        </p:nvSpPr>
-        <p:spPr>
-          <a:xfrm xmlns:a="http://schemas.openxmlformats.org/drawingml/2006/main">
-            <a:off x="5381625" y="1971675"/>
+                <a16:creationId xmlns:a16="http://schemas.microsoft.com/office/drawing/2014/main" id="{93FB4D83-6DD7-4BE6-9A6A-357000A7ADC1}"/>
+              </a:ext>
+            </a:extLst>
+          </p:cNvPr>
+          <p:cNvSpPr>
+            <a:spLocks xmlns:a="http://schemas.openxmlformats.org/drawingml/2006/main" noGrp="1"/>
+          </p:cNvSpPr>
+          <p:nvPr/>
+        </p:nvSpPr>
+        <p:spPr>
+          <a:xfrm xmlns:a="http://schemas.openxmlformats.org/drawingml/2006/main">
+            <a:off x="5667375" y="2124075"/>
             <a:ext cx="1428750" cy="38100"/>
           </a:xfrm>
           <a:prstGeom xmlns:a="http://schemas.openxmlformats.org/drawingml/2006/main" prst="rect">
@@ -3599,18 +3522,18 @@
           <p:cNvPr id="44" name="">
             <a:extLst xmlns:a="http://schemas.openxmlformats.org/drawingml/2006/main">
               <a:ext uri="{FF2B5EF4-FFF2-40B4-BE49-F238E27FC236}">
-                <a16:creationId xmlns:a16="http://schemas.microsoft.com/office/drawing/2014/main" id="{5A75CD17-ECF2-4DB6-907F-340B3CDC79B2}"/>
-              </a:ext>
-            </a:extLst>
-          </p:cNvPr>
-          <p:cNvSpPr>
-            <a:spLocks xmlns:a="http://schemas.openxmlformats.org/drawingml/2006/main" noGrp="1"/>
-          </p:cNvSpPr>
-          <p:nvPr/>
-        </p:nvSpPr>
-        <p:spPr>
-          <a:xfrm xmlns:a="http://schemas.openxmlformats.org/drawingml/2006/main">
-            <a:off x="3714750" y="2095500"/>
+                <a16:creationId xmlns:a16="http://schemas.microsoft.com/office/drawing/2014/main" id="{D9EF211D-6E13-4A47-9D08-7E636231200E}"/>
+              </a:ext>
+            </a:extLst>
+          </p:cNvPr>
+          <p:cNvSpPr>
+            <a:spLocks xmlns:a="http://schemas.openxmlformats.org/drawingml/2006/main" noGrp="1"/>
+          </p:cNvSpPr>
+          <p:nvPr/>
+        </p:nvSpPr>
+        <p:spPr>
+          <a:xfrm xmlns:a="http://schemas.openxmlformats.org/drawingml/2006/main">
+            <a:off x="4000500" y="2247900"/>
             <a:ext cx="19050" cy="3524250"/>
           </a:xfrm>
           <a:prstGeom xmlns:a="http://schemas.openxmlformats.org/drawingml/2006/main" prst="rect">
@@ -3630,18 +3553,18 @@
           <p:cNvPr id="45" name="">
             <a:extLst xmlns:a="http://schemas.openxmlformats.org/drawingml/2006/main">
               <a:ext uri="{FF2B5EF4-FFF2-40B4-BE49-F238E27FC236}">
-                <a16:creationId xmlns:a16="http://schemas.microsoft.com/office/drawing/2014/main" id="{05AC51F4-9196-4235-AB14-7DBAD908CEAA}"/>
-              </a:ext>
-            </a:extLst>
-          </p:cNvPr>
-          <p:cNvSpPr>
-            <a:spLocks xmlns:a="http://schemas.openxmlformats.org/drawingml/2006/main" noGrp="1"/>
-          </p:cNvSpPr>
-          <p:nvPr/>
-        </p:nvSpPr>
-        <p:spPr>
-          <a:xfrm xmlns:a="http://schemas.openxmlformats.org/drawingml/2006/main">
-            <a:off x="3581400" y="2409825"/>
+                <a16:creationId xmlns:a16="http://schemas.microsoft.com/office/drawing/2014/main" id="{09426171-8D87-4F1E-94C9-ABEBF578B715}"/>
+              </a:ext>
+            </a:extLst>
+          </p:cNvPr>
+          <p:cNvSpPr>
+            <a:spLocks xmlns:a="http://schemas.openxmlformats.org/drawingml/2006/main" noGrp="1"/>
+          </p:cNvSpPr>
+          <p:nvPr/>
+        </p:nvSpPr>
+        <p:spPr>
+          <a:xfrm xmlns:a="http://schemas.openxmlformats.org/drawingml/2006/main">
+            <a:off x="3867150" y="2562225"/>
             <a:ext cx="285750" cy="285750"/>
           </a:xfrm>
           <a:prstGeom xmlns:a="http://schemas.openxmlformats.org/drawingml/2006/main" prst="ellipse">
@@ -3663,18 +3586,18 @@
           <p:cNvPr id="46" name="">
             <a:extLst xmlns:a="http://schemas.openxmlformats.org/drawingml/2006/main">
               <a:ext uri="{FF2B5EF4-FFF2-40B4-BE49-F238E27FC236}">
-                <a16:creationId xmlns:a16="http://schemas.microsoft.com/office/drawing/2014/main" id="{B911A015-D2F4-4620-9E66-A9437A5855A7}"/>
-              </a:ext>
-            </a:extLst>
-          </p:cNvPr>
-          <p:cNvSpPr>
-            <a:spLocks xmlns:a="http://schemas.openxmlformats.org/drawingml/2006/main" noGrp="1"/>
-          </p:cNvSpPr>
-          <p:nvPr/>
-        </p:nvSpPr>
-        <p:spPr>
-          <a:xfrm xmlns:a="http://schemas.openxmlformats.org/drawingml/2006/main">
-            <a:off x="4381500" y="2352675"/>
+                <a16:creationId xmlns:a16="http://schemas.microsoft.com/office/drawing/2014/main" id="{D2875AF1-5981-436F-91D2-468882A14844}"/>
+              </a:ext>
+            </a:extLst>
+          </p:cNvPr>
+          <p:cNvSpPr>
+            <a:spLocks xmlns:a="http://schemas.openxmlformats.org/drawingml/2006/main" noGrp="1"/>
+          </p:cNvSpPr>
+          <p:nvPr/>
+        </p:nvSpPr>
+        <p:spPr>
+          <a:xfrm xmlns:a="http://schemas.openxmlformats.org/drawingml/2006/main">
+            <a:off x="4667250" y="2505075"/>
             <a:ext cx="1952625" cy="323850"/>
           </a:xfrm>
           <a:prstGeom xmlns:a="http://schemas.openxmlformats.org/drawingml/2006/main" prst="rect">
@@ -3719,19 +3642,19 @@
           <p:cNvPr id="47" name="">
             <a:extLst xmlns:a="http://schemas.openxmlformats.org/drawingml/2006/main">
               <a:ext uri="{FF2B5EF4-FFF2-40B4-BE49-F238E27FC236}">
-                <a16:creationId xmlns:a16="http://schemas.microsoft.com/office/drawing/2014/main" id="{00BB29CA-9867-43F4-9A6F-1AC61011B06F}"/>
-              </a:ext>
-            </a:extLst>
-          </p:cNvPr>
-          <p:cNvSpPr>
-            <a:spLocks xmlns:a="http://schemas.openxmlformats.org/drawingml/2006/main" noGrp="1"/>
-          </p:cNvSpPr>
-          <p:nvPr/>
-        </p:nvSpPr>
-        <p:spPr>
-          <a:xfrm xmlns:a="http://schemas.openxmlformats.org/drawingml/2006/main">
-            <a:off x="6572250" y="2276475"/>
-            <a:ext cx="5143500" cy="247650"/>
+                <a16:creationId xmlns:a16="http://schemas.microsoft.com/office/drawing/2014/main" id="{558C89AE-A1AB-4FEF-94E0-59B48AADAB95}"/>
+              </a:ext>
+            </a:extLst>
+          </p:cNvPr>
+          <p:cNvSpPr>
+            <a:spLocks xmlns:a="http://schemas.openxmlformats.org/drawingml/2006/main" noGrp="1"/>
+          </p:cNvSpPr>
+          <p:nvPr/>
+        </p:nvSpPr>
+        <p:spPr>
+          <a:xfrm xmlns:a="http://schemas.openxmlformats.org/drawingml/2006/main">
+            <a:off x="6858000" y="2428875"/>
+            <a:ext cx="4857750" cy="247650"/>
           </a:xfrm>
           <a:prstGeom xmlns:a="http://schemas.openxmlformats.org/drawingml/2006/main" prst="rect">
             <a:avLst/>
@@ -3775,19 +3698,19 @@
           <p:cNvPr id="48" name="">
             <a:extLst xmlns:a="http://schemas.openxmlformats.org/drawingml/2006/main">
               <a:ext uri="{FF2B5EF4-FFF2-40B4-BE49-F238E27FC236}">
-                <a16:creationId xmlns:a16="http://schemas.microsoft.com/office/drawing/2014/main" id="{20ADFF5D-46B0-4B4D-AC83-1A02E9F65EA6}"/>
-              </a:ext>
-            </a:extLst>
-          </p:cNvPr>
-          <p:cNvSpPr>
-            <a:spLocks xmlns:a="http://schemas.openxmlformats.org/drawingml/2006/main" noGrp="1"/>
-          </p:cNvSpPr>
-          <p:nvPr/>
-        </p:nvSpPr>
-        <p:spPr>
-          <a:xfrm xmlns:a="http://schemas.openxmlformats.org/drawingml/2006/main">
-            <a:off x="6572250" y="2552700"/>
-            <a:ext cx="5143500" cy="238125"/>
+                <a16:creationId xmlns:a16="http://schemas.microsoft.com/office/drawing/2014/main" id="{C65935F9-F862-4E5A-91EC-8C408925058A}"/>
+              </a:ext>
+            </a:extLst>
+          </p:cNvPr>
+          <p:cNvSpPr>
+            <a:spLocks xmlns:a="http://schemas.openxmlformats.org/drawingml/2006/main" noGrp="1"/>
+          </p:cNvSpPr>
+          <p:nvPr/>
+        </p:nvSpPr>
+        <p:spPr>
+          <a:xfrm xmlns:a="http://schemas.openxmlformats.org/drawingml/2006/main">
+            <a:off x="6858000" y="2705100"/>
+            <a:ext cx="4857750" cy="238125"/>
           </a:xfrm>
           <a:prstGeom xmlns:a="http://schemas.openxmlformats.org/drawingml/2006/main" prst="rect">
             <a:avLst/>
@@ -3831,18 +3754,18 @@
           <p:cNvPr id="49" name="">
             <a:extLst xmlns:a="http://schemas.openxmlformats.org/drawingml/2006/main">
               <a:ext uri="{FF2B5EF4-FFF2-40B4-BE49-F238E27FC236}">
-                <a16:creationId xmlns:a16="http://schemas.microsoft.com/office/drawing/2014/main" id="{84B82A4A-54F6-4E43-A22A-CCADFC07805B}"/>
-              </a:ext>
-            </a:extLst>
-          </p:cNvPr>
-          <p:cNvSpPr>
-            <a:spLocks xmlns:a="http://schemas.openxmlformats.org/drawingml/2006/main" noGrp="1"/>
-          </p:cNvSpPr>
-          <p:nvPr/>
-        </p:nvSpPr>
-        <p:spPr>
-          <a:xfrm xmlns:a="http://schemas.openxmlformats.org/drawingml/2006/main">
-            <a:off x="3581400" y="3286125"/>
+                <a16:creationId xmlns:a16="http://schemas.microsoft.com/office/drawing/2014/main" id="{39C1567D-436E-4F55-ABA8-0EF6EEB09095}"/>
+              </a:ext>
+            </a:extLst>
+          </p:cNvPr>
+          <p:cNvSpPr>
+            <a:spLocks xmlns:a="http://schemas.openxmlformats.org/drawingml/2006/main" noGrp="1"/>
+          </p:cNvSpPr>
+          <p:nvPr/>
+        </p:nvSpPr>
+        <p:spPr>
+          <a:xfrm xmlns:a="http://schemas.openxmlformats.org/drawingml/2006/main">
+            <a:off x="3867150" y="3438525"/>
             <a:ext cx="285750" cy="285750"/>
           </a:xfrm>
           <a:prstGeom xmlns:a="http://schemas.openxmlformats.org/drawingml/2006/main" prst="ellipse">
@@ -3864,18 +3787,18 @@
           <p:cNvPr id="50" name="">
             <a:extLst xmlns:a="http://schemas.openxmlformats.org/drawingml/2006/main">
               <a:ext uri="{FF2B5EF4-FFF2-40B4-BE49-F238E27FC236}">
-                <a16:creationId xmlns:a16="http://schemas.microsoft.com/office/drawing/2014/main" id="{14907599-3AE4-4ACD-8F71-0AC0719380C8}"/>
-              </a:ext>
-            </a:extLst>
-          </p:cNvPr>
-          <p:cNvSpPr>
-            <a:spLocks xmlns:a="http://schemas.openxmlformats.org/drawingml/2006/main" noGrp="1"/>
-          </p:cNvSpPr>
-          <p:nvPr/>
-        </p:nvSpPr>
-        <p:spPr>
-          <a:xfrm xmlns:a="http://schemas.openxmlformats.org/drawingml/2006/main">
-            <a:off x="4381500" y="3228975"/>
+                <a16:creationId xmlns:a16="http://schemas.microsoft.com/office/drawing/2014/main" id="{0F747441-AA01-4242-84EF-B734A9B20AE4}"/>
+              </a:ext>
+            </a:extLst>
+          </p:cNvPr>
+          <p:cNvSpPr>
+            <a:spLocks xmlns:a="http://schemas.openxmlformats.org/drawingml/2006/main" noGrp="1"/>
+          </p:cNvSpPr>
+          <p:nvPr/>
+        </p:nvSpPr>
+        <p:spPr>
+          <a:xfrm xmlns:a="http://schemas.openxmlformats.org/drawingml/2006/main">
+            <a:off x="4667250" y="3381375"/>
             <a:ext cx="1952625" cy="323850"/>
           </a:xfrm>
           <a:prstGeom xmlns:a="http://schemas.openxmlformats.org/drawingml/2006/main" prst="rect">
@@ -3920,19 +3843,19 @@
           <p:cNvPr id="51" name="">
             <a:extLst xmlns:a="http://schemas.openxmlformats.org/drawingml/2006/main">
               <a:ext uri="{FF2B5EF4-FFF2-40B4-BE49-F238E27FC236}">
-                <a16:creationId xmlns:a16="http://schemas.microsoft.com/office/drawing/2014/main" id="{E5F41AFA-D4AA-4A5A-9449-919962B51E03}"/>
-              </a:ext>
-            </a:extLst>
-          </p:cNvPr>
-          <p:cNvSpPr>
-            <a:spLocks xmlns:a="http://schemas.openxmlformats.org/drawingml/2006/main" noGrp="1"/>
-          </p:cNvSpPr>
-          <p:nvPr/>
-        </p:nvSpPr>
-        <p:spPr>
-          <a:xfrm xmlns:a="http://schemas.openxmlformats.org/drawingml/2006/main">
-            <a:off x="6572250" y="3152775"/>
-            <a:ext cx="5143500" cy="247650"/>
+                <a16:creationId xmlns:a16="http://schemas.microsoft.com/office/drawing/2014/main" id="{10C7079B-A222-4EF2-B903-BD14C0E4197D}"/>
+              </a:ext>
+            </a:extLst>
+          </p:cNvPr>
+          <p:cNvSpPr>
+            <a:spLocks xmlns:a="http://schemas.openxmlformats.org/drawingml/2006/main" noGrp="1"/>
+          </p:cNvSpPr>
+          <p:nvPr/>
+        </p:nvSpPr>
+        <p:spPr>
+          <a:xfrm xmlns:a="http://schemas.openxmlformats.org/drawingml/2006/main">
+            <a:off x="6858000" y="3305175"/>
+            <a:ext cx="4857750" cy="247650"/>
           </a:xfrm>
           <a:prstGeom xmlns:a="http://schemas.openxmlformats.org/drawingml/2006/main" prst="rect">
             <a:avLst/>
@@ -3976,19 +3899,19 @@
           <p:cNvPr id="52" name="">
             <a:extLst xmlns:a="http://schemas.openxmlformats.org/drawingml/2006/main">
               <a:ext uri="{FF2B5EF4-FFF2-40B4-BE49-F238E27FC236}">
-                <a16:creationId xmlns:a16="http://schemas.microsoft.com/office/drawing/2014/main" id="{7AAB9711-E852-4D81-BE07-91955C000995}"/>
-              </a:ext>
-            </a:extLst>
-          </p:cNvPr>
-          <p:cNvSpPr>
-            <a:spLocks xmlns:a="http://schemas.openxmlformats.org/drawingml/2006/main" noGrp="1"/>
-          </p:cNvSpPr>
-          <p:nvPr/>
-        </p:nvSpPr>
-        <p:spPr>
-          <a:xfrm xmlns:a="http://schemas.openxmlformats.org/drawingml/2006/main">
-            <a:off x="6572250" y="3429000"/>
-            <a:ext cx="5143500" cy="238125"/>
+                <a16:creationId xmlns:a16="http://schemas.microsoft.com/office/drawing/2014/main" id="{8E8FF9E3-7658-4AFC-A8F6-808212ACCCC8}"/>
+              </a:ext>
+            </a:extLst>
+          </p:cNvPr>
+          <p:cNvSpPr>
+            <a:spLocks xmlns:a="http://schemas.openxmlformats.org/drawingml/2006/main" noGrp="1"/>
+          </p:cNvSpPr>
+          <p:nvPr/>
+        </p:nvSpPr>
+        <p:spPr>
+          <a:xfrm xmlns:a="http://schemas.openxmlformats.org/drawingml/2006/main">
+            <a:off x="6858000" y="3581400"/>
+            <a:ext cx="4857750" cy="238125"/>
           </a:xfrm>
           <a:prstGeom xmlns:a="http://schemas.openxmlformats.org/drawingml/2006/main" prst="rect">
             <a:avLst/>
@@ -4032,18 +3955,18 @@
           <p:cNvPr id="53" name="">
             <a:extLst xmlns:a="http://schemas.openxmlformats.org/drawingml/2006/main">
               <a:ext uri="{FF2B5EF4-FFF2-40B4-BE49-F238E27FC236}">
-                <a16:creationId xmlns:a16="http://schemas.microsoft.com/office/drawing/2014/main" id="{CCA0D984-91C0-4248-94DF-5D4009DE7887}"/>
-              </a:ext>
-            </a:extLst>
-          </p:cNvPr>
-          <p:cNvSpPr>
-            <a:spLocks xmlns:a="http://schemas.openxmlformats.org/drawingml/2006/main" noGrp="1"/>
-          </p:cNvSpPr>
-          <p:nvPr/>
-        </p:nvSpPr>
-        <p:spPr>
-          <a:xfrm xmlns:a="http://schemas.openxmlformats.org/drawingml/2006/main">
-            <a:off x="3581400" y="4162425"/>
+                <a16:creationId xmlns:a16="http://schemas.microsoft.com/office/drawing/2014/main" id="{A0FDA5B7-EFCE-49B4-A3F9-6F060F1741AB}"/>
+              </a:ext>
+            </a:extLst>
+          </p:cNvPr>
+          <p:cNvSpPr>
+            <a:spLocks xmlns:a="http://schemas.openxmlformats.org/drawingml/2006/main" noGrp="1"/>
+          </p:cNvSpPr>
+          <p:nvPr/>
+        </p:nvSpPr>
+        <p:spPr>
+          <a:xfrm xmlns:a="http://schemas.openxmlformats.org/drawingml/2006/main">
+            <a:off x="3867150" y="4314825"/>
             <a:ext cx="285750" cy="285750"/>
           </a:xfrm>
           <a:prstGeom xmlns:a="http://schemas.openxmlformats.org/drawingml/2006/main" prst="ellipse">
@@ -4065,18 +3988,18 @@
           <p:cNvPr id="54" name="">
             <a:extLst xmlns:a="http://schemas.openxmlformats.org/drawingml/2006/main">
               <a:ext uri="{FF2B5EF4-FFF2-40B4-BE49-F238E27FC236}">
-                <a16:creationId xmlns:a16="http://schemas.microsoft.com/office/drawing/2014/main" id="{EE4F2781-009F-4D64-B5CE-2560963838F0}"/>
-              </a:ext>
-            </a:extLst>
-          </p:cNvPr>
-          <p:cNvSpPr>
-            <a:spLocks xmlns:a="http://schemas.openxmlformats.org/drawingml/2006/main" noGrp="1"/>
-          </p:cNvSpPr>
-          <p:nvPr/>
-        </p:nvSpPr>
-        <p:spPr>
-          <a:xfrm xmlns:a="http://schemas.openxmlformats.org/drawingml/2006/main">
-            <a:off x="4381500" y="4105275"/>
+                <a16:creationId xmlns:a16="http://schemas.microsoft.com/office/drawing/2014/main" id="{1DC81526-2AC1-43CC-B47F-874D3D9C397D}"/>
+              </a:ext>
+            </a:extLst>
+          </p:cNvPr>
+          <p:cNvSpPr>
+            <a:spLocks xmlns:a="http://schemas.openxmlformats.org/drawingml/2006/main" noGrp="1"/>
+          </p:cNvSpPr>
+          <p:nvPr/>
+        </p:nvSpPr>
+        <p:spPr>
+          <a:xfrm xmlns:a="http://schemas.openxmlformats.org/drawingml/2006/main">
+            <a:off x="4667250" y="4257675"/>
             <a:ext cx="1952625" cy="323850"/>
           </a:xfrm>
           <a:prstGeom xmlns:a="http://schemas.openxmlformats.org/drawingml/2006/main" prst="rect">
@@ -4121,19 +4044,19 @@
           <p:cNvPr id="55" name="">
             <a:extLst xmlns:a="http://schemas.openxmlformats.org/drawingml/2006/main">
               <a:ext uri="{FF2B5EF4-FFF2-40B4-BE49-F238E27FC236}">
-                <a16:creationId xmlns:a16="http://schemas.microsoft.com/office/drawing/2014/main" id="{C6D30414-23D8-4B6A-A53B-522740B8EB9A}"/>
-              </a:ext>
-            </a:extLst>
-          </p:cNvPr>
-          <p:cNvSpPr>
-            <a:spLocks xmlns:a="http://schemas.openxmlformats.org/drawingml/2006/main" noGrp="1"/>
-          </p:cNvSpPr>
-          <p:nvPr/>
-        </p:nvSpPr>
-        <p:spPr>
-          <a:xfrm xmlns:a="http://schemas.openxmlformats.org/drawingml/2006/main">
-            <a:off x="6572250" y="4029075"/>
-            <a:ext cx="5143500" cy="247650"/>
+                <a16:creationId xmlns:a16="http://schemas.microsoft.com/office/drawing/2014/main" id="{012F496B-444A-4156-9688-A49090011453}"/>
+              </a:ext>
+            </a:extLst>
+          </p:cNvPr>
+          <p:cNvSpPr>
+            <a:spLocks xmlns:a="http://schemas.openxmlformats.org/drawingml/2006/main" noGrp="1"/>
+          </p:cNvSpPr>
+          <p:nvPr/>
+        </p:nvSpPr>
+        <p:spPr>
+          <a:xfrm xmlns:a="http://schemas.openxmlformats.org/drawingml/2006/main">
+            <a:off x="6858000" y="4181475"/>
+            <a:ext cx="4857750" cy="247650"/>
           </a:xfrm>
           <a:prstGeom xmlns:a="http://schemas.openxmlformats.org/drawingml/2006/main" prst="rect">
             <a:avLst/>
@@ -4177,19 +4100,19 @@
           <p:cNvPr id="56" name="">
             <a:extLst xmlns:a="http://schemas.openxmlformats.org/drawingml/2006/main">
               <a:ext uri="{FF2B5EF4-FFF2-40B4-BE49-F238E27FC236}">
-                <a16:creationId xmlns:a16="http://schemas.microsoft.com/office/drawing/2014/main" id="{2B3189CF-A712-45F1-9461-573E718A85F9}"/>
-              </a:ext>
-            </a:extLst>
-          </p:cNvPr>
-          <p:cNvSpPr>
-            <a:spLocks xmlns:a="http://schemas.openxmlformats.org/drawingml/2006/main" noGrp="1"/>
-          </p:cNvSpPr>
-          <p:nvPr/>
-        </p:nvSpPr>
-        <p:spPr>
-          <a:xfrm xmlns:a="http://schemas.openxmlformats.org/drawingml/2006/main">
-            <a:off x="6572250" y="4305300"/>
-            <a:ext cx="5143500" cy="238125"/>
+                <a16:creationId xmlns:a16="http://schemas.microsoft.com/office/drawing/2014/main" id="{53D37021-A47F-4D9F-A5A6-3069E9D6DA54}"/>
+              </a:ext>
+            </a:extLst>
+          </p:cNvPr>
+          <p:cNvSpPr>
+            <a:spLocks xmlns:a="http://schemas.openxmlformats.org/drawingml/2006/main" noGrp="1"/>
+          </p:cNvSpPr>
+          <p:nvPr/>
+        </p:nvSpPr>
+        <p:spPr>
+          <a:xfrm xmlns:a="http://schemas.openxmlformats.org/drawingml/2006/main">
+            <a:off x="6858000" y="4457700"/>
+            <a:ext cx="4857750" cy="238125"/>
           </a:xfrm>
           <a:prstGeom xmlns:a="http://schemas.openxmlformats.org/drawingml/2006/main" prst="rect">
             <a:avLst/>
@@ -4233,18 +4156,18 @@
           <p:cNvPr id="57" name="">
             <a:extLst xmlns:a="http://schemas.openxmlformats.org/drawingml/2006/main">
               <a:ext uri="{FF2B5EF4-FFF2-40B4-BE49-F238E27FC236}">
-                <a16:creationId xmlns:a16="http://schemas.microsoft.com/office/drawing/2014/main" id="{A748BC5B-2D1C-4073-8853-E631D09DB3A7}"/>
-              </a:ext>
-            </a:extLst>
-          </p:cNvPr>
-          <p:cNvSpPr>
-            <a:spLocks xmlns:a="http://schemas.openxmlformats.org/drawingml/2006/main" noGrp="1"/>
-          </p:cNvSpPr>
-          <p:nvPr/>
-        </p:nvSpPr>
-        <p:spPr>
-          <a:xfrm xmlns:a="http://schemas.openxmlformats.org/drawingml/2006/main">
-            <a:off x="3581400" y="5038725"/>
+                <a16:creationId xmlns:a16="http://schemas.microsoft.com/office/drawing/2014/main" id="{BA74DC9F-8A59-4998-BD99-CADC090940DA}"/>
+              </a:ext>
+            </a:extLst>
+          </p:cNvPr>
+          <p:cNvSpPr>
+            <a:spLocks xmlns:a="http://schemas.openxmlformats.org/drawingml/2006/main" noGrp="1"/>
+          </p:cNvSpPr>
+          <p:nvPr/>
+        </p:nvSpPr>
+        <p:spPr>
+          <a:xfrm xmlns:a="http://schemas.openxmlformats.org/drawingml/2006/main">
+            <a:off x="3867150" y="5191125"/>
             <a:ext cx="285750" cy="285750"/>
           </a:xfrm>
           <a:prstGeom xmlns:a="http://schemas.openxmlformats.org/drawingml/2006/main" prst="ellipse">
@@ -4266,18 +4189,18 @@
           <p:cNvPr id="58" name="">
             <a:extLst xmlns:a="http://schemas.openxmlformats.org/drawingml/2006/main">
               <a:ext uri="{FF2B5EF4-FFF2-40B4-BE49-F238E27FC236}">
-                <a16:creationId xmlns:a16="http://schemas.microsoft.com/office/drawing/2014/main" id="{C98889B5-92FA-4E30-811D-750E441B017D}"/>
-              </a:ext>
-            </a:extLst>
-          </p:cNvPr>
-          <p:cNvSpPr>
-            <a:spLocks xmlns:a="http://schemas.openxmlformats.org/drawingml/2006/main" noGrp="1"/>
-          </p:cNvSpPr>
-          <p:nvPr/>
-        </p:nvSpPr>
-        <p:spPr>
-          <a:xfrm xmlns:a="http://schemas.openxmlformats.org/drawingml/2006/main">
-            <a:off x="4381500" y="4981575"/>
+                <a16:creationId xmlns:a16="http://schemas.microsoft.com/office/drawing/2014/main" id="{A8366F22-6D34-4FFF-B453-2E3ACEEDDA3A}"/>
+              </a:ext>
+            </a:extLst>
+          </p:cNvPr>
+          <p:cNvSpPr>
+            <a:spLocks xmlns:a="http://schemas.openxmlformats.org/drawingml/2006/main" noGrp="1"/>
+          </p:cNvSpPr>
+          <p:nvPr/>
+        </p:nvSpPr>
+        <p:spPr>
+          <a:xfrm xmlns:a="http://schemas.openxmlformats.org/drawingml/2006/main">
+            <a:off x="4667250" y="5133975"/>
             <a:ext cx="1952625" cy="323850"/>
           </a:xfrm>
           <a:prstGeom xmlns:a="http://schemas.openxmlformats.org/drawingml/2006/main" prst="rect">
@@ -4322,19 +4245,19 @@
           <p:cNvPr id="59" name="">
             <a:extLst xmlns:a="http://schemas.openxmlformats.org/drawingml/2006/main">
               <a:ext uri="{FF2B5EF4-FFF2-40B4-BE49-F238E27FC236}">
-                <a16:creationId xmlns:a16="http://schemas.microsoft.com/office/drawing/2014/main" id="{2A988CD5-8C4E-41A3-97F2-591D1F3908C7}"/>
-              </a:ext>
-            </a:extLst>
-          </p:cNvPr>
-          <p:cNvSpPr>
-            <a:spLocks xmlns:a="http://schemas.openxmlformats.org/drawingml/2006/main" noGrp="1"/>
-          </p:cNvSpPr>
-          <p:nvPr/>
-        </p:nvSpPr>
-        <p:spPr>
-          <a:xfrm xmlns:a="http://schemas.openxmlformats.org/drawingml/2006/main">
-            <a:off x="6572250" y="4905375"/>
-            <a:ext cx="5143500" cy="247650"/>
+                <a16:creationId xmlns:a16="http://schemas.microsoft.com/office/drawing/2014/main" id="{47A9A361-8F90-4BD9-95C4-64C30CE033C4}"/>
+              </a:ext>
+            </a:extLst>
+          </p:cNvPr>
+          <p:cNvSpPr>
+            <a:spLocks xmlns:a="http://schemas.openxmlformats.org/drawingml/2006/main" noGrp="1"/>
+          </p:cNvSpPr>
+          <p:nvPr/>
+        </p:nvSpPr>
+        <p:spPr>
+          <a:xfrm xmlns:a="http://schemas.openxmlformats.org/drawingml/2006/main">
+            <a:off x="6858000" y="5057775"/>
+            <a:ext cx="4857750" cy="247650"/>
           </a:xfrm>
           <a:prstGeom xmlns:a="http://schemas.openxmlformats.org/drawingml/2006/main" prst="rect">
             <a:avLst/>
@@ -4378,19 +4301,19 @@
           <p:cNvPr id="60" name="">
             <a:extLst xmlns:a="http://schemas.openxmlformats.org/drawingml/2006/main">
               <a:ext uri="{FF2B5EF4-FFF2-40B4-BE49-F238E27FC236}">
-                <a16:creationId xmlns:a16="http://schemas.microsoft.com/office/drawing/2014/main" id="{48461C02-E6FB-422C-B8CB-6FB6AFEF2F18}"/>
-              </a:ext>
-            </a:extLst>
-          </p:cNvPr>
-          <p:cNvSpPr>
-            <a:spLocks xmlns:a="http://schemas.openxmlformats.org/drawingml/2006/main" noGrp="1"/>
-          </p:cNvSpPr>
-          <p:nvPr/>
-        </p:nvSpPr>
-        <p:spPr>
-          <a:xfrm xmlns:a="http://schemas.openxmlformats.org/drawingml/2006/main">
-            <a:off x="6572250" y="5181600"/>
-            <a:ext cx="5143500" cy="238125"/>
+                <a16:creationId xmlns:a16="http://schemas.microsoft.com/office/drawing/2014/main" id="{C3D4FAD3-EE8B-4011-9E15-1559344E97D7}"/>
+              </a:ext>
+            </a:extLst>
+          </p:cNvPr>
+          <p:cNvSpPr>
+            <a:spLocks xmlns:a="http://schemas.openxmlformats.org/drawingml/2006/main" noGrp="1"/>
+          </p:cNvSpPr>
+          <p:nvPr/>
+        </p:nvSpPr>
+        <p:spPr>
+          <a:xfrm xmlns:a="http://schemas.openxmlformats.org/drawingml/2006/main">
+            <a:off x="6858000" y="5334000"/>
+            <a:ext cx="4857750" cy="238125"/>
           </a:xfrm>
           <a:prstGeom xmlns:a="http://schemas.openxmlformats.org/drawingml/2006/main" prst="rect">
             <a:avLst/>
@@ -4438,12 +4361,12 @@
           <p:nvPr/>
         </p:nvPicPr>
         <p:blipFill>
-          <a:blip xmlns:r="http://schemas.openxmlformats.org/officeDocument/2006/relationships" xmlns:a="http://schemas.openxmlformats.org/drawingml/2006/main" r:embed="R8fec904f4fbd4d8f"/>
+          <a:blip xmlns:r="http://schemas.openxmlformats.org/officeDocument/2006/relationships" xmlns:a="http://schemas.openxmlformats.org/drawingml/2006/main" r:embed="Rb94722f449364bd3"/>
           <a:stretch xmlns:a="http://schemas.openxmlformats.org/drawingml/2006/main"/>
         </p:blipFill>
         <p:spPr>
           <a:xfrm xmlns:a="http://schemas.openxmlformats.org/drawingml/2006/main">
-            <a:off x="2114550" y="2228850"/>
+            <a:off x="2400300" y="2381250"/>
             <a:ext cx="647700" cy="647700"/>
           </a:xfrm>
           <a:prstGeom xmlns:a="http://schemas.openxmlformats.org/drawingml/2006/main" prst="rect">
@@ -4460,12 +4383,12 @@
           <p:nvPr/>
         </p:nvPicPr>
         <p:blipFill>
-          <a:blip xmlns:r="http://schemas.openxmlformats.org/officeDocument/2006/relationships" xmlns:a="http://schemas.openxmlformats.org/drawingml/2006/main" r:embed="R5f970bc1712342a2"/>
+          <a:blip xmlns:r="http://schemas.openxmlformats.org/officeDocument/2006/relationships" xmlns:a="http://schemas.openxmlformats.org/drawingml/2006/main" r:embed="R8a8c26531e0e4b63"/>
           <a:stretch xmlns:a="http://schemas.openxmlformats.org/drawingml/2006/main"/>
         </p:blipFill>
         <p:spPr>
           <a:xfrm xmlns:a="http://schemas.openxmlformats.org/drawingml/2006/main">
-            <a:off x="1733550" y="3724221"/>
+            <a:off x="2019300" y="3876621"/>
             <a:ext cx="1581150" cy="285858"/>
           </a:xfrm>
           <a:prstGeom xmlns:a="http://schemas.openxmlformats.org/drawingml/2006/main" prst="rect">
@@ -4482,12 +4405,12 @@
           <p:nvPr/>
         </p:nvPicPr>
         <p:blipFill>
-          <a:blip xmlns:r="http://schemas.openxmlformats.org/officeDocument/2006/relationships" xmlns:a="http://schemas.openxmlformats.org/drawingml/2006/main" r:embed="R071d90089de74cb2"/>
+          <a:blip xmlns:r="http://schemas.openxmlformats.org/officeDocument/2006/relationships" xmlns:a="http://schemas.openxmlformats.org/drawingml/2006/main" r:embed="R43d03ca191b246b5"/>
           <a:stretch xmlns:a="http://schemas.openxmlformats.org/drawingml/2006/main"/>
         </p:blipFill>
         <p:spPr>
           <a:xfrm xmlns:a="http://schemas.openxmlformats.org/drawingml/2006/main">
-            <a:off x="2133600" y="4879693"/>
+            <a:off x="2419350" y="5032093"/>
             <a:ext cx="609600" cy="603815"/>
           </a:xfrm>
           <a:prstGeom xmlns:a="http://schemas.openxmlformats.org/drawingml/2006/main" prst="rect">
@@ -4495,6 +4418,95 @@
           </a:prstGeom>
         </p:spPr>
       </p:pic>
+      <p:sp>
+        <p:nvSpPr>
+          <p:cNvPr id="64" name="">
+            <a:extLst xmlns:a="http://schemas.openxmlformats.org/drawingml/2006/main">
+              <a:ext uri="{FF2B5EF4-FFF2-40B4-BE49-F238E27FC236}">
+                <a16:creationId xmlns:a16="http://schemas.microsoft.com/office/drawing/2014/main" id="{A93C5C90-FA8D-440E-B241-5CC38578C3F8}"/>
+              </a:ext>
+            </a:extLst>
+          </p:cNvPr>
+          <p:cNvSpPr>
+            <a:spLocks xmlns:a="http://schemas.openxmlformats.org/drawingml/2006/main" noGrp="1"/>
+          </p:cNvSpPr>
+          <p:nvPr/>
+        </p:nvSpPr>
+        <p:spPr>
+          <a:xfrm xmlns:a="http://schemas.openxmlformats.org/drawingml/2006/main">
+            <a:off x="1162050" y="400050"/>
+            <a:ext cx="6400800" cy="419100"/>
+          </a:xfrm>
+          <a:prstGeom xmlns:a="http://schemas.openxmlformats.org/drawingml/2006/main" prst="roundRect">
+            <a:avLst>
+              <a:gd name="adj" fmla="val 18182"/>
+            </a:avLst>
+          </a:prstGeom>
+          <a:solidFill xmlns:a="http://schemas.openxmlformats.org/drawingml/2006/main">
+            <a:srgbClr val="635BFF"/>
+          </a:solidFill>
+          <a:ln xmlns:a="http://schemas.openxmlformats.org/drawingml/2006/main" w="0">
+            <a:noFill/>
+            <a:prstDash val="solid"/>
+          </a:ln>
+        </p:spPr>
+      </p:sp>
+      <p:sp>
+        <p:nvSpPr>
+          <p:cNvPr id="65" name="">
+            <a:extLst xmlns:a="http://schemas.openxmlformats.org/drawingml/2006/main">
+              <a:ext uri="{FF2B5EF4-FFF2-40B4-BE49-F238E27FC236}">
+                <a16:creationId xmlns:a16="http://schemas.microsoft.com/office/drawing/2014/main" id="{C8FF85D4-EBC7-4A1A-BE1B-437820C3D8C7}"/>
+              </a:ext>
+            </a:extLst>
+          </p:cNvPr>
+          <p:cNvSpPr>
+            <a:spLocks xmlns:a="http://schemas.openxmlformats.org/drawingml/2006/main" noGrp="1"/>
+          </p:cNvSpPr>
+          <p:nvPr/>
+        </p:nvSpPr>
+        <p:spPr>
+          <a:xfrm xmlns:a="http://schemas.openxmlformats.org/drawingml/2006/main">
+            <a:off x="1333500" y="466725"/>
+            <a:ext cx="6057900" cy="266700"/>
+          </a:xfrm>
+          <a:prstGeom xmlns:a="http://schemas.openxmlformats.org/drawingml/2006/main" prst="rect">
+            <a:avLst/>
+          </a:prstGeom>
+          <a:noFill xmlns:a="http://schemas.openxmlformats.org/drawingml/2006/main"/>
+          <a:ln xmlns:a="http://schemas.openxmlformats.org/drawingml/2006/main" w="0">
+            <a:noFill/>
+            <a:prstDash val="solid"/>
+          </a:ln>
+        </p:spPr>
+        <p:txBody>
+          <a:bodyPr xmlns:a="http://schemas.openxmlformats.org/drawingml/2006/main" wrap="square" lIns="0" tIns="0" rIns="0" bIns="0"/>
+          <a:lstStyle xmlns:a="http://schemas.openxmlformats.org/drawingml/2006/main"/>
+          <a:p xmlns:a="http://schemas.openxmlformats.org/drawingml/2006/main">
+            <a:pPr algn="ctr">
+              <a:defRPr sz="1800" b="1">
+                <a:solidFill>
+                  <a:srgbClr val="FFFFFF"/>
+                </a:solidFill>
+                <a:latin typeface="PingFang SC"/>
+                <a:ea typeface="PingFang SC"/>
+                <a:cs typeface="PingFang SC"/>
+              </a:defRPr>
+            </a:pPr>
+            <a:r>
+              <a:rPr sz="1800" b="1">
+                <a:solidFill>
+                  <a:srgbClr val="FFFFFF"/>
+                </a:solidFill>
+                <a:latin typeface="PingFang SC"/>
+                <a:ea typeface="PingFang SC"/>
+                <a:cs typeface="PingFang SC"/>
+              </a:rPr>
+              <a:t>个人介绍</a:t>
+            </a:r>
+          </a:p>
+        </p:txBody>
+      </p:sp>
     </p:spTree>
     <p:extLst>
       <p:ext uri="{BB962C8B-B14F-4D97-AF65-F5344CB8AC3E}">

</xml_diff>

<commit_message>
Merge refreshed opening sections
</commit_message>
<xml_diff>
--- a/output/sections/01-个人介绍.pptx
+++ b/output/sections/01-个人介绍.pptx
@@ -2,15 +2,15 @@
 <file path=ppt/presentation.xml><?xml version="1.0" encoding="utf-8"?>
 <p:presentation xmlns:p="http://schemas.openxmlformats.org/presentationml/2006/main">
   <p:sldMasterIdLst>
-    <p:sldMasterId xmlns:r="http://schemas.openxmlformats.org/officeDocument/2006/relationships" id="2147483648" r:id="Rdf0973935e8a4be3"/>
+    <p:sldMasterId xmlns:r="http://schemas.openxmlformats.org/officeDocument/2006/relationships" id="2147483648" r:id="R9ef6d90b94bd45c0"/>
   </p:sldMasterIdLst>
   <p:notesMasterIdLst>
-    <p:notesMasterId xmlns:r="http://schemas.openxmlformats.org/officeDocument/2006/relationships" r:id="Rabf79f3a1ef14656"/>
+    <p:notesMasterId xmlns:r="http://schemas.openxmlformats.org/officeDocument/2006/relationships" r:id="R4086d85deef34935"/>
   </p:notesMasterIdLst>
   <p:sldIdLst>
-    <p:sldId xmlns:r="http://schemas.openxmlformats.org/officeDocument/2006/relationships" id="256" r:id="Rd4b6f63b757d4cb6"/>
-    <p:sldId xmlns:r="http://schemas.openxmlformats.org/officeDocument/2006/relationships" id="257" r:id="R9c12a26a5c5c4361"/>
-    <p:sldId xmlns:r="http://schemas.openxmlformats.org/officeDocument/2006/relationships" id="258" r:id="Ra8346eee93024065"/>
+    <p:sldId xmlns:r="http://schemas.openxmlformats.org/officeDocument/2006/relationships" id="256" r:id="R649eae0b2e7f4afd"/>
+    <p:sldId xmlns:r="http://schemas.openxmlformats.org/officeDocument/2006/relationships" id="257" r:id="R3869cfb8b7b84efc"/>
+    <p:sldId xmlns:r="http://schemas.openxmlformats.org/officeDocument/2006/relationships" id="258" r:id="R2f474e1581424362"/>
   </p:sldIdLst>
   <p:sldSz cx="12192000" cy="6858000"/>
   <p:notesSz cx="6858000" cy="9144000"/>
@@ -735,7 +735,7 @@
   </p:cSld>
   <p:clrMap bg1="lt1" tx1="dk1" bg2="lt2" tx2="dk2" accent1="accent1" accent2="accent2" accent3="accent3" accent4="accent4" accent5="accent5" accent6="accent6" hlink="hlink" folHlink="folHlink"/>
   <p:sldLayoutIdLst>
-    <p:sldLayoutId xmlns:r="http://schemas.openxmlformats.org/officeDocument/2006/relationships" id="2147483649" r:id="Rf65b422d54044c0c"/>
+    <p:sldLayoutId xmlns:r="http://schemas.openxmlformats.org/officeDocument/2006/relationships" id="2147483649" r:id="R44d67ee6961247e2"/>
   </p:sldLayoutIdLst>
   <p:txStyles>
     <p:titleStyle>
@@ -1345,14 +1345,14 @@
       </p:sp>
       <p:pic>
         <p:nvPicPr>
-          <p:cNvPr id="27" name=""/>
+          <p:cNvPr id="25" name=""/>
           <p:cNvPicPr>
             <a:picLocks xmlns:a="http://schemas.openxmlformats.org/drawingml/2006/main" noChangeAspect="1"/>
           </p:cNvPicPr>
           <p:nvPr/>
         </p:nvPicPr>
         <p:blipFill>
-          <a:blip xmlns:r="http://schemas.openxmlformats.org/officeDocument/2006/relationships" xmlns:a="http://schemas.openxmlformats.org/drawingml/2006/main" r:embed="Rae7c05efdc3144b8"/>
+          <a:blip xmlns:r="http://schemas.openxmlformats.org/officeDocument/2006/relationships" xmlns:a="http://schemas.openxmlformats.org/drawingml/2006/main" r:embed="R65f501f5eb014db5"/>
           <a:stretch xmlns:a="http://schemas.openxmlformats.org/drawingml/2006/main"/>
         </p:blipFill>
         <p:spPr>
@@ -1427,18 +1427,18 @@
           <p:cNvPr id="14" name="">
             <a:extLst xmlns:a="http://schemas.openxmlformats.org/drawingml/2006/main">
               <a:ext uri="{FF2B5EF4-FFF2-40B4-BE49-F238E27FC236}">
-                <a16:creationId xmlns:a16="http://schemas.microsoft.com/office/drawing/2014/main" id="{2987E94D-1273-4986-844D-ED5DCDCE5927}"/>
-              </a:ext>
-            </a:extLst>
-          </p:cNvPr>
-          <p:cNvSpPr>
-            <a:spLocks xmlns:a="http://schemas.openxmlformats.org/drawingml/2006/main" noGrp="1"/>
-          </p:cNvSpPr>
-          <p:nvPr/>
-        </p:nvSpPr>
-        <p:spPr>
-          <a:xfrm xmlns:a="http://schemas.openxmlformats.org/drawingml/2006/main">
-            <a:off x="914400" y="2343150"/>
+                <a16:creationId xmlns:a16="http://schemas.microsoft.com/office/drawing/2014/main" id="{00E0D45D-2C82-456F-A66B-1CCAED16452D}"/>
+              </a:ext>
+            </a:extLst>
+          </p:cNvPr>
+          <p:cNvSpPr>
+            <a:spLocks xmlns:a="http://schemas.openxmlformats.org/drawingml/2006/main" noGrp="1"/>
+          </p:cNvSpPr>
+          <p:nvPr/>
+        </p:nvSpPr>
+        <p:spPr>
+          <a:xfrm xmlns:a="http://schemas.openxmlformats.org/drawingml/2006/main">
+            <a:off x="914400" y="2533650"/>
             <a:ext cx="838200" cy="57150"/>
           </a:xfrm>
           <a:prstGeom xmlns:a="http://schemas.openxmlformats.org/drawingml/2006/main" prst="rect">
@@ -1458,18 +1458,18 @@
           <p:cNvPr id="15" name="">
             <a:extLst xmlns:a="http://schemas.openxmlformats.org/drawingml/2006/main">
               <a:ext uri="{FF2B5EF4-FFF2-40B4-BE49-F238E27FC236}">
-                <a16:creationId xmlns:a16="http://schemas.microsoft.com/office/drawing/2014/main" id="{98CF785B-B4D1-40D9-8FE6-0287E4A0D4DC}"/>
-              </a:ext>
-            </a:extLst>
-          </p:cNvPr>
-          <p:cNvSpPr>
-            <a:spLocks xmlns:a="http://schemas.openxmlformats.org/drawingml/2006/main" noGrp="1"/>
-          </p:cNvSpPr>
-          <p:nvPr/>
-        </p:nvSpPr>
-        <p:spPr>
-          <a:xfrm xmlns:a="http://schemas.openxmlformats.org/drawingml/2006/main">
-            <a:off x="914400" y="2571750"/>
+                <a16:creationId xmlns:a16="http://schemas.microsoft.com/office/drawing/2014/main" id="{4101B1BB-FE37-48A6-A829-78B56C1227E2}"/>
+              </a:ext>
+            </a:extLst>
+          </p:cNvPr>
+          <p:cNvSpPr>
+            <a:spLocks xmlns:a="http://schemas.openxmlformats.org/drawingml/2006/main" noGrp="1"/>
+          </p:cNvSpPr>
+          <p:nvPr/>
+        </p:nvSpPr>
+        <p:spPr>
+          <a:xfrm xmlns:a="http://schemas.openxmlformats.org/drawingml/2006/main">
+            <a:off x="914400" y="2762250"/>
             <a:ext cx="6286500" cy="552450"/>
           </a:xfrm>
           <a:prstGeom xmlns:a="http://schemas.openxmlformats.org/drawingml/2006/main" prst="rect">
@@ -1514,18 +1514,18 @@
           <p:cNvPr id="16" name="">
             <a:extLst xmlns:a="http://schemas.openxmlformats.org/drawingml/2006/main">
               <a:ext uri="{FF2B5EF4-FFF2-40B4-BE49-F238E27FC236}">
-                <a16:creationId xmlns:a16="http://schemas.microsoft.com/office/drawing/2014/main" id="{6A9AC68A-EF07-47E7-B3E0-040F0F735E92}"/>
-              </a:ext>
-            </a:extLst>
-          </p:cNvPr>
-          <p:cNvSpPr>
-            <a:spLocks xmlns:a="http://schemas.openxmlformats.org/drawingml/2006/main" noGrp="1"/>
-          </p:cNvSpPr>
-          <p:nvPr/>
-        </p:nvSpPr>
-        <p:spPr>
-          <a:xfrm xmlns:a="http://schemas.openxmlformats.org/drawingml/2006/main">
-            <a:off x="933450" y="3257550"/>
+                <a16:creationId xmlns:a16="http://schemas.microsoft.com/office/drawing/2014/main" id="{3705A44C-C95D-4B62-BBD4-95715F7B29DB}"/>
+              </a:ext>
+            </a:extLst>
+          </p:cNvPr>
+          <p:cNvSpPr>
+            <a:spLocks xmlns:a="http://schemas.openxmlformats.org/drawingml/2006/main" noGrp="1"/>
+          </p:cNvSpPr>
+          <p:nvPr/>
+        </p:nvSpPr>
+        <p:spPr>
+          <a:xfrm xmlns:a="http://schemas.openxmlformats.org/drawingml/2006/main">
+            <a:off x="933450" y="3448050"/>
             <a:ext cx="4000500" cy="342900"/>
           </a:xfrm>
           <a:prstGeom xmlns:a="http://schemas.openxmlformats.org/drawingml/2006/main" prst="rect">
@@ -1570,18 +1570,18 @@
           <p:cNvPr id="17" name="">
             <a:extLst xmlns:a="http://schemas.openxmlformats.org/drawingml/2006/main">
               <a:ext uri="{FF2B5EF4-FFF2-40B4-BE49-F238E27FC236}">
-                <a16:creationId xmlns:a16="http://schemas.microsoft.com/office/drawing/2014/main" id="{9338C4FC-BD67-4A26-B1E0-A0E5FE4E201F}"/>
-              </a:ext>
-            </a:extLst>
-          </p:cNvPr>
-          <p:cNvSpPr>
-            <a:spLocks xmlns:a="http://schemas.openxmlformats.org/drawingml/2006/main" noGrp="1"/>
-          </p:cNvSpPr>
-          <p:nvPr/>
-        </p:nvSpPr>
-        <p:spPr>
-          <a:xfrm xmlns:a="http://schemas.openxmlformats.org/drawingml/2006/main">
-            <a:off x="933450" y="3790950"/>
+                <a16:creationId xmlns:a16="http://schemas.microsoft.com/office/drawing/2014/main" id="{B06FF0B4-E508-47CC-9860-55A59583E6BA}"/>
+              </a:ext>
+            </a:extLst>
+          </p:cNvPr>
+          <p:cNvSpPr>
+            <a:spLocks xmlns:a="http://schemas.openxmlformats.org/drawingml/2006/main" noGrp="1"/>
+          </p:cNvSpPr>
+          <p:nvPr/>
+        </p:nvSpPr>
+        <p:spPr>
+          <a:xfrm xmlns:a="http://schemas.openxmlformats.org/drawingml/2006/main">
+            <a:off x="933450" y="3981450"/>
             <a:ext cx="4953000" cy="19050"/>
           </a:xfrm>
           <a:prstGeom xmlns:a="http://schemas.openxmlformats.org/drawingml/2006/main" prst="rect">
@@ -1601,18 +1601,18 @@
           <p:cNvPr id="18" name="">
             <a:extLst xmlns:a="http://schemas.openxmlformats.org/drawingml/2006/main">
               <a:ext uri="{FF2B5EF4-FFF2-40B4-BE49-F238E27FC236}">
-                <a16:creationId xmlns:a16="http://schemas.microsoft.com/office/drawing/2014/main" id="{7EA4820E-CBAC-441C-9D8A-64E94672EF64}"/>
-              </a:ext>
-            </a:extLst>
-          </p:cNvPr>
-          <p:cNvSpPr>
-            <a:spLocks xmlns:a="http://schemas.openxmlformats.org/drawingml/2006/main" noGrp="1"/>
-          </p:cNvSpPr>
-          <p:nvPr/>
-        </p:nvSpPr>
-        <p:spPr>
-          <a:xfrm xmlns:a="http://schemas.openxmlformats.org/drawingml/2006/main">
-            <a:off x="933450" y="4191000"/>
+                <a16:creationId xmlns:a16="http://schemas.microsoft.com/office/drawing/2014/main" id="{4F63A4DE-C442-4694-AED9-6F61026E36CC}"/>
+              </a:ext>
+            </a:extLst>
+          </p:cNvPr>
+          <p:cNvSpPr>
+            <a:spLocks xmlns:a="http://schemas.openxmlformats.org/drawingml/2006/main" noGrp="1"/>
+          </p:cNvSpPr>
+          <p:nvPr/>
+        </p:nvSpPr>
+        <p:spPr>
+          <a:xfrm xmlns:a="http://schemas.openxmlformats.org/drawingml/2006/main">
+            <a:off x="933450" y="4362450"/>
             <a:ext cx="3429000" cy="266700"/>
           </a:xfrm>
           <a:prstGeom xmlns:a="http://schemas.openxmlformats.org/drawingml/2006/main" prst="rect">
@@ -1657,18 +1657,18 @@
           <p:cNvPr id="19" name="">
             <a:extLst xmlns:a="http://schemas.openxmlformats.org/drawingml/2006/main">
               <a:ext uri="{FF2B5EF4-FFF2-40B4-BE49-F238E27FC236}">
-                <a16:creationId xmlns:a16="http://schemas.microsoft.com/office/drawing/2014/main" id="{DC857404-3ADD-43EB-A332-EF6E77247438}"/>
-              </a:ext>
-            </a:extLst>
-          </p:cNvPr>
-          <p:cNvSpPr>
-            <a:spLocks xmlns:a="http://schemas.openxmlformats.org/drawingml/2006/main" noGrp="1"/>
-          </p:cNvSpPr>
-          <p:nvPr/>
-        </p:nvSpPr>
-        <p:spPr>
-          <a:xfrm xmlns:a="http://schemas.openxmlformats.org/drawingml/2006/main">
-            <a:off x="933450" y="4533900"/>
+                <a16:creationId xmlns:a16="http://schemas.microsoft.com/office/drawing/2014/main" id="{7FC2606D-C29F-4568-AB51-229B759A2809}"/>
+              </a:ext>
+            </a:extLst>
+          </p:cNvPr>
+          <p:cNvSpPr>
+            <a:spLocks xmlns:a="http://schemas.openxmlformats.org/drawingml/2006/main" noGrp="1"/>
+          </p:cNvSpPr>
+          <p:nvPr/>
+        </p:nvSpPr>
+        <p:spPr>
+          <a:xfrm xmlns:a="http://schemas.openxmlformats.org/drawingml/2006/main">
+            <a:off x="933450" y="4705350"/>
             <a:ext cx="3429000" cy="228600"/>
           </a:xfrm>
           <a:prstGeom xmlns:a="http://schemas.openxmlformats.org/drawingml/2006/main" prst="rect">
@@ -1713,63 +1713,7 @@
           <p:cNvPr id="20" name="">
             <a:extLst xmlns:a="http://schemas.openxmlformats.org/drawingml/2006/main">
               <a:ext uri="{FF2B5EF4-FFF2-40B4-BE49-F238E27FC236}">
-                <a16:creationId xmlns:a16="http://schemas.microsoft.com/office/drawing/2014/main" id="{C1892D26-BB1B-4BCB-B826-C021EA9F5A66}"/>
-              </a:ext>
-            </a:extLst>
-          </p:cNvPr>
-          <p:cNvSpPr>
-            <a:spLocks xmlns:a="http://schemas.openxmlformats.org/drawingml/2006/main" noGrp="1"/>
-          </p:cNvSpPr>
-          <p:nvPr/>
-        </p:nvSpPr>
-        <p:spPr>
-          <a:xfrm xmlns:a="http://schemas.openxmlformats.org/drawingml/2006/main">
-            <a:off x="933450" y="5162550"/>
-            <a:ext cx="6286500" cy="304800"/>
-          </a:xfrm>
-          <a:prstGeom xmlns:a="http://schemas.openxmlformats.org/drawingml/2006/main" prst="rect">
-            <a:avLst/>
-          </a:prstGeom>
-          <a:noFill xmlns:a="http://schemas.openxmlformats.org/drawingml/2006/main"/>
-          <a:ln xmlns:a="http://schemas.openxmlformats.org/drawingml/2006/main" w="0">
-            <a:noFill/>
-            <a:prstDash val="solid"/>
-          </a:ln>
-        </p:spPr>
-        <p:txBody>
-          <a:bodyPr xmlns:a="http://schemas.openxmlformats.org/drawingml/2006/main" wrap="square" lIns="0" tIns="0" rIns="0" bIns="0"/>
-          <a:lstStyle xmlns:a="http://schemas.openxmlformats.org/drawingml/2006/main"/>
-          <a:p xmlns:a="http://schemas.openxmlformats.org/drawingml/2006/main">
-            <a:pPr>
-              <a:defRPr sz="1650" b="0">
-                <a:solidFill>
-                  <a:srgbClr val="111827"/>
-                </a:solidFill>
-                <a:latin typeface="PingFang SC"/>
-                <a:ea typeface="PingFang SC"/>
-                <a:cs typeface="PingFang SC"/>
-              </a:defRPr>
-            </a:pPr>
-            <a:r>
-              <a:rPr sz="1650" b="0">
-                <a:solidFill>
-                  <a:srgbClr val="111827"/>
-                </a:solidFill>
-                <a:latin typeface="PingFang SC"/>
-                <a:ea typeface="PingFang SC"/>
-                <a:cs typeface="PingFang SC"/>
-              </a:rPr>
-              <a:t>从教育资源理解到可约束、可评估的生成式推荐链路</a:t>
-            </a:r>
-          </a:p>
-        </p:txBody>
-      </p:sp>
-      <p:sp>
-        <p:nvSpPr>
-          <p:cNvPr id="21" name="">
-            <a:extLst xmlns:a="http://schemas.openxmlformats.org/drawingml/2006/main">
-              <a:ext uri="{FF2B5EF4-FFF2-40B4-BE49-F238E27FC236}">
-                <a16:creationId xmlns:a16="http://schemas.microsoft.com/office/drawing/2014/main" id="{5F9E95DE-EC8D-4CAA-8737-4E31510E1B41}"/>
+                <a16:creationId xmlns:a16="http://schemas.microsoft.com/office/drawing/2014/main" id="{2176891E-B8A8-4A28-9EF8-1DA6807923DF}"/>
               </a:ext>
             </a:extLst>
           </p:cNvPr>
@@ -1797,10 +1741,10 @@
       </p:sp>
       <p:sp>
         <p:nvSpPr>
-          <p:cNvPr id="22" name="">
-            <a:extLst xmlns:a="http://schemas.openxmlformats.org/drawingml/2006/main">
-              <a:ext uri="{FF2B5EF4-FFF2-40B4-BE49-F238E27FC236}">
-                <a16:creationId xmlns:a16="http://schemas.microsoft.com/office/drawing/2014/main" id="{899BF721-C97F-4899-BA0D-0A0E870AC1AC}"/>
+          <p:cNvPr id="21" name="">
+            <a:extLst xmlns:a="http://schemas.openxmlformats.org/drawingml/2006/main">
+              <a:ext uri="{FF2B5EF4-FFF2-40B4-BE49-F238E27FC236}">
+                <a16:creationId xmlns:a16="http://schemas.microsoft.com/office/drawing/2014/main" id="{23FCEC3D-7D3D-4336-AE5D-0B61F11A6D60}"/>
               </a:ext>
             </a:extLst>
           </p:cNvPr>
@@ -1828,66 +1772,10 @@
       </p:sp>
       <p:sp>
         <p:nvSpPr>
-          <p:cNvPr id="23" name="">
-            <a:extLst xmlns:a="http://schemas.openxmlformats.org/drawingml/2006/main">
-              <a:ext uri="{FF2B5EF4-FFF2-40B4-BE49-F238E27FC236}">
-                <a16:creationId xmlns:a16="http://schemas.microsoft.com/office/drawing/2014/main" id="{1CB5850A-5AB3-4AF7-83BB-73B452CA526E}"/>
-              </a:ext>
-            </a:extLst>
-          </p:cNvPr>
-          <p:cNvSpPr>
-            <a:spLocks xmlns:a="http://schemas.openxmlformats.org/drawingml/2006/main" noGrp="1"/>
-          </p:cNvSpPr>
-          <p:nvPr/>
-        </p:nvSpPr>
-        <p:spPr>
-          <a:xfrm xmlns:a="http://schemas.openxmlformats.org/drawingml/2006/main">
-            <a:off x="8972550" y="4895850"/>
-            <a:ext cx="2476500" cy="419100"/>
-          </a:xfrm>
-          <a:prstGeom xmlns:a="http://schemas.openxmlformats.org/drawingml/2006/main" prst="rect">
-            <a:avLst/>
-          </a:prstGeom>
-          <a:noFill xmlns:a="http://schemas.openxmlformats.org/drawingml/2006/main"/>
-          <a:ln xmlns:a="http://schemas.openxmlformats.org/drawingml/2006/main" w="0">
-            <a:noFill/>
-            <a:prstDash val="solid"/>
-          </a:ln>
-        </p:spPr>
-        <p:txBody>
-          <a:bodyPr xmlns:a="http://schemas.openxmlformats.org/drawingml/2006/main" wrap="square" lIns="0" tIns="0" rIns="0" bIns="0"/>
-          <a:lstStyle xmlns:a="http://schemas.openxmlformats.org/drawingml/2006/main"/>
-          <a:p xmlns:a="http://schemas.openxmlformats.org/drawingml/2006/main">
-            <a:pPr algn="ctr">
-              <a:defRPr sz="2550" b="1">
-                <a:solidFill>
-                  <a:srgbClr val="FFFFFF"/>
-                </a:solidFill>
-                <a:latin typeface="PingFang SC"/>
-                <a:ea typeface="PingFang SC"/>
-                <a:cs typeface="PingFang SC"/>
-              </a:defRPr>
-            </a:pPr>
-            <a:r>
-              <a:rPr sz="2550" b="1">
-                <a:solidFill>
-                  <a:srgbClr val="FFFFFF"/>
-                </a:solidFill>
-                <a:latin typeface="PingFang SC"/>
-                <a:ea typeface="PingFang SC"/>
-                <a:cs typeface="PingFang SC"/>
-              </a:rPr>
-              <a:t>OneRec</a:t>
-            </a:r>
-          </a:p>
-        </p:txBody>
-      </p:sp>
-      <p:sp>
-        <p:nvSpPr>
-          <p:cNvPr id="24" name="">
-            <a:extLst xmlns:a="http://schemas.openxmlformats.org/drawingml/2006/main">
-              <a:ext uri="{FF2B5EF4-FFF2-40B4-BE49-F238E27FC236}">
-                <a16:creationId xmlns:a16="http://schemas.microsoft.com/office/drawing/2014/main" id="{C7D6BE6C-1706-487E-B0B4-40B1DBE729E6}"/>
+          <p:cNvPr id="22" name="">
+            <a:extLst xmlns:a="http://schemas.openxmlformats.org/drawingml/2006/main">
+              <a:ext uri="{FF2B5EF4-FFF2-40B4-BE49-F238E27FC236}">
+                <a16:creationId xmlns:a16="http://schemas.microsoft.com/office/drawing/2014/main" id="{04503346-DEFC-446B-9E07-EA35D23E4086}"/>
               </a:ext>
             </a:extLst>
           </p:cNvPr>
@@ -1976,7 +1864,7 @@
           <p:nvPr/>
         </p:nvPicPr>
         <p:blipFill>
-          <a:blip xmlns:r="http://schemas.openxmlformats.org/officeDocument/2006/relationships" xmlns:a="http://schemas.openxmlformats.org/drawingml/2006/main" r:embed="R7172acc2ecc041bf"/>
+          <a:blip xmlns:r="http://schemas.openxmlformats.org/officeDocument/2006/relationships" xmlns:a="http://schemas.openxmlformats.org/drawingml/2006/main" r:embed="R8795ea7d87504de2"/>
           <a:stretch xmlns:a="http://schemas.openxmlformats.org/drawingml/2006/main"/>
         </p:blipFill>
         <p:spPr>
@@ -2196,7 +2084,7 @@
           <p:cNvPr id="32" name="">
             <a:extLst xmlns:a="http://schemas.openxmlformats.org/drawingml/2006/main">
               <a:ext uri="{FF2B5EF4-FFF2-40B4-BE49-F238E27FC236}">
-                <a16:creationId xmlns:a16="http://schemas.microsoft.com/office/drawing/2014/main" id="{F16D27AC-19A9-4C93-96D8-4750F67C067C}"/>
+                <a16:creationId xmlns:a16="http://schemas.microsoft.com/office/drawing/2014/main" id="{475B8486-AEFF-4308-9D7D-3E774450F5A1}"/>
               </a:ext>
             </a:extLst>
           </p:cNvPr>
@@ -2229,7 +2117,7 @@
           <p:cNvPr id="33" name="">
             <a:extLst xmlns:a="http://schemas.openxmlformats.org/drawingml/2006/main">
               <a:ext uri="{FF2B5EF4-FFF2-40B4-BE49-F238E27FC236}">
-                <a16:creationId xmlns:a16="http://schemas.microsoft.com/office/drawing/2014/main" id="{FD3D387D-E54C-4607-87FF-89BB8A33A0C1}"/>
+                <a16:creationId xmlns:a16="http://schemas.microsoft.com/office/drawing/2014/main" id="{EC94850F-ABF6-443F-ADBB-E9DB09B43425}"/>
               </a:ext>
             </a:extLst>
           </p:cNvPr>
@@ -2262,7 +2150,7 @@
           <p:cNvPr id="34" name="">
             <a:extLst xmlns:a="http://schemas.openxmlformats.org/drawingml/2006/main">
               <a:ext uri="{FF2B5EF4-FFF2-40B4-BE49-F238E27FC236}">
-                <a16:creationId xmlns:a16="http://schemas.microsoft.com/office/drawing/2014/main" id="{BC55A9E8-D287-4638-A3AA-2236B1FB60A3}"/>
+                <a16:creationId xmlns:a16="http://schemas.microsoft.com/office/drawing/2014/main" id="{9132F4E0-61AE-4F0F-BEFD-6074F2A6B900}"/>
               </a:ext>
             </a:extLst>
           </p:cNvPr>
@@ -2318,7 +2206,7 @@
           <p:cNvPr id="35" name="">
             <a:extLst xmlns:a="http://schemas.openxmlformats.org/drawingml/2006/main">
               <a:ext uri="{FF2B5EF4-FFF2-40B4-BE49-F238E27FC236}">
-                <a16:creationId xmlns:a16="http://schemas.microsoft.com/office/drawing/2014/main" id="{5961F8CD-7DBA-4B8B-85D5-000F784ED6DA}"/>
+                <a16:creationId xmlns:a16="http://schemas.microsoft.com/office/drawing/2014/main" id="{9B35BAF4-5AF9-4F5B-A4D3-DA58AE8BCEBF}"/>
               </a:ext>
             </a:extLst>
           </p:cNvPr>
@@ -2374,7 +2262,7 @@
           <p:cNvPr id="36" name="">
             <a:extLst xmlns:a="http://schemas.openxmlformats.org/drawingml/2006/main">
               <a:ext uri="{FF2B5EF4-FFF2-40B4-BE49-F238E27FC236}">
-                <a16:creationId xmlns:a16="http://schemas.microsoft.com/office/drawing/2014/main" id="{F3F0F92B-6DE1-41F4-999C-90FB47AF7EE4}"/>
+                <a16:creationId xmlns:a16="http://schemas.microsoft.com/office/drawing/2014/main" id="{70069D01-2BC0-4362-B42C-F7F2B911084D}"/>
               </a:ext>
             </a:extLst>
           </p:cNvPr>
@@ -2407,7 +2295,7 @@
           <p:cNvPr id="37" name="">
             <a:extLst xmlns:a="http://schemas.openxmlformats.org/drawingml/2006/main">
               <a:ext uri="{FF2B5EF4-FFF2-40B4-BE49-F238E27FC236}">
-                <a16:creationId xmlns:a16="http://schemas.microsoft.com/office/drawing/2014/main" id="{7A8EE630-C959-42C0-9054-F18DC410DC8E}"/>
+                <a16:creationId xmlns:a16="http://schemas.microsoft.com/office/drawing/2014/main" id="{0C51D502-55EF-4DE2-8402-2C3BBABCF75B}"/>
               </a:ext>
             </a:extLst>
           </p:cNvPr>
@@ -2440,7 +2328,7 @@
           <p:cNvPr id="38" name="">
             <a:extLst xmlns:a="http://schemas.openxmlformats.org/drawingml/2006/main">
               <a:ext uri="{FF2B5EF4-FFF2-40B4-BE49-F238E27FC236}">
-                <a16:creationId xmlns:a16="http://schemas.microsoft.com/office/drawing/2014/main" id="{E5812703-78A4-43E1-87AD-2247E2336F03}"/>
+                <a16:creationId xmlns:a16="http://schemas.microsoft.com/office/drawing/2014/main" id="{E7D84F4B-F7F5-4FBB-9E6D-232D3455B39F}"/>
               </a:ext>
             </a:extLst>
           </p:cNvPr>
@@ -2496,7 +2384,7 @@
           <p:cNvPr id="39" name="">
             <a:extLst xmlns:a="http://schemas.openxmlformats.org/drawingml/2006/main">
               <a:ext uri="{FF2B5EF4-FFF2-40B4-BE49-F238E27FC236}">
-                <a16:creationId xmlns:a16="http://schemas.microsoft.com/office/drawing/2014/main" id="{25D6F881-65C1-4650-AA15-ECAF03894BAD}"/>
+                <a16:creationId xmlns:a16="http://schemas.microsoft.com/office/drawing/2014/main" id="{67E62B3F-9DB9-4F53-91A1-7608DB28A980}"/>
               </a:ext>
             </a:extLst>
           </p:cNvPr>
@@ -2552,7 +2440,7 @@
           <p:cNvPr id="40" name="">
             <a:extLst xmlns:a="http://schemas.openxmlformats.org/drawingml/2006/main">
               <a:ext uri="{FF2B5EF4-FFF2-40B4-BE49-F238E27FC236}">
-                <a16:creationId xmlns:a16="http://schemas.microsoft.com/office/drawing/2014/main" id="{D4A48415-0D44-4361-80DF-ADD23FA5C4B1}"/>
+                <a16:creationId xmlns:a16="http://schemas.microsoft.com/office/drawing/2014/main" id="{6565DC7B-DAEA-4CAE-9B71-4B86989760A6}"/>
               </a:ext>
             </a:extLst>
           </p:cNvPr>
@@ -2585,7 +2473,7 @@
           <p:cNvPr id="41" name="">
             <a:extLst xmlns:a="http://schemas.openxmlformats.org/drawingml/2006/main">
               <a:ext uri="{FF2B5EF4-FFF2-40B4-BE49-F238E27FC236}">
-                <a16:creationId xmlns:a16="http://schemas.microsoft.com/office/drawing/2014/main" id="{FD545873-A43F-4D45-B0FD-DEF3DA9CFF4E}"/>
+                <a16:creationId xmlns:a16="http://schemas.microsoft.com/office/drawing/2014/main" id="{79BE0575-9061-4CC1-B6DB-20C781C78E40}"/>
               </a:ext>
             </a:extLst>
           </p:cNvPr>
@@ -2618,7 +2506,7 @@
           <p:cNvPr id="42" name="">
             <a:extLst xmlns:a="http://schemas.openxmlformats.org/drawingml/2006/main">
               <a:ext uri="{FF2B5EF4-FFF2-40B4-BE49-F238E27FC236}">
-                <a16:creationId xmlns:a16="http://schemas.microsoft.com/office/drawing/2014/main" id="{29402EDF-8521-4BB9-BB50-50BC965A2899}"/>
+                <a16:creationId xmlns:a16="http://schemas.microsoft.com/office/drawing/2014/main" id="{CBAA2F65-8D15-4EEF-9B74-2F285CD7ECD8}"/>
               </a:ext>
             </a:extLst>
           </p:cNvPr>
@@ -2674,7 +2562,7 @@
           <p:cNvPr id="43" name="">
             <a:extLst xmlns:a="http://schemas.openxmlformats.org/drawingml/2006/main">
               <a:ext uri="{FF2B5EF4-FFF2-40B4-BE49-F238E27FC236}">
-                <a16:creationId xmlns:a16="http://schemas.microsoft.com/office/drawing/2014/main" id="{8764DB23-6E76-45FE-BDE9-35691D468DD1}"/>
+                <a16:creationId xmlns:a16="http://schemas.microsoft.com/office/drawing/2014/main" id="{6CC0C2DF-B5D2-48A4-AB89-D892334FB19F}"/>
               </a:ext>
             </a:extLst>
           </p:cNvPr>
@@ -2730,7 +2618,7 @@
           <p:cNvPr id="44" name="">
             <a:extLst xmlns:a="http://schemas.openxmlformats.org/drawingml/2006/main">
               <a:ext uri="{FF2B5EF4-FFF2-40B4-BE49-F238E27FC236}">
-                <a16:creationId xmlns:a16="http://schemas.microsoft.com/office/drawing/2014/main" id="{73C655CD-E016-4E1E-930E-3041075CB888}"/>
+                <a16:creationId xmlns:a16="http://schemas.microsoft.com/office/drawing/2014/main" id="{380B19B6-BF59-4981-98F6-01CEE8AD129D}"/>
               </a:ext>
             </a:extLst>
           </p:cNvPr>
@@ -2763,7 +2651,7 @@
           <p:cNvPr id="45" name="">
             <a:extLst xmlns:a="http://schemas.openxmlformats.org/drawingml/2006/main">
               <a:ext uri="{FF2B5EF4-FFF2-40B4-BE49-F238E27FC236}">
-                <a16:creationId xmlns:a16="http://schemas.microsoft.com/office/drawing/2014/main" id="{FBD50473-296C-498A-ABF4-032132B80E39}"/>
+                <a16:creationId xmlns:a16="http://schemas.microsoft.com/office/drawing/2014/main" id="{23499762-BE33-4F7D-A7E9-AB14D265F409}"/>
               </a:ext>
             </a:extLst>
           </p:cNvPr>
@@ -2796,7 +2684,7 @@
           <p:cNvPr id="46" name="">
             <a:extLst xmlns:a="http://schemas.openxmlformats.org/drawingml/2006/main">
               <a:ext uri="{FF2B5EF4-FFF2-40B4-BE49-F238E27FC236}">
-                <a16:creationId xmlns:a16="http://schemas.microsoft.com/office/drawing/2014/main" id="{ECAD5998-BA1E-46E8-B826-4B589842E69B}"/>
+                <a16:creationId xmlns:a16="http://schemas.microsoft.com/office/drawing/2014/main" id="{53F1E885-D187-49E7-B1B9-CBA3A7800EC3}"/>
               </a:ext>
             </a:extLst>
           </p:cNvPr>
@@ -2852,7 +2740,7 @@
           <p:cNvPr id="47" name="">
             <a:extLst xmlns:a="http://schemas.openxmlformats.org/drawingml/2006/main">
               <a:ext uri="{FF2B5EF4-FFF2-40B4-BE49-F238E27FC236}">
-                <a16:creationId xmlns:a16="http://schemas.microsoft.com/office/drawing/2014/main" id="{DF92BD1D-83AF-4833-AECC-696BC97B08D1}"/>
+                <a16:creationId xmlns:a16="http://schemas.microsoft.com/office/drawing/2014/main" id="{5F7023C6-332A-4BDF-99AB-C0CC370B19B0}"/>
               </a:ext>
             </a:extLst>
           </p:cNvPr>
@@ -2908,7 +2796,7 @@
           <p:cNvPr id="48" name="">
             <a:extLst xmlns:a="http://schemas.openxmlformats.org/drawingml/2006/main">
               <a:ext uri="{FF2B5EF4-FFF2-40B4-BE49-F238E27FC236}">
-                <a16:creationId xmlns:a16="http://schemas.microsoft.com/office/drawing/2014/main" id="{8D7D96B7-A54A-4555-BBD1-4338673F1F63}"/>
+                <a16:creationId xmlns:a16="http://schemas.microsoft.com/office/drawing/2014/main" id="{96534A46-D45A-4600-A689-BD0BC94DC122}"/>
               </a:ext>
             </a:extLst>
           </p:cNvPr>
@@ -2941,7 +2829,7 @@
           <p:cNvPr id="49" name="">
             <a:extLst xmlns:a="http://schemas.openxmlformats.org/drawingml/2006/main">
               <a:ext uri="{FF2B5EF4-FFF2-40B4-BE49-F238E27FC236}">
-                <a16:creationId xmlns:a16="http://schemas.microsoft.com/office/drawing/2014/main" id="{001E5C0B-4FE5-499C-B3E0-3E43311E74D3}"/>
+                <a16:creationId xmlns:a16="http://schemas.microsoft.com/office/drawing/2014/main" id="{B37B2157-0F39-48D4-AA1B-310E026F5D92}"/>
               </a:ext>
             </a:extLst>
           </p:cNvPr>
@@ -2974,7 +2862,7 @@
           <p:cNvPr id="50" name="">
             <a:extLst xmlns:a="http://schemas.openxmlformats.org/drawingml/2006/main">
               <a:ext uri="{FF2B5EF4-FFF2-40B4-BE49-F238E27FC236}">
-                <a16:creationId xmlns:a16="http://schemas.microsoft.com/office/drawing/2014/main" id="{6A47921F-6E8A-4602-BAAD-29DDCE60CB03}"/>
+                <a16:creationId xmlns:a16="http://schemas.microsoft.com/office/drawing/2014/main" id="{6EE0D452-6D79-4977-BBDE-47BCE13EF443}"/>
               </a:ext>
             </a:extLst>
           </p:cNvPr>
@@ -3030,7 +2918,7 @@
           <p:cNvPr id="51" name="">
             <a:extLst xmlns:a="http://schemas.openxmlformats.org/drawingml/2006/main">
               <a:ext uri="{FF2B5EF4-FFF2-40B4-BE49-F238E27FC236}">
-                <a16:creationId xmlns:a16="http://schemas.microsoft.com/office/drawing/2014/main" id="{B3A0DF90-6003-4E14-AB69-F70D67C07375}"/>
+                <a16:creationId xmlns:a16="http://schemas.microsoft.com/office/drawing/2014/main" id="{6ED00A26-BF26-4AE1-9C5E-7A6246786F06}"/>
               </a:ext>
             </a:extLst>
           </p:cNvPr>
@@ -3119,7 +3007,7 @@
           <p:nvPr/>
         </p:nvPicPr>
         <p:blipFill>
-          <a:blip xmlns:r="http://schemas.openxmlformats.org/officeDocument/2006/relationships" xmlns:a="http://schemas.openxmlformats.org/drawingml/2006/main" r:embed="R025cadecbfdf4d87"/>
+          <a:blip xmlns:r="http://schemas.openxmlformats.org/officeDocument/2006/relationships" xmlns:a="http://schemas.openxmlformats.org/drawingml/2006/main" r:embed="Re9ad820f4d754576"/>
           <a:stretch xmlns:a="http://schemas.openxmlformats.org/drawingml/2006/main"/>
         </p:blipFill>
         <p:spPr>
@@ -3435,7 +3323,7 @@
           <p:cNvPr id="42" name="">
             <a:extLst xmlns:a="http://schemas.openxmlformats.org/drawingml/2006/main">
               <a:ext uri="{FF2B5EF4-FFF2-40B4-BE49-F238E27FC236}">
-                <a16:creationId xmlns:a16="http://schemas.microsoft.com/office/drawing/2014/main" id="{D1244D01-F644-4603-9478-796BF56FA386}"/>
+                <a16:creationId xmlns:a16="http://schemas.microsoft.com/office/drawing/2014/main" id="{9C515339-67EC-406A-BBE6-41C340DB5A89}"/>
               </a:ext>
             </a:extLst>
           </p:cNvPr>
@@ -3491,7 +3379,7 @@
           <p:cNvPr id="43" name="">
             <a:extLst xmlns:a="http://schemas.openxmlformats.org/drawingml/2006/main">
               <a:ext uri="{FF2B5EF4-FFF2-40B4-BE49-F238E27FC236}">
-                <a16:creationId xmlns:a16="http://schemas.microsoft.com/office/drawing/2014/main" id="{93FB4D83-6DD7-4BE6-9A6A-357000A7ADC1}"/>
+                <a16:creationId xmlns:a16="http://schemas.microsoft.com/office/drawing/2014/main" id="{5A769ADF-46E4-42DC-B85F-7F160AF73931}"/>
               </a:ext>
             </a:extLst>
           </p:cNvPr>
@@ -3522,7 +3410,7 @@
           <p:cNvPr id="44" name="">
             <a:extLst xmlns:a="http://schemas.openxmlformats.org/drawingml/2006/main">
               <a:ext uri="{FF2B5EF4-FFF2-40B4-BE49-F238E27FC236}">
-                <a16:creationId xmlns:a16="http://schemas.microsoft.com/office/drawing/2014/main" id="{D9EF211D-6E13-4A47-9D08-7E636231200E}"/>
+                <a16:creationId xmlns:a16="http://schemas.microsoft.com/office/drawing/2014/main" id="{5D206A65-0879-466A-ACC2-5180C6406D53}"/>
               </a:ext>
             </a:extLst>
           </p:cNvPr>
@@ -3553,7 +3441,7 @@
           <p:cNvPr id="45" name="">
             <a:extLst xmlns:a="http://schemas.openxmlformats.org/drawingml/2006/main">
               <a:ext uri="{FF2B5EF4-FFF2-40B4-BE49-F238E27FC236}">
-                <a16:creationId xmlns:a16="http://schemas.microsoft.com/office/drawing/2014/main" id="{09426171-8D87-4F1E-94C9-ABEBF578B715}"/>
+                <a16:creationId xmlns:a16="http://schemas.microsoft.com/office/drawing/2014/main" id="{D4196568-5524-405A-8DED-C1BA6E2AF9E6}"/>
               </a:ext>
             </a:extLst>
           </p:cNvPr>
@@ -3586,7 +3474,7 @@
           <p:cNvPr id="46" name="">
             <a:extLst xmlns:a="http://schemas.openxmlformats.org/drawingml/2006/main">
               <a:ext uri="{FF2B5EF4-FFF2-40B4-BE49-F238E27FC236}">
-                <a16:creationId xmlns:a16="http://schemas.microsoft.com/office/drawing/2014/main" id="{D2875AF1-5981-436F-91D2-468882A14844}"/>
+                <a16:creationId xmlns:a16="http://schemas.microsoft.com/office/drawing/2014/main" id="{7BA285A2-330E-419F-B4BB-4D6A907B40AE}"/>
               </a:ext>
             </a:extLst>
           </p:cNvPr>
@@ -3642,7 +3530,7 @@
           <p:cNvPr id="47" name="">
             <a:extLst xmlns:a="http://schemas.openxmlformats.org/drawingml/2006/main">
               <a:ext uri="{FF2B5EF4-FFF2-40B4-BE49-F238E27FC236}">
-                <a16:creationId xmlns:a16="http://schemas.microsoft.com/office/drawing/2014/main" id="{558C89AE-A1AB-4FEF-94E0-59B48AADAB95}"/>
+                <a16:creationId xmlns:a16="http://schemas.microsoft.com/office/drawing/2014/main" id="{06A66574-C9F2-4F8C-8DA4-F0462CF3C2DA}"/>
               </a:ext>
             </a:extLst>
           </p:cNvPr>
@@ -3698,7 +3586,7 @@
           <p:cNvPr id="48" name="">
             <a:extLst xmlns:a="http://schemas.openxmlformats.org/drawingml/2006/main">
               <a:ext uri="{FF2B5EF4-FFF2-40B4-BE49-F238E27FC236}">
-                <a16:creationId xmlns:a16="http://schemas.microsoft.com/office/drawing/2014/main" id="{C65935F9-F862-4E5A-91EC-8C408925058A}"/>
+                <a16:creationId xmlns:a16="http://schemas.microsoft.com/office/drawing/2014/main" id="{1BBC10E9-D571-489F-BDF8-2D077D5EB132}"/>
               </a:ext>
             </a:extLst>
           </p:cNvPr>
@@ -3754,7 +3642,7 @@
           <p:cNvPr id="49" name="">
             <a:extLst xmlns:a="http://schemas.openxmlformats.org/drawingml/2006/main">
               <a:ext uri="{FF2B5EF4-FFF2-40B4-BE49-F238E27FC236}">
-                <a16:creationId xmlns:a16="http://schemas.microsoft.com/office/drawing/2014/main" id="{39C1567D-436E-4F55-ABA8-0EF6EEB09095}"/>
+                <a16:creationId xmlns:a16="http://schemas.microsoft.com/office/drawing/2014/main" id="{0DD98587-3FF5-4074-A35E-120884DB42F2}"/>
               </a:ext>
             </a:extLst>
           </p:cNvPr>
@@ -3787,7 +3675,7 @@
           <p:cNvPr id="50" name="">
             <a:extLst xmlns:a="http://schemas.openxmlformats.org/drawingml/2006/main">
               <a:ext uri="{FF2B5EF4-FFF2-40B4-BE49-F238E27FC236}">
-                <a16:creationId xmlns:a16="http://schemas.microsoft.com/office/drawing/2014/main" id="{0F747441-AA01-4242-84EF-B734A9B20AE4}"/>
+                <a16:creationId xmlns:a16="http://schemas.microsoft.com/office/drawing/2014/main" id="{D8ED6F38-4F3E-4BD3-8DAB-29E0B98FD3C8}"/>
               </a:ext>
             </a:extLst>
           </p:cNvPr>
@@ -3843,7 +3731,7 @@
           <p:cNvPr id="51" name="">
             <a:extLst xmlns:a="http://schemas.openxmlformats.org/drawingml/2006/main">
               <a:ext uri="{FF2B5EF4-FFF2-40B4-BE49-F238E27FC236}">
-                <a16:creationId xmlns:a16="http://schemas.microsoft.com/office/drawing/2014/main" id="{10C7079B-A222-4EF2-B903-BD14C0E4197D}"/>
+                <a16:creationId xmlns:a16="http://schemas.microsoft.com/office/drawing/2014/main" id="{56F750A5-9FE6-41BD-929D-4AE50A25EAE6}"/>
               </a:ext>
             </a:extLst>
           </p:cNvPr>
@@ -3899,7 +3787,7 @@
           <p:cNvPr id="52" name="">
             <a:extLst xmlns:a="http://schemas.openxmlformats.org/drawingml/2006/main">
               <a:ext uri="{FF2B5EF4-FFF2-40B4-BE49-F238E27FC236}">
-                <a16:creationId xmlns:a16="http://schemas.microsoft.com/office/drawing/2014/main" id="{8E8FF9E3-7658-4AFC-A8F6-808212ACCCC8}"/>
+                <a16:creationId xmlns:a16="http://schemas.microsoft.com/office/drawing/2014/main" id="{1EA3FD58-85DA-43FB-8F4D-4422BEA4578C}"/>
               </a:ext>
             </a:extLst>
           </p:cNvPr>
@@ -3955,7 +3843,7 @@
           <p:cNvPr id="53" name="">
             <a:extLst xmlns:a="http://schemas.openxmlformats.org/drawingml/2006/main">
               <a:ext uri="{FF2B5EF4-FFF2-40B4-BE49-F238E27FC236}">
-                <a16:creationId xmlns:a16="http://schemas.microsoft.com/office/drawing/2014/main" id="{A0FDA5B7-EFCE-49B4-A3F9-6F060F1741AB}"/>
+                <a16:creationId xmlns:a16="http://schemas.microsoft.com/office/drawing/2014/main" id="{16C3D401-7053-475E-A41A-666759DCC36C}"/>
               </a:ext>
             </a:extLst>
           </p:cNvPr>
@@ -3988,7 +3876,7 @@
           <p:cNvPr id="54" name="">
             <a:extLst xmlns:a="http://schemas.openxmlformats.org/drawingml/2006/main">
               <a:ext uri="{FF2B5EF4-FFF2-40B4-BE49-F238E27FC236}">
-                <a16:creationId xmlns:a16="http://schemas.microsoft.com/office/drawing/2014/main" id="{1DC81526-2AC1-43CC-B47F-874D3D9C397D}"/>
+                <a16:creationId xmlns:a16="http://schemas.microsoft.com/office/drawing/2014/main" id="{8099F7F5-9D16-4560-A3D6-BE225551417B}"/>
               </a:ext>
             </a:extLst>
           </p:cNvPr>
@@ -4044,7 +3932,7 @@
           <p:cNvPr id="55" name="">
             <a:extLst xmlns:a="http://schemas.openxmlformats.org/drawingml/2006/main">
               <a:ext uri="{FF2B5EF4-FFF2-40B4-BE49-F238E27FC236}">
-                <a16:creationId xmlns:a16="http://schemas.microsoft.com/office/drawing/2014/main" id="{012F496B-444A-4156-9688-A49090011453}"/>
+                <a16:creationId xmlns:a16="http://schemas.microsoft.com/office/drawing/2014/main" id="{7AF56947-E6A8-4EF3-9C1C-7B29E7513F3D}"/>
               </a:ext>
             </a:extLst>
           </p:cNvPr>
@@ -4100,7 +3988,7 @@
           <p:cNvPr id="56" name="">
             <a:extLst xmlns:a="http://schemas.openxmlformats.org/drawingml/2006/main">
               <a:ext uri="{FF2B5EF4-FFF2-40B4-BE49-F238E27FC236}">
-                <a16:creationId xmlns:a16="http://schemas.microsoft.com/office/drawing/2014/main" id="{53D37021-A47F-4D9F-A5A6-3069E9D6DA54}"/>
+                <a16:creationId xmlns:a16="http://schemas.microsoft.com/office/drawing/2014/main" id="{4F2F6F83-535B-43F1-8745-4DAD6D0CD8B7}"/>
               </a:ext>
             </a:extLst>
           </p:cNvPr>
@@ -4156,7 +4044,7 @@
           <p:cNvPr id="57" name="">
             <a:extLst xmlns:a="http://schemas.openxmlformats.org/drawingml/2006/main">
               <a:ext uri="{FF2B5EF4-FFF2-40B4-BE49-F238E27FC236}">
-                <a16:creationId xmlns:a16="http://schemas.microsoft.com/office/drawing/2014/main" id="{BA74DC9F-8A59-4998-BD99-CADC090940DA}"/>
+                <a16:creationId xmlns:a16="http://schemas.microsoft.com/office/drawing/2014/main" id="{CC3AAF68-4B2C-428A-A9AF-B92E2783F322}"/>
               </a:ext>
             </a:extLst>
           </p:cNvPr>
@@ -4189,7 +4077,7 @@
           <p:cNvPr id="58" name="">
             <a:extLst xmlns:a="http://schemas.openxmlformats.org/drawingml/2006/main">
               <a:ext uri="{FF2B5EF4-FFF2-40B4-BE49-F238E27FC236}">
-                <a16:creationId xmlns:a16="http://schemas.microsoft.com/office/drawing/2014/main" id="{A8366F22-6D34-4FFF-B453-2E3ACEEDDA3A}"/>
+                <a16:creationId xmlns:a16="http://schemas.microsoft.com/office/drawing/2014/main" id="{329AB681-29D0-455D-A474-C0FFDA9DA16A}"/>
               </a:ext>
             </a:extLst>
           </p:cNvPr>
@@ -4245,7 +4133,7 @@
           <p:cNvPr id="59" name="">
             <a:extLst xmlns:a="http://schemas.openxmlformats.org/drawingml/2006/main">
               <a:ext uri="{FF2B5EF4-FFF2-40B4-BE49-F238E27FC236}">
-                <a16:creationId xmlns:a16="http://schemas.microsoft.com/office/drawing/2014/main" id="{47A9A361-8F90-4BD9-95C4-64C30CE033C4}"/>
+                <a16:creationId xmlns:a16="http://schemas.microsoft.com/office/drawing/2014/main" id="{0468DED1-367A-44A5-A18F-DA789E5B024E}"/>
               </a:ext>
             </a:extLst>
           </p:cNvPr>
@@ -4301,7 +4189,7 @@
           <p:cNvPr id="60" name="">
             <a:extLst xmlns:a="http://schemas.openxmlformats.org/drawingml/2006/main">
               <a:ext uri="{FF2B5EF4-FFF2-40B4-BE49-F238E27FC236}">
-                <a16:creationId xmlns:a16="http://schemas.microsoft.com/office/drawing/2014/main" id="{C3D4FAD3-EE8B-4011-9E15-1559344E97D7}"/>
+                <a16:creationId xmlns:a16="http://schemas.microsoft.com/office/drawing/2014/main" id="{A5DA8331-8D16-4551-855B-EDF16EC87B07}"/>
               </a:ext>
             </a:extLst>
           </p:cNvPr>
@@ -4361,7 +4249,7 @@
           <p:nvPr/>
         </p:nvPicPr>
         <p:blipFill>
-          <a:blip xmlns:r="http://schemas.openxmlformats.org/officeDocument/2006/relationships" xmlns:a="http://schemas.openxmlformats.org/drawingml/2006/main" r:embed="Rb94722f449364bd3"/>
+          <a:blip xmlns:r="http://schemas.openxmlformats.org/officeDocument/2006/relationships" xmlns:a="http://schemas.openxmlformats.org/drawingml/2006/main" r:embed="R7adced09159947cd"/>
           <a:stretch xmlns:a="http://schemas.openxmlformats.org/drawingml/2006/main"/>
         </p:blipFill>
         <p:spPr>
@@ -4383,7 +4271,7 @@
           <p:nvPr/>
         </p:nvPicPr>
         <p:blipFill>
-          <a:blip xmlns:r="http://schemas.openxmlformats.org/officeDocument/2006/relationships" xmlns:a="http://schemas.openxmlformats.org/drawingml/2006/main" r:embed="R8a8c26531e0e4b63"/>
+          <a:blip xmlns:r="http://schemas.openxmlformats.org/officeDocument/2006/relationships" xmlns:a="http://schemas.openxmlformats.org/drawingml/2006/main" r:embed="R145c078773994156"/>
           <a:stretch xmlns:a="http://schemas.openxmlformats.org/drawingml/2006/main"/>
         </p:blipFill>
         <p:spPr>
@@ -4405,7 +4293,7 @@
           <p:nvPr/>
         </p:nvPicPr>
         <p:blipFill>
-          <a:blip xmlns:r="http://schemas.openxmlformats.org/officeDocument/2006/relationships" xmlns:a="http://schemas.openxmlformats.org/drawingml/2006/main" r:embed="R43d03ca191b246b5"/>
+          <a:blip xmlns:r="http://schemas.openxmlformats.org/officeDocument/2006/relationships" xmlns:a="http://schemas.openxmlformats.org/drawingml/2006/main" r:embed="R357a32ae10044b68"/>
           <a:stretch xmlns:a="http://schemas.openxmlformats.org/drawingml/2006/main"/>
         </p:blipFill>
         <p:spPr>
@@ -4423,7 +4311,7 @@
           <p:cNvPr id="64" name="">
             <a:extLst xmlns:a="http://schemas.openxmlformats.org/drawingml/2006/main">
               <a:ext uri="{FF2B5EF4-FFF2-40B4-BE49-F238E27FC236}">
-                <a16:creationId xmlns:a16="http://schemas.microsoft.com/office/drawing/2014/main" id="{A93C5C90-FA8D-440E-B241-5CC38578C3F8}"/>
+                <a16:creationId xmlns:a16="http://schemas.microsoft.com/office/drawing/2014/main" id="{1FB215EC-9757-446B-B77C-8D105B675300}"/>
               </a:ext>
             </a:extLst>
           </p:cNvPr>
@@ -4456,7 +4344,7 @@
           <p:cNvPr id="65" name="">
             <a:extLst xmlns:a="http://schemas.openxmlformats.org/drawingml/2006/main">
               <a:ext uri="{FF2B5EF4-FFF2-40B4-BE49-F238E27FC236}">
-                <a16:creationId xmlns:a16="http://schemas.microsoft.com/office/drawing/2014/main" id="{C8FF85D4-EBC7-4A1A-BE1B-437820C3D8C7}"/>
+                <a16:creationId xmlns:a16="http://schemas.microsoft.com/office/drawing/2014/main" id="{2C214F05-FFDE-46FF-81EB-49CC23CB94E1}"/>
               </a:ext>
             </a:extLst>
           </p:cNvPr>

</xml_diff>